<commit_message>
Fix leaderboard slide: relocate grey box, add rank clarification, add date range
Move 'Only 8 districts fell below Troy' annotation to bottom-right corner
of scatter plot. Add '2019 → 2025' to subtitle and chart title. Table
header now reads 'lower rank = higher performance' for clarity.

Co-Authored-By: Claude Opus 4.6 <noreply@anthropic.com>
</commit_message>
<xml_diff>
--- a/analysis/Troy_K5_ELA_Executive_Summary.pptx
+++ b/analysis/Troy_K5_ELA_Executive_Summary.pptx
@@ -19145,7 +19145,7 @@
                 </a:solidFill>
                 <a:latin typeface="Calibri"/>
               </a:rPr>
-              <a:t>Absolute performance level among 504 peers — not just change, but where Troy sits now</a:t>
+              <a:t>2019 → 2025 absolute performance level among 504 peers — not just change, but where Troy sits now</a:t>
             </a:r>
           </a:p>
         </p:txBody>
@@ -19272,7 +19272,7 @@
                 </a:solidFill>
                 <a:latin typeface="Calibri"/>
               </a:rPr>
-              <a:t>Every subgroup: pre-COVID rank → post-COVID rank (among 504 level-matched peers, 1 = highest)</a:t>
+              <a:t>Every subgroup: pre-COVID rank → post-COVID rank among 504 level-matched peers  (lower rank = higher performance)</a:t>
             </a:r>
           </a:p>
         </p:txBody>

</xml_diff>

<commit_message>
Fix slide numbering and move annotations to correct slide
- Count title as slide 1: renumber all footers sequentially 2-29
  (previously skipped 9, making footer numbers off by 1)
- Total is now 29 (was incorrectly 30)
- Move date range and rank clarification to slide 23 (delta histogram):
  subtitle now reads "2019 → 2025 change analysis", subgroup table
  header says "higher rank = worse decline"
- Revert slide 24 (leaderboard) subtitle and table header to original

Co-Authored-By: Claude Opus 4.6 <noreply@anthropic.com>
</commit_message>
<xml_diff>
--- a/analysis/Troy_K5_ELA_Executive_Summary.pptx
+++ b/analysis/Troy_K5_ELA_Executive_Summary.pptx
@@ -4202,7 +4202,7 @@
                 </a:solidFill>
                 <a:latin typeface="Calibri"/>
               </a:rPr>
-              <a:t>11 / 30</a:t>
+              <a:t>10 / 29</a:t>
             </a:r>
           </a:p>
         </p:txBody>
@@ -4802,7 +4802,7 @@
                 </a:solidFill>
                 <a:latin typeface="Calibri"/>
               </a:rPr>
-              <a:t>12 / 30</a:t>
+              <a:t>11 / 29</a:t>
             </a:r>
           </a:p>
         </p:txBody>
@@ -5378,7 +5378,7 @@
                 </a:solidFill>
                 <a:latin typeface="Calibri"/>
               </a:rPr>
-              <a:t>13 / 30</a:t>
+              <a:t>12 / 29</a:t>
             </a:r>
           </a:p>
         </p:txBody>
@@ -6000,7 +6000,7 @@
                 </a:solidFill>
                 <a:latin typeface="Calibri"/>
               </a:rPr>
-              <a:t>14 / 30</a:t>
+              <a:t>13 / 29</a:t>
             </a:r>
           </a:p>
         </p:txBody>
@@ -7130,7 +7130,7 @@
                 </a:solidFill>
                 <a:latin typeface="Calibri"/>
               </a:rPr>
-              <a:t>15 / 30</a:t>
+              <a:t>14 / 29</a:t>
             </a:r>
           </a:p>
         </p:txBody>
@@ -7952,7 +7952,7 @@
                 </a:solidFill>
                 <a:latin typeface="Calibri"/>
               </a:rPr>
-              <a:t>16 / 30</a:t>
+              <a:t>15 / 29</a:t>
             </a:r>
           </a:p>
         </p:txBody>
@@ -8526,7 +8526,7 @@
                 </a:solidFill>
                 <a:latin typeface="Calibri"/>
               </a:rPr>
-              <a:t>17 / 30</a:t>
+              <a:t>16 / 29</a:t>
             </a:r>
           </a:p>
         </p:txBody>
@@ -9430,7 +9430,7 @@
                 </a:solidFill>
                 <a:latin typeface="Calibri"/>
               </a:rPr>
-              <a:t>18 / 30</a:t>
+              <a:t>17 / 29</a:t>
             </a:r>
           </a:p>
         </p:txBody>
@@ -10412,7 +10412,7 @@
                 </a:solidFill>
                 <a:latin typeface="Calibri"/>
               </a:rPr>
-              <a:t>19 / 30</a:t>
+              <a:t>18 / 29</a:t>
             </a:r>
           </a:p>
         </p:txBody>
@@ -12994,7 +12994,7 @@
                 </a:solidFill>
                 <a:latin typeface="Calibri"/>
               </a:rPr>
-              <a:t>20 / 30</a:t>
+              <a:t>19 / 29</a:t>
             </a:r>
           </a:p>
         </p:txBody>
@@ -14130,7 +14130,7 @@
                 </a:solidFill>
                 <a:latin typeface="Calibri"/>
               </a:rPr>
-              <a:t>2 / 30</a:t>
+              <a:t>2 / 29</a:t>
             </a:r>
           </a:p>
         </p:txBody>
@@ -14976,7 +14976,7 @@
                 </a:solidFill>
                 <a:latin typeface="Calibri"/>
               </a:rPr>
-              <a:t>21 / 30</a:t>
+              <a:t>20 / 29</a:t>
             </a:r>
           </a:p>
         </p:txBody>
@@ -16887,7 +16887,7 @@
                 </a:solidFill>
                 <a:latin typeface="Calibri"/>
               </a:rPr>
-              <a:t>22 / 30</a:t>
+              <a:t>21 / 29</a:t>
             </a:r>
           </a:p>
         </p:txBody>
@@ -17655,7 +17655,7 @@
                 </a:solidFill>
                 <a:latin typeface="Calibri"/>
               </a:rPr>
-              <a:t>23 / 30</a:t>
+              <a:t>22 / 29</a:t>
             </a:r>
           </a:p>
         </p:txBody>
@@ -17787,7 +17787,7 @@
                 </a:solidFill>
                 <a:latin typeface="Calibri"/>
               </a:rPr>
-              <a:t>Pre-COVID baseline ±0.25 of Troy, enrollment ≥150/grade-year, complete 2017-2025 data</a:t>
+              <a:t>2019 → 2025 change analysis  •  Pre-COVID baseline ±0.25 of Troy, enrollment ≥150/grade-year</a:t>
             </a:r>
           </a:p>
         </p:txBody>
@@ -18161,7 +18161,7 @@
                 </a:solidFill>
                 <a:latin typeface="Calibri"/>
               </a:rPr>
-              <a:t>Subgroup Δ ranks (post − pre COVID)</a:t>
+              <a:t>Subgroup Δ ranks — higher rank = worse decline</a:t>
             </a:r>
           </a:p>
         </p:txBody>
@@ -19013,7 +19013,7 @@
                 </a:solidFill>
                 <a:latin typeface="Calibri"/>
               </a:rPr>
-              <a:t>24 / 30</a:t>
+              <a:t>23 / 29</a:t>
             </a:r>
           </a:p>
         </p:txBody>
@@ -19145,7 +19145,7 @@
                 </a:solidFill>
                 <a:latin typeface="Calibri"/>
               </a:rPr>
-              <a:t>2019 → 2025 absolute performance level among 504 peers — not just change, but where Troy sits now</a:t>
+              <a:t>Absolute performance level among 504 peers — not just change, but where Troy sits now</a:t>
             </a:r>
           </a:p>
         </p:txBody>
@@ -19272,7 +19272,7 @@
                 </a:solidFill>
                 <a:latin typeface="Calibri"/>
               </a:rPr>
-              <a:t>Every subgroup: pre-COVID rank → post-COVID rank among 504 level-matched peers  (lower rank = higher performance)</a:t>
+              <a:t>Every subgroup: pre-COVID rank → post-COVID rank (among 504 level-matched peers, 1 = highest)</a:t>
             </a:r>
           </a:p>
         </p:txBody>
@@ -21302,7 +21302,7 @@
                 </a:solidFill>
                 <a:latin typeface="Calibri"/>
               </a:rPr>
-              <a:t>25 / 30</a:t>
+              <a:t>24 / 29</a:t>
             </a:r>
           </a:p>
         </p:txBody>
@@ -23441,7 +23441,7 @@
                 </a:solidFill>
                 <a:latin typeface="Calibri"/>
               </a:rPr>
-              <a:t>26 / 30</a:t>
+              <a:t>25 / 29</a:t>
             </a:r>
           </a:p>
         </p:txBody>
@@ -24537,7 +24537,7 @@
                 </a:solidFill>
                 <a:latin typeface="Calibri"/>
               </a:rPr>
-              <a:t>27 / 30</a:t>
+              <a:t>26 / 29</a:t>
             </a:r>
           </a:p>
         </p:txBody>
@@ -26229,7 +26229,7 @@
                 </a:solidFill>
                 <a:latin typeface="Calibri"/>
               </a:rPr>
-              <a:t>28 / 30</a:t>
+              <a:t>27 / 29</a:t>
             </a:r>
           </a:p>
         </p:txBody>
@@ -28517,7 +28517,7 @@
                 </a:solidFill>
                 <a:latin typeface="Calibri"/>
               </a:rPr>
-              <a:t>29 / 30</a:t>
+              <a:t>28 / 29</a:t>
             </a:r>
           </a:p>
         </p:txBody>
@@ -30452,7 +30452,7 @@
                 </a:solidFill>
                 <a:latin typeface="Calibri"/>
               </a:rPr>
-              <a:t>30 / 30</a:t>
+              <a:t>29 / 29</a:t>
             </a:r>
           </a:p>
         </p:txBody>
@@ -31263,7 +31263,7 @@
                 </a:solidFill>
                 <a:latin typeface="Calibri"/>
               </a:rPr>
-              <a:t>3 / 30</a:t>
+              <a:t>3 / 29</a:t>
             </a:r>
           </a:p>
         </p:txBody>
@@ -31920,7 +31920,7 @@
                 </a:solidFill>
                 <a:latin typeface="Calibri"/>
               </a:rPr>
-              <a:t>4 / 30</a:t>
+              <a:t>4 / 29</a:t>
             </a:r>
           </a:p>
         </p:txBody>
@@ -32520,7 +32520,7 @@
                 </a:solidFill>
                 <a:latin typeface="Calibri"/>
               </a:rPr>
-              <a:t>5 / 30</a:t>
+              <a:t>5 / 29</a:t>
             </a:r>
           </a:p>
         </p:txBody>
@@ -35154,7 +35154,7 @@
                 </a:solidFill>
                 <a:latin typeface="Calibri"/>
               </a:rPr>
-              <a:t>6 / 30</a:t>
+              <a:t>6 / 29</a:t>
             </a:r>
           </a:p>
         </p:txBody>
@@ -37888,7 +37888,7 @@
                 </a:solidFill>
                 <a:latin typeface="Calibri"/>
               </a:rPr>
-              <a:t>7 / 30</a:t>
+              <a:t>7 / 29</a:t>
             </a:r>
           </a:p>
         </p:txBody>
@@ -40889,7 +40889,7 @@
                 </a:solidFill>
                 <a:latin typeface="Calibri"/>
               </a:rPr>
-              <a:t>8 / 30</a:t>
+              <a:t>8 / 29</a:t>
             </a:r>
           </a:p>
         </p:txBody>
@@ -42170,7 +42170,7 @@
                 </a:solidFill>
                 <a:latin typeface="Calibri"/>
               </a:rPr>
-              <a:t>10 / 30</a:t>
+              <a:t>9 / 29</a:t>
             </a:r>
           </a:p>
         </p:txBody>

</xml_diff>

<commit_message>
Fix slide 23 histogram overlap and slide 24 footer
Rebuilt chart_seda_ela_peers.png without the grey bbox annotation that
overlapped histogram bars — methodology info is already in the slide
subtitle. Compressed slide 24 subgroup table spacing so footer is no
longer hidden behind the grey background rect.

Co-Authored-By: Claude Opus 4.6 <noreply@anthropic.com>
</commit_message>
<xml_diff>
--- a/analysis/Troy_K5_ELA_Executive_Summary.pptx
+++ b/analysis/Troy_K5_ELA_Executive_Summary.pptx
@@ -17809,7 +17809,7 @@
         <p:spPr>
           <a:xfrm>
             <a:off x="274320" y="868680"/>
-            <a:ext cx="7589520" cy="3794760"/>
+            <a:ext cx="7589520" cy="3761671"/>
           </a:xfrm>
           <a:prstGeom prst="rect">
             <a:avLst/>
@@ -19206,8 +19206,8 @@
         </p:nvSpPr>
         <p:spPr>
           <a:xfrm>
-            <a:off x="274320" y="5120640"/>
-            <a:ext cx="11612880" cy="1554480"/>
+            <a:off x="274320" y="5029200"/>
+            <a:ext cx="11612880" cy="1371600"/>
           </a:xfrm>
           <a:prstGeom prst="rect">
             <a:avLst/>
@@ -19250,23 +19250,23 @@
         </p:nvSpPr>
         <p:spPr>
           <a:xfrm>
-            <a:off x="457200" y="5166360"/>
-            <a:ext cx="10972800" cy="274320"/>
-          </a:xfrm>
-          <a:prstGeom prst="rect">
-            <a:avLst/>
-          </a:prstGeom>
-          <a:noFill/>
-        </p:spPr>
-        <p:txBody>
-          <a:bodyPr wrap="square" lIns="0" rIns="0" tIns="0" bIns="0">
-            <a:spAutoFit/>
-          </a:bodyPr>
-          <a:lstStyle/>
-          <a:p>
-            <a:pPr algn="l"/>
-            <a:r>
-              <a:rPr sz="1100" b="1" i="0">
+            <a:off x="457200" y="5074920"/>
+            <a:ext cx="10972800" cy="228600"/>
+          </a:xfrm>
+          <a:prstGeom prst="rect">
+            <a:avLst/>
+          </a:prstGeom>
+          <a:noFill/>
+        </p:spPr>
+        <p:txBody>
+          <a:bodyPr wrap="square" lIns="0" rIns="0" tIns="0" bIns="0">
+            <a:spAutoFit/>
+          </a:bodyPr>
+          <a:lstStyle/>
+          <a:p>
+            <a:pPr algn="l"/>
+            <a:r>
+              <a:rPr sz="1000" b="1" i="0">
                 <a:solidFill>
                   <a:srgbClr val="1F3A5F"/>
                 </a:solidFill>
@@ -19285,8 +19285,8 @@
         </p:nvSpPr>
         <p:spPr>
           <a:xfrm>
-            <a:off x="457200" y="5440680"/>
-            <a:ext cx="1463040" cy="201168"/>
+            <a:off x="457200" y="5321808"/>
+            <a:ext cx="1463040" cy="182880"/>
           </a:xfrm>
           <a:prstGeom prst="rect">
             <a:avLst/>
@@ -19320,8 +19320,8 @@
         </p:nvSpPr>
         <p:spPr>
           <a:xfrm>
-            <a:off x="2377440" y="5440680"/>
-            <a:ext cx="1463040" cy="201168"/>
+            <a:off x="2377440" y="5321808"/>
+            <a:ext cx="1463040" cy="182880"/>
           </a:xfrm>
           <a:prstGeom prst="rect">
             <a:avLst/>
@@ -19355,8 +19355,8 @@
         </p:nvSpPr>
         <p:spPr>
           <a:xfrm>
-            <a:off x="4114800" y="5440680"/>
-            <a:ext cx="1463040" cy="201168"/>
+            <a:off x="4114800" y="5321808"/>
+            <a:ext cx="1463040" cy="182880"/>
           </a:xfrm>
           <a:prstGeom prst="rect">
             <a:avLst/>
@@ -19390,8 +19390,8 @@
         </p:nvSpPr>
         <p:spPr>
           <a:xfrm>
-            <a:off x="5760720" y="5440680"/>
-            <a:ext cx="1463040" cy="201168"/>
+            <a:off x="5760720" y="5321808"/>
+            <a:ext cx="1463040" cy="182880"/>
           </a:xfrm>
           <a:prstGeom prst="rect">
             <a:avLst/>
@@ -19425,8 +19425,8 @@
         </p:nvSpPr>
         <p:spPr>
           <a:xfrm>
-            <a:off x="7132320" y="5440680"/>
-            <a:ext cx="1463040" cy="201168"/>
+            <a:off x="7132320" y="5321808"/>
+            <a:ext cx="1463040" cy="182880"/>
           </a:xfrm>
           <a:prstGeom prst="rect">
             <a:avLst/>
@@ -19460,8 +19460,8 @@
         </p:nvSpPr>
         <p:spPr>
           <a:xfrm>
-            <a:off x="8686800" y="5440680"/>
-            <a:ext cx="1463040" cy="201168"/>
+            <a:off x="8686800" y="5321808"/>
+            <a:ext cx="1463040" cy="182880"/>
           </a:xfrm>
           <a:prstGeom prst="rect">
             <a:avLst/>
@@ -19495,8 +19495,8 @@
         </p:nvSpPr>
         <p:spPr>
           <a:xfrm>
-            <a:off x="10241280" y="5440680"/>
-            <a:ext cx="1463040" cy="201168"/>
+            <a:off x="10241280" y="5321808"/>
+            <a:ext cx="1463040" cy="182880"/>
           </a:xfrm>
           <a:prstGeom prst="rect">
             <a:avLst/>
@@ -19530,8 +19530,8 @@
         </p:nvSpPr>
         <p:spPr>
           <a:xfrm>
-            <a:off x="457200" y="5669280"/>
-            <a:ext cx="1463040" cy="182880"/>
+            <a:off x="457200" y="5532120"/>
+            <a:ext cx="1463040" cy="155448"/>
           </a:xfrm>
           <a:prstGeom prst="rect">
             <a:avLst/>
@@ -19565,8 +19565,8 @@
         </p:nvSpPr>
         <p:spPr>
           <a:xfrm>
-            <a:off x="2377440" y="5669280"/>
-            <a:ext cx="1463040" cy="182880"/>
+            <a:off x="2377440" y="5532120"/>
+            <a:ext cx="1463040" cy="155448"/>
           </a:xfrm>
           <a:prstGeom prst="rect">
             <a:avLst/>
@@ -19600,8 +19600,8 @@
         </p:nvSpPr>
         <p:spPr>
           <a:xfrm>
-            <a:off x="4114800" y="5669280"/>
-            <a:ext cx="1463040" cy="182880"/>
+            <a:off x="4114800" y="5532120"/>
+            <a:ext cx="1463040" cy="155448"/>
           </a:xfrm>
           <a:prstGeom prst="rect">
             <a:avLst/>
@@ -19635,8 +19635,8 @@
         </p:nvSpPr>
         <p:spPr>
           <a:xfrm>
-            <a:off x="5760720" y="5669280"/>
-            <a:ext cx="1463040" cy="182880"/>
+            <a:off x="5760720" y="5532120"/>
+            <a:ext cx="1463040" cy="155448"/>
           </a:xfrm>
           <a:prstGeom prst="rect">
             <a:avLst/>
@@ -19670,8 +19670,8 @@
         </p:nvSpPr>
         <p:spPr>
           <a:xfrm>
-            <a:off x="7132320" y="5669280"/>
-            <a:ext cx="1463040" cy="182880"/>
+            <a:off x="7132320" y="5532120"/>
+            <a:ext cx="1463040" cy="155448"/>
           </a:xfrm>
           <a:prstGeom prst="rect">
             <a:avLst/>
@@ -19705,8 +19705,8 @@
         </p:nvSpPr>
         <p:spPr>
           <a:xfrm>
-            <a:off x="8686800" y="5669280"/>
-            <a:ext cx="1463040" cy="182880"/>
+            <a:off x="8686800" y="5532120"/>
+            <a:ext cx="1463040" cy="155448"/>
           </a:xfrm>
           <a:prstGeom prst="rect">
             <a:avLst/>
@@ -19740,8 +19740,8 @@
         </p:nvSpPr>
         <p:spPr>
           <a:xfrm>
-            <a:off x="10241280" y="5669280"/>
-            <a:ext cx="1463040" cy="182880"/>
+            <a:off x="10241280" y="5532120"/>
+            <a:ext cx="1463040" cy="155448"/>
           </a:xfrm>
           <a:prstGeom prst="rect">
             <a:avLst/>
@@ -19775,8 +19775,8 @@
         </p:nvSpPr>
         <p:spPr>
           <a:xfrm>
-            <a:off x="457200" y="5852160"/>
-            <a:ext cx="1463040" cy="182880"/>
+            <a:off x="457200" y="5646420"/>
+            <a:ext cx="1463040" cy="155448"/>
           </a:xfrm>
           <a:prstGeom prst="rect">
             <a:avLst/>
@@ -19810,8 +19810,8 @@
         </p:nvSpPr>
         <p:spPr>
           <a:xfrm>
-            <a:off x="2377440" y="5852160"/>
-            <a:ext cx="1463040" cy="182880"/>
+            <a:off x="2377440" y="5646420"/>
+            <a:ext cx="1463040" cy="155448"/>
           </a:xfrm>
           <a:prstGeom prst="rect">
             <a:avLst/>
@@ -19845,8 +19845,8 @@
         </p:nvSpPr>
         <p:spPr>
           <a:xfrm>
-            <a:off x="4114800" y="5852160"/>
-            <a:ext cx="1463040" cy="182880"/>
+            <a:off x="4114800" y="5646420"/>
+            <a:ext cx="1463040" cy="155448"/>
           </a:xfrm>
           <a:prstGeom prst="rect">
             <a:avLst/>
@@ -19880,8 +19880,8 @@
         </p:nvSpPr>
         <p:spPr>
           <a:xfrm>
-            <a:off x="5760720" y="5852160"/>
-            <a:ext cx="1463040" cy="182880"/>
+            <a:off x="5760720" y="5646420"/>
+            <a:ext cx="1463040" cy="155448"/>
           </a:xfrm>
           <a:prstGeom prst="rect">
             <a:avLst/>
@@ -19915,8 +19915,8 @@
         </p:nvSpPr>
         <p:spPr>
           <a:xfrm>
-            <a:off x="7132320" y="5852160"/>
-            <a:ext cx="1463040" cy="182880"/>
+            <a:off x="7132320" y="5646420"/>
+            <a:ext cx="1463040" cy="155448"/>
           </a:xfrm>
           <a:prstGeom prst="rect">
             <a:avLst/>
@@ -19950,8 +19950,8 @@
         </p:nvSpPr>
         <p:spPr>
           <a:xfrm>
-            <a:off x="8686800" y="5852160"/>
-            <a:ext cx="1463040" cy="182880"/>
+            <a:off x="8686800" y="5646420"/>
+            <a:ext cx="1463040" cy="155448"/>
           </a:xfrm>
           <a:prstGeom prst="rect">
             <a:avLst/>
@@ -19985,8 +19985,8 @@
         </p:nvSpPr>
         <p:spPr>
           <a:xfrm>
-            <a:off x="10241280" y="5852160"/>
-            <a:ext cx="1463040" cy="182880"/>
+            <a:off x="10241280" y="5646420"/>
+            <a:ext cx="1463040" cy="155448"/>
           </a:xfrm>
           <a:prstGeom prst="rect">
             <a:avLst/>
@@ -20020,8 +20020,8 @@
         </p:nvSpPr>
         <p:spPr>
           <a:xfrm>
-            <a:off x="457200" y="6035040"/>
-            <a:ext cx="1463040" cy="182880"/>
+            <a:off x="457200" y="5760720"/>
+            <a:ext cx="1463040" cy="155448"/>
           </a:xfrm>
           <a:prstGeom prst="rect">
             <a:avLst/>
@@ -20055,8 +20055,8 @@
         </p:nvSpPr>
         <p:spPr>
           <a:xfrm>
-            <a:off x="2377440" y="6035040"/>
-            <a:ext cx="1463040" cy="182880"/>
+            <a:off x="2377440" y="5760720"/>
+            <a:ext cx="1463040" cy="155448"/>
           </a:xfrm>
           <a:prstGeom prst="rect">
             <a:avLst/>
@@ -20090,8 +20090,8 @@
         </p:nvSpPr>
         <p:spPr>
           <a:xfrm>
-            <a:off x="4114800" y="6035040"/>
-            <a:ext cx="1463040" cy="182880"/>
+            <a:off x="4114800" y="5760720"/>
+            <a:ext cx="1463040" cy="155448"/>
           </a:xfrm>
           <a:prstGeom prst="rect">
             <a:avLst/>
@@ -20125,8 +20125,8 @@
         </p:nvSpPr>
         <p:spPr>
           <a:xfrm>
-            <a:off x="5760720" y="6035040"/>
-            <a:ext cx="1463040" cy="182880"/>
+            <a:off x="5760720" y="5760720"/>
+            <a:ext cx="1463040" cy="155448"/>
           </a:xfrm>
           <a:prstGeom prst="rect">
             <a:avLst/>
@@ -20160,8 +20160,8 @@
         </p:nvSpPr>
         <p:spPr>
           <a:xfrm>
-            <a:off x="7132320" y="6035040"/>
-            <a:ext cx="1463040" cy="182880"/>
+            <a:off x="7132320" y="5760720"/>
+            <a:ext cx="1463040" cy="155448"/>
           </a:xfrm>
           <a:prstGeom prst="rect">
             <a:avLst/>
@@ -20195,8 +20195,8 @@
         </p:nvSpPr>
         <p:spPr>
           <a:xfrm>
-            <a:off x="8686800" y="6035040"/>
-            <a:ext cx="1463040" cy="182880"/>
+            <a:off x="8686800" y="5760720"/>
+            <a:ext cx="1463040" cy="155448"/>
           </a:xfrm>
           <a:prstGeom prst="rect">
             <a:avLst/>
@@ -20230,8 +20230,8 @@
         </p:nvSpPr>
         <p:spPr>
           <a:xfrm>
-            <a:off x="10241280" y="6035040"/>
-            <a:ext cx="1463040" cy="182880"/>
+            <a:off x="10241280" y="5760720"/>
+            <a:ext cx="1463040" cy="155448"/>
           </a:xfrm>
           <a:prstGeom prst="rect">
             <a:avLst/>
@@ -20265,8 +20265,743 @@
         </p:nvSpPr>
         <p:spPr>
           <a:xfrm>
+            <a:off x="457200" y="5875020"/>
+            <a:ext cx="1463040" cy="155448"/>
+          </a:xfrm>
+          <a:prstGeom prst="rect">
+            <a:avLst/>
+          </a:prstGeom>
+          <a:noFill/>
+        </p:spPr>
+        <p:txBody>
+          <a:bodyPr wrap="square" lIns="0" rIns="0" tIns="0" bIns="0">
+            <a:spAutoFit/>
+          </a:bodyPr>
+          <a:lstStyle/>
+          <a:p>
+            <a:pPr algn="l"/>
+            <a:r>
+              <a:rPr sz="850" b="0" i="0">
+                <a:solidFill>
+                  <a:srgbClr val="333333"/>
+                </a:solidFill>
+                <a:latin typeface="Calibri"/>
+              </a:rPr>
+              <a:t>Black</a:t>
+            </a:r>
+          </a:p>
+        </p:txBody>
+      </p:sp>
+      <p:sp>
+        <p:nvSpPr>
+          <p:cNvPr id="38" name="TextBox 37"/>
+          <p:cNvSpPr txBox="1"/>
+          <p:nvPr/>
+        </p:nvSpPr>
+        <p:spPr>
+          <a:xfrm>
+            <a:off x="2377440" y="5875020"/>
+            <a:ext cx="1463040" cy="155448"/>
+          </a:xfrm>
+          <a:prstGeom prst="rect">
+            <a:avLst/>
+          </a:prstGeom>
+          <a:noFill/>
+        </p:spPr>
+        <p:txBody>
+          <a:bodyPr wrap="square" lIns="0" rIns="0" tIns="0" bIns="0">
+            <a:spAutoFit/>
+          </a:bodyPr>
+          <a:lstStyle/>
+          <a:p>
+            <a:pPr algn="l"/>
+            <a:r>
+              <a:rPr sz="850" b="0" i="0">
+                <a:solidFill>
+                  <a:srgbClr val="333333"/>
+                </a:solidFill>
+                <a:latin typeface="Calibri"/>
+              </a:rPr>
+              <a:t>124 / 175</a:t>
+            </a:r>
+          </a:p>
+        </p:txBody>
+      </p:sp>
+      <p:sp>
+        <p:nvSpPr>
+          <p:cNvPr id="39" name="TextBox 38"/>
+          <p:cNvSpPr txBox="1"/>
+          <p:nvPr/>
+        </p:nvSpPr>
+        <p:spPr>
+          <a:xfrm>
+            <a:off x="4114800" y="5875020"/>
+            <a:ext cx="1463040" cy="155448"/>
+          </a:xfrm>
+          <a:prstGeom prst="rect">
+            <a:avLst/>
+          </a:prstGeom>
+          <a:noFill/>
+        </p:spPr>
+        <p:txBody>
+          <a:bodyPr wrap="square" lIns="0" rIns="0" tIns="0" bIns="0">
+            <a:spAutoFit/>
+          </a:bodyPr>
+          <a:lstStyle/>
+          <a:p>
+            <a:pPr algn="l"/>
+            <a:r>
+              <a:rPr sz="850" b="0" i="0">
+                <a:solidFill>
+                  <a:srgbClr val="333333"/>
+                </a:solidFill>
+                <a:latin typeface="Calibri"/>
+              </a:rPr>
+              <a:t>147 / 179</a:t>
+            </a:r>
+          </a:p>
+        </p:txBody>
+      </p:sp>
+      <p:sp>
+        <p:nvSpPr>
+          <p:cNvPr id="40" name="TextBox 39"/>
+          <p:cNvSpPr txBox="1"/>
+          <p:nvPr/>
+        </p:nvSpPr>
+        <p:spPr>
+          <a:xfrm>
+            <a:off x="5760720" y="5875020"/>
+            <a:ext cx="1463040" cy="155448"/>
+          </a:xfrm>
+          <a:prstGeom prst="rect">
+            <a:avLst/>
+          </a:prstGeom>
+          <a:noFill/>
+        </p:spPr>
+        <p:txBody>
+          <a:bodyPr wrap="square" lIns="0" rIns="0" tIns="0" bIns="0">
+            <a:spAutoFit/>
+          </a:bodyPr>
+          <a:lstStyle/>
+          <a:p>
+            <a:pPr algn="l"/>
+            <a:r>
+              <a:rPr sz="850" b="1" i="0">
+                <a:solidFill>
+                  <a:srgbClr val="333333"/>
+                </a:solidFill>
+                <a:latin typeface="Calibri"/>
+              </a:rPr>
+              <a:t>▼ 23</a:t>
+            </a:r>
+          </a:p>
+        </p:txBody>
+      </p:sp>
+      <p:sp>
+        <p:nvSpPr>
+          <p:cNvPr id="41" name="TextBox 40"/>
+          <p:cNvSpPr txBox="1"/>
+          <p:nvPr/>
+        </p:nvSpPr>
+        <p:spPr>
+          <a:xfrm>
+            <a:off x="7132320" y="5875020"/>
+            <a:ext cx="1463040" cy="155448"/>
+          </a:xfrm>
+          <a:prstGeom prst="rect">
+            <a:avLst/>
+          </a:prstGeom>
+          <a:noFill/>
+        </p:spPr>
+        <p:txBody>
+          <a:bodyPr wrap="square" lIns="0" rIns="0" tIns="0" bIns="0">
+            <a:spAutoFit/>
+          </a:bodyPr>
+          <a:lstStyle/>
+          <a:p>
+            <a:pPr algn="l"/>
+            <a:r>
+              <a:rPr sz="850" b="0" i="0">
+                <a:solidFill>
+                  <a:srgbClr val="333333"/>
+                </a:solidFill>
+                <a:latin typeface="Calibri"/>
+              </a:rPr>
+              <a:t>-0.054</a:t>
+            </a:r>
+          </a:p>
+        </p:txBody>
+      </p:sp>
+      <p:sp>
+        <p:nvSpPr>
+          <p:cNvPr id="42" name="TextBox 41"/>
+          <p:cNvSpPr txBox="1"/>
+          <p:nvPr/>
+        </p:nvSpPr>
+        <p:spPr>
+          <a:xfrm>
+            <a:off x="8686800" y="5875020"/>
+            <a:ext cx="1463040" cy="155448"/>
+          </a:xfrm>
+          <a:prstGeom prst="rect">
+            <a:avLst/>
+          </a:prstGeom>
+          <a:noFill/>
+        </p:spPr>
+        <p:txBody>
+          <a:bodyPr wrap="square" lIns="0" rIns="0" tIns="0" bIns="0">
+            <a:spAutoFit/>
+          </a:bodyPr>
+          <a:lstStyle/>
+          <a:p>
+            <a:pPr algn="l"/>
+            <a:r>
+              <a:rPr sz="850" b="0" i="0">
+                <a:solidFill>
+                  <a:srgbClr val="333333"/>
+                </a:solidFill>
+                <a:latin typeface="Calibri"/>
+              </a:rPr>
+              <a:t>-0.324</a:t>
+            </a:r>
+          </a:p>
+        </p:txBody>
+      </p:sp>
+      <p:sp>
+        <p:nvSpPr>
+          <p:cNvPr id="43" name="TextBox 42"/>
+          <p:cNvSpPr txBox="1"/>
+          <p:nvPr/>
+        </p:nvSpPr>
+        <p:spPr>
+          <a:xfrm>
+            <a:off x="10241280" y="5875020"/>
+            <a:ext cx="1463040" cy="155448"/>
+          </a:xfrm>
+          <a:prstGeom prst="rect">
+            <a:avLst/>
+          </a:prstGeom>
+          <a:noFill/>
+        </p:spPr>
+        <p:txBody>
+          <a:bodyPr wrap="square" lIns="0" rIns="0" tIns="0" bIns="0">
+            <a:spAutoFit/>
+          </a:bodyPr>
+          <a:lstStyle/>
+          <a:p>
+            <a:pPr algn="l"/>
+            <a:r>
+              <a:rPr sz="850" b="0" i="0">
+                <a:solidFill>
+                  <a:srgbClr val="333333"/>
+                </a:solidFill>
+                <a:latin typeface="Calibri"/>
+              </a:rPr>
+              <a:t>-0.270</a:t>
+            </a:r>
+          </a:p>
+        </p:txBody>
+      </p:sp>
+      <p:sp>
+        <p:nvSpPr>
+          <p:cNvPr id="44" name="TextBox 43"/>
+          <p:cNvSpPr txBox="1"/>
+          <p:nvPr/>
+        </p:nvSpPr>
+        <p:spPr>
+          <a:xfrm>
+            <a:off x="457200" y="5989320"/>
+            <a:ext cx="1463040" cy="155448"/>
+          </a:xfrm>
+          <a:prstGeom prst="rect">
+            <a:avLst/>
+          </a:prstGeom>
+          <a:noFill/>
+        </p:spPr>
+        <p:txBody>
+          <a:bodyPr wrap="square" lIns="0" rIns="0" tIns="0" bIns="0">
+            <a:spAutoFit/>
+          </a:bodyPr>
+          <a:lstStyle/>
+          <a:p>
+            <a:pPr algn="l"/>
+            <a:r>
+              <a:rPr sz="850" b="0" i="0">
+                <a:solidFill>
+                  <a:srgbClr val="333333"/>
+                </a:solidFill>
+                <a:latin typeface="Calibri"/>
+              </a:rPr>
+              <a:t>Hispanic</a:t>
+            </a:r>
+          </a:p>
+        </p:txBody>
+      </p:sp>
+      <p:sp>
+        <p:nvSpPr>
+          <p:cNvPr id="45" name="TextBox 44"/>
+          <p:cNvSpPr txBox="1"/>
+          <p:nvPr/>
+        </p:nvSpPr>
+        <p:spPr>
+          <a:xfrm>
+            <a:off x="2377440" y="5989320"/>
+            <a:ext cx="1463040" cy="155448"/>
+          </a:xfrm>
+          <a:prstGeom prst="rect">
+            <a:avLst/>
+          </a:prstGeom>
+          <a:noFill/>
+        </p:spPr>
+        <p:txBody>
+          <a:bodyPr wrap="square" lIns="0" rIns="0" tIns="0" bIns="0">
+            <a:spAutoFit/>
+          </a:bodyPr>
+          <a:lstStyle/>
+          <a:p>
+            <a:pPr algn="l"/>
+            <a:r>
+              <a:rPr sz="850" b="0" i="0">
+                <a:solidFill>
+                  <a:srgbClr val="333333"/>
+                </a:solidFill>
+                <a:latin typeface="Calibri"/>
+              </a:rPr>
+              <a:t>230 / 331</a:t>
+            </a:r>
+          </a:p>
+        </p:txBody>
+      </p:sp>
+      <p:sp>
+        <p:nvSpPr>
+          <p:cNvPr id="46" name="TextBox 45"/>
+          <p:cNvSpPr txBox="1"/>
+          <p:nvPr/>
+        </p:nvSpPr>
+        <p:spPr>
+          <a:xfrm>
+            <a:off x="4114800" y="5989320"/>
+            <a:ext cx="1463040" cy="155448"/>
+          </a:xfrm>
+          <a:prstGeom prst="rect">
+            <a:avLst/>
+          </a:prstGeom>
+          <a:noFill/>
+        </p:spPr>
+        <p:txBody>
+          <a:bodyPr wrap="square" lIns="0" rIns="0" tIns="0" bIns="0">
+            <a:spAutoFit/>
+          </a:bodyPr>
+          <a:lstStyle/>
+          <a:p>
+            <a:pPr algn="l"/>
+            <a:r>
+              <a:rPr sz="850" b="0" i="0">
+                <a:solidFill>
+                  <a:srgbClr val="333333"/>
+                </a:solidFill>
+                <a:latin typeface="Calibri"/>
+              </a:rPr>
+              <a:t>197 / 376</a:t>
+            </a:r>
+          </a:p>
+        </p:txBody>
+      </p:sp>
+      <p:sp>
+        <p:nvSpPr>
+          <p:cNvPr id="47" name="TextBox 46"/>
+          <p:cNvSpPr txBox="1"/>
+          <p:nvPr/>
+        </p:nvSpPr>
+        <p:spPr>
+          <a:xfrm>
+            <a:off x="5760720" y="5989320"/>
+            <a:ext cx="1463040" cy="155448"/>
+          </a:xfrm>
+          <a:prstGeom prst="rect">
+            <a:avLst/>
+          </a:prstGeom>
+          <a:noFill/>
+        </p:spPr>
+        <p:txBody>
+          <a:bodyPr wrap="square" lIns="0" rIns="0" tIns="0" bIns="0">
+            <a:spAutoFit/>
+          </a:bodyPr>
+          <a:lstStyle/>
+          <a:p>
+            <a:pPr algn="l"/>
+            <a:r>
+              <a:rPr sz="850" b="1" i="0">
+                <a:solidFill>
+                  <a:srgbClr val="1F7A3D"/>
+                </a:solidFill>
+                <a:latin typeface="Calibri"/>
+              </a:rPr>
+              <a:t>▲ 33</a:t>
+            </a:r>
+          </a:p>
+        </p:txBody>
+      </p:sp>
+      <p:sp>
+        <p:nvSpPr>
+          <p:cNvPr id="48" name="TextBox 47"/>
+          <p:cNvSpPr txBox="1"/>
+          <p:nvPr/>
+        </p:nvSpPr>
+        <p:spPr>
+          <a:xfrm>
+            <a:off x="7132320" y="5989320"/>
+            <a:ext cx="1463040" cy="155448"/>
+          </a:xfrm>
+          <a:prstGeom prst="rect">
+            <a:avLst/>
+          </a:prstGeom>
+          <a:noFill/>
+        </p:spPr>
+        <p:txBody>
+          <a:bodyPr wrap="square" lIns="0" rIns="0" tIns="0" bIns="0">
+            <a:spAutoFit/>
+          </a:bodyPr>
+          <a:lstStyle/>
+          <a:p>
+            <a:pPr algn="l"/>
+            <a:r>
+              <a:rPr sz="850" b="0" i="0">
+                <a:solidFill>
+                  <a:srgbClr val="333333"/>
+                </a:solidFill>
+                <a:latin typeface="Calibri"/>
+              </a:rPr>
+              <a:t>+0.160</a:t>
+            </a:r>
+          </a:p>
+        </p:txBody>
+      </p:sp>
+      <p:sp>
+        <p:nvSpPr>
+          <p:cNvPr id="49" name="TextBox 48"/>
+          <p:cNvSpPr txBox="1"/>
+          <p:nvPr/>
+        </p:nvSpPr>
+        <p:spPr>
+          <a:xfrm>
+            <a:off x="8686800" y="5989320"/>
+            <a:ext cx="1463040" cy="155448"/>
+          </a:xfrm>
+          <a:prstGeom prst="rect">
+            <a:avLst/>
+          </a:prstGeom>
+          <a:noFill/>
+        </p:spPr>
+        <p:txBody>
+          <a:bodyPr wrap="square" lIns="0" rIns="0" tIns="0" bIns="0">
+            <a:spAutoFit/>
+          </a:bodyPr>
+          <a:lstStyle/>
+          <a:p>
+            <a:pPr algn="l"/>
+            <a:r>
+              <a:rPr sz="850" b="0" i="0">
+                <a:solidFill>
+                  <a:srgbClr val="333333"/>
+                </a:solidFill>
+                <a:latin typeface="Calibri"/>
+              </a:rPr>
+              <a:t>+0.127</a:t>
+            </a:r>
+          </a:p>
+        </p:txBody>
+      </p:sp>
+      <p:sp>
+        <p:nvSpPr>
+          <p:cNvPr id="50" name="TextBox 49"/>
+          <p:cNvSpPr txBox="1"/>
+          <p:nvPr/>
+        </p:nvSpPr>
+        <p:spPr>
+          <a:xfrm>
+            <a:off x="10241280" y="5989320"/>
+            <a:ext cx="1463040" cy="155448"/>
+          </a:xfrm>
+          <a:prstGeom prst="rect">
+            <a:avLst/>
+          </a:prstGeom>
+          <a:noFill/>
+        </p:spPr>
+        <p:txBody>
+          <a:bodyPr wrap="square" lIns="0" rIns="0" tIns="0" bIns="0">
+            <a:spAutoFit/>
+          </a:bodyPr>
+          <a:lstStyle/>
+          <a:p>
+            <a:pPr algn="l"/>
+            <a:r>
+              <a:rPr sz="850" b="0" i="0">
+                <a:solidFill>
+                  <a:srgbClr val="333333"/>
+                </a:solidFill>
+                <a:latin typeface="Calibri"/>
+              </a:rPr>
+              <a:t>-0.033</a:t>
+            </a:r>
+          </a:p>
+        </p:txBody>
+      </p:sp>
+      <p:sp>
+        <p:nvSpPr>
+          <p:cNvPr id="51" name="TextBox 50"/>
+          <p:cNvSpPr txBox="1"/>
+          <p:nvPr/>
+        </p:nvSpPr>
+        <p:spPr>
+          <a:xfrm>
+            <a:off x="457200" y="6103620"/>
+            <a:ext cx="1463040" cy="155448"/>
+          </a:xfrm>
+          <a:prstGeom prst="rect">
+            <a:avLst/>
+          </a:prstGeom>
+          <a:noFill/>
+        </p:spPr>
+        <p:txBody>
+          <a:bodyPr wrap="square" lIns="0" rIns="0" tIns="0" bIns="0">
+            <a:spAutoFit/>
+          </a:bodyPr>
+          <a:lstStyle/>
+          <a:p>
+            <a:pPr algn="l"/>
+            <a:r>
+              <a:rPr sz="850" b="0" i="0">
+                <a:solidFill>
+                  <a:srgbClr val="333333"/>
+                </a:solidFill>
+                <a:latin typeface="Calibri"/>
+              </a:rPr>
+              <a:t>Not Econ Disadv</a:t>
+            </a:r>
+          </a:p>
+        </p:txBody>
+      </p:sp>
+      <p:sp>
+        <p:nvSpPr>
+          <p:cNvPr id="52" name="TextBox 51"/>
+          <p:cNvSpPr txBox="1"/>
+          <p:nvPr/>
+        </p:nvSpPr>
+        <p:spPr>
+          <a:xfrm>
+            <a:off x="2377440" y="6103620"/>
+            <a:ext cx="1463040" cy="155448"/>
+          </a:xfrm>
+          <a:prstGeom prst="rect">
+            <a:avLst/>
+          </a:prstGeom>
+          <a:noFill/>
+        </p:spPr>
+        <p:txBody>
+          <a:bodyPr wrap="square" lIns="0" rIns="0" tIns="0" bIns="0">
+            <a:spAutoFit/>
+          </a:bodyPr>
+          <a:lstStyle/>
+          <a:p>
+            <a:pPr algn="l"/>
+            <a:r>
+              <a:rPr sz="850" b="0" i="0">
+                <a:solidFill>
+                  <a:srgbClr val="333333"/>
+                </a:solidFill>
+                <a:latin typeface="Calibri"/>
+              </a:rPr>
+              <a:t>155 / 503</a:t>
+            </a:r>
+          </a:p>
+        </p:txBody>
+      </p:sp>
+      <p:sp>
+        <p:nvSpPr>
+          <p:cNvPr id="53" name="TextBox 52"/>
+          <p:cNvSpPr txBox="1"/>
+          <p:nvPr/>
+        </p:nvSpPr>
+        <p:spPr>
+          <a:xfrm>
+            <a:off x="4114800" y="6103620"/>
+            <a:ext cx="1463040" cy="155448"/>
+          </a:xfrm>
+          <a:prstGeom prst="rect">
+            <a:avLst/>
+          </a:prstGeom>
+          <a:noFill/>
+        </p:spPr>
+        <p:txBody>
+          <a:bodyPr wrap="square" lIns="0" rIns="0" tIns="0" bIns="0">
+            <a:spAutoFit/>
+          </a:bodyPr>
+          <a:lstStyle/>
+          <a:p>
+            <a:pPr algn="l"/>
+            <a:r>
+              <a:rPr sz="850" b="0" i="0">
+                <a:solidFill>
+                  <a:srgbClr val="333333"/>
+                </a:solidFill>
+                <a:latin typeface="Calibri"/>
+              </a:rPr>
+              <a:t>325 / 495</a:t>
+            </a:r>
+          </a:p>
+        </p:txBody>
+      </p:sp>
+      <p:sp>
+        <p:nvSpPr>
+          <p:cNvPr id="54" name="TextBox 53"/>
+          <p:cNvSpPr txBox="1"/>
+          <p:nvPr/>
+        </p:nvSpPr>
+        <p:spPr>
+          <a:xfrm>
+            <a:off x="5760720" y="6103620"/>
+            <a:ext cx="1463040" cy="155448"/>
+          </a:xfrm>
+          <a:prstGeom prst="rect">
+            <a:avLst/>
+          </a:prstGeom>
+          <a:noFill/>
+        </p:spPr>
+        <p:txBody>
+          <a:bodyPr wrap="square" lIns="0" rIns="0" tIns="0" bIns="0">
+            <a:spAutoFit/>
+          </a:bodyPr>
+          <a:lstStyle/>
+          <a:p>
+            <a:pPr algn="l"/>
+            <a:r>
+              <a:rPr sz="850" b="1" i="0">
+                <a:solidFill>
+                  <a:srgbClr val="B02121"/>
+                </a:solidFill>
+                <a:latin typeface="Calibri"/>
+              </a:rPr>
+              <a:t>▼ 170</a:t>
+            </a:r>
+          </a:p>
+        </p:txBody>
+      </p:sp>
+      <p:sp>
+        <p:nvSpPr>
+          <p:cNvPr id="55" name="TextBox 54"/>
+          <p:cNvSpPr txBox="1"/>
+          <p:nvPr/>
+        </p:nvSpPr>
+        <p:spPr>
+          <a:xfrm>
+            <a:off x="7132320" y="6103620"/>
+            <a:ext cx="1463040" cy="155448"/>
+          </a:xfrm>
+          <a:prstGeom prst="rect">
+            <a:avLst/>
+          </a:prstGeom>
+          <a:noFill/>
+        </p:spPr>
+        <p:txBody>
+          <a:bodyPr wrap="square" lIns="0" rIns="0" tIns="0" bIns="0">
+            <a:spAutoFit/>
+          </a:bodyPr>
+          <a:lstStyle/>
+          <a:p>
+            <a:pPr algn="l"/>
+            <a:r>
+              <a:rPr sz="850" b="0" i="0">
+                <a:solidFill>
+                  <a:srgbClr val="333333"/>
+                </a:solidFill>
+                <a:latin typeface="Calibri"/>
+              </a:rPr>
+              <a:t>+0.846</a:t>
+            </a:r>
+          </a:p>
+        </p:txBody>
+      </p:sp>
+      <p:sp>
+        <p:nvSpPr>
+          <p:cNvPr id="56" name="TextBox 55"/>
+          <p:cNvSpPr txBox="1"/>
+          <p:nvPr/>
+        </p:nvSpPr>
+        <p:spPr>
+          <a:xfrm>
+            <a:off x="8686800" y="6103620"/>
+            <a:ext cx="1463040" cy="155448"/>
+          </a:xfrm>
+          <a:prstGeom prst="rect">
+            <a:avLst/>
+          </a:prstGeom>
+          <a:noFill/>
+        </p:spPr>
+        <p:txBody>
+          <a:bodyPr wrap="square" lIns="0" rIns="0" tIns="0" bIns="0">
+            <a:spAutoFit/>
+          </a:bodyPr>
+          <a:lstStyle/>
+          <a:p>
+            <a:pPr algn="l"/>
+            <a:r>
+              <a:rPr sz="850" b="0" i="0">
+                <a:solidFill>
+                  <a:srgbClr val="333333"/>
+                </a:solidFill>
+                <a:latin typeface="Calibri"/>
+              </a:rPr>
+              <a:t>+0.595</a:t>
+            </a:r>
+          </a:p>
+        </p:txBody>
+      </p:sp>
+      <p:sp>
+        <p:nvSpPr>
+          <p:cNvPr id="57" name="TextBox 56"/>
+          <p:cNvSpPr txBox="1"/>
+          <p:nvPr/>
+        </p:nvSpPr>
+        <p:spPr>
+          <a:xfrm>
+            <a:off x="10241280" y="6103620"/>
+            <a:ext cx="1463040" cy="155448"/>
+          </a:xfrm>
+          <a:prstGeom prst="rect">
+            <a:avLst/>
+          </a:prstGeom>
+          <a:noFill/>
+        </p:spPr>
+        <p:txBody>
+          <a:bodyPr wrap="square" lIns="0" rIns="0" tIns="0" bIns="0">
+            <a:spAutoFit/>
+          </a:bodyPr>
+          <a:lstStyle/>
+          <a:p>
+            <a:pPr algn="l"/>
+            <a:r>
+              <a:rPr sz="850" b="0" i="0">
+                <a:solidFill>
+                  <a:srgbClr val="333333"/>
+                </a:solidFill>
+                <a:latin typeface="Calibri"/>
+              </a:rPr>
+              <a:t>-0.251</a:t>
+            </a:r>
+          </a:p>
+        </p:txBody>
+      </p:sp>
+      <p:sp>
+        <p:nvSpPr>
+          <p:cNvPr id="58" name="TextBox 57"/>
+          <p:cNvSpPr txBox="1"/>
+          <p:nvPr/>
+        </p:nvSpPr>
+        <p:spPr>
+          <a:xfrm>
             <a:off x="457200" y="6217920"/>
-            <a:ext cx="1463040" cy="182880"/>
+            <a:ext cx="1463040" cy="155448"/>
           </a:xfrm>
           <a:prstGeom prst="rect">
             <a:avLst/>
@@ -20287,21 +21022,21 @@
                 </a:solidFill>
                 <a:latin typeface="Calibri"/>
               </a:rPr>
-              <a:t>Black</a:t>
-            </a:r>
-          </a:p>
-        </p:txBody>
-      </p:sp>
-      <p:sp>
-        <p:nvSpPr>
-          <p:cNvPr id="38" name="TextBox 37"/>
+              <a:t>Econ Disadv</a:t>
+            </a:r>
+          </a:p>
+        </p:txBody>
+      </p:sp>
+      <p:sp>
+        <p:nvSpPr>
+          <p:cNvPr id="59" name="TextBox 58"/>
           <p:cNvSpPr txBox="1"/>
           <p:nvPr/>
         </p:nvSpPr>
         <p:spPr>
           <a:xfrm>
             <a:off x="2377440" y="6217920"/>
-            <a:ext cx="1463040" cy="182880"/>
+            <a:ext cx="1463040" cy="155448"/>
           </a:xfrm>
           <a:prstGeom prst="rect">
             <a:avLst/>
@@ -20322,21 +21057,21 @@
                 </a:solidFill>
                 <a:latin typeface="Calibri"/>
               </a:rPr>
-              <a:t>124 / 175</a:t>
-            </a:r>
-          </a:p>
-        </p:txBody>
-      </p:sp>
-      <p:sp>
-        <p:nvSpPr>
-          <p:cNvPr id="39" name="TextBox 38"/>
+              <a:t>313 / 449</a:t>
+            </a:r>
+          </a:p>
+        </p:txBody>
+      </p:sp>
+      <p:sp>
+        <p:nvSpPr>
+          <p:cNvPr id="60" name="TextBox 59"/>
           <p:cNvSpPr txBox="1"/>
           <p:nvPr/>
         </p:nvSpPr>
         <p:spPr>
           <a:xfrm>
             <a:off x="4114800" y="6217920"/>
-            <a:ext cx="1463040" cy="182880"/>
+            <a:ext cx="1463040" cy="155448"/>
           </a:xfrm>
           <a:prstGeom prst="rect">
             <a:avLst/>
@@ -20357,21 +21092,21 @@
                 </a:solidFill>
                 <a:latin typeface="Calibri"/>
               </a:rPr>
-              <a:t>147 / 179</a:t>
-            </a:r>
-          </a:p>
-        </p:txBody>
-      </p:sp>
-      <p:sp>
-        <p:nvSpPr>
-          <p:cNvPr id="40" name="TextBox 39"/>
+              <a:t>318 / 461</a:t>
+            </a:r>
+          </a:p>
+        </p:txBody>
+      </p:sp>
+      <p:sp>
+        <p:nvSpPr>
+          <p:cNvPr id="61" name="TextBox 60"/>
           <p:cNvSpPr txBox="1"/>
           <p:nvPr/>
         </p:nvSpPr>
         <p:spPr>
           <a:xfrm>
             <a:off x="5760720" y="6217920"/>
-            <a:ext cx="1463040" cy="182880"/>
+            <a:ext cx="1463040" cy="155448"/>
           </a:xfrm>
           <a:prstGeom prst="rect">
             <a:avLst/>
@@ -20392,21 +21127,21 @@
                 </a:solidFill>
                 <a:latin typeface="Calibri"/>
               </a:rPr>
-              <a:t>▼ 23</a:t>
-            </a:r>
-          </a:p>
-        </p:txBody>
-      </p:sp>
-      <p:sp>
-        <p:nvSpPr>
-          <p:cNvPr id="41" name="TextBox 40"/>
+              <a:t>▼ 5</a:t>
+            </a:r>
+          </a:p>
+        </p:txBody>
+      </p:sp>
+      <p:sp>
+        <p:nvSpPr>
+          <p:cNvPr id="62" name="TextBox 61"/>
           <p:cNvSpPr txBox="1"/>
           <p:nvPr/>
         </p:nvSpPr>
         <p:spPr>
           <a:xfrm>
             <a:off x="7132320" y="6217920"/>
-            <a:ext cx="1463040" cy="182880"/>
+            <a:ext cx="1463040" cy="155448"/>
           </a:xfrm>
           <a:prstGeom prst="rect">
             <a:avLst/>
@@ -20427,21 +21162,21 @@
                 </a:solidFill>
                 <a:latin typeface="Calibri"/>
               </a:rPr>
-              <a:t>-0.054</a:t>
-            </a:r>
-          </a:p>
-        </p:txBody>
-      </p:sp>
-      <p:sp>
-        <p:nvSpPr>
-          <p:cNvPr id="42" name="TextBox 41"/>
+              <a:t>+0.012</a:t>
+            </a:r>
+          </a:p>
+        </p:txBody>
+      </p:sp>
+      <p:sp>
+        <p:nvSpPr>
+          <p:cNvPr id="63" name="TextBox 62"/>
           <p:cNvSpPr txBox="1"/>
           <p:nvPr/>
         </p:nvSpPr>
         <p:spPr>
           <a:xfrm>
             <a:off x="8686800" y="6217920"/>
-            <a:ext cx="1463040" cy="182880"/>
+            <a:ext cx="1463040" cy="155448"/>
           </a:xfrm>
           <a:prstGeom prst="rect">
             <a:avLst/>
@@ -20462,756 +21197,21 @@
                 </a:solidFill>
                 <a:latin typeface="Calibri"/>
               </a:rPr>
-              <a:t>-0.324</a:t>
-            </a:r>
-          </a:p>
-        </p:txBody>
-      </p:sp>
-      <p:sp>
-        <p:nvSpPr>
-          <p:cNvPr id="43" name="TextBox 42"/>
+              <a:t>-0.133</a:t>
+            </a:r>
+          </a:p>
+        </p:txBody>
+      </p:sp>
+      <p:sp>
+        <p:nvSpPr>
+          <p:cNvPr id="64" name="TextBox 63"/>
           <p:cNvSpPr txBox="1"/>
           <p:nvPr/>
         </p:nvSpPr>
         <p:spPr>
           <a:xfrm>
             <a:off x="10241280" y="6217920"/>
-            <a:ext cx="1463040" cy="182880"/>
-          </a:xfrm>
-          <a:prstGeom prst="rect">
-            <a:avLst/>
-          </a:prstGeom>
-          <a:noFill/>
-        </p:spPr>
-        <p:txBody>
-          <a:bodyPr wrap="square" lIns="0" rIns="0" tIns="0" bIns="0">
-            <a:spAutoFit/>
-          </a:bodyPr>
-          <a:lstStyle/>
-          <a:p>
-            <a:pPr algn="l"/>
-            <a:r>
-              <a:rPr sz="850" b="0" i="0">
-                <a:solidFill>
-                  <a:srgbClr val="333333"/>
-                </a:solidFill>
-                <a:latin typeface="Calibri"/>
-              </a:rPr>
-              <a:t>-0.270</a:t>
-            </a:r>
-          </a:p>
-        </p:txBody>
-      </p:sp>
-      <p:sp>
-        <p:nvSpPr>
-          <p:cNvPr id="44" name="TextBox 43"/>
-          <p:cNvSpPr txBox="1"/>
-          <p:nvPr/>
-        </p:nvSpPr>
-        <p:spPr>
-          <a:xfrm>
-            <a:off x="457200" y="6400800"/>
-            <a:ext cx="1463040" cy="182880"/>
-          </a:xfrm>
-          <a:prstGeom prst="rect">
-            <a:avLst/>
-          </a:prstGeom>
-          <a:noFill/>
-        </p:spPr>
-        <p:txBody>
-          <a:bodyPr wrap="square" lIns="0" rIns="0" tIns="0" bIns="0">
-            <a:spAutoFit/>
-          </a:bodyPr>
-          <a:lstStyle/>
-          <a:p>
-            <a:pPr algn="l"/>
-            <a:r>
-              <a:rPr sz="850" b="0" i="0">
-                <a:solidFill>
-                  <a:srgbClr val="333333"/>
-                </a:solidFill>
-                <a:latin typeface="Calibri"/>
-              </a:rPr>
-              <a:t>Hispanic</a:t>
-            </a:r>
-          </a:p>
-        </p:txBody>
-      </p:sp>
-      <p:sp>
-        <p:nvSpPr>
-          <p:cNvPr id="45" name="TextBox 44"/>
-          <p:cNvSpPr txBox="1"/>
-          <p:nvPr/>
-        </p:nvSpPr>
-        <p:spPr>
-          <a:xfrm>
-            <a:off x="2377440" y="6400800"/>
-            <a:ext cx="1463040" cy="182880"/>
-          </a:xfrm>
-          <a:prstGeom prst="rect">
-            <a:avLst/>
-          </a:prstGeom>
-          <a:noFill/>
-        </p:spPr>
-        <p:txBody>
-          <a:bodyPr wrap="square" lIns="0" rIns="0" tIns="0" bIns="0">
-            <a:spAutoFit/>
-          </a:bodyPr>
-          <a:lstStyle/>
-          <a:p>
-            <a:pPr algn="l"/>
-            <a:r>
-              <a:rPr sz="850" b="0" i="0">
-                <a:solidFill>
-                  <a:srgbClr val="333333"/>
-                </a:solidFill>
-                <a:latin typeface="Calibri"/>
-              </a:rPr>
-              <a:t>230 / 331</a:t>
-            </a:r>
-          </a:p>
-        </p:txBody>
-      </p:sp>
-      <p:sp>
-        <p:nvSpPr>
-          <p:cNvPr id="46" name="TextBox 45"/>
-          <p:cNvSpPr txBox="1"/>
-          <p:nvPr/>
-        </p:nvSpPr>
-        <p:spPr>
-          <a:xfrm>
-            <a:off x="4114800" y="6400800"/>
-            <a:ext cx="1463040" cy="182880"/>
-          </a:xfrm>
-          <a:prstGeom prst="rect">
-            <a:avLst/>
-          </a:prstGeom>
-          <a:noFill/>
-        </p:spPr>
-        <p:txBody>
-          <a:bodyPr wrap="square" lIns="0" rIns="0" tIns="0" bIns="0">
-            <a:spAutoFit/>
-          </a:bodyPr>
-          <a:lstStyle/>
-          <a:p>
-            <a:pPr algn="l"/>
-            <a:r>
-              <a:rPr sz="850" b="0" i="0">
-                <a:solidFill>
-                  <a:srgbClr val="333333"/>
-                </a:solidFill>
-                <a:latin typeface="Calibri"/>
-              </a:rPr>
-              <a:t>197 / 376</a:t>
-            </a:r>
-          </a:p>
-        </p:txBody>
-      </p:sp>
-      <p:sp>
-        <p:nvSpPr>
-          <p:cNvPr id="47" name="TextBox 46"/>
-          <p:cNvSpPr txBox="1"/>
-          <p:nvPr/>
-        </p:nvSpPr>
-        <p:spPr>
-          <a:xfrm>
-            <a:off x="5760720" y="6400800"/>
-            <a:ext cx="1463040" cy="182880"/>
-          </a:xfrm>
-          <a:prstGeom prst="rect">
-            <a:avLst/>
-          </a:prstGeom>
-          <a:noFill/>
-        </p:spPr>
-        <p:txBody>
-          <a:bodyPr wrap="square" lIns="0" rIns="0" tIns="0" bIns="0">
-            <a:spAutoFit/>
-          </a:bodyPr>
-          <a:lstStyle/>
-          <a:p>
-            <a:pPr algn="l"/>
-            <a:r>
-              <a:rPr sz="850" b="1" i="0">
-                <a:solidFill>
-                  <a:srgbClr val="1F7A3D"/>
-                </a:solidFill>
-                <a:latin typeface="Calibri"/>
-              </a:rPr>
-              <a:t>▲ 33</a:t>
-            </a:r>
-          </a:p>
-        </p:txBody>
-      </p:sp>
-      <p:sp>
-        <p:nvSpPr>
-          <p:cNvPr id="48" name="TextBox 47"/>
-          <p:cNvSpPr txBox="1"/>
-          <p:nvPr/>
-        </p:nvSpPr>
-        <p:spPr>
-          <a:xfrm>
-            <a:off x="7132320" y="6400800"/>
-            <a:ext cx="1463040" cy="182880"/>
-          </a:xfrm>
-          <a:prstGeom prst="rect">
-            <a:avLst/>
-          </a:prstGeom>
-          <a:noFill/>
-        </p:spPr>
-        <p:txBody>
-          <a:bodyPr wrap="square" lIns="0" rIns="0" tIns="0" bIns="0">
-            <a:spAutoFit/>
-          </a:bodyPr>
-          <a:lstStyle/>
-          <a:p>
-            <a:pPr algn="l"/>
-            <a:r>
-              <a:rPr sz="850" b="0" i="0">
-                <a:solidFill>
-                  <a:srgbClr val="333333"/>
-                </a:solidFill>
-                <a:latin typeface="Calibri"/>
-              </a:rPr>
-              <a:t>+0.160</a:t>
-            </a:r>
-          </a:p>
-        </p:txBody>
-      </p:sp>
-      <p:sp>
-        <p:nvSpPr>
-          <p:cNvPr id="49" name="TextBox 48"/>
-          <p:cNvSpPr txBox="1"/>
-          <p:nvPr/>
-        </p:nvSpPr>
-        <p:spPr>
-          <a:xfrm>
-            <a:off x="8686800" y="6400800"/>
-            <a:ext cx="1463040" cy="182880"/>
-          </a:xfrm>
-          <a:prstGeom prst="rect">
-            <a:avLst/>
-          </a:prstGeom>
-          <a:noFill/>
-        </p:spPr>
-        <p:txBody>
-          <a:bodyPr wrap="square" lIns="0" rIns="0" tIns="0" bIns="0">
-            <a:spAutoFit/>
-          </a:bodyPr>
-          <a:lstStyle/>
-          <a:p>
-            <a:pPr algn="l"/>
-            <a:r>
-              <a:rPr sz="850" b="0" i="0">
-                <a:solidFill>
-                  <a:srgbClr val="333333"/>
-                </a:solidFill>
-                <a:latin typeface="Calibri"/>
-              </a:rPr>
-              <a:t>+0.127</a:t>
-            </a:r>
-          </a:p>
-        </p:txBody>
-      </p:sp>
-      <p:sp>
-        <p:nvSpPr>
-          <p:cNvPr id="50" name="TextBox 49"/>
-          <p:cNvSpPr txBox="1"/>
-          <p:nvPr/>
-        </p:nvSpPr>
-        <p:spPr>
-          <a:xfrm>
-            <a:off x="10241280" y="6400800"/>
-            <a:ext cx="1463040" cy="182880"/>
-          </a:xfrm>
-          <a:prstGeom prst="rect">
-            <a:avLst/>
-          </a:prstGeom>
-          <a:noFill/>
-        </p:spPr>
-        <p:txBody>
-          <a:bodyPr wrap="square" lIns="0" rIns="0" tIns="0" bIns="0">
-            <a:spAutoFit/>
-          </a:bodyPr>
-          <a:lstStyle/>
-          <a:p>
-            <a:pPr algn="l"/>
-            <a:r>
-              <a:rPr sz="850" b="0" i="0">
-                <a:solidFill>
-                  <a:srgbClr val="333333"/>
-                </a:solidFill>
-                <a:latin typeface="Calibri"/>
-              </a:rPr>
-              <a:t>-0.033</a:t>
-            </a:r>
-          </a:p>
-        </p:txBody>
-      </p:sp>
-      <p:sp>
-        <p:nvSpPr>
-          <p:cNvPr id="51" name="TextBox 50"/>
-          <p:cNvSpPr txBox="1"/>
-          <p:nvPr/>
-        </p:nvSpPr>
-        <p:spPr>
-          <a:xfrm>
-            <a:off x="457200" y="6583680"/>
-            <a:ext cx="1463040" cy="182880"/>
-          </a:xfrm>
-          <a:prstGeom prst="rect">
-            <a:avLst/>
-          </a:prstGeom>
-          <a:noFill/>
-        </p:spPr>
-        <p:txBody>
-          <a:bodyPr wrap="square" lIns="0" rIns="0" tIns="0" bIns="0">
-            <a:spAutoFit/>
-          </a:bodyPr>
-          <a:lstStyle/>
-          <a:p>
-            <a:pPr algn="l"/>
-            <a:r>
-              <a:rPr sz="850" b="0" i="0">
-                <a:solidFill>
-                  <a:srgbClr val="333333"/>
-                </a:solidFill>
-                <a:latin typeface="Calibri"/>
-              </a:rPr>
-              <a:t>Not Econ Disadv</a:t>
-            </a:r>
-          </a:p>
-        </p:txBody>
-      </p:sp>
-      <p:sp>
-        <p:nvSpPr>
-          <p:cNvPr id="52" name="TextBox 51"/>
-          <p:cNvSpPr txBox="1"/>
-          <p:nvPr/>
-        </p:nvSpPr>
-        <p:spPr>
-          <a:xfrm>
-            <a:off x="2377440" y="6583680"/>
-            <a:ext cx="1463040" cy="182880"/>
-          </a:xfrm>
-          <a:prstGeom prst="rect">
-            <a:avLst/>
-          </a:prstGeom>
-          <a:noFill/>
-        </p:spPr>
-        <p:txBody>
-          <a:bodyPr wrap="square" lIns="0" rIns="0" tIns="0" bIns="0">
-            <a:spAutoFit/>
-          </a:bodyPr>
-          <a:lstStyle/>
-          <a:p>
-            <a:pPr algn="l"/>
-            <a:r>
-              <a:rPr sz="850" b="0" i="0">
-                <a:solidFill>
-                  <a:srgbClr val="333333"/>
-                </a:solidFill>
-                <a:latin typeface="Calibri"/>
-              </a:rPr>
-              <a:t>155 / 503</a:t>
-            </a:r>
-          </a:p>
-        </p:txBody>
-      </p:sp>
-      <p:sp>
-        <p:nvSpPr>
-          <p:cNvPr id="53" name="TextBox 52"/>
-          <p:cNvSpPr txBox="1"/>
-          <p:nvPr/>
-        </p:nvSpPr>
-        <p:spPr>
-          <a:xfrm>
-            <a:off x="4114800" y="6583680"/>
-            <a:ext cx="1463040" cy="182880"/>
-          </a:xfrm>
-          <a:prstGeom prst="rect">
-            <a:avLst/>
-          </a:prstGeom>
-          <a:noFill/>
-        </p:spPr>
-        <p:txBody>
-          <a:bodyPr wrap="square" lIns="0" rIns="0" tIns="0" bIns="0">
-            <a:spAutoFit/>
-          </a:bodyPr>
-          <a:lstStyle/>
-          <a:p>
-            <a:pPr algn="l"/>
-            <a:r>
-              <a:rPr sz="850" b="0" i="0">
-                <a:solidFill>
-                  <a:srgbClr val="333333"/>
-                </a:solidFill>
-                <a:latin typeface="Calibri"/>
-              </a:rPr>
-              <a:t>325 / 495</a:t>
-            </a:r>
-          </a:p>
-        </p:txBody>
-      </p:sp>
-      <p:sp>
-        <p:nvSpPr>
-          <p:cNvPr id="54" name="TextBox 53"/>
-          <p:cNvSpPr txBox="1"/>
-          <p:nvPr/>
-        </p:nvSpPr>
-        <p:spPr>
-          <a:xfrm>
-            <a:off x="5760720" y="6583680"/>
-            <a:ext cx="1463040" cy="182880"/>
-          </a:xfrm>
-          <a:prstGeom prst="rect">
-            <a:avLst/>
-          </a:prstGeom>
-          <a:noFill/>
-        </p:spPr>
-        <p:txBody>
-          <a:bodyPr wrap="square" lIns="0" rIns="0" tIns="0" bIns="0">
-            <a:spAutoFit/>
-          </a:bodyPr>
-          <a:lstStyle/>
-          <a:p>
-            <a:pPr algn="l"/>
-            <a:r>
-              <a:rPr sz="850" b="1" i="0">
-                <a:solidFill>
-                  <a:srgbClr val="B02121"/>
-                </a:solidFill>
-                <a:latin typeface="Calibri"/>
-              </a:rPr>
-              <a:t>▼ 170</a:t>
-            </a:r>
-          </a:p>
-        </p:txBody>
-      </p:sp>
-      <p:sp>
-        <p:nvSpPr>
-          <p:cNvPr id="55" name="TextBox 54"/>
-          <p:cNvSpPr txBox="1"/>
-          <p:nvPr/>
-        </p:nvSpPr>
-        <p:spPr>
-          <a:xfrm>
-            <a:off x="7132320" y="6583680"/>
-            <a:ext cx="1463040" cy="182880"/>
-          </a:xfrm>
-          <a:prstGeom prst="rect">
-            <a:avLst/>
-          </a:prstGeom>
-          <a:noFill/>
-        </p:spPr>
-        <p:txBody>
-          <a:bodyPr wrap="square" lIns="0" rIns="0" tIns="0" bIns="0">
-            <a:spAutoFit/>
-          </a:bodyPr>
-          <a:lstStyle/>
-          <a:p>
-            <a:pPr algn="l"/>
-            <a:r>
-              <a:rPr sz="850" b="0" i="0">
-                <a:solidFill>
-                  <a:srgbClr val="333333"/>
-                </a:solidFill>
-                <a:latin typeface="Calibri"/>
-              </a:rPr>
-              <a:t>+0.846</a:t>
-            </a:r>
-          </a:p>
-        </p:txBody>
-      </p:sp>
-      <p:sp>
-        <p:nvSpPr>
-          <p:cNvPr id="56" name="TextBox 55"/>
-          <p:cNvSpPr txBox="1"/>
-          <p:nvPr/>
-        </p:nvSpPr>
-        <p:spPr>
-          <a:xfrm>
-            <a:off x="8686800" y="6583680"/>
-            <a:ext cx="1463040" cy="182880"/>
-          </a:xfrm>
-          <a:prstGeom prst="rect">
-            <a:avLst/>
-          </a:prstGeom>
-          <a:noFill/>
-        </p:spPr>
-        <p:txBody>
-          <a:bodyPr wrap="square" lIns="0" rIns="0" tIns="0" bIns="0">
-            <a:spAutoFit/>
-          </a:bodyPr>
-          <a:lstStyle/>
-          <a:p>
-            <a:pPr algn="l"/>
-            <a:r>
-              <a:rPr sz="850" b="0" i="0">
-                <a:solidFill>
-                  <a:srgbClr val="333333"/>
-                </a:solidFill>
-                <a:latin typeface="Calibri"/>
-              </a:rPr>
-              <a:t>+0.595</a:t>
-            </a:r>
-          </a:p>
-        </p:txBody>
-      </p:sp>
-      <p:sp>
-        <p:nvSpPr>
-          <p:cNvPr id="57" name="TextBox 56"/>
-          <p:cNvSpPr txBox="1"/>
-          <p:nvPr/>
-        </p:nvSpPr>
-        <p:spPr>
-          <a:xfrm>
-            <a:off x="10241280" y="6583680"/>
-            <a:ext cx="1463040" cy="182880"/>
-          </a:xfrm>
-          <a:prstGeom prst="rect">
-            <a:avLst/>
-          </a:prstGeom>
-          <a:noFill/>
-        </p:spPr>
-        <p:txBody>
-          <a:bodyPr wrap="square" lIns="0" rIns="0" tIns="0" bIns="0">
-            <a:spAutoFit/>
-          </a:bodyPr>
-          <a:lstStyle/>
-          <a:p>
-            <a:pPr algn="l"/>
-            <a:r>
-              <a:rPr sz="850" b="0" i="0">
-                <a:solidFill>
-                  <a:srgbClr val="333333"/>
-                </a:solidFill>
-                <a:latin typeface="Calibri"/>
-              </a:rPr>
-              <a:t>-0.251</a:t>
-            </a:r>
-          </a:p>
-        </p:txBody>
-      </p:sp>
-      <p:sp>
-        <p:nvSpPr>
-          <p:cNvPr id="58" name="TextBox 57"/>
-          <p:cNvSpPr txBox="1"/>
-          <p:nvPr/>
-        </p:nvSpPr>
-        <p:spPr>
-          <a:xfrm>
-            <a:off x="457200" y="6766560"/>
-            <a:ext cx="1463040" cy="182880"/>
-          </a:xfrm>
-          <a:prstGeom prst="rect">
-            <a:avLst/>
-          </a:prstGeom>
-          <a:noFill/>
-        </p:spPr>
-        <p:txBody>
-          <a:bodyPr wrap="square" lIns="0" rIns="0" tIns="0" bIns="0">
-            <a:spAutoFit/>
-          </a:bodyPr>
-          <a:lstStyle/>
-          <a:p>
-            <a:pPr algn="l"/>
-            <a:r>
-              <a:rPr sz="850" b="0" i="0">
-                <a:solidFill>
-                  <a:srgbClr val="333333"/>
-                </a:solidFill>
-                <a:latin typeface="Calibri"/>
-              </a:rPr>
-              <a:t>Econ Disadv</a:t>
-            </a:r>
-          </a:p>
-        </p:txBody>
-      </p:sp>
-      <p:sp>
-        <p:nvSpPr>
-          <p:cNvPr id="59" name="TextBox 58"/>
-          <p:cNvSpPr txBox="1"/>
-          <p:nvPr/>
-        </p:nvSpPr>
-        <p:spPr>
-          <a:xfrm>
-            <a:off x="2377440" y="6766560"/>
-            <a:ext cx="1463040" cy="182880"/>
-          </a:xfrm>
-          <a:prstGeom prst="rect">
-            <a:avLst/>
-          </a:prstGeom>
-          <a:noFill/>
-        </p:spPr>
-        <p:txBody>
-          <a:bodyPr wrap="square" lIns="0" rIns="0" tIns="0" bIns="0">
-            <a:spAutoFit/>
-          </a:bodyPr>
-          <a:lstStyle/>
-          <a:p>
-            <a:pPr algn="l"/>
-            <a:r>
-              <a:rPr sz="850" b="0" i="0">
-                <a:solidFill>
-                  <a:srgbClr val="333333"/>
-                </a:solidFill>
-                <a:latin typeface="Calibri"/>
-              </a:rPr>
-              <a:t>313 / 449</a:t>
-            </a:r>
-          </a:p>
-        </p:txBody>
-      </p:sp>
-      <p:sp>
-        <p:nvSpPr>
-          <p:cNvPr id="60" name="TextBox 59"/>
-          <p:cNvSpPr txBox="1"/>
-          <p:nvPr/>
-        </p:nvSpPr>
-        <p:spPr>
-          <a:xfrm>
-            <a:off x="4114800" y="6766560"/>
-            <a:ext cx="1463040" cy="182880"/>
-          </a:xfrm>
-          <a:prstGeom prst="rect">
-            <a:avLst/>
-          </a:prstGeom>
-          <a:noFill/>
-        </p:spPr>
-        <p:txBody>
-          <a:bodyPr wrap="square" lIns="0" rIns="0" tIns="0" bIns="0">
-            <a:spAutoFit/>
-          </a:bodyPr>
-          <a:lstStyle/>
-          <a:p>
-            <a:pPr algn="l"/>
-            <a:r>
-              <a:rPr sz="850" b="0" i="0">
-                <a:solidFill>
-                  <a:srgbClr val="333333"/>
-                </a:solidFill>
-                <a:latin typeface="Calibri"/>
-              </a:rPr>
-              <a:t>318 / 461</a:t>
-            </a:r>
-          </a:p>
-        </p:txBody>
-      </p:sp>
-      <p:sp>
-        <p:nvSpPr>
-          <p:cNvPr id="61" name="TextBox 60"/>
-          <p:cNvSpPr txBox="1"/>
-          <p:nvPr/>
-        </p:nvSpPr>
-        <p:spPr>
-          <a:xfrm>
-            <a:off x="5760720" y="6766560"/>
-            <a:ext cx="1463040" cy="182880"/>
-          </a:xfrm>
-          <a:prstGeom prst="rect">
-            <a:avLst/>
-          </a:prstGeom>
-          <a:noFill/>
-        </p:spPr>
-        <p:txBody>
-          <a:bodyPr wrap="square" lIns="0" rIns="0" tIns="0" bIns="0">
-            <a:spAutoFit/>
-          </a:bodyPr>
-          <a:lstStyle/>
-          <a:p>
-            <a:pPr algn="l"/>
-            <a:r>
-              <a:rPr sz="850" b="1" i="0">
-                <a:solidFill>
-                  <a:srgbClr val="333333"/>
-                </a:solidFill>
-                <a:latin typeface="Calibri"/>
-              </a:rPr>
-              <a:t>▼ 5</a:t>
-            </a:r>
-          </a:p>
-        </p:txBody>
-      </p:sp>
-      <p:sp>
-        <p:nvSpPr>
-          <p:cNvPr id="62" name="TextBox 61"/>
-          <p:cNvSpPr txBox="1"/>
-          <p:nvPr/>
-        </p:nvSpPr>
-        <p:spPr>
-          <a:xfrm>
-            <a:off x="7132320" y="6766560"/>
-            <a:ext cx="1463040" cy="182880"/>
-          </a:xfrm>
-          <a:prstGeom prst="rect">
-            <a:avLst/>
-          </a:prstGeom>
-          <a:noFill/>
-        </p:spPr>
-        <p:txBody>
-          <a:bodyPr wrap="square" lIns="0" rIns="0" tIns="0" bIns="0">
-            <a:spAutoFit/>
-          </a:bodyPr>
-          <a:lstStyle/>
-          <a:p>
-            <a:pPr algn="l"/>
-            <a:r>
-              <a:rPr sz="850" b="0" i="0">
-                <a:solidFill>
-                  <a:srgbClr val="333333"/>
-                </a:solidFill>
-                <a:latin typeface="Calibri"/>
-              </a:rPr>
-              <a:t>+0.012</a:t>
-            </a:r>
-          </a:p>
-        </p:txBody>
-      </p:sp>
-      <p:sp>
-        <p:nvSpPr>
-          <p:cNvPr id="63" name="TextBox 62"/>
-          <p:cNvSpPr txBox="1"/>
-          <p:nvPr/>
-        </p:nvSpPr>
-        <p:spPr>
-          <a:xfrm>
-            <a:off x="8686800" y="6766560"/>
-            <a:ext cx="1463040" cy="182880"/>
-          </a:xfrm>
-          <a:prstGeom prst="rect">
-            <a:avLst/>
-          </a:prstGeom>
-          <a:noFill/>
-        </p:spPr>
-        <p:txBody>
-          <a:bodyPr wrap="square" lIns="0" rIns="0" tIns="0" bIns="0">
-            <a:spAutoFit/>
-          </a:bodyPr>
-          <a:lstStyle/>
-          <a:p>
-            <a:pPr algn="l"/>
-            <a:r>
-              <a:rPr sz="850" b="0" i="0">
-                <a:solidFill>
-                  <a:srgbClr val="333333"/>
-                </a:solidFill>
-                <a:latin typeface="Calibri"/>
-              </a:rPr>
-              <a:t>-0.133</a:t>
-            </a:r>
-          </a:p>
-        </p:txBody>
-      </p:sp>
-      <p:sp>
-        <p:nvSpPr>
-          <p:cNvPr id="64" name="TextBox 63"/>
-          <p:cNvSpPr txBox="1"/>
-          <p:nvPr/>
-        </p:nvSpPr>
-        <p:spPr>
-          <a:xfrm>
-            <a:off x="10241280" y="6766560"/>
-            <a:ext cx="1463040" cy="182880"/>
+            <a:ext cx="1463040" cy="155448"/>
           </a:xfrm>
           <a:prstGeom prst="rect">
             <a:avLst/>

</xml_diff>

<commit_message>
Optimize font sizes and reduce whitespace across 7 slides
Slide 7 (DOTR): summary box text 9→10pt
Slide 12 (Not-ECD): "Why this matters" body 10→11.5pt
Slide 22 (Methodology): right column district list 10.5→11.5pt,
  counts text 9.5→10.5pt
Slide 26 (Refs 2): row spacing 0.8→0.95", title 13→14pt, body
  10.5→12pt, number badges 14→16pt — fills unused right-side space
Slide 28 (Refs 4): URL body text 8.5→9.5pt
Slide 29 (File map): file names and descriptions 8.5→9.5pt,
  row height 0.26→0.29"

Co-Authored-By: Claude Opus 4.6 <noreply@anthropic.com>
</commit_message>
<xml_diff>
--- a/analysis/Troy_K5_ELA_Executive_Summary.pptx
+++ b/analysis/Troy_K5_ELA_Executive_Summary.pptx
@@ -5302,7 +5302,7 @@
           <a:p>
             <a:pPr algn="l"/>
             <a:r>
-              <a:rPr sz="1000" b="0" i="0">
+              <a:rPr sz="1150" b="0" i="0">
                 <a:solidFill>
                   <a:srgbClr val="333333"/>
                 </a:solidFill>
@@ -17365,7 +17365,7 @@
           <a:p>
             <a:pPr algn="l"/>
             <a:r>
-              <a:rPr sz="1050" b="0" i="0">
+              <a:rPr sz="1150" b="0" i="0">
                 <a:solidFill>
                   <a:srgbClr val="333333"/>
                 </a:solidFill>
@@ -17377,7 +17377,7 @@
           <a:p>
             <a:pPr algn="l"/>
             <a:r>
-              <a:rPr sz="1050" b="0" i="0">
+              <a:rPr sz="1150" b="0" i="0">
                 <a:solidFill>
                   <a:srgbClr val="333333"/>
                 </a:solidFill>
@@ -17389,7 +17389,7 @@
           <a:p>
             <a:pPr algn="l"/>
             <a:r>
-              <a:rPr sz="1050" b="0" i="0">
+              <a:rPr sz="1150" b="0" i="0">
                 <a:solidFill>
                   <a:srgbClr val="333333"/>
                 </a:solidFill>
@@ -17401,7 +17401,7 @@
           <a:p>
             <a:pPr algn="l"/>
             <a:r>
-              <a:rPr sz="1050" b="0" i="0">
+              <a:rPr sz="1150" b="0" i="0">
                 <a:solidFill>
                   <a:srgbClr val="333333"/>
                 </a:solidFill>
@@ -17413,7 +17413,7 @@
           <a:p>
             <a:pPr algn="l"/>
             <a:r>
-              <a:rPr sz="1050" b="0" i="0">
+              <a:rPr sz="1150" b="0" i="0">
                 <a:solidFill>
                   <a:srgbClr val="333333"/>
                 </a:solidFill>
@@ -17425,7 +17425,7 @@
           <a:p>
             <a:pPr algn="l"/>
             <a:r>
-              <a:rPr sz="1050" b="0" i="0">
+              <a:rPr sz="1150" b="0" i="0">
                 <a:solidFill>
                   <a:srgbClr val="333333"/>
                 </a:solidFill>
@@ -17437,7 +17437,7 @@
           <a:p>
             <a:pPr algn="l"/>
             <a:r>
-              <a:rPr sz="1050" b="0" i="0">
+              <a:rPr sz="1150" b="0" i="0">
                 <a:solidFill>
                   <a:srgbClr val="333333"/>
                 </a:solidFill>
@@ -17449,7 +17449,7 @@
           <a:p>
             <a:pPr algn="l"/>
             <a:r>
-              <a:rPr sz="1050" b="0" i="0">
+              <a:rPr sz="1150" b="0" i="0">
                 <a:solidFill>
                   <a:srgbClr val="333333"/>
                 </a:solidFill>
@@ -17461,7 +17461,7 @@
           <a:p>
             <a:pPr algn="l"/>
             <a:r>
-              <a:rPr sz="1050" b="0" i="0">
+              <a:rPr sz="1150" b="0" i="0">
                 <a:solidFill>
                   <a:srgbClr val="333333"/>
                 </a:solidFill>
@@ -17473,7 +17473,7 @@
           <a:p>
             <a:pPr algn="l"/>
             <a:r>
-              <a:rPr sz="1050" b="0" i="0">
+              <a:rPr sz="1150" b="0" i="0">
                 <a:solidFill>
                   <a:srgbClr val="333333"/>
                 </a:solidFill>
@@ -17485,7 +17485,7 @@
           <a:p>
             <a:pPr algn="l"/>
             <a:r>
-              <a:rPr sz="1050" b="0" i="0">
+              <a:rPr sz="1150" b="0" i="0">
                 <a:solidFill>
                   <a:srgbClr val="333333"/>
                 </a:solidFill>
@@ -17497,7 +17497,7 @@
           <a:p>
             <a:pPr algn="l"/>
             <a:r>
-              <a:rPr sz="1050" b="0" i="0">
+              <a:rPr sz="1150" b="0" i="0">
                 <a:solidFill>
                   <a:srgbClr val="333333"/>
                 </a:solidFill>
@@ -17509,7 +17509,7 @@
           <a:p>
             <a:pPr algn="l"/>
             <a:r>
-              <a:rPr sz="1050" b="0" i="0">
+              <a:rPr sz="1150" b="0" i="0">
                 <a:solidFill>
                   <a:srgbClr val="333333"/>
                 </a:solidFill>
@@ -17544,7 +17544,7 @@
           <a:p>
             <a:pPr algn="l"/>
             <a:r>
-              <a:rPr sz="1050" b="1" i="0">
+              <a:rPr sz="1100" b="1" i="0">
                 <a:solidFill>
                   <a:srgbClr val="1F3A5F"/>
                 </a:solidFill>
@@ -17579,7 +17579,7 @@
           <a:p>
             <a:pPr algn="l"/>
             <a:r>
-              <a:rPr sz="950" b="0" i="1">
+              <a:rPr sz="1050" b="0" i="1">
                 <a:solidFill>
                   <a:srgbClr val="333333"/>
                 </a:solidFill>
@@ -23587,7 +23587,7 @@
         <p:spPr>
           <a:xfrm>
             <a:off x="365760" y="914400"/>
-            <a:ext cx="502920" cy="640080"/>
+            <a:ext cx="502920" cy="731520"/>
           </a:xfrm>
           <a:prstGeom prst="rect">
             <a:avLst/>
@@ -23630,8 +23630,8 @@
         </p:nvSpPr>
         <p:spPr>
           <a:xfrm>
-            <a:off x="365760" y="1097280"/>
-            <a:ext cx="502920" cy="274320"/>
+            <a:off x="365760" y="1115568"/>
+            <a:ext cx="502920" cy="320040"/>
           </a:xfrm>
           <a:prstGeom prst="rect">
             <a:avLst/>
@@ -23646,43 +23646,43 @@
           <a:p>
             <a:pPr algn="ctr"/>
             <a:r>
+              <a:rPr sz="1600" b="1" i="0">
+                <a:solidFill>
+                  <a:srgbClr val="FFFFFF"/>
+                </a:solidFill>
+                <a:latin typeface="Calibri"/>
+              </a:rPr>
+              <a:t>14</a:t>
+            </a:r>
+          </a:p>
+        </p:txBody>
+      </p:sp>
+      <p:sp>
+        <p:nvSpPr>
+          <p:cNvPr id="7" name="TextBox 6"/>
+          <p:cNvSpPr txBox="1"/>
+          <p:nvPr/>
+        </p:nvSpPr>
+        <p:spPr>
+          <a:xfrm>
+            <a:off x="1005840" y="960120"/>
+            <a:ext cx="10698480" cy="320040"/>
+          </a:xfrm>
+          <a:prstGeom prst="rect">
+            <a:avLst/>
+          </a:prstGeom>
+          <a:noFill/>
+        </p:spPr>
+        <p:txBody>
+          <a:bodyPr wrap="square" lIns="0" rIns="0" tIns="0" bIns="0">
+            <a:spAutoFit/>
+          </a:bodyPr>
+          <a:lstStyle/>
+          <a:p>
+            <a:pPr algn="l"/>
+            <a:r>
               <a:rPr sz="1400" b="1" i="0">
                 <a:solidFill>
-                  <a:srgbClr val="FFFFFF"/>
-                </a:solidFill>
-                <a:latin typeface="Calibri"/>
-              </a:rPr>
-              <a:t>14</a:t>
-            </a:r>
-          </a:p>
-        </p:txBody>
-      </p:sp>
-      <p:sp>
-        <p:nvSpPr>
-          <p:cNvPr id="7" name="TextBox 6"/>
-          <p:cNvSpPr txBox="1"/>
-          <p:nvPr/>
-        </p:nvSpPr>
-        <p:spPr>
-          <a:xfrm>
-            <a:off x="1005840" y="960120"/>
-            <a:ext cx="10698480" cy="274320"/>
-          </a:xfrm>
-          <a:prstGeom prst="rect">
-            <a:avLst/>
-          </a:prstGeom>
-          <a:noFill/>
-        </p:spPr>
-        <p:txBody>
-          <a:bodyPr wrap="square" lIns="0" rIns="0" tIns="0" bIns="0">
-            <a:spAutoFit/>
-          </a:bodyPr>
-          <a:lstStyle/>
-          <a:p>
-            <a:pPr algn="l"/>
-            <a:r>
-              <a:rPr sz="1300" b="1" i="0">
-                <a:solidFill>
                   <a:srgbClr val="1F3A5F"/>
                 </a:solidFill>
                 <a:latin typeface="Calibri"/>
@@ -23700,23 +23700,23 @@
         </p:nvSpPr>
         <p:spPr>
           <a:xfrm>
-            <a:off x="1005840" y="1207008"/>
-            <a:ext cx="10698480" cy="365760"/>
-          </a:xfrm>
-          <a:prstGeom prst="rect">
-            <a:avLst/>
-          </a:prstGeom>
-          <a:noFill/>
-        </p:spPr>
-        <p:txBody>
-          <a:bodyPr wrap="square" lIns="0" rIns="0" tIns="0" bIns="0">
-            <a:spAutoFit/>
-          </a:bodyPr>
-          <a:lstStyle/>
-          <a:p>
-            <a:pPr algn="l"/>
-            <a:r>
-              <a:rPr sz="1050" b="0" i="0">
+            <a:off x="1005840" y="1261872"/>
+            <a:ext cx="10698480" cy="411480"/>
+          </a:xfrm>
+          <a:prstGeom prst="rect">
+            <a:avLst/>
+          </a:prstGeom>
+          <a:noFill/>
+        </p:spPr>
+        <p:txBody>
+          <a:bodyPr wrap="square" lIns="0" rIns="0" tIns="0" bIns="0">
+            <a:spAutoFit/>
+          </a:bodyPr>
+          <a:lstStyle/>
+          <a:p>
+            <a:pPr algn="l"/>
+            <a:r>
+              <a:rPr sz="1200" b="0" i="0">
                 <a:solidFill>
                   <a:srgbClr val="333333"/>
                 </a:solidFill>
@@ -23735,8 +23735,8 @@
         </p:nvSpPr>
         <p:spPr>
           <a:xfrm>
-            <a:off x="365760" y="1645920"/>
-            <a:ext cx="502920" cy="640080"/>
+            <a:off x="365760" y="1783080"/>
+            <a:ext cx="502920" cy="731520"/>
           </a:xfrm>
           <a:prstGeom prst="rect">
             <a:avLst/>
@@ -23779,8 +23779,8 @@
         </p:nvSpPr>
         <p:spPr>
           <a:xfrm>
-            <a:off x="365760" y="1828800"/>
-            <a:ext cx="502920" cy="274320"/>
+            <a:off x="365760" y="1984248"/>
+            <a:ext cx="502920" cy="320040"/>
           </a:xfrm>
           <a:prstGeom prst="rect">
             <a:avLst/>
@@ -23795,43 +23795,43 @@
           <a:p>
             <a:pPr algn="ctr"/>
             <a:r>
+              <a:rPr sz="1600" b="1" i="0">
+                <a:solidFill>
+                  <a:srgbClr val="FFFFFF"/>
+                </a:solidFill>
+                <a:latin typeface="Calibri"/>
+              </a:rPr>
+              <a:t>15</a:t>
+            </a:r>
+          </a:p>
+        </p:txBody>
+      </p:sp>
+      <p:sp>
+        <p:nvSpPr>
+          <p:cNvPr id="11" name="TextBox 10"/>
+          <p:cNvSpPr txBox="1"/>
+          <p:nvPr/>
+        </p:nvSpPr>
+        <p:spPr>
+          <a:xfrm>
+            <a:off x="1005840" y="1828800"/>
+            <a:ext cx="10698480" cy="320040"/>
+          </a:xfrm>
+          <a:prstGeom prst="rect">
+            <a:avLst/>
+          </a:prstGeom>
+          <a:noFill/>
+        </p:spPr>
+        <p:txBody>
+          <a:bodyPr wrap="square" lIns="0" rIns="0" tIns="0" bIns="0">
+            <a:spAutoFit/>
+          </a:bodyPr>
+          <a:lstStyle/>
+          <a:p>
+            <a:pPr algn="l"/>
+            <a:r>
               <a:rPr sz="1400" b="1" i="0">
                 <a:solidFill>
-                  <a:srgbClr val="FFFFFF"/>
-                </a:solidFill>
-                <a:latin typeface="Calibri"/>
-              </a:rPr>
-              <a:t>15</a:t>
-            </a:r>
-          </a:p>
-        </p:txBody>
-      </p:sp>
-      <p:sp>
-        <p:nvSpPr>
-          <p:cNvPr id="11" name="TextBox 10"/>
-          <p:cNvSpPr txBox="1"/>
-          <p:nvPr/>
-        </p:nvSpPr>
-        <p:spPr>
-          <a:xfrm>
-            <a:off x="1005840" y="1691640"/>
-            <a:ext cx="10698480" cy="274320"/>
-          </a:xfrm>
-          <a:prstGeom prst="rect">
-            <a:avLst/>
-          </a:prstGeom>
-          <a:noFill/>
-        </p:spPr>
-        <p:txBody>
-          <a:bodyPr wrap="square" lIns="0" rIns="0" tIns="0" bIns="0">
-            <a:spAutoFit/>
-          </a:bodyPr>
-          <a:lstStyle/>
-          <a:p>
-            <a:pPr algn="l"/>
-            <a:r>
-              <a:rPr sz="1300" b="1" i="0">
-                <a:solidFill>
                   <a:srgbClr val="1F3A5F"/>
                 </a:solidFill>
                 <a:latin typeface="Calibri"/>
@@ -23849,23 +23849,23 @@
         </p:nvSpPr>
         <p:spPr>
           <a:xfrm>
-            <a:off x="1005840" y="1938528"/>
-            <a:ext cx="10698480" cy="365760"/>
-          </a:xfrm>
-          <a:prstGeom prst="rect">
-            <a:avLst/>
-          </a:prstGeom>
-          <a:noFill/>
-        </p:spPr>
-        <p:txBody>
-          <a:bodyPr wrap="square" lIns="0" rIns="0" tIns="0" bIns="0">
-            <a:spAutoFit/>
-          </a:bodyPr>
-          <a:lstStyle/>
-          <a:p>
-            <a:pPr algn="l"/>
-            <a:r>
-              <a:rPr sz="1050" b="0" i="0">
+            <a:off x="1005840" y="2130552"/>
+            <a:ext cx="10698480" cy="411480"/>
+          </a:xfrm>
+          <a:prstGeom prst="rect">
+            <a:avLst/>
+          </a:prstGeom>
+          <a:noFill/>
+        </p:spPr>
+        <p:txBody>
+          <a:bodyPr wrap="square" lIns="0" rIns="0" tIns="0" bIns="0">
+            <a:spAutoFit/>
+          </a:bodyPr>
+          <a:lstStyle/>
+          <a:p>
+            <a:pPr algn="l"/>
+            <a:r>
+              <a:rPr sz="1200" b="0" i="0">
                 <a:solidFill>
                   <a:srgbClr val="333333"/>
                 </a:solidFill>
@@ -23884,8 +23884,8 @@
         </p:nvSpPr>
         <p:spPr>
           <a:xfrm>
-            <a:off x="365760" y="2377440"/>
-            <a:ext cx="502920" cy="640080"/>
+            <a:off x="365760" y="2651760"/>
+            <a:ext cx="502920" cy="731520"/>
           </a:xfrm>
           <a:prstGeom prst="rect">
             <a:avLst/>
@@ -23928,8 +23928,8 @@
         </p:nvSpPr>
         <p:spPr>
           <a:xfrm>
-            <a:off x="365760" y="2560320"/>
-            <a:ext cx="502920" cy="274320"/>
+            <a:off x="365760" y="2852928"/>
+            <a:ext cx="502920" cy="320040"/>
           </a:xfrm>
           <a:prstGeom prst="rect">
             <a:avLst/>
@@ -23944,43 +23944,43 @@
           <a:p>
             <a:pPr algn="ctr"/>
             <a:r>
+              <a:rPr sz="1600" b="1" i="0">
+                <a:solidFill>
+                  <a:srgbClr val="FFFFFF"/>
+                </a:solidFill>
+                <a:latin typeface="Calibri"/>
+              </a:rPr>
+              <a:t>16</a:t>
+            </a:r>
+          </a:p>
+        </p:txBody>
+      </p:sp>
+      <p:sp>
+        <p:nvSpPr>
+          <p:cNvPr id="15" name="TextBox 14"/>
+          <p:cNvSpPr txBox="1"/>
+          <p:nvPr/>
+        </p:nvSpPr>
+        <p:spPr>
+          <a:xfrm>
+            <a:off x="1005840" y="2697480"/>
+            <a:ext cx="10698480" cy="320040"/>
+          </a:xfrm>
+          <a:prstGeom prst="rect">
+            <a:avLst/>
+          </a:prstGeom>
+          <a:noFill/>
+        </p:spPr>
+        <p:txBody>
+          <a:bodyPr wrap="square" lIns="0" rIns="0" tIns="0" bIns="0">
+            <a:spAutoFit/>
+          </a:bodyPr>
+          <a:lstStyle/>
+          <a:p>
+            <a:pPr algn="l"/>
+            <a:r>
               <a:rPr sz="1400" b="1" i="0">
                 <a:solidFill>
-                  <a:srgbClr val="FFFFFF"/>
-                </a:solidFill>
-                <a:latin typeface="Calibri"/>
-              </a:rPr>
-              <a:t>16</a:t>
-            </a:r>
-          </a:p>
-        </p:txBody>
-      </p:sp>
-      <p:sp>
-        <p:nvSpPr>
-          <p:cNvPr id="15" name="TextBox 14"/>
-          <p:cNvSpPr txBox="1"/>
-          <p:nvPr/>
-        </p:nvSpPr>
-        <p:spPr>
-          <a:xfrm>
-            <a:off x="1005840" y="2423160"/>
-            <a:ext cx="10698480" cy="274320"/>
-          </a:xfrm>
-          <a:prstGeom prst="rect">
-            <a:avLst/>
-          </a:prstGeom>
-          <a:noFill/>
-        </p:spPr>
-        <p:txBody>
-          <a:bodyPr wrap="square" lIns="0" rIns="0" tIns="0" bIns="0">
-            <a:spAutoFit/>
-          </a:bodyPr>
-          <a:lstStyle/>
-          <a:p>
-            <a:pPr algn="l"/>
-            <a:r>
-              <a:rPr sz="1300" b="1" i="0">
-                <a:solidFill>
                   <a:srgbClr val="1F3A5F"/>
                 </a:solidFill>
                 <a:latin typeface="Calibri"/>
@@ -23998,23 +23998,23 @@
         </p:nvSpPr>
         <p:spPr>
           <a:xfrm>
-            <a:off x="1005840" y="2670048"/>
-            <a:ext cx="10698480" cy="365760"/>
-          </a:xfrm>
-          <a:prstGeom prst="rect">
-            <a:avLst/>
-          </a:prstGeom>
-          <a:noFill/>
-        </p:spPr>
-        <p:txBody>
-          <a:bodyPr wrap="square" lIns="0" rIns="0" tIns="0" bIns="0">
-            <a:spAutoFit/>
-          </a:bodyPr>
-          <a:lstStyle/>
-          <a:p>
-            <a:pPr algn="l"/>
-            <a:r>
-              <a:rPr sz="1050" b="0" i="0">
+            <a:off x="1005840" y="2999232"/>
+            <a:ext cx="10698480" cy="411480"/>
+          </a:xfrm>
+          <a:prstGeom prst="rect">
+            <a:avLst/>
+          </a:prstGeom>
+          <a:noFill/>
+        </p:spPr>
+        <p:txBody>
+          <a:bodyPr wrap="square" lIns="0" rIns="0" tIns="0" bIns="0">
+            <a:spAutoFit/>
+          </a:bodyPr>
+          <a:lstStyle/>
+          <a:p>
+            <a:pPr algn="l"/>
+            <a:r>
+              <a:rPr sz="1200" b="0" i="0">
                 <a:solidFill>
                   <a:srgbClr val="333333"/>
                 </a:solidFill>
@@ -24033,8 +24033,8 @@
         </p:nvSpPr>
         <p:spPr>
           <a:xfrm>
-            <a:off x="365760" y="3108960"/>
-            <a:ext cx="502920" cy="640080"/>
+            <a:off x="365760" y="3520440"/>
+            <a:ext cx="502920" cy="731520"/>
           </a:xfrm>
           <a:prstGeom prst="rect">
             <a:avLst/>
@@ -24077,8 +24077,8 @@
         </p:nvSpPr>
         <p:spPr>
           <a:xfrm>
-            <a:off x="365760" y="3291840"/>
-            <a:ext cx="502920" cy="274320"/>
+            <a:off x="365760" y="3721608"/>
+            <a:ext cx="502920" cy="320040"/>
           </a:xfrm>
           <a:prstGeom prst="rect">
             <a:avLst/>
@@ -24093,43 +24093,43 @@
           <a:p>
             <a:pPr algn="ctr"/>
             <a:r>
+              <a:rPr sz="1600" b="1" i="0">
+                <a:solidFill>
+                  <a:srgbClr val="FFFFFF"/>
+                </a:solidFill>
+                <a:latin typeface="Calibri"/>
+              </a:rPr>
+              <a:t>17</a:t>
+            </a:r>
+          </a:p>
+        </p:txBody>
+      </p:sp>
+      <p:sp>
+        <p:nvSpPr>
+          <p:cNvPr id="19" name="TextBox 18"/>
+          <p:cNvSpPr txBox="1"/>
+          <p:nvPr/>
+        </p:nvSpPr>
+        <p:spPr>
+          <a:xfrm>
+            <a:off x="1005840" y="3566160"/>
+            <a:ext cx="10698480" cy="320040"/>
+          </a:xfrm>
+          <a:prstGeom prst="rect">
+            <a:avLst/>
+          </a:prstGeom>
+          <a:noFill/>
+        </p:spPr>
+        <p:txBody>
+          <a:bodyPr wrap="square" lIns="0" rIns="0" tIns="0" bIns="0">
+            <a:spAutoFit/>
+          </a:bodyPr>
+          <a:lstStyle/>
+          <a:p>
+            <a:pPr algn="l"/>
+            <a:r>
               <a:rPr sz="1400" b="1" i="0">
                 <a:solidFill>
-                  <a:srgbClr val="FFFFFF"/>
-                </a:solidFill>
-                <a:latin typeface="Calibri"/>
-              </a:rPr>
-              <a:t>17</a:t>
-            </a:r>
-          </a:p>
-        </p:txBody>
-      </p:sp>
-      <p:sp>
-        <p:nvSpPr>
-          <p:cNvPr id="19" name="TextBox 18"/>
-          <p:cNvSpPr txBox="1"/>
-          <p:nvPr/>
-        </p:nvSpPr>
-        <p:spPr>
-          <a:xfrm>
-            <a:off x="1005840" y="3154680"/>
-            <a:ext cx="10698480" cy="274320"/>
-          </a:xfrm>
-          <a:prstGeom prst="rect">
-            <a:avLst/>
-          </a:prstGeom>
-          <a:noFill/>
-        </p:spPr>
-        <p:txBody>
-          <a:bodyPr wrap="square" lIns="0" rIns="0" tIns="0" bIns="0">
-            <a:spAutoFit/>
-          </a:bodyPr>
-          <a:lstStyle/>
-          <a:p>
-            <a:pPr algn="l"/>
-            <a:r>
-              <a:rPr sz="1300" b="1" i="0">
-                <a:solidFill>
                   <a:srgbClr val="1F3A5F"/>
                 </a:solidFill>
                 <a:latin typeface="Calibri"/>
@@ -24147,23 +24147,23 @@
         </p:nvSpPr>
         <p:spPr>
           <a:xfrm>
-            <a:off x="1005840" y="3401568"/>
-            <a:ext cx="10698480" cy="365760"/>
-          </a:xfrm>
-          <a:prstGeom prst="rect">
-            <a:avLst/>
-          </a:prstGeom>
-          <a:noFill/>
-        </p:spPr>
-        <p:txBody>
-          <a:bodyPr wrap="square" lIns="0" rIns="0" tIns="0" bIns="0">
-            <a:spAutoFit/>
-          </a:bodyPr>
-          <a:lstStyle/>
-          <a:p>
-            <a:pPr algn="l"/>
-            <a:r>
-              <a:rPr sz="1050" b="0" i="0">
+            <a:off x="1005840" y="3867912"/>
+            <a:ext cx="10698480" cy="411480"/>
+          </a:xfrm>
+          <a:prstGeom prst="rect">
+            <a:avLst/>
+          </a:prstGeom>
+          <a:noFill/>
+        </p:spPr>
+        <p:txBody>
+          <a:bodyPr wrap="square" lIns="0" rIns="0" tIns="0" bIns="0">
+            <a:spAutoFit/>
+          </a:bodyPr>
+          <a:lstStyle/>
+          <a:p>
+            <a:pPr algn="l"/>
+            <a:r>
+              <a:rPr sz="1200" b="0" i="0">
                 <a:solidFill>
                   <a:srgbClr val="333333"/>
                 </a:solidFill>
@@ -24182,8 +24182,8 @@
         </p:nvSpPr>
         <p:spPr>
           <a:xfrm>
-            <a:off x="365760" y="3840480"/>
-            <a:ext cx="502920" cy="640080"/>
+            <a:off x="365760" y="4389120"/>
+            <a:ext cx="502920" cy="731520"/>
           </a:xfrm>
           <a:prstGeom prst="rect">
             <a:avLst/>
@@ -24226,8 +24226,8 @@
         </p:nvSpPr>
         <p:spPr>
           <a:xfrm>
-            <a:off x="365760" y="4023360"/>
-            <a:ext cx="502920" cy="274320"/>
+            <a:off x="365760" y="4590288"/>
+            <a:ext cx="502920" cy="320040"/>
           </a:xfrm>
           <a:prstGeom prst="rect">
             <a:avLst/>
@@ -24242,43 +24242,43 @@
           <a:p>
             <a:pPr algn="ctr"/>
             <a:r>
+              <a:rPr sz="1600" b="1" i="0">
+                <a:solidFill>
+                  <a:srgbClr val="FFFFFF"/>
+                </a:solidFill>
+                <a:latin typeface="Calibri"/>
+              </a:rPr>
+              <a:t>18</a:t>
+            </a:r>
+          </a:p>
+        </p:txBody>
+      </p:sp>
+      <p:sp>
+        <p:nvSpPr>
+          <p:cNvPr id="23" name="TextBox 22"/>
+          <p:cNvSpPr txBox="1"/>
+          <p:nvPr/>
+        </p:nvSpPr>
+        <p:spPr>
+          <a:xfrm>
+            <a:off x="1005840" y="4434840"/>
+            <a:ext cx="10698480" cy="320040"/>
+          </a:xfrm>
+          <a:prstGeom prst="rect">
+            <a:avLst/>
+          </a:prstGeom>
+          <a:noFill/>
+        </p:spPr>
+        <p:txBody>
+          <a:bodyPr wrap="square" lIns="0" rIns="0" tIns="0" bIns="0">
+            <a:spAutoFit/>
+          </a:bodyPr>
+          <a:lstStyle/>
+          <a:p>
+            <a:pPr algn="l"/>
+            <a:r>
               <a:rPr sz="1400" b="1" i="0">
                 <a:solidFill>
-                  <a:srgbClr val="FFFFFF"/>
-                </a:solidFill>
-                <a:latin typeface="Calibri"/>
-              </a:rPr>
-              <a:t>18</a:t>
-            </a:r>
-          </a:p>
-        </p:txBody>
-      </p:sp>
-      <p:sp>
-        <p:nvSpPr>
-          <p:cNvPr id="23" name="TextBox 22"/>
-          <p:cNvSpPr txBox="1"/>
-          <p:nvPr/>
-        </p:nvSpPr>
-        <p:spPr>
-          <a:xfrm>
-            <a:off x="1005840" y="3886200"/>
-            <a:ext cx="10698480" cy="274320"/>
-          </a:xfrm>
-          <a:prstGeom prst="rect">
-            <a:avLst/>
-          </a:prstGeom>
-          <a:noFill/>
-        </p:spPr>
-        <p:txBody>
-          <a:bodyPr wrap="square" lIns="0" rIns="0" tIns="0" bIns="0">
-            <a:spAutoFit/>
-          </a:bodyPr>
-          <a:lstStyle/>
-          <a:p>
-            <a:pPr algn="l"/>
-            <a:r>
-              <a:rPr sz="1300" b="1" i="0">
-                <a:solidFill>
                   <a:srgbClr val="1F3A5F"/>
                 </a:solidFill>
                 <a:latin typeface="Calibri"/>
@@ -24296,23 +24296,23 @@
         </p:nvSpPr>
         <p:spPr>
           <a:xfrm>
-            <a:off x="1005840" y="4133088"/>
-            <a:ext cx="10698480" cy="365760"/>
-          </a:xfrm>
-          <a:prstGeom prst="rect">
-            <a:avLst/>
-          </a:prstGeom>
-          <a:noFill/>
-        </p:spPr>
-        <p:txBody>
-          <a:bodyPr wrap="square" lIns="0" rIns="0" tIns="0" bIns="0">
-            <a:spAutoFit/>
-          </a:bodyPr>
-          <a:lstStyle/>
-          <a:p>
-            <a:pPr algn="l"/>
-            <a:r>
-              <a:rPr sz="1050" b="0" i="0">
+            <a:off x="1005840" y="4736592"/>
+            <a:ext cx="10698480" cy="411480"/>
+          </a:xfrm>
+          <a:prstGeom prst="rect">
+            <a:avLst/>
+          </a:prstGeom>
+          <a:noFill/>
+        </p:spPr>
+        <p:txBody>
+          <a:bodyPr wrap="square" lIns="0" rIns="0" tIns="0" bIns="0">
+            <a:spAutoFit/>
+          </a:bodyPr>
+          <a:lstStyle/>
+          <a:p>
+            <a:pPr algn="l"/>
+            <a:r>
+              <a:rPr sz="1200" b="0" i="0">
                 <a:solidFill>
                   <a:srgbClr val="333333"/>
                 </a:solidFill>
@@ -24331,8 +24331,8 @@
         </p:nvSpPr>
         <p:spPr>
           <a:xfrm>
-            <a:off x="365760" y="4572000"/>
-            <a:ext cx="502920" cy="640080"/>
+            <a:off x="365760" y="5257800"/>
+            <a:ext cx="502920" cy="731520"/>
           </a:xfrm>
           <a:prstGeom prst="rect">
             <a:avLst/>
@@ -24375,8 +24375,8 @@
         </p:nvSpPr>
         <p:spPr>
           <a:xfrm>
-            <a:off x="365760" y="4754880"/>
-            <a:ext cx="502920" cy="274320"/>
+            <a:off x="365760" y="5458968"/>
+            <a:ext cx="502920" cy="320040"/>
           </a:xfrm>
           <a:prstGeom prst="rect">
             <a:avLst/>
@@ -24391,43 +24391,43 @@
           <a:p>
             <a:pPr algn="ctr"/>
             <a:r>
+              <a:rPr sz="1600" b="1" i="0">
+                <a:solidFill>
+                  <a:srgbClr val="FFFFFF"/>
+                </a:solidFill>
+                <a:latin typeface="Calibri"/>
+              </a:rPr>
+              <a:t>19</a:t>
+            </a:r>
+          </a:p>
+        </p:txBody>
+      </p:sp>
+      <p:sp>
+        <p:nvSpPr>
+          <p:cNvPr id="27" name="TextBox 26"/>
+          <p:cNvSpPr txBox="1"/>
+          <p:nvPr/>
+        </p:nvSpPr>
+        <p:spPr>
+          <a:xfrm>
+            <a:off x="1005840" y="5303520"/>
+            <a:ext cx="10698480" cy="320040"/>
+          </a:xfrm>
+          <a:prstGeom prst="rect">
+            <a:avLst/>
+          </a:prstGeom>
+          <a:noFill/>
+        </p:spPr>
+        <p:txBody>
+          <a:bodyPr wrap="square" lIns="0" rIns="0" tIns="0" bIns="0">
+            <a:spAutoFit/>
+          </a:bodyPr>
+          <a:lstStyle/>
+          <a:p>
+            <a:pPr algn="l"/>
+            <a:r>
               <a:rPr sz="1400" b="1" i="0">
                 <a:solidFill>
-                  <a:srgbClr val="FFFFFF"/>
-                </a:solidFill>
-                <a:latin typeface="Calibri"/>
-              </a:rPr>
-              <a:t>19</a:t>
-            </a:r>
-          </a:p>
-        </p:txBody>
-      </p:sp>
-      <p:sp>
-        <p:nvSpPr>
-          <p:cNvPr id="27" name="TextBox 26"/>
-          <p:cNvSpPr txBox="1"/>
-          <p:nvPr/>
-        </p:nvSpPr>
-        <p:spPr>
-          <a:xfrm>
-            <a:off x="1005840" y="4617720"/>
-            <a:ext cx="10698480" cy="274320"/>
-          </a:xfrm>
-          <a:prstGeom prst="rect">
-            <a:avLst/>
-          </a:prstGeom>
-          <a:noFill/>
-        </p:spPr>
-        <p:txBody>
-          <a:bodyPr wrap="square" lIns="0" rIns="0" tIns="0" bIns="0">
-            <a:spAutoFit/>
-          </a:bodyPr>
-          <a:lstStyle/>
-          <a:p>
-            <a:pPr algn="l"/>
-            <a:r>
-              <a:rPr sz="1300" b="1" i="0">
-                <a:solidFill>
                   <a:srgbClr val="1F3A5F"/>
                 </a:solidFill>
                 <a:latin typeface="Calibri"/>
@@ -24445,23 +24445,23 @@
         </p:nvSpPr>
         <p:spPr>
           <a:xfrm>
-            <a:off x="1005840" y="4864608"/>
-            <a:ext cx="10698480" cy="365760"/>
-          </a:xfrm>
-          <a:prstGeom prst="rect">
-            <a:avLst/>
-          </a:prstGeom>
-          <a:noFill/>
-        </p:spPr>
-        <p:txBody>
-          <a:bodyPr wrap="square" lIns="0" rIns="0" tIns="0" bIns="0">
-            <a:spAutoFit/>
-          </a:bodyPr>
-          <a:lstStyle/>
-          <a:p>
-            <a:pPr algn="l"/>
-            <a:r>
-              <a:rPr sz="1050" b="0" i="0">
+            <a:off x="1005840" y="5605272"/>
+            <a:ext cx="10698480" cy="411480"/>
+          </a:xfrm>
+          <a:prstGeom prst="rect">
+            <a:avLst/>
+          </a:prstGeom>
+          <a:noFill/>
+        </p:spPr>
+        <p:txBody>
+          <a:bodyPr wrap="square" lIns="0" rIns="0" tIns="0" bIns="0">
+            <a:spAutoFit/>
+          </a:bodyPr>
+          <a:lstStyle/>
+          <a:p>
+            <a:pPr algn="l"/>
+            <a:r>
+              <a:rPr sz="1200" b="0" i="0">
                 <a:solidFill>
                   <a:srgbClr val="333333"/>
                 </a:solidFill>
@@ -26504,7 +26504,7 @@
           <a:p>
             <a:pPr algn="l"/>
             <a:r>
-              <a:rPr sz="850" b="0" i="0">
+              <a:rPr sz="950" b="0" i="0">
                 <a:solidFill>
                   <a:srgbClr val="333333"/>
                 </a:solidFill>
@@ -26653,7 +26653,7 @@
           <a:p>
             <a:pPr algn="l"/>
             <a:r>
-              <a:rPr sz="850" b="0" i="0">
+              <a:rPr sz="950" b="0" i="0">
                 <a:solidFill>
                   <a:srgbClr val="333333"/>
                 </a:solidFill>
@@ -26802,7 +26802,7 @@
           <a:p>
             <a:pPr algn="l"/>
             <a:r>
-              <a:rPr sz="850" b="0" i="0">
+              <a:rPr sz="950" b="0" i="0">
                 <a:solidFill>
                   <a:srgbClr val="333333"/>
                 </a:solidFill>
@@ -26951,7 +26951,7 @@
           <a:p>
             <a:pPr algn="l"/>
             <a:r>
-              <a:rPr sz="850" b="0" i="0">
+              <a:rPr sz="950" b="0" i="0">
                 <a:solidFill>
                   <a:srgbClr val="333333"/>
                 </a:solidFill>
@@ -27100,7 +27100,7 @@
           <a:p>
             <a:pPr algn="l"/>
             <a:r>
-              <a:rPr sz="850" b="0" i="0">
+              <a:rPr sz="950" b="0" i="0">
                 <a:solidFill>
                   <a:srgbClr val="333333"/>
                 </a:solidFill>
@@ -27249,7 +27249,7 @@
           <a:p>
             <a:pPr algn="l"/>
             <a:r>
-              <a:rPr sz="850" b="0" i="0">
+              <a:rPr sz="950" b="0" i="0">
                 <a:solidFill>
                   <a:srgbClr val="333333"/>
                 </a:solidFill>
@@ -27398,7 +27398,7 @@
           <a:p>
             <a:pPr algn="l"/>
             <a:r>
-              <a:rPr sz="850" b="0" i="0">
+              <a:rPr sz="950" b="0" i="0">
                 <a:solidFill>
                   <a:srgbClr val="333333"/>
                 </a:solidFill>
@@ -27547,7 +27547,7 @@
           <a:p>
             <a:pPr algn="l"/>
             <a:r>
-              <a:rPr sz="850" b="0" i="0">
+              <a:rPr sz="950" b="0" i="0">
                 <a:solidFill>
                   <a:srgbClr val="333333"/>
                 </a:solidFill>
@@ -27696,7 +27696,7 @@
           <a:p>
             <a:pPr algn="l"/>
             <a:r>
-              <a:rPr sz="850" b="0" i="0">
+              <a:rPr sz="950" b="0" i="0">
                 <a:solidFill>
                   <a:srgbClr val="333333"/>
                 </a:solidFill>
@@ -27845,7 +27845,7 @@
           <a:p>
             <a:pPr algn="l"/>
             <a:r>
-              <a:rPr sz="850" b="0" i="0">
+              <a:rPr sz="950" b="0" i="0">
                 <a:solidFill>
                   <a:srgbClr val="333333"/>
                 </a:solidFill>
@@ -27994,7 +27994,7 @@
           <a:p>
             <a:pPr algn="l"/>
             <a:r>
-              <a:rPr sz="850" b="0" i="0">
+              <a:rPr sz="950" b="0" i="0">
                 <a:solidFill>
                   <a:srgbClr val="333333"/>
                 </a:solidFill>
@@ -28143,7 +28143,7 @@
           <a:p>
             <a:pPr algn="l"/>
             <a:r>
-              <a:rPr sz="850" b="0" i="0">
+              <a:rPr sz="950" b="0" i="0">
                 <a:solidFill>
                   <a:srgbClr val="333333"/>
                 </a:solidFill>
@@ -28292,7 +28292,7 @@
           <a:p>
             <a:pPr algn="l"/>
             <a:r>
-              <a:rPr sz="850" b="0" i="0">
+              <a:rPr sz="950" b="0" i="0">
                 <a:solidFill>
                   <a:srgbClr val="333333"/>
                 </a:solidFill>
@@ -28441,7 +28441,7 @@
           <a:p>
             <a:pPr algn="l"/>
             <a:r>
-              <a:rPr sz="850" b="0" i="0">
+              <a:rPr sz="950" b="0" i="0">
                 <a:solidFill>
                   <a:srgbClr val="333333"/>
                 </a:solidFill>
@@ -28821,22 +28821,22 @@
         <p:spPr>
           <a:xfrm>
             <a:off x="640080" y="1737360"/>
-            <a:ext cx="3291840" cy="201168"/>
-          </a:xfrm>
-          <a:prstGeom prst="rect">
-            <a:avLst/>
-          </a:prstGeom>
-          <a:noFill/>
-        </p:spPr>
-        <p:txBody>
-          <a:bodyPr wrap="square" lIns="0" rIns="0" tIns="0" bIns="0">
-            <a:spAutoFit/>
-          </a:bodyPr>
-          <a:lstStyle/>
-          <a:p>
-            <a:pPr algn="l"/>
-            <a:r>
-              <a:rPr sz="850" b="1" i="0">
+            <a:ext cx="3291840" cy="228600"/>
+          </a:xfrm>
+          <a:prstGeom prst="rect">
+            <a:avLst/>
+          </a:prstGeom>
+          <a:noFill/>
+        </p:spPr>
+        <p:txBody>
+          <a:bodyPr wrap="square" lIns="0" rIns="0" tIns="0" bIns="0">
+            <a:spAutoFit/>
+          </a:bodyPr>
+          <a:lstStyle/>
+          <a:p>
+            <a:pPr algn="l"/>
+            <a:r>
+              <a:rPr sz="950" b="1" i="0">
                 <a:solidFill>
                   <a:srgbClr val="333333"/>
                 </a:solidFill>
@@ -28856,22 +28856,22 @@
         <p:spPr>
           <a:xfrm>
             <a:off x="3977640" y="1737360"/>
-            <a:ext cx="2286000" cy="201168"/>
-          </a:xfrm>
-          <a:prstGeom prst="rect">
-            <a:avLst/>
-          </a:prstGeom>
-          <a:noFill/>
-        </p:spPr>
-        <p:txBody>
-          <a:bodyPr wrap="square" lIns="0" rIns="0" tIns="0" bIns="0">
-            <a:spAutoFit/>
-          </a:bodyPr>
-          <a:lstStyle/>
-          <a:p>
-            <a:pPr algn="l"/>
-            <a:r>
-              <a:rPr sz="850" b="0" i="0">
+            <a:ext cx="2286000" cy="228600"/>
+          </a:xfrm>
+          <a:prstGeom prst="rect">
+            <a:avLst/>
+          </a:prstGeom>
+          <a:noFill/>
+        </p:spPr>
+        <p:txBody>
+          <a:bodyPr wrap="square" lIns="0" rIns="0" tIns="0" bIns="0">
+            <a:spAutoFit/>
+          </a:bodyPr>
+          <a:lstStyle/>
+          <a:p>
+            <a:pPr algn="l"/>
+            <a:r>
+              <a:rPr sz="950" b="0" i="0">
                 <a:solidFill>
                   <a:srgbClr val="707070"/>
                 </a:solidFill>
@@ -28890,23 +28890,23 @@
         </p:nvSpPr>
         <p:spPr>
           <a:xfrm>
-            <a:off x="640080" y="1975104"/>
-            <a:ext cx="3291840" cy="201168"/>
-          </a:xfrm>
-          <a:prstGeom prst="rect">
-            <a:avLst/>
-          </a:prstGeom>
-          <a:noFill/>
-        </p:spPr>
-        <p:txBody>
-          <a:bodyPr wrap="square" lIns="0" rIns="0" tIns="0" bIns="0">
-            <a:spAutoFit/>
-          </a:bodyPr>
-          <a:lstStyle/>
-          <a:p>
-            <a:pPr algn="l"/>
-            <a:r>
-              <a:rPr sz="850" b="1" i="0">
+            <a:off x="640080" y="2002536"/>
+            <a:ext cx="3291840" cy="228600"/>
+          </a:xfrm>
+          <a:prstGeom prst="rect">
+            <a:avLst/>
+          </a:prstGeom>
+          <a:noFill/>
+        </p:spPr>
+        <p:txBody>
+          <a:bodyPr wrap="square" lIns="0" rIns="0" tIns="0" bIns="0">
+            <a:spAutoFit/>
+          </a:bodyPr>
+          <a:lstStyle/>
+          <a:p>
+            <a:pPr algn="l"/>
+            <a:r>
+              <a:rPr sz="950" b="1" i="0">
                 <a:solidFill>
                   <a:srgbClr val="333333"/>
                 </a:solidFill>
@@ -28925,23 +28925,23 @@
         </p:nvSpPr>
         <p:spPr>
           <a:xfrm>
-            <a:off x="3977640" y="1975104"/>
-            <a:ext cx="2286000" cy="201168"/>
-          </a:xfrm>
-          <a:prstGeom prst="rect">
-            <a:avLst/>
-          </a:prstGeom>
-          <a:noFill/>
-        </p:spPr>
-        <p:txBody>
-          <a:bodyPr wrap="square" lIns="0" rIns="0" tIns="0" bIns="0">
-            <a:spAutoFit/>
-          </a:bodyPr>
-          <a:lstStyle/>
-          <a:p>
-            <a:pPr algn="l"/>
-            <a:r>
-              <a:rPr sz="850" b="0" i="0">
+            <a:off x="3977640" y="2002536"/>
+            <a:ext cx="2286000" cy="228600"/>
+          </a:xfrm>
+          <a:prstGeom prst="rect">
+            <a:avLst/>
+          </a:prstGeom>
+          <a:noFill/>
+        </p:spPr>
+        <p:txBody>
+          <a:bodyPr wrap="square" lIns="0" rIns="0" tIns="0" bIns="0">
+            <a:spAutoFit/>
+          </a:bodyPr>
+          <a:lstStyle/>
+          <a:p>
+            <a:pPr algn="l"/>
+            <a:r>
+              <a:rPr sz="950" b="0" i="0">
                 <a:solidFill>
                   <a:srgbClr val="707070"/>
                 </a:solidFill>
@@ -28960,23 +28960,23 @@
         </p:nvSpPr>
         <p:spPr>
           <a:xfrm>
-            <a:off x="640080" y="2212848"/>
-            <a:ext cx="3291840" cy="201168"/>
-          </a:xfrm>
-          <a:prstGeom prst="rect">
-            <a:avLst/>
-          </a:prstGeom>
-          <a:noFill/>
-        </p:spPr>
-        <p:txBody>
-          <a:bodyPr wrap="square" lIns="0" rIns="0" tIns="0" bIns="0">
-            <a:spAutoFit/>
-          </a:bodyPr>
-          <a:lstStyle/>
-          <a:p>
-            <a:pPr algn="l"/>
-            <a:r>
-              <a:rPr sz="850" b="1" i="0">
+            <a:off x="640080" y="2267712"/>
+            <a:ext cx="3291840" cy="228600"/>
+          </a:xfrm>
+          <a:prstGeom prst="rect">
+            <a:avLst/>
+          </a:prstGeom>
+          <a:noFill/>
+        </p:spPr>
+        <p:txBody>
+          <a:bodyPr wrap="square" lIns="0" rIns="0" tIns="0" bIns="0">
+            <a:spAutoFit/>
+          </a:bodyPr>
+          <a:lstStyle/>
+          <a:p>
+            <a:pPr algn="l"/>
+            <a:r>
+              <a:rPr sz="950" b="1" i="0">
                 <a:solidFill>
                   <a:srgbClr val="333333"/>
                 </a:solidFill>
@@ -28995,23 +28995,23 @@
         </p:nvSpPr>
         <p:spPr>
           <a:xfrm>
-            <a:off x="3977640" y="2212848"/>
-            <a:ext cx="2286000" cy="201168"/>
-          </a:xfrm>
-          <a:prstGeom prst="rect">
-            <a:avLst/>
-          </a:prstGeom>
-          <a:noFill/>
-        </p:spPr>
-        <p:txBody>
-          <a:bodyPr wrap="square" lIns="0" rIns="0" tIns="0" bIns="0">
-            <a:spAutoFit/>
-          </a:bodyPr>
-          <a:lstStyle/>
-          <a:p>
-            <a:pPr algn="l"/>
-            <a:r>
-              <a:rPr sz="850" b="0" i="0">
+            <a:off x="3977640" y="2267712"/>
+            <a:ext cx="2286000" cy="228600"/>
+          </a:xfrm>
+          <a:prstGeom prst="rect">
+            <a:avLst/>
+          </a:prstGeom>
+          <a:noFill/>
+        </p:spPr>
+        <p:txBody>
+          <a:bodyPr wrap="square" lIns="0" rIns="0" tIns="0" bIns="0">
+            <a:spAutoFit/>
+          </a:bodyPr>
+          <a:lstStyle/>
+          <a:p>
+            <a:pPr algn="l"/>
+            <a:r>
+              <a:rPr sz="950" b="0" i="0">
                 <a:solidFill>
                   <a:srgbClr val="707070"/>
                 </a:solidFill>
@@ -29030,23 +29030,23 @@
         </p:nvSpPr>
         <p:spPr>
           <a:xfrm>
-            <a:off x="640080" y="2450592"/>
-            <a:ext cx="3291840" cy="201168"/>
-          </a:xfrm>
-          <a:prstGeom prst="rect">
-            <a:avLst/>
-          </a:prstGeom>
-          <a:noFill/>
-        </p:spPr>
-        <p:txBody>
-          <a:bodyPr wrap="square" lIns="0" rIns="0" tIns="0" bIns="0">
-            <a:spAutoFit/>
-          </a:bodyPr>
-          <a:lstStyle/>
-          <a:p>
-            <a:pPr algn="l"/>
-            <a:r>
-              <a:rPr sz="850" b="1" i="0">
+            <a:off x="640080" y="2532888"/>
+            <a:ext cx="3291840" cy="228600"/>
+          </a:xfrm>
+          <a:prstGeom prst="rect">
+            <a:avLst/>
+          </a:prstGeom>
+          <a:noFill/>
+        </p:spPr>
+        <p:txBody>
+          <a:bodyPr wrap="square" lIns="0" rIns="0" tIns="0" bIns="0">
+            <a:spAutoFit/>
+          </a:bodyPr>
+          <a:lstStyle/>
+          <a:p>
+            <a:pPr algn="l"/>
+            <a:r>
+              <a:rPr sz="950" b="1" i="0">
                 <a:solidFill>
                   <a:srgbClr val="333333"/>
                 </a:solidFill>
@@ -29065,23 +29065,23 @@
         </p:nvSpPr>
         <p:spPr>
           <a:xfrm>
-            <a:off x="3977640" y="2450592"/>
-            <a:ext cx="2286000" cy="201168"/>
-          </a:xfrm>
-          <a:prstGeom prst="rect">
-            <a:avLst/>
-          </a:prstGeom>
-          <a:noFill/>
-        </p:spPr>
-        <p:txBody>
-          <a:bodyPr wrap="square" lIns="0" rIns="0" tIns="0" bIns="0">
-            <a:spAutoFit/>
-          </a:bodyPr>
-          <a:lstStyle/>
-          <a:p>
-            <a:pPr algn="l"/>
-            <a:r>
-              <a:rPr sz="850" b="0" i="0">
+            <a:off x="3977640" y="2532888"/>
+            <a:ext cx="2286000" cy="228600"/>
+          </a:xfrm>
+          <a:prstGeom prst="rect">
+            <a:avLst/>
+          </a:prstGeom>
+          <a:noFill/>
+        </p:spPr>
+        <p:txBody>
+          <a:bodyPr wrap="square" lIns="0" rIns="0" tIns="0" bIns="0">
+            <a:spAutoFit/>
+          </a:bodyPr>
+          <a:lstStyle/>
+          <a:p>
+            <a:pPr algn="l"/>
+            <a:r>
+              <a:rPr sz="950" b="0" i="0">
                 <a:solidFill>
                   <a:srgbClr val="707070"/>
                 </a:solidFill>
@@ -29100,7 +29100,7 @@
         </p:nvSpPr>
         <p:spPr>
           <a:xfrm>
-            <a:off x="502920" y="2825496"/>
+            <a:off x="502920" y="2935224"/>
             <a:ext cx="5486400" cy="274320"/>
           </a:xfrm>
           <a:prstGeom prst="rect">
@@ -29135,23 +29135,23 @@
         </p:nvSpPr>
         <p:spPr>
           <a:xfrm>
-            <a:off x="640080" y="3145536"/>
-            <a:ext cx="3291840" cy="201168"/>
-          </a:xfrm>
-          <a:prstGeom prst="rect">
-            <a:avLst/>
-          </a:prstGeom>
-          <a:noFill/>
-        </p:spPr>
-        <p:txBody>
-          <a:bodyPr wrap="square" lIns="0" rIns="0" tIns="0" bIns="0">
-            <a:spAutoFit/>
-          </a:bodyPr>
-          <a:lstStyle/>
-          <a:p>
-            <a:pPr algn="l"/>
-            <a:r>
-              <a:rPr sz="850" b="1" i="0">
+            <a:off x="640080" y="3255264"/>
+            <a:ext cx="3291840" cy="228600"/>
+          </a:xfrm>
+          <a:prstGeom prst="rect">
+            <a:avLst/>
+          </a:prstGeom>
+          <a:noFill/>
+        </p:spPr>
+        <p:txBody>
+          <a:bodyPr wrap="square" lIns="0" rIns="0" tIns="0" bIns="0">
+            <a:spAutoFit/>
+          </a:bodyPr>
+          <a:lstStyle/>
+          <a:p>
+            <a:pPr algn="l"/>
+            <a:r>
+              <a:rPr sz="950" b="1" i="0">
                 <a:solidFill>
                   <a:srgbClr val="333333"/>
                 </a:solidFill>
@@ -29170,23 +29170,23 @@
         </p:nvSpPr>
         <p:spPr>
           <a:xfrm>
-            <a:off x="3977640" y="3145536"/>
-            <a:ext cx="2286000" cy="201168"/>
-          </a:xfrm>
-          <a:prstGeom prst="rect">
-            <a:avLst/>
-          </a:prstGeom>
-          <a:noFill/>
-        </p:spPr>
-        <p:txBody>
-          <a:bodyPr wrap="square" lIns="0" rIns="0" tIns="0" bIns="0">
-            <a:spAutoFit/>
-          </a:bodyPr>
-          <a:lstStyle/>
-          <a:p>
-            <a:pPr algn="l"/>
-            <a:r>
-              <a:rPr sz="850" b="0" i="0">
+            <a:off x="3977640" y="3255264"/>
+            <a:ext cx="2286000" cy="228600"/>
+          </a:xfrm>
+          <a:prstGeom prst="rect">
+            <a:avLst/>
+          </a:prstGeom>
+          <a:noFill/>
+        </p:spPr>
+        <p:txBody>
+          <a:bodyPr wrap="square" lIns="0" rIns="0" tIns="0" bIns="0">
+            <a:spAutoFit/>
+          </a:bodyPr>
+          <a:lstStyle/>
+          <a:p>
+            <a:pPr algn="l"/>
+            <a:r>
+              <a:rPr sz="950" b="0" i="0">
                 <a:solidFill>
                   <a:srgbClr val="707070"/>
                 </a:solidFill>
@@ -29205,23 +29205,23 @@
         </p:nvSpPr>
         <p:spPr>
           <a:xfrm>
-            <a:off x="640080" y="3383280"/>
-            <a:ext cx="3291840" cy="201168"/>
-          </a:xfrm>
-          <a:prstGeom prst="rect">
-            <a:avLst/>
-          </a:prstGeom>
-          <a:noFill/>
-        </p:spPr>
-        <p:txBody>
-          <a:bodyPr wrap="square" lIns="0" rIns="0" tIns="0" bIns="0">
-            <a:spAutoFit/>
-          </a:bodyPr>
-          <a:lstStyle/>
-          <a:p>
-            <a:pPr algn="l"/>
-            <a:r>
-              <a:rPr sz="850" b="1" i="0">
+            <a:off x="640080" y="3520440"/>
+            <a:ext cx="3291840" cy="228600"/>
+          </a:xfrm>
+          <a:prstGeom prst="rect">
+            <a:avLst/>
+          </a:prstGeom>
+          <a:noFill/>
+        </p:spPr>
+        <p:txBody>
+          <a:bodyPr wrap="square" lIns="0" rIns="0" tIns="0" bIns="0">
+            <a:spAutoFit/>
+          </a:bodyPr>
+          <a:lstStyle/>
+          <a:p>
+            <a:pPr algn="l"/>
+            <a:r>
+              <a:rPr sz="950" b="1" i="0">
                 <a:solidFill>
                   <a:srgbClr val="333333"/>
                 </a:solidFill>
@@ -29240,23 +29240,23 @@
         </p:nvSpPr>
         <p:spPr>
           <a:xfrm>
-            <a:off x="3977640" y="3383280"/>
-            <a:ext cx="2286000" cy="201168"/>
-          </a:xfrm>
-          <a:prstGeom prst="rect">
-            <a:avLst/>
-          </a:prstGeom>
-          <a:noFill/>
-        </p:spPr>
-        <p:txBody>
-          <a:bodyPr wrap="square" lIns="0" rIns="0" tIns="0" bIns="0">
-            <a:spAutoFit/>
-          </a:bodyPr>
-          <a:lstStyle/>
-          <a:p>
-            <a:pPr algn="l"/>
-            <a:r>
-              <a:rPr sz="850" b="0" i="0">
+            <a:off x="3977640" y="3520440"/>
+            <a:ext cx="2286000" cy="228600"/>
+          </a:xfrm>
+          <a:prstGeom prst="rect">
+            <a:avLst/>
+          </a:prstGeom>
+          <a:noFill/>
+        </p:spPr>
+        <p:txBody>
+          <a:bodyPr wrap="square" lIns="0" rIns="0" tIns="0" bIns="0">
+            <a:spAutoFit/>
+          </a:bodyPr>
+          <a:lstStyle/>
+          <a:p>
+            <a:pPr algn="l"/>
+            <a:r>
+              <a:rPr sz="950" b="0" i="0">
                 <a:solidFill>
                   <a:srgbClr val="707070"/>
                 </a:solidFill>
@@ -29275,23 +29275,23 @@
         </p:nvSpPr>
         <p:spPr>
           <a:xfrm>
-            <a:off x="640080" y="3621024"/>
-            <a:ext cx="3291840" cy="201168"/>
-          </a:xfrm>
-          <a:prstGeom prst="rect">
-            <a:avLst/>
-          </a:prstGeom>
-          <a:noFill/>
-        </p:spPr>
-        <p:txBody>
-          <a:bodyPr wrap="square" lIns="0" rIns="0" tIns="0" bIns="0">
-            <a:spAutoFit/>
-          </a:bodyPr>
-          <a:lstStyle/>
-          <a:p>
-            <a:pPr algn="l"/>
-            <a:r>
-              <a:rPr sz="850" b="1" i="0">
+            <a:off x="640080" y="3785616"/>
+            <a:ext cx="3291840" cy="228600"/>
+          </a:xfrm>
+          <a:prstGeom prst="rect">
+            <a:avLst/>
+          </a:prstGeom>
+          <a:noFill/>
+        </p:spPr>
+        <p:txBody>
+          <a:bodyPr wrap="square" lIns="0" rIns="0" tIns="0" bIns="0">
+            <a:spAutoFit/>
+          </a:bodyPr>
+          <a:lstStyle/>
+          <a:p>
+            <a:pPr algn="l"/>
+            <a:r>
+              <a:rPr sz="950" b="1" i="0">
                 <a:solidFill>
                   <a:srgbClr val="333333"/>
                 </a:solidFill>
@@ -29310,23 +29310,23 @@
         </p:nvSpPr>
         <p:spPr>
           <a:xfrm>
-            <a:off x="3977640" y="3621024"/>
-            <a:ext cx="2286000" cy="201168"/>
-          </a:xfrm>
-          <a:prstGeom prst="rect">
-            <a:avLst/>
-          </a:prstGeom>
-          <a:noFill/>
-        </p:spPr>
-        <p:txBody>
-          <a:bodyPr wrap="square" lIns="0" rIns="0" tIns="0" bIns="0">
-            <a:spAutoFit/>
-          </a:bodyPr>
-          <a:lstStyle/>
-          <a:p>
-            <a:pPr algn="l"/>
-            <a:r>
-              <a:rPr sz="850" b="0" i="0">
+            <a:off x="3977640" y="3785616"/>
+            <a:ext cx="2286000" cy="228600"/>
+          </a:xfrm>
+          <a:prstGeom prst="rect">
+            <a:avLst/>
+          </a:prstGeom>
+          <a:noFill/>
+        </p:spPr>
+        <p:txBody>
+          <a:bodyPr wrap="square" lIns="0" rIns="0" tIns="0" bIns="0">
+            <a:spAutoFit/>
+          </a:bodyPr>
+          <a:lstStyle/>
+          <a:p>
+            <a:pPr algn="l"/>
+            <a:r>
+              <a:rPr sz="950" b="0" i="0">
                 <a:solidFill>
                   <a:srgbClr val="707070"/>
                 </a:solidFill>
@@ -29345,23 +29345,23 @@
         </p:nvSpPr>
         <p:spPr>
           <a:xfrm>
-            <a:off x="640080" y="3858768"/>
-            <a:ext cx="3291840" cy="201168"/>
-          </a:xfrm>
-          <a:prstGeom prst="rect">
-            <a:avLst/>
-          </a:prstGeom>
-          <a:noFill/>
-        </p:spPr>
-        <p:txBody>
-          <a:bodyPr wrap="square" lIns="0" rIns="0" tIns="0" bIns="0">
-            <a:spAutoFit/>
-          </a:bodyPr>
-          <a:lstStyle/>
-          <a:p>
-            <a:pPr algn="l"/>
-            <a:r>
-              <a:rPr sz="850" b="1" i="0">
+            <a:off x="640080" y="4050792"/>
+            <a:ext cx="3291840" cy="228600"/>
+          </a:xfrm>
+          <a:prstGeom prst="rect">
+            <a:avLst/>
+          </a:prstGeom>
+          <a:noFill/>
+        </p:spPr>
+        <p:txBody>
+          <a:bodyPr wrap="square" lIns="0" rIns="0" tIns="0" bIns="0">
+            <a:spAutoFit/>
+          </a:bodyPr>
+          <a:lstStyle/>
+          <a:p>
+            <a:pPr algn="l"/>
+            <a:r>
+              <a:rPr sz="950" b="1" i="0">
                 <a:solidFill>
                   <a:srgbClr val="333333"/>
                 </a:solidFill>
@@ -29380,23 +29380,23 @@
         </p:nvSpPr>
         <p:spPr>
           <a:xfrm>
-            <a:off x="3977640" y="3858768"/>
-            <a:ext cx="2286000" cy="201168"/>
-          </a:xfrm>
-          <a:prstGeom prst="rect">
-            <a:avLst/>
-          </a:prstGeom>
-          <a:noFill/>
-        </p:spPr>
-        <p:txBody>
-          <a:bodyPr wrap="square" lIns="0" rIns="0" tIns="0" bIns="0">
-            <a:spAutoFit/>
-          </a:bodyPr>
-          <a:lstStyle/>
-          <a:p>
-            <a:pPr algn="l"/>
-            <a:r>
-              <a:rPr sz="850" b="0" i="0">
+            <a:off x="3977640" y="4050792"/>
+            <a:ext cx="2286000" cy="228600"/>
+          </a:xfrm>
+          <a:prstGeom prst="rect">
+            <a:avLst/>
+          </a:prstGeom>
+          <a:noFill/>
+        </p:spPr>
+        <p:txBody>
+          <a:bodyPr wrap="square" lIns="0" rIns="0" tIns="0" bIns="0">
+            <a:spAutoFit/>
+          </a:bodyPr>
+          <a:lstStyle/>
+          <a:p>
+            <a:pPr algn="l"/>
+            <a:r>
+              <a:rPr sz="950" b="0" i="0">
                 <a:solidFill>
                   <a:srgbClr val="707070"/>
                 </a:solidFill>
@@ -29415,23 +29415,23 @@
         </p:nvSpPr>
         <p:spPr>
           <a:xfrm>
-            <a:off x="640080" y="4096512"/>
-            <a:ext cx="3291840" cy="201168"/>
-          </a:xfrm>
-          <a:prstGeom prst="rect">
-            <a:avLst/>
-          </a:prstGeom>
-          <a:noFill/>
-        </p:spPr>
-        <p:txBody>
-          <a:bodyPr wrap="square" lIns="0" rIns="0" tIns="0" bIns="0">
-            <a:spAutoFit/>
-          </a:bodyPr>
-          <a:lstStyle/>
-          <a:p>
-            <a:pPr algn="l"/>
-            <a:r>
-              <a:rPr sz="850" b="1" i="0">
+            <a:off x="640080" y="4315968"/>
+            <a:ext cx="3291840" cy="228600"/>
+          </a:xfrm>
+          <a:prstGeom prst="rect">
+            <a:avLst/>
+          </a:prstGeom>
+          <a:noFill/>
+        </p:spPr>
+        <p:txBody>
+          <a:bodyPr wrap="square" lIns="0" rIns="0" tIns="0" bIns="0">
+            <a:spAutoFit/>
+          </a:bodyPr>
+          <a:lstStyle/>
+          <a:p>
+            <a:pPr algn="l"/>
+            <a:r>
+              <a:rPr sz="950" b="1" i="0">
                 <a:solidFill>
                   <a:srgbClr val="333333"/>
                 </a:solidFill>
@@ -29450,23 +29450,23 @@
         </p:nvSpPr>
         <p:spPr>
           <a:xfrm>
-            <a:off x="3977640" y="4096512"/>
-            <a:ext cx="2286000" cy="201168"/>
-          </a:xfrm>
-          <a:prstGeom prst="rect">
-            <a:avLst/>
-          </a:prstGeom>
-          <a:noFill/>
-        </p:spPr>
-        <p:txBody>
-          <a:bodyPr wrap="square" lIns="0" rIns="0" tIns="0" bIns="0">
-            <a:spAutoFit/>
-          </a:bodyPr>
-          <a:lstStyle/>
-          <a:p>
-            <a:pPr algn="l"/>
-            <a:r>
-              <a:rPr sz="850" b="0" i="0">
+            <a:off x="3977640" y="4315968"/>
+            <a:ext cx="2286000" cy="228600"/>
+          </a:xfrm>
+          <a:prstGeom prst="rect">
+            <a:avLst/>
+          </a:prstGeom>
+          <a:noFill/>
+        </p:spPr>
+        <p:txBody>
+          <a:bodyPr wrap="square" lIns="0" rIns="0" tIns="0" bIns="0">
+            <a:spAutoFit/>
+          </a:bodyPr>
+          <a:lstStyle/>
+          <a:p>
+            <a:pPr algn="l"/>
+            <a:r>
+              <a:rPr sz="950" b="0" i="0">
                 <a:solidFill>
                   <a:srgbClr val="707070"/>
                 </a:solidFill>
@@ -29485,23 +29485,23 @@
         </p:nvSpPr>
         <p:spPr>
           <a:xfrm>
-            <a:off x="640080" y="4334256"/>
-            <a:ext cx="3291840" cy="201168"/>
-          </a:xfrm>
-          <a:prstGeom prst="rect">
-            <a:avLst/>
-          </a:prstGeom>
-          <a:noFill/>
-        </p:spPr>
-        <p:txBody>
-          <a:bodyPr wrap="square" lIns="0" rIns="0" tIns="0" bIns="0">
-            <a:spAutoFit/>
-          </a:bodyPr>
-          <a:lstStyle/>
-          <a:p>
-            <a:pPr algn="l"/>
-            <a:r>
-              <a:rPr sz="850" b="1" i="0">
+            <a:off x="640080" y="4581144"/>
+            <a:ext cx="3291840" cy="228600"/>
+          </a:xfrm>
+          <a:prstGeom prst="rect">
+            <a:avLst/>
+          </a:prstGeom>
+          <a:noFill/>
+        </p:spPr>
+        <p:txBody>
+          <a:bodyPr wrap="square" lIns="0" rIns="0" tIns="0" bIns="0">
+            <a:spAutoFit/>
+          </a:bodyPr>
+          <a:lstStyle/>
+          <a:p>
+            <a:pPr algn="l"/>
+            <a:r>
+              <a:rPr sz="950" b="1" i="0">
                 <a:solidFill>
                   <a:srgbClr val="333333"/>
                 </a:solidFill>
@@ -29520,23 +29520,23 @@
         </p:nvSpPr>
         <p:spPr>
           <a:xfrm>
-            <a:off x="3977640" y="4334256"/>
-            <a:ext cx="2286000" cy="201168"/>
-          </a:xfrm>
-          <a:prstGeom prst="rect">
-            <a:avLst/>
-          </a:prstGeom>
-          <a:noFill/>
-        </p:spPr>
-        <p:txBody>
-          <a:bodyPr wrap="square" lIns="0" rIns="0" tIns="0" bIns="0">
-            <a:spAutoFit/>
-          </a:bodyPr>
-          <a:lstStyle/>
-          <a:p>
-            <a:pPr algn="l"/>
-            <a:r>
-              <a:rPr sz="850" b="0" i="0">
+            <a:off x="3977640" y="4581144"/>
+            <a:ext cx="2286000" cy="228600"/>
+          </a:xfrm>
+          <a:prstGeom prst="rect">
+            <a:avLst/>
+          </a:prstGeom>
+          <a:noFill/>
+        </p:spPr>
+        <p:txBody>
+          <a:bodyPr wrap="square" lIns="0" rIns="0" tIns="0" bIns="0">
+            <a:spAutoFit/>
+          </a:bodyPr>
+          <a:lstStyle/>
+          <a:p>
+            <a:pPr algn="l"/>
+            <a:r>
+              <a:rPr sz="950" b="0" i="0">
                 <a:solidFill>
                   <a:srgbClr val="707070"/>
                 </a:solidFill>
@@ -29591,22 +29591,22 @@
         <p:spPr>
           <a:xfrm>
             <a:off x="6629400" y="1737360"/>
-            <a:ext cx="3291840" cy="201168"/>
-          </a:xfrm>
-          <a:prstGeom prst="rect">
-            <a:avLst/>
-          </a:prstGeom>
-          <a:noFill/>
-        </p:spPr>
-        <p:txBody>
-          <a:bodyPr wrap="square" lIns="0" rIns="0" tIns="0" bIns="0">
-            <a:spAutoFit/>
-          </a:bodyPr>
-          <a:lstStyle/>
-          <a:p>
-            <a:pPr algn="l"/>
-            <a:r>
-              <a:rPr sz="850" b="1" i="0">
+            <a:ext cx="3291840" cy="228600"/>
+          </a:xfrm>
+          <a:prstGeom prst="rect">
+            <a:avLst/>
+          </a:prstGeom>
+          <a:noFill/>
+        </p:spPr>
+        <p:txBody>
+          <a:bodyPr wrap="square" lIns="0" rIns="0" tIns="0" bIns="0">
+            <a:spAutoFit/>
+          </a:bodyPr>
+          <a:lstStyle/>
+          <a:p>
+            <a:pPr algn="l"/>
+            <a:r>
+              <a:rPr sz="950" b="1" i="0">
                 <a:solidFill>
                   <a:srgbClr val="333333"/>
                 </a:solidFill>
@@ -29626,22 +29626,22 @@
         <p:spPr>
           <a:xfrm>
             <a:off x="9966960" y="1737360"/>
-            <a:ext cx="2286000" cy="201168"/>
-          </a:xfrm>
-          <a:prstGeom prst="rect">
-            <a:avLst/>
-          </a:prstGeom>
-          <a:noFill/>
-        </p:spPr>
-        <p:txBody>
-          <a:bodyPr wrap="square" lIns="0" rIns="0" tIns="0" bIns="0">
-            <a:spAutoFit/>
-          </a:bodyPr>
-          <a:lstStyle/>
-          <a:p>
-            <a:pPr algn="l"/>
-            <a:r>
-              <a:rPr sz="850" b="0" i="0">
+            <a:ext cx="2286000" cy="228600"/>
+          </a:xfrm>
+          <a:prstGeom prst="rect">
+            <a:avLst/>
+          </a:prstGeom>
+          <a:noFill/>
+        </p:spPr>
+        <p:txBody>
+          <a:bodyPr wrap="square" lIns="0" rIns="0" tIns="0" bIns="0">
+            <a:spAutoFit/>
+          </a:bodyPr>
+          <a:lstStyle/>
+          <a:p>
+            <a:pPr algn="l"/>
+            <a:r>
+              <a:rPr sz="950" b="0" i="0">
                 <a:solidFill>
                   <a:srgbClr val="707070"/>
                 </a:solidFill>
@@ -29660,23 +29660,23 @@
         </p:nvSpPr>
         <p:spPr>
           <a:xfrm>
-            <a:off x="6629400" y="1975104"/>
-            <a:ext cx="3291840" cy="201168"/>
-          </a:xfrm>
-          <a:prstGeom prst="rect">
-            <a:avLst/>
-          </a:prstGeom>
-          <a:noFill/>
-        </p:spPr>
-        <p:txBody>
-          <a:bodyPr wrap="square" lIns="0" rIns="0" tIns="0" bIns="0">
-            <a:spAutoFit/>
-          </a:bodyPr>
-          <a:lstStyle/>
-          <a:p>
-            <a:pPr algn="l"/>
-            <a:r>
-              <a:rPr sz="850" b="1" i="0">
+            <a:off x="6629400" y="2002536"/>
+            <a:ext cx="3291840" cy="228600"/>
+          </a:xfrm>
+          <a:prstGeom prst="rect">
+            <a:avLst/>
+          </a:prstGeom>
+          <a:noFill/>
+        </p:spPr>
+        <p:txBody>
+          <a:bodyPr wrap="square" lIns="0" rIns="0" tIns="0" bIns="0">
+            <a:spAutoFit/>
+          </a:bodyPr>
+          <a:lstStyle/>
+          <a:p>
+            <a:pPr algn="l"/>
+            <a:r>
+              <a:rPr sz="950" b="1" i="0">
                 <a:solidFill>
                   <a:srgbClr val="333333"/>
                 </a:solidFill>
@@ -29695,23 +29695,23 @@
         </p:nvSpPr>
         <p:spPr>
           <a:xfrm>
-            <a:off x="9966960" y="1975104"/>
-            <a:ext cx="2286000" cy="201168"/>
-          </a:xfrm>
-          <a:prstGeom prst="rect">
-            <a:avLst/>
-          </a:prstGeom>
-          <a:noFill/>
-        </p:spPr>
-        <p:txBody>
-          <a:bodyPr wrap="square" lIns="0" rIns="0" tIns="0" bIns="0">
-            <a:spAutoFit/>
-          </a:bodyPr>
-          <a:lstStyle/>
-          <a:p>
-            <a:pPr algn="l"/>
-            <a:r>
-              <a:rPr sz="850" b="0" i="0">
+            <a:off x="9966960" y="2002536"/>
+            <a:ext cx="2286000" cy="228600"/>
+          </a:xfrm>
+          <a:prstGeom prst="rect">
+            <a:avLst/>
+          </a:prstGeom>
+          <a:noFill/>
+        </p:spPr>
+        <p:txBody>
+          <a:bodyPr wrap="square" lIns="0" rIns="0" tIns="0" bIns="0">
+            <a:spAutoFit/>
+          </a:bodyPr>
+          <a:lstStyle/>
+          <a:p>
+            <a:pPr algn="l"/>
+            <a:r>
+              <a:rPr sz="950" b="0" i="0">
                 <a:solidFill>
                   <a:srgbClr val="707070"/>
                 </a:solidFill>
@@ -29730,23 +29730,23 @@
         </p:nvSpPr>
         <p:spPr>
           <a:xfrm>
-            <a:off x="6629400" y="2212848"/>
-            <a:ext cx="3291840" cy="201168"/>
-          </a:xfrm>
-          <a:prstGeom prst="rect">
-            <a:avLst/>
-          </a:prstGeom>
-          <a:noFill/>
-        </p:spPr>
-        <p:txBody>
-          <a:bodyPr wrap="square" lIns="0" rIns="0" tIns="0" bIns="0">
-            <a:spAutoFit/>
-          </a:bodyPr>
-          <a:lstStyle/>
-          <a:p>
-            <a:pPr algn="l"/>
-            <a:r>
-              <a:rPr sz="850" b="1" i="0">
+            <a:off x="6629400" y="2267712"/>
+            <a:ext cx="3291840" cy="228600"/>
+          </a:xfrm>
+          <a:prstGeom prst="rect">
+            <a:avLst/>
+          </a:prstGeom>
+          <a:noFill/>
+        </p:spPr>
+        <p:txBody>
+          <a:bodyPr wrap="square" lIns="0" rIns="0" tIns="0" bIns="0">
+            <a:spAutoFit/>
+          </a:bodyPr>
+          <a:lstStyle/>
+          <a:p>
+            <a:pPr algn="l"/>
+            <a:r>
+              <a:rPr sz="950" b="1" i="0">
                 <a:solidFill>
                   <a:srgbClr val="333333"/>
                 </a:solidFill>
@@ -29765,23 +29765,23 @@
         </p:nvSpPr>
         <p:spPr>
           <a:xfrm>
-            <a:off x="9966960" y="2212848"/>
-            <a:ext cx="2286000" cy="201168"/>
-          </a:xfrm>
-          <a:prstGeom prst="rect">
-            <a:avLst/>
-          </a:prstGeom>
-          <a:noFill/>
-        </p:spPr>
-        <p:txBody>
-          <a:bodyPr wrap="square" lIns="0" rIns="0" tIns="0" bIns="0">
-            <a:spAutoFit/>
-          </a:bodyPr>
-          <a:lstStyle/>
-          <a:p>
-            <a:pPr algn="l"/>
-            <a:r>
-              <a:rPr sz="850" b="0" i="0">
+            <a:off x="9966960" y="2267712"/>
+            <a:ext cx="2286000" cy="228600"/>
+          </a:xfrm>
+          <a:prstGeom prst="rect">
+            <a:avLst/>
+          </a:prstGeom>
+          <a:noFill/>
+        </p:spPr>
+        <p:txBody>
+          <a:bodyPr wrap="square" lIns="0" rIns="0" tIns="0" bIns="0">
+            <a:spAutoFit/>
+          </a:bodyPr>
+          <a:lstStyle/>
+          <a:p>
+            <a:pPr algn="l"/>
+            <a:r>
+              <a:rPr sz="950" b="0" i="0">
                 <a:solidFill>
                   <a:srgbClr val="707070"/>
                 </a:solidFill>
@@ -29800,23 +29800,23 @@
         </p:nvSpPr>
         <p:spPr>
           <a:xfrm>
-            <a:off x="6629400" y="2450592"/>
-            <a:ext cx="3291840" cy="201168"/>
-          </a:xfrm>
-          <a:prstGeom prst="rect">
-            <a:avLst/>
-          </a:prstGeom>
-          <a:noFill/>
-        </p:spPr>
-        <p:txBody>
-          <a:bodyPr wrap="square" lIns="0" rIns="0" tIns="0" bIns="0">
-            <a:spAutoFit/>
-          </a:bodyPr>
-          <a:lstStyle/>
-          <a:p>
-            <a:pPr algn="l"/>
-            <a:r>
-              <a:rPr sz="850" b="1" i="0">
+            <a:off x="6629400" y="2532888"/>
+            <a:ext cx="3291840" cy="228600"/>
+          </a:xfrm>
+          <a:prstGeom prst="rect">
+            <a:avLst/>
+          </a:prstGeom>
+          <a:noFill/>
+        </p:spPr>
+        <p:txBody>
+          <a:bodyPr wrap="square" lIns="0" rIns="0" tIns="0" bIns="0">
+            <a:spAutoFit/>
+          </a:bodyPr>
+          <a:lstStyle/>
+          <a:p>
+            <a:pPr algn="l"/>
+            <a:r>
+              <a:rPr sz="950" b="1" i="0">
                 <a:solidFill>
                   <a:srgbClr val="333333"/>
                 </a:solidFill>
@@ -29835,23 +29835,23 @@
         </p:nvSpPr>
         <p:spPr>
           <a:xfrm>
-            <a:off x="9966960" y="2450592"/>
-            <a:ext cx="2286000" cy="201168"/>
-          </a:xfrm>
-          <a:prstGeom prst="rect">
-            <a:avLst/>
-          </a:prstGeom>
-          <a:noFill/>
-        </p:spPr>
-        <p:txBody>
-          <a:bodyPr wrap="square" lIns="0" rIns="0" tIns="0" bIns="0">
-            <a:spAutoFit/>
-          </a:bodyPr>
-          <a:lstStyle/>
-          <a:p>
-            <a:pPr algn="l"/>
-            <a:r>
-              <a:rPr sz="850" b="0" i="0">
+            <a:off x="9966960" y="2532888"/>
+            <a:ext cx="2286000" cy="228600"/>
+          </a:xfrm>
+          <a:prstGeom prst="rect">
+            <a:avLst/>
+          </a:prstGeom>
+          <a:noFill/>
+        </p:spPr>
+        <p:txBody>
+          <a:bodyPr wrap="square" lIns="0" rIns="0" tIns="0" bIns="0">
+            <a:spAutoFit/>
+          </a:bodyPr>
+          <a:lstStyle/>
+          <a:p>
+            <a:pPr algn="l"/>
+            <a:r>
+              <a:rPr sz="950" b="0" i="0">
                 <a:solidFill>
                   <a:srgbClr val="707070"/>
                 </a:solidFill>
@@ -29870,23 +29870,23 @@
         </p:nvSpPr>
         <p:spPr>
           <a:xfrm>
-            <a:off x="6629400" y="2688336"/>
-            <a:ext cx="3291840" cy="201168"/>
-          </a:xfrm>
-          <a:prstGeom prst="rect">
-            <a:avLst/>
-          </a:prstGeom>
-          <a:noFill/>
-        </p:spPr>
-        <p:txBody>
-          <a:bodyPr wrap="square" lIns="0" rIns="0" tIns="0" bIns="0">
-            <a:spAutoFit/>
-          </a:bodyPr>
-          <a:lstStyle/>
-          <a:p>
-            <a:pPr algn="l"/>
-            <a:r>
-              <a:rPr sz="850" b="1" i="0">
+            <a:off x="6629400" y="2798064"/>
+            <a:ext cx="3291840" cy="228600"/>
+          </a:xfrm>
+          <a:prstGeom prst="rect">
+            <a:avLst/>
+          </a:prstGeom>
+          <a:noFill/>
+        </p:spPr>
+        <p:txBody>
+          <a:bodyPr wrap="square" lIns="0" rIns="0" tIns="0" bIns="0">
+            <a:spAutoFit/>
+          </a:bodyPr>
+          <a:lstStyle/>
+          <a:p>
+            <a:pPr algn="l"/>
+            <a:r>
+              <a:rPr sz="950" b="1" i="0">
                 <a:solidFill>
                   <a:srgbClr val="333333"/>
                 </a:solidFill>
@@ -29905,23 +29905,23 @@
         </p:nvSpPr>
         <p:spPr>
           <a:xfrm>
-            <a:off x="9966960" y="2688336"/>
-            <a:ext cx="2286000" cy="201168"/>
-          </a:xfrm>
-          <a:prstGeom prst="rect">
-            <a:avLst/>
-          </a:prstGeom>
-          <a:noFill/>
-        </p:spPr>
-        <p:txBody>
-          <a:bodyPr wrap="square" lIns="0" rIns="0" tIns="0" bIns="0">
-            <a:spAutoFit/>
-          </a:bodyPr>
-          <a:lstStyle/>
-          <a:p>
-            <a:pPr algn="l"/>
-            <a:r>
-              <a:rPr sz="850" b="0" i="0">
+            <a:off x="9966960" y="2798064"/>
+            <a:ext cx="2286000" cy="228600"/>
+          </a:xfrm>
+          <a:prstGeom prst="rect">
+            <a:avLst/>
+          </a:prstGeom>
+          <a:noFill/>
+        </p:spPr>
+        <p:txBody>
+          <a:bodyPr wrap="square" lIns="0" rIns="0" tIns="0" bIns="0">
+            <a:spAutoFit/>
+          </a:bodyPr>
+          <a:lstStyle/>
+          <a:p>
+            <a:pPr algn="l"/>
+            <a:r>
+              <a:rPr sz="950" b="0" i="0">
                 <a:solidFill>
                   <a:srgbClr val="707070"/>
                 </a:solidFill>
@@ -29940,23 +29940,23 @@
         </p:nvSpPr>
         <p:spPr>
           <a:xfrm>
-            <a:off x="6629400" y="2926080"/>
-            <a:ext cx="3291840" cy="201168"/>
-          </a:xfrm>
-          <a:prstGeom prst="rect">
-            <a:avLst/>
-          </a:prstGeom>
-          <a:noFill/>
-        </p:spPr>
-        <p:txBody>
-          <a:bodyPr wrap="square" lIns="0" rIns="0" tIns="0" bIns="0">
-            <a:spAutoFit/>
-          </a:bodyPr>
-          <a:lstStyle/>
-          <a:p>
-            <a:pPr algn="l"/>
-            <a:r>
-              <a:rPr sz="850" b="1" i="0">
+            <a:off x="6629400" y="3063240"/>
+            <a:ext cx="3291840" cy="228600"/>
+          </a:xfrm>
+          <a:prstGeom prst="rect">
+            <a:avLst/>
+          </a:prstGeom>
+          <a:noFill/>
+        </p:spPr>
+        <p:txBody>
+          <a:bodyPr wrap="square" lIns="0" rIns="0" tIns="0" bIns="0">
+            <a:spAutoFit/>
+          </a:bodyPr>
+          <a:lstStyle/>
+          <a:p>
+            <a:pPr algn="l"/>
+            <a:r>
+              <a:rPr sz="950" b="1" i="0">
                 <a:solidFill>
                   <a:srgbClr val="333333"/>
                 </a:solidFill>
@@ -29975,23 +29975,23 @@
         </p:nvSpPr>
         <p:spPr>
           <a:xfrm>
-            <a:off x="9966960" y="2926080"/>
-            <a:ext cx="2286000" cy="201168"/>
-          </a:xfrm>
-          <a:prstGeom prst="rect">
-            <a:avLst/>
-          </a:prstGeom>
-          <a:noFill/>
-        </p:spPr>
-        <p:txBody>
-          <a:bodyPr wrap="square" lIns="0" rIns="0" tIns="0" bIns="0">
-            <a:spAutoFit/>
-          </a:bodyPr>
-          <a:lstStyle/>
-          <a:p>
-            <a:pPr algn="l"/>
-            <a:r>
-              <a:rPr sz="850" b="0" i="0">
+            <a:off x="9966960" y="3063240"/>
+            <a:ext cx="2286000" cy="228600"/>
+          </a:xfrm>
+          <a:prstGeom prst="rect">
+            <a:avLst/>
+          </a:prstGeom>
+          <a:noFill/>
+        </p:spPr>
+        <p:txBody>
+          <a:bodyPr wrap="square" lIns="0" rIns="0" tIns="0" bIns="0">
+            <a:spAutoFit/>
+          </a:bodyPr>
+          <a:lstStyle/>
+          <a:p>
+            <a:pPr algn="l"/>
+            <a:r>
+              <a:rPr sz="950" b="0" i="0">
                 <a:solidFill>
                   <a:srgbClr val="707070"/>
                 </a:solidFill>
@@ -30010,7 +30010,7 @@
         </p:nvSpPr>
         <p:spPr>
           <a:xfrm>
-            <a:off x="6492240" y="3300984"/>
+            <a:off x="6492240" y="3465576"/>
             <a:ext cx="5486400" cy="274320"/>
           </a:xfrm>
           <a:prstGeom prst="rect">
@@ -30045,23 +30045,23 @@
         </p:nvSpPr>
         <p:spPr>
           <a:xfrm>
-            <a:off x="6629400" y="3621024"/>
-            <a:ext cx="3291840" cy="201168"/>
-          </a:xfrm>
-          <a:prstGeom prst="rect">
-            <a:avLst/>
-          </a:prstGeom>
-          <a:noFill/>
-        </p:spPr>
-        <p:txBody>
-          <a:bodyPr wrap="square" lIns="0" rIns="0" tIns="0" bIns="0">
-            <a:spAutoFit/>
-          </a:bodyPr>
-          <a:lstStyle/>
-          <a:p>
-            <a:pPr algn="l"/>
-            <a:r>
-              <a:rPr sz="850" b="1" i="0">
+            <a:off x="6629400" y="3785616"/>
+            <a:ext cx="3291840" cy="228600"/>
+          </a:xfrm>
+          <a:prstGeom prst="rect">
+            <a:avLst/>
+          </a:prstGeom>
+          <a:noFill/>
+        </p:spPr>
+        <p:txBody>
+          <a:bodyPr wrap="square" lIns="0" rIns="0" tIns="0" bIns="0">
+            <a:spAutoFit/>
+          </a:bodyPr>
+          <a:lstStyle/>
+          <a:p>
+            <a:pPr algn="l"/>
+            <a:r>
+              <a:rPr sz="950" b="1" i="0">
                 <a:solidFill>
                   <a:srgbClr val="333333"/>
                 </a:solidFill>
@@ -30080,23 +30080,23 @@
         </p:nvSpPr>
         <p:spPr>
           <a:xfrm>
-            <a:off x="9966960" y="3621024"/>
-            <a:ext cx="2286000" cy="201168"/>
-          </a:xfrm>
-          <a:prstGeom prst="rect">
-            <a:avLst/>
-          </a:prstGeom>
-          <a:noFill/>
-        </p:spPr>
-        <p:txBody>
-          <a:bodyPr wrap="square" lIns="0" rIns="0" tIns="0" bIns="0">
-            <a:spAutoFit/>
-          </a:bodyPr>
-          <a:lstStyle/>
-          <a:p>
-            <a:pPr algn="l"/>
-            <a:r>
-              <a:rPr sz="850" b="0" i="0">
+            <a:off x="9966960" y="3785616"/>
+            <a:ext cx="2286000" cy="228600"/>
+          </a:xfrm>
+          <a:prstGeom prst="rect">
+            <a:avLst/>
+          </a:prstGeom>
+          <a:noFill/>
+        </p:spPr>
+        <p:txBody>
+          <a:bodyPr wrap="square" lIns="0" rIns="0" tIns="0" bIns="0">
+            <a:spAutoFit/>
+          </a:bodyPr>
+          <a:lstStyle/>
+          <a:p>
+            <a:pPr algn="l"/>
+            <a:r>
+              <a:rPr sz="950" b="0" i="0">
                 <a:solidFill>
                   <a:srgbClr val="707070"/>
                 </a:solidFill>
@@ -30115,23 +30115,23 @@
         </p:nvSpPr>
         <p:spPr>
           <a:xfrm>
-            <a:off x="6629400" y="3858768"/>
-            <a:ext cx="3291840" cy="201168"/>
-          </a:xfrm>
-          <a:prstGeom prst="rect">
-            <a:avLst/>
-          </a:prstGeom>
-          <a:noFill/>
-        </p:spPr>
-        <p:txBody>
-          <a:bodyPr wrap="square" lIns="0" rIns="0" tIns="0" bIns="0">
-            <a:spAutoFit/>
-          </a:bodyPr>
-          <a:lstStyle/>
-          <a:p>
-            <a:pPr algn="l"/>
-            <a:r>
-              <a:rPr sz="850" b="1" i="0">
+            <a:off x="6629400" y="4050792"/>
+            <a:ext cx="3291840" cy="228600"/>
+          </a:xfrm>
+          <a:prstGeom prst="rect">
+            <a:avLst/>
+          </a:prstGeom>
+          <a:noFill/>
+        </p:spPr>
+        <p:txBody>
+          <a:bodyPr wrap="square" lIns="0" rIns="0" tIns="0" bIns="0">
+            <a:spAutoFit/>
+          </a:bodyPr>
+          <a:lstStyle/>
+          <a:p>
+            <a:pPr algn="l"/>
+            <a:r>
+              <a:rPr sz="950" b="1" i="0">
                 <a:solidFill>
                   <a:srgbClr val="333333"/>
                 </a:solidFill>
@@ -30150,23 +30150,23 @@
         </p:nvSpPr>
         <p:spPr>
           <a:xfrm>
-            <a:off x="9966960" y="3858768"/>
-            <a:ext cx="2286000" cy="201168"/>
-          </a:xfrm>
-          <a:prstGeom prst="rect">
-            <a:avLst/>
-          </a:prstGeom>
-          <a:noFill/>
-        </p:spPr>
-        <p:txBody>
-          <a:bodyPr wrap="square" lIns="0" rIns="0" tIns="0" bIns="0">
-            <a:spAutoFit/>
-          </a:bodyPr>
-          <a:lstStyle/>
-          <a:p>
-            <a:pPr algn="l"/>
-            <a:r>
-              <a:rPr sz="850" b="0" i="0">
+            <a:off x="9966960" y="4050792"/>
+            <a:ext cx="2286000" cy="228600"/>
+          </a:xfrm>
+          <a:prstGeom prst="rect">
+            <a:avLst/>
+          </a:prstGeom>
+          <a:noFill/>
+        </p:spPr>
+        <p:txBody>
+          <a:bodyPr wrap="square" lIns="0" rIns="0" tIns="0" bIns="0">
+            <a:spAutoFit/>
+          </a:bodyPr>
+          <a:lstStyle/>
+          <a:p>
+            <a:pPr algn="l"/>
+            <a:r>
+              <a:rPr sz="950" b="0" i="0">
                 <a:solidFill>
                   <a:srgbClr val="707070"/>
                 </a:solidFill>
@@ -30185,23 +30185,23 @@
         </p:nvSpPr>
         <p:spPr>
           <a:xfrm>
-            <a:off x="6629400" y="4096512"/>
-            <a:ext cx="3291840" cy="201168"/>
-          </a:xfrm>
-          <a:prstGeom prst="rect">
-            <a:avLst/>
-          </a:prstGeom>
-          <a:noFill/>
-        </p:spPr>
-        <p:txBody>
-          <a:bodyPr wrap="square" lIns="0" rIns="0" tIns="0" bIns="0">
-            <a:spAutoFit/>
-          </a:bodyPr>
-          <a:lstStyle/>
-          <a:p>
-            <a:pPr algn="l"/>
-            <a:r>
-              <a:rPr sz="850" b="1" i="0">
+            <a:off x="6629400" y="4315968"/>
+            <a:ext cx="3291840" cy="228600"/>
+          </a:xfrm>
+          <a:prstGeom prst="rect">
+            <a:avLst/>
+          </a:prstGeom>
+          <a:noFill/>
+        </p:spPr>
+        <p:txBody>
+          <a:bodyPr wrap="square" lIns="0" rIns="0" tIns="0" bIns="0">
+            <a:spAutoFit/>
+          </a:bodyPr>
+          <a:lstStyle/>
+          <a:p>
+            <a:pPr algn="l"/>
+            <a:r>
+              <a:rPr sz="950" b="1" i="0">
                 <a:solidFill>
                   <a:srgbClr val="333333"/>
                 </a:solidFill>
@@ -30220,23 +30220,23 @@
         </p:nvSpPr>
         <p:spPr>
           <a:xfrm>
-            <a:off x="9966960" y="4096512"/>
-            <a:ext cx="2286000" cy="201168"/>
-          </a:xfrm>
-          <a:prstGeom prst="rect">
-            <a:avLst/>
-          </a:prstGeom>
-          <a:noFill/>
-        </p:spPr>
-        <p:txBody>
-          <a:bodyPr wrap="square" lIns="0" rIns="0" tIns="0" bIns="0">
-            <a:spAutoFit/>
-          </a:bodyPr>
-          <a:lstStyle/>
-          <a:p>
-            <a:pPr algn="l"/>
-            <a:r>
-              <a:rPr sz="850" b="0" i="0">
+            <a:off x="9966960" y="4315968"/>
+            <a:ext cx="2286000" cy="228600"/>
+          </a:xfrm>
+          <a:prstGeom prst="rect">
+            <a:avLst/>
+          </a:prstGeom>
+          <a:noFill/>
+        </p:spPr>
+        <p:txBody>
+          <a:bodyPr wrap="square" lIns="0" rIns="0" tIns="0" bIns="0">
+            <a:spAutoFit/>
+          </a:bodyPr>
+          <a:lstStyle/>
+          <a:p>
+            <a:pPr algn="l"/>
+            <a:r>
+              <a:rPr sz="950" b="0" i="0">
                 <a:solidFill>
                   <a:srgbClr val="707070"/>
                 </a:solidFill>
@@ -30255,23 +30255,23 @@
         </p:nvSpPr>
         <p:spPr>
           <a:xfrm>
-            <a:off x="6629400" y="4334256"/>
-            <a:ext cx="3291840" cy="201168"/>
-          </a:xfrm>
-          <a:prstGeom prst="rect">
-            <a:avLst/>
-          </a:prstGeom>
-          <a:noFill/>
-        </p:spPr>
-        <p:txBody>
-          <a:bodyPr wrap="square" lIns="0" rIns="0" tIns="0" bIns="0">
-            <a:spAutoFit/>
-          </a:bodyPr>
-          <a:lstStyle/>
-          <a:p>
-            <a:pPr algn="l"/>
-            <a:r>
-              <a:rPr sz="850" b="1" i="0">
+            <a:off x="6629400" y="4581144"/>
+            <a:ext cx="3291840" cy="228600"/>
+          </a:xfrm>
+          <a:prstGeom prst="rect">
+            <a:avLst/>
+          </a:prstGeom>
+          <a:noFill/>
+        </p:spPr>
+        <p:txBody>
+          <a:bodyPr wrap="square" lIns="0" rIns="0" tIns="0" bIns="0">
+            <a:spAutoFit/>
+          </a:bodyPr>
+          <a:lstStyle/>
+          <a:p>
+            <a:pPr algn="l"/>
+            <a:r>
+              <a:rPr sz="950" b="1" i="0">
                 <a:solidFill>
                   <a:srgbClr val="333333"/>
                 </a:solidFill>
@@ -30290,23 +30290,23 @@
         </p:nvSpPr>
         <p:spPr>
           <a:xfrm>
-            <a:off x="9966960" y="4334256"/>
-            <a:ext cx="2286000" cy="201168"/>
-          </a:xfrm>
-          <a:prstGeom prst="rect">
-            <a:avLst/>
-          </a:prstGeom>
-          <a:noFill/>
-        </p:spPr>
-        <p:txBody>
-          <a:bodyPr wrap="square" lIns="0" rIns="0" tIns="0" bIns="0">
-            <a:spAutoFit/>
-          </a:bodyPr>
-          <a:lstStyle/>
-          <a:p>
-            <a:pPr algn="l"/>
-            <a:r>
-              <a:rPr sz="850" b="0" i="0">
+            <a:off x="9966960" y="4581144"/>
+            <a:ext cx="2286000" cy="228600"/>
+          </a:xfrm>
+          <a:prstGeom prst="rect">
+            <a:avLst/>
+          </a:prstGeom>
+          <a:noFill/>
+        </p:spPr>
+        <p:txBody>
+          <a:bodyPr wrap="square" lIns="0" rIns="0" tIns="0" bIns="0">
+            <a:spAutoFit/>
+          </a:bodyPr>
+          <a:lstStyle/>
+          <a:p>
+            <a:pPr algn="l"/>
+            <a:r>
+              <a:rPr sz="950" b="0" i="0">
                 <a:solidFill>
                   <a:srgbClr val="707070"/>
                 </a:solidFill>
@@ -30325,23 +30325,23 @@
         </p:nvSpPr>
         <p:spPr>
           <a:xfrm>
-            <a:off x="6629400" y="4572000"/>
-            <a:ext cx="3291840" cy="201168"/>
-          </a:xfrm>
-          <a:prstGeom prst="rect">
-            <a:avLst/>
-          </a:prstGeom>
-          <a:noFill/>
-        </p:spPr>
-        <p:txBody>
-          <a:bodyPr wrap="square" lIns="0" rIns="0" tIns="0" bIns="0">
-            <a:spAutoFit/>
-          </a:bodyPr>
-          <a:lstStyle/>
-          <a:p>
-            <a:pPr algn="l"/>
-            <a:r>
-              <a:rPr sz="850" b="1" i="0">
+            <a:off x="6629400" y="4846320"/>
+            <a:ext cx="3291840" cy="228600"/>
+          </a:xfrm>
+          <a:prstGeom prst="rect">
+            <a:avLst/>
+          </a:prstGeom>
+          <a:noFill/>
+        </p:spPr>
+        <p:txBody>
+          <a:bodyPr wrap="square" lIns="0" rIns="0" tIns="0" bIns="0">
+            <a:spAutoFit/>
+          </a:bodyPr>
+          <a:lstStyle/>
+          <a:p>
+            <a:pPr algn="l"/>
+            <a:r>
+              <a:rPr sz="950" b="1" i="0">
                 <a:solidFill>
                   <a:srgbClr val="333333"/>
                 </a:solidFill>
@@ -30360,23 +30360,23 @@
         </p:nvSpPr>
         <p:spPr>
           <a:xfrm>
-            <a:off x="9966960" y="4572000"/>
-            <a:ext cx="2286000" cy="201168"/>
-          </a:xfrm>
-          <a:prstGeom prst="rect">
-            <a:avLst/>
-          </a:prstGeom>
-          <a:noFill/>
-        </p:spPr>
-        <p:txBody>
-          <a:bodyPr wrap="square" lIns="0" rIns="0" tIns="0" bIns="0">
-            <a:spAutoFit/>
-          </a:bodyPr>
-          <a:lstStyle/>
-          <a:p>
-            <a:pPr algn="l"/>
-            <a:r>
-              <a:rPr sz="850" b="0" i="0">
+            <a:off x="9966960" y="4846320"/>
+            <a:ext cx="2286000" cy="228600"/>
+          </a:xfrm>
+          <a:prstGeom prst="rect">
+            <a:avLst/>
+          </a:prstGeom>
+          <a:noFill/>
+        </p:spPr>
+        <p:txBody>
+          <a:bodyPr wrap="square" lIns="0" rIns="0" tIns="0" bIns="0">
+            <a:spAutoFit/>
+          </a:bodyPr>
+          <a:lstStyle/>
+          <a:p>
+            <a:pPr algn="l"/>
+            <a:r>
+              <a:rPr sz="950" b="0" i="0">
                 <a:solidFill>
                   <a:srgbClr val="707070"/>
                 </a:solidFill>
@@ -37694,7 +37694,7 @@
           <a:p>
             <a:pPr algn="l"/>
             <a:r>
-              <a:rPr sz="900" b="0" i="0">
+              <a:rPr sz="1000" b="0" i="0">
                 <a:solidFill>
                   <a:srgbClr val="333333"/>
                 </a:solidFill>
@@ -37706,7 +37706,7 @@
           <a:p>
             <a:pPr algn="l"/>
             <a:r>
-              <a:rPr sz="900" b="0" i="0">
+              <a:rPr sz="1000" b="0" i="0">
                 <a:solidFill>
                   <a:srgbClr val="333333"/>
                 </a:solidFill>
@@ -37718,7 +37718,7 @@
           <a:p>
             <a:pPr algn="l"/>
             <a:r>
-              <a:rPr sz="900" b="0" i="0">
+              <a:rPr sz="1000" b="0" i="0">
                 <a:solidFill>
                   <a:srgbClr val="333333"/>
                 </a:solidFill>
@@ -37730,7 +37730,7 @@
           <a:p>
             <a:pPr algn="l"/>
             <a:r>
-              <a:rPr sz="900" b="0" i="0">
+              <a:rPr sz="1000" b="0" i="0">
                 <a:solidFill>
                   <a:srgbClr val="333333"/>
                 </a:solidFill>
@@ -37742,7 +37742,7 @@
           <a:p>
             <a:pPr algn="l"/>
             <a:r>
-              <a:rPr sz="900" b="0" i="0">
+              <a:rPr sz="1000" b="0" i="0">
                 <a:solidFill>
                   <a:srgbClr val="333333"/>
                 </a:solidFill>

</xml_diff>

<commit_message>
Fix slide 28 footer overlap and slide 29 grey box text spill
Slide 28: reduced row spacing 0.45→0.42" and body text 9.5→9pt so
14 references no longer extend into the footer zone.
Slide 29: reverted file map text from 9.5→8.5pt to prevent wrapping
that caused text to overflow the grey background boxes.

Co-Authored-By: Claude Opus 4.6 <noreply@anthropic.com>
</commit_message>
<xml_diff>
--- a/analysis/Troy_K5_ELA_Executive_Summary.pptx
+++ b/analysis/Troy_K5_ELA_Executive_Summary.pptx
@@ -26375,7 +26375,7 @@
         <p:spPr>
           <a:xfrm>
             <a:off x="365760" y="914400"/>
-            <a:ext cx="502920" cy="384048"/>
+            <a:ext cx="502920" cy="365760"/>
           </a:xfrm>
           <a:prstGeom prst="rect">
             <a:avLst/>
@@ -26418,7 +26418,7 @@
         </p:nvSpPr>
         <p:spPr>
           <a:xfrm>
-            <a:off x="365760" y="969264"/>
+            <a:off x="365760" y="960120"/>
             <a:ext cx="502920" cy="274320"/>
           </a:xfrm>
           <a:prstGeom prst="rect">
@@ -26454,7 +26454,7 @@
         <p:spPr>
           <a:xfrm>
             <a:off x="1005840" y="914400"/>
-            <a:ext cx="10698480" cy="201168"/>
+            <a:ext cx="10698480" cy="182880"/>
           </a:xfrm>
           <a:prstGeom prst="rect">
             <a:avLst/>
@@ -26488,23 +26488,23 @@
         </p:nvSpPr>
         <p:spPr>
           <a:xfrm>
-            <a:off x="1005840" y="1115568"/>
-            <a:ext cx="10698480" cy="201168"/>
-          </a:xfrm>
-          <a:prstGeom prst="rect">
-            <a:avLst/>
-          </a:prstGeom>
-          <a:noFill/>
-        </p:spPr>
-        <p:txBody>
-          <a:bodyPr wrap="square" lIns="0" rIns="0" tIns="0" bIns="0">
-            <a:spAutoFit/>
-          </a:bodyPr>
-          <a:lstStyle/>
-          <a:p>
-            <a:pPr algn="l"/>
-            <a:r>
-              <a:rPr sz="950" b="0" i="0">
+            <a:off x="1005840" y="1097280"/>
+            <a:ext cx="10698480" cy="182880"/>
+          </a:xfrm>
+          <a:prstGeom prst="rect">
+            <a:avLst/>
+          </a:prstGeom>
+          <a:noFill/>
+        </p:spPr>
+        <p:txBody>
+          <a:bodyPr wrap="square" lIns="0" rIns="0" tIns="0" bIns="0">
+            <a:spAutoFit/>
+          </a:bodyPr>
+          <a:lstStyle/>
+          <a:p>
+            <a:pPr algn="l"/>
+            <a:r>
+              <a:rPr sz="900" b="0" i="0">
                 <a:solidFill>
                   <a:srgbClr val="333333"/>
                 </a:solidFill>
@@ -26523,8 +26523,8 @@
         </p:nvSpPr>
         <p:spPr>
           <a:xfrm>
-            <a:off x="365760" y="1325880"/>
-            <a:ext cx="502920" cy="384048"/>
+            <a:off x="365760" y="1298448"/>
+            <a:ext cx="502920" cy="365760"/>
           </a:xfrm>
           <a:prstGeom prst="rect">
             <a:avLst/>
@@ -26567,7 +26567,7 @@
         </p:nvSpPr>
         <p:spPr>
           <a:xfrm>
-            <a:off x="365760" y="1380744"/>
+            <a:off x="365760" y="1344168"/>
             <a:ext cx="502920" cy="274320"/>
           </a:xfrm>
           <a:prstGeom prst="rect">
@@ -26602,8 +26602,8 @@
         </p:nvSpPr>
         <p:spPr>
           <a:xfrm>
-            <a:off x="1005840" y="1325880"/>
-            <a:ext cx="10698480" cy="201168"/>
+            <a:off x="1005840" y="1298448"/>
+            <a:ext cx="10698480" cy="182880"/>
           </a:xfrm>
           <a:prstGeom prst="rect">
             <a:avLst/>
@@ -26637,23 +26637,23 @@
         </p:nvSpPr>
         <p:spPr>
           <a:xfrm>
-            <a:off x="1005840" y="1527048"/>
-            <a:ext cx="10698480" cy="201168"/>
-          </a:xfrm>
-          <a:prstGeom prst="rect">
-            <a:avLst/>
-          </a:prstGeom>
-          <a:noFill/>
-        </p:spPr>
-        <p:txBody>
-          <a:bodyPr wrap="square" lIns="0" rIns="0" tIns="0" bIns="0">
-            <a:spAutoFit/>
-          </a:bodyPr>
-          <a:lstStyle/>
-          <a:p>
-            <a:pPr algn="l"/>
-            <a:r>
-              <a:rPr sz="950" b="0" i="0">
+            <a:off x="1005840" y="1481328"/>
+            <a:ext cx="10698480" cy="182880"/>
+          </a:xfrm>
+          <a:prstGeom prst="rect">
+            <a:avLst/>
+          </a:prstGeom>
+          <a:noFill/>
+        </p:spPr>
+        <p:txBody>
+          <a:bodyPr wrap="square" lIns="0" rIns="0" tIns="0" bIns="0">
+            <a:spAutoFit/>
+          </a:bodyPr>
+          <a:lstStyle/>
+          <a:p>
+            <a:pPr algn="l"/>
+            <a:r>
+              <a:rPr sz="900" b="0" i="0">
                 <a:solidFill>
                   <a:srgbClr val="333333"/>
                 </a:solidFill>
@@ -26672,8 +26672,8 @@
         </p:nvSpPr>
         <p:spPr>
           <a:xfrm>
-            <a:off x="365760" y="1737360"/>
-            <a:ext cx="502920" cy="384048"/>
+            <a:off x="365760" y="1682496"/>
+            <a:ext cx="502920" cy="365760"/>
           </a:xfrm>
           <a:prstGeom prst="rect">
             <a:avLst/>
@@ -26716,7 +26716,7 @@
         </p:nvSpPr>
         <p:spPr>
           <a:xfrm>
-            <a:off x="365760" y="1792224"/>
+            <a:off x="365760" y="1728216"/>
             <a:ext cx="502920" cy="274320"/>
           </a:xfrm>
           <a:prstGeom prst="rect">
@@ -26751,8 +26751,8 @@
         </p:nvSpPr>
         <p:spPr>
           <a:xfrm>
-            <a:off x="1005840" y="1737360"/>
-            <a:ext cx="10698480" cy="201168"/>
+            <a:off x="1005840" y="1682496"/>
+            <a:ext cx="10698480" cy="182880"/>
           </a:xfrm>
           <a:prstGeom prst="rect">
             <a:avLst/>
@@ -26786,23 +26786,23 @@
         </p:nvSpPr>
         <p:spPr>
           <a:xfrm>
-            <a:off x="1005840" y="1938528"/>
-            <a:ext cx="10698480" cy="201168"/>
-          </a:xfrm>
-          <a:prstGeom prst="rect">
-            <a:avLst/>
-          </a:prstGeom>
-          <a:noFill/>
-        </p:spPr>
-        <p:txBody>
-          <a:bodyPr wrap="square" lIns="0" rIns="0" tIns="0" bIns="0">
-            <a:spAutoFit/>
-          </a:bodyPr>
-          <a:lstStyle/>
-          <a:p>
-            <a:pPr algn="l"/>
-            <a:r>
-              <a:rPr sz="950" b="0" i="0">
+            <a:off x="1005840" y="1865376"/>
+            <a:ext cx="10698480" cy="182880"/>
+          </a:xfrm>
+          <a:prstGeom prst="rect">
+            <a:avLst/>
+          </a:prstGeom>
+          <a:noFill/>
+        </p:spPr>
+        <p:txBody>
+          <a:bodyPr wrap="square" lIns="0" rIns="0" tIns="0" bIns="0">
+            <a:spAutoFit/>
+          </a:bodyPr>
+          <a:lstStyle/>
+          <a:p>
+            <a:pPr algn="l"/>
+            <a:r>
+              <a:rPr sz="900" b="0" i="0">
                 <a:solidFill>
                   <a:srgbClr val="333333"/>
                 </a:solidFill>
@@ -26821,8 +26821,8 @@
         </p:nvSpPr>
         <p:spPr>
           <a:xfrm>
-            <a:off x="365760" y="2148840"/>
-            <a:ext cx="502920" cy="384048"/>
+            <a:off x="365760" y="2066544"/>
+            <a:ext cx="502920" cy="365760"/>
           </a:xfrm>
           <a:prstGeom prst="rect">
             <a:avLst/>
@@ -26865,7 +26865,7 @@
         </p:nvSpPr>
         <p:spPr>
           <a:xfrm>
-            <a:off x="365760" y="2203704"/>
+            <a:off x="365760" y="2112264"/>
             <a:ext cx="502920" cy="274320"/>
           </a:xfrm>
           <a:prstGeom prst="rect">
@@ -26900,8 +26900,8 @@
         </p:nvSpPr>
         <p:spPr>
           <a:xfrm>
-            <a:off x="1005840" y="2148840"/>
-            <a:ext cx="10698480" cy="201168"/>
+            <a:off x="1005840" y="2066544"/>
+            <a:ext cx="10698480" cy="182880"/>
           </a:xfrm>
           <a:prstGeom prst="rect">
             <a:avLst/>
@@ -26935,23 +26935,23 @@
         </p:nvSpPr>
         <p:spPr>
           <a:xfrm>
-            <a:off x="1005840" y="2350008"/>
-            <a:ext cx="10698480" cy="201168"/>
-          </a:xfrm>
-          <a:prstGeom prst="rect">
-            <a:avLst/>
-          </a:prstGeom>
-          <a:noFill/>
-        </p:spPr>
-        <p:txBody>
-          <a:bodyPr wrap="square" lIns="0" rIns="0" tIns="0" bIns="0">
-            <a:spAutoFit/>
-          </a:bodyPr>
-          <a:lstStyle/>
-          <a:p>
-            <a:pPr algn="l"/>
-            <a:r>
-              <a:rPr sz="950" b="0" i="0">
+            <a:off x="1005840" y="2249424"/>
+            <a:ext cx="10698480" cy="182880"/>
+          </a:xfrm>
+          <a:prstGeom prst="rect">
+            <a:avLst/>
+          </a:prstGeom>
+          <a:noFill/>
+        </p:spPr>
+        <p:txBody>
+          <a:bodyPr wrap="square" lIns="0" rIns="0" tIns="0" bIns="0">
+            <a:spAutoFit/>
+          </a:bodyPr>
+          <a:lstStyle/>
+          <a:p>
+            <a:pPr algn="l"/>
+            <a:r>
+              <a:rPr sz="900" b="0" i="0">
                 <a:solidFill>
                   <a:srgbClr val="333333"/>
                 </a:solidFill>
@@ -26970,8 +26970,8 @@
         </p:nvSpPr>
         <p:spPr>
           <a:xfrm>
-            <a:off x="365760" y="2560320"/>
-            <a:ext cx="502920" cy="384048"/>
+            <a:off x="365760" y="2450592"/>
+            <a:ext cx="502920" cy="365760"/>
           </a:xfrm>
           <a:prstGeom prst="rect">
             <a:avLst/>
@@ -27014,7 +27014,7 @@
         </p:nvSpPr>
         <p:spPr>
           <a:xfrm>
-            <a:off x="365760" y="2615184"/>
+            <a:off x="365760" y="2496312"/>
             <a:ext cx="502920" cy="274320"/>
           </a:xfrm>
           <a:prstGeom prst="rect">
@@ -27049,8 +27049,8 @@
         </p:nvSpPr>
         <p:spPr>
           <a:xfrm>
-            <a:off x="1005840" y="2560320"/>
-            <a:ext cx="10698480" cy="201168"/>
+            <a:off x="1005840" y="2450592"/>
+            <a:ext cx="10698480" cy="182880"/>
           </a:xfrm>
           <a:prstGeom prst="rect">
             <a:avLst/>
@@ -27084,23 +27084,23 @@
         </p:nvSpPr>
         <p:spPr>
           <a:xfrm>
-            <a:off x="1005840" y="2761488"/>
-            <a:ext cx="10698480" cy="201168"/>
-          </a:xfrm>
-          <a:prstGeom prst="rect">
-            <a:avLst/>
-          </a:prstGeom>
-          <a:noFill/>
-        </p:spPr>
-        <p:txBody>
-          <a:bodyPr wrap="square" lIns="0" rIns="0" tIns="0" bIns="0">
-            <a:spAutoFit/>
-          </a:bodyPr>
-          <a:lstStyle/>
-          <a:p>
-            <a:pPr algn="l"/>
-            <a:r>
-              <a:rPr sz="950" b="0" i="0">
+            <a:off x="1005840" y="2633472"/>
+            <a:ext cx="10698480" cy="182880"/>
+          </a:xfrm>
+          <a:prstGeom prst="rect">
+            <a:avLst/>
+          </a:prstGeom>
+          <a:noFill/>
+        </p:spPr>
+        <p:txBody>
+          <a:bodyPr wrap="square" lIns="0" rIns="0" tIns="0" bIns="0">
+            <a:spAutoFit/>
+          </a:bodyPr>
+          <a:lstStyle/>
+          <a:p>
+            <a:pPr algn="l"/>
+            <a:r>
+              <a:rPr sz="900" b="0" i="0">
                 <a:solidFill>
                   <a:srgbClr val="333333"/>
                 </a:solidFill>
@@ -27119,8 +27119,8 @@
         </p:nvSpPr>
         <p:spPr>
           <a:xfrm>
-            <a:off x="365760" y="2971800"/>
-            <a:ext cx="502920" cy="384048"/>
+            <a:off x="365760" y="2834640"/>
+            <a:ext cx="502920" cy="365760"/>
           </a:xfrm>
           <a:prstGeom prst="rect">
             <a:avLst/>
@@ -27163,7 +27163,7 @@
         </p:nvSpPr>
         <p:spPr>
           <a:xfrm>
-            <a:off x="365760" y="3026664"/>
+            <a:off x="365760" y="2880360"/>
             <a:ext cx="502920" cy="274320"/>
           </a:xfrm>
           <a:prstGeom prst="rect">
@@ -27198,8 +27198,8 @@
         </p:nvSpPr>
         <p:spPr>
           <a:xfrm>
-            <a:off x="1005840" y="2971800"/>
-            <a:ext cx="10698480" cy="201168"/>
+            <a:off x="1005840" y="2834640"/>
+            <a:ext cx="10698480" cy="182880"/>
           </a:xfrm>
           <a:prstGeom prst="rect">
             <a:avLst/>
@@ -27233,23 +27233,23 @@
         </p:nvSpPr>
         <p:spPr>
           <a:xfrm>
-            <a:off x="1005840" y="3172968"/>
-            <a:ext cx="10698480" cy="201168"/>
-          </a:xfrm>
-          <a:prstGeom prst="rect">
-            <a:avLst/>
-          </a:prstGeom>
-          <a:noFill/>
-        </p:spPr>
-        <p:txBody>
-          <a:bodyPr wrap="square" lIns="0" rIns="0" tIns="0" bIns="0">
-            <a:spAutoFit/>
-          </a:bodyPr>
-          <a:lstStyle/>
-          <a:p>
-            <a:pPr algn="l"/>
-            <a:r>
-              <a:rPr sz="950" b="0" i="0">
+            <a:off x="1005840" y="3017520"/>
+            <a:ext cx="10698480" cy="182880"/>
+          </a:xfrm>
+          <a:prstGeom prst="rect">
+            <a:avLst/>
+          </a:prstGeom>
+          <a:noFill/>
+        </p:spPr>
+        <p:txBody>
+          <a:bodyPr wrap="square" lIns="0" rIns="0" tIns="0" bIns="0">
+            <a:spAutoFit/>
+          </a:bodyPr>
+          <a:lstStyle/>
+          <a:p>
+            <a:pPr algn="l"/>
+            <a:r>
+              <a:rPr sz="900" b="0" i="0">
                 <a:solidFill>
                   <a:srgbClr val="333333"/>
                 </a:solidFill>
@@ -27268,8 +27268,8 @@
         </p:nvSpPr>
         <p:spPr>
           <a:xfrm>
-            <a:off x="365760" y="3383280"/>
-            <a:ext cx="502920" cy="384048"/>
+            <a:off x="365760" y="3218688"/>
+            <a:ext cx="502920" cy="365760"/>
           </a:xfrm>
           <a:prstGeom prst="rect">
             <a:avLst/>
@@ -27312,7 +27312,7 @@
         </p:nvSpPr>
         <p:spPr>
           <a:xfrm>
-            <a:off x="365760" y="3438144"/>
+            <a:off x="365760" y="3264408"/>
             <a:ext cx="502920" cy="274320"/>
           </a:xfrm>
           <a:prstGeom prst="rect">
@@ -27347,8 +27347,8 @@
         </p:nvSpPr>
         <p:spPr>
           <a:xfrm>
-            <a:off x="1005840" y="3383280"/>
-            <a:ext cx="10698480" cy="201168"/>
+            <a:off x="1005840" y="3218688"/>
+            <a:ext cx="10698480" cy="182880"/>
           </a:xfrm>
           <a:prstGeom prst="rect">
             <a:avLst/>
@@ -27382,23 +27382,23 @@
         </p:nvSpPr>
         <p:spPr>
           <a:xfrm>
-            <a:off x="1005840" y="3584448"/>
-            <a:ext cx="10698480" cy="201168"/>
-          </a:xfrm>
-          <a:prstGeom prst="rect">
-            <a:avLst/>
-          </a:prstGeom>
-          <a:noFill/>
-        </p:spPr>
-        <p:txBody>
-          <a:bodyPr wrap="square" lIns="0" rIns="0" tIns="0" bIns="0">
-            <a:spAutoFit/>
-          </a:bodyPr>
-          <a:lstStyle/>
-          <a:p>
-            <a:pPr algn="l"/>
-            <a:r>
-              <a:rPr sz="950" b="0" i="0">
+            <a:off x="1005840" y="3401568"/>
+            <a:ext cx="10698480" cy="182880"/>
+          </a:xfrm>
+          <a:prstGeom prst="rect">
+            <a:avLst/>
+          </a:prstGeom>
+          <a:noFill/>
+        </p:spPr>
+        <p:txBody>
+          <a:bodyPr wrap="square" lIns="0" rIns="0" tIns="0" bIns="0">
+            <a:spAutoFit/>
+          </a:bodyPr>
+          <a:lstStyle/>
+          <a:p>
+            <a:pPr algn="l"/>
+            <a:r>
+              <a:rPr sz="900" b="0" i="0">
                 <a:solidFill>
                   <a:srgbClr val="333333"/>
                 </a:solidFill>
@@ -27417,8 +27417,8 @@
         </p:nvSpPr>
         <p:spPr>
           <a:xfrm>
-            <a:off x="365760" y="3794760"/>
-            <a:ext cx="502920" cy="384048"/>
+            <a:off x="365760" y="3602736"/>
+            <a:ext cx="502920" cy="365760"/>
           </a:xfrm>
           <a:prstGeom prst="rect">
             <a:avLst/>
@@ -27461,7 +27461,7 @@
         </p:nvSpPr>
         <p:spPr>
           <a:xfrm>
-            <a:off x="365760" y="3849624"/>
+            <a:off x="365760" y="3648456"/>
             <a:ext cx="502920" cy="274320"/>
           </a:xfrm>
           <a:prstGeom prst="rect">
@@ -27496,8 +27496,8 @@
         </p:nvSpPr>
         <p:spPr>
           <a:xfrm>
-            <a:off x="1005840" y="3794760"/>
-            <a:ext cx="10698480" cy="201168"/>
+            <a:off x="1005840" y="3602736"/>
+            <a:ext cx="10698480" cy="182880"/>
           </a:xfrm>
           <a:prstGeom prst="rect">
             <a:avLst/>
@@ -27531,23 +27531,23 @@
         </p:nvSpPr>
         <p:spPr>
           <a:xfrm>
-            <a:off x="1005840" y="3995928"/>
-            <a:ext cx="10698480" cy="201168"/>
-          </a:xfrm>
-          <a:prstGeom prst="rect">
-            <a:avLst/>
-          </a:prstGeom>
-          <a:noFill/>
-        </p:spPr>
-        <p:txBody>
-          <a:bodyPr wrap="square" lIns="0" rIns="0" tIns="0" bIns="0">
-            <a:spAutoFit/>
-          </a:bodyPr>
-          <a:lstStyle/>
-          <a:p>
-            <a:pPr algn="l"/>
-            <a:r>
-              <a:rPr sz="950" b="0" i="0">
+            <a:off x="1005840" y="3785616"/>
+            <a:ext cx="10698480" cy="182880"/>
+          </a:xfrm>
+          <a:prstGeom prst="rect">
+            <a:avLst/>
+          </a:prstGeom>
+          <a:noFill/>
+        </p:spPr>
+        <p:txBody>
+          <a:bodyPr wrap="square" lIns="0" rIns="0" tIns="0" bIns="0">
+            <a:spAutoFit/>
+          </a:bodyPr>
+          <a:lstStyle/>
+          <a:p>
+            <a:pPr algn="l"/>
+            <a:r>
+              <a:rPr sz="900" b="0" i="0">
                 <a:solidFill>
                   <a:srgbClr val="333333"/>
                 </a:solidFill>
@@ -27566,8 +27566,8 @@
         </p:nvSpPr>
         <p:spPr>
           <a:xfrm>
-            <a:off x="365760" y="4206240"/>
-            <a:ext cx="502920" cy="384048"/>
+            <a:off x="365760" y="3986784"/>
+            <a:ext cx="502920" cy="365760"/>
           </a:xfrm>
           <a:prstGeom prst="rect">
             <a:avLst/>
@@ -27610,7 +27610,7 @@
         </p:nvSpPr>
         <p:spPr>
           <a:xfrm>
-            <a:off x="365760" y="4261104"/>
+            <a:off x="365760" y="4032504"/>
             <a:ext cx="502920" cy="274320"/>
           </a:xfrm>
           <a:prstGeom prst="rect">
@@ -27645,8 +27645,8 @@
         </p:nvSpPr>
         <p:spPr>
           <a:xfrm>
-            <a:off x="1005840" y="4206240"/>
-            <a:ext cx="10698480" cy="201168"/>
+            <a:off x="1005840" y="3986784"/>
+            <a:ext cx="10698480" cy="182880"/>
           </a:xfrm>
           <a:prstGeom prst="rect">
             <a:avLst/>
@@ -27680,23 +27680,23 @@
         </p:nvSpPr>
         <p:spPr>
           <a:xfrm>
-            <a:off x="1005840" y="4407408"/>
-            <a:ext cx="10698480" cy="201168"/>
-          </a:xfrm>
-          <a:prstGeom prst="rect">
-            <a:avLst/>
-          </a:prstGeom>
-          <a:noFill/>
-        </p:spPr>
-        <p:txBody>
-          <a:bodyPr wrap="square" lIns="0" rIns="0" tIns="0" bIns="0">
-            <a:spAutoFit/>
-          </a:bodyPr>
-          <a:lstStyle/>
-          <a:p>
-            <a:pPr algn="l"/>
-            <a:r>
-              <a:rPr sz="950" b="0" i="0">
+            <a:off x="1005840" y="4169664"/>
+            <a:ext cx="10698480" cy="182880"/>
+          </a:xfrm>
+          <a:prstGeom prst="rect">
+            <a:avLst/>
+          </a:prstGeom>
+          <a:noFill/>
+        </p:spPr>
+        <p:txBody>
+          <a:bodyPr wrap="square" lIns="0" rIns="0" tIns="0" bIns="0">
+            <a:spAutoFit/>
+          </a:bodyPr>
+          <a:lstStyle/>
+          <a:p>
+            <a:pPr algn="l"/>
+            <a:r>
+              <a:rPr sz="900" b="0" i="0">
                 <a:solidFill>
                   <a:srgbClr val="333333"/>
                 </a:solidFill>
@@ -27715,8 +27715,8 @@
         </p:nvSpPr>
         <p:spPr>
           <a:xfrm>
-            <a:off x="365760" y="4617720"/>
-            <a:ext cx="502920" cy="384048"/>
+            <a:off x="365760" y="4370832"/>
+            <a:ext cx="502920" cy="365760"/>
           </a:xfrm>
           <a:prstGeom prst="rect">
             <a:avLst/>
@@ -27759,7 +27759,7 @@
         </p:nvSpPr>
         <p:spPr>
           <a:xfrm>
-            <a:off x="365760" y="4672584"/>
+            <a:off x="365760" y="4416552"/>
             <a:ext cx="502920" cy="274320"/>
           </a:xfrm>
           <a:prstGeom prst="rect">
@@ -27794,8 +27794,8 @@
         </p:nvSpPr>
         <p:spPr>
           <a:xfrm>
-            <a:off x="1005840" y="4617720"/>
-            <a:ext cx="10698480" cy="201168"/>
+            <a:off x="1005840" y="4370832"/>
+            <a:ext cx="10698480" cy="182880"/>
           </a:xfrm>
           <a:prstGeom prst="rect">
             <a:avLst/>
@@ -27829,23 +27829,23 @@
         </p:nvSpPr>
         <p:spPr>
           <a:xfrm>
-            <a:off x="1005840" y="4818888"/>
-            <a:ext cx="10698480" cy="201168"/>
-          </a:xfrm>
-          <a:prstGeom prst="rect">
-            <a:avLst/>
-          </a:prstGeom>
-          <a:noFill/>
-        </p:spPr>
-        <p:txBody>
-          <a:bodyPr wrap="square" lIns="0" rIns="0" tIns="0" bIns="0">
-            <a:spAutoFit/>
-          </a:bodyPr>
-          <a:lstStyle/>
-          <a:p>
-            <a:pPr algn="l"/>
-            <a:r>
-              <a:rPr sz="950" b="0" i="0">
+            <a:off x="1005840" y="4553712"/>
+            <a:ext cx="10698480" cy="182880"/>
+          </a:xfrm>
+          <a:prstGeom prst="rect">
+            <a:avLst/>
+          </a:prstGeom>
+          <a:noFill/>
+        </p:spPr>
+        <p:txBody>
+          <a:bodyPr wrap="square" lIns="0" rIns="0" tIns="0" bIns="0">
+            <a:spAutoFit/>
+          </a:bodyPr>
+          <a:lstStyle/>
+          <a:p>
+            <a:pPr algn="l"/>
+            <a:r>
+              <a:rPr sz="900" b="0" i="0">
                 <a:solidFill>
                   <a:srgbClr val="333333"/>
                 </a:solidFill>
@@ -27864,8 +27864,8 @@
         </p:nvSpPr>
         <p:spPr>
           <a:xfrm>
-            <a:off x="365760" y="5029200"/>
-            <a:ext cx="502920" cy="384048"/>
+            <a:off x="365760" y="4754880"/>
+            <a:ext cx="502920" cy="365760"/>
           </a:xfrm>
           <a:prstGeom prst="rect">
             <a:avLst/>
@@ -27908,7 +27908,7 @@
         </p:nvSpPr>
         <p:spPr>
           <a:xfrm>
-            <a:off x="365760" y="5084064"/>
+            <a:off x="365760" y="4800600"/>
             <a:ext cx="502920" cy="274320"/>
           </a:xfrm>
           <a:prstGeom prst="rect">
@@ -27943,8 +27943,8 @@
         </p:nvSpPr>
         <p:spPr>
           <a:xfrm>
-            <a:off x="1005840" y="5029200"/>
-            <a:ext cx="10698480" cy="201168"/>
+            <a:off x="1005840" y="4754880"/>
+            <a:ext cx="10698480" cy="182880"/>
           </a:xfrm>
           <a:prstGeom prst="rect">
             <a:avLst/>
@@ -27978,23 +27978,23 @@
         </p:nvSpPr>
         <p:spPr>
           <a:xfrm>
-            <a:off x="1005840" y="5230368"/>
-            <a:ext cx="10698480" cy="201168"/>
-          </a:xfrm>
-          <a:prstGeom prst="rect">
-            <a:avLst/>
-          </a:prstGeom>
-          <a:noFill/>
-        </p:spPr>
-        <p:txBody>
-          <a:bodyPr wrap="square" lIns="0" rIns="0" tIns="0" bIns="0">
-            <a:spAutoFit/>
-          </a:bodyPr>
-          <a:lstStyle/>
-          <a:p>
-            <a:pPr algn="l"/>
-            <a:r>
-              <a:rPr sz="950" b="0" i="0">
+            <a:off x="1005840" y="4937760"/>
+            <a:ext cx="10698480" cy="182880"/>
+          </a:xfrm>
+          <a:prstGeom prst="rect">
+            <a:avLst/>
+          </a:prstGeom>
+          <a:noFill/>
+        </p:spPr>
+        <p:txBody>
+          <a:bodyPr wrap="square" lIns="0" rIns="0" tIns="0" bIns="0">
+            <a:spAutoFit/>
+          </a:bodyPr>
+          <a:lstStyle/>
+          <a:p>
+            <a:pPr algn="l"/>
+            <a:r>
+              <a:rPr sz="900" b="0" i="0">
                 <a:solidFill>
                   <a:srgbClr val="333333"/>
                 </a:solidFill>
@@ -28013,8 +28013,8 @@
         </p:nvSpPr>
         <p:spPr>
           <a:xfrm>
-            <a:off x="365760" y="5440680"/>
-            <a:ext cx="502920" cy="384048"/>
+            <a:off x="365760" y="5138928"/>
+            <a:ext cx="502920" cy="365760"/>
           </a:xfrm>
           <a:prstGeom prst="rect">
             <a:avLst/>
@@ -28057,7 +28057,7 @@
         </p:nvSpPr>
         <p:spPr>
           <a:xfrm>
-            <a:off x="365760" y="5495544"/>
+            <a:off x="365760" y="5184648"/>
             <a:ext cx="502920" cy="274320"/>
           </a:xfrm>
           <a:prstGeom prst="rect">
@@ -28092,8 +28092,8 @@
         </p:nvSpPr>
         <p:spPr>
           <a:xfrm>
-            <a:off x="1005840" y="5440680"/>
-            <a:ext cx="10698480" cy="201168"/>
+            <a:off x="1005840" y="5138928"/>
+            <a:ext cx="10698480" cy="182880"/>
           </a:xfrm>
           <a:prstGeom prst="rect">
             <a:avLst/>
@@ -28127,23 +28127,23 @@
         </p:nvSpPr>
         <p:spPr>
           <a:xfrm>
-            <a:off x="1005840" y="5641848"/>
-            <a:ext cx="10698480" cy="201168"/>
-          </a:xfrm>
-          <a:prstGeom prst="rect">
-            <a:avLst/>
-          </a:prstGeom>
-          <a:noFill/>
-        </p:spPr>
-        <p:txBody>
-          <a:bodyPr wrap="square" lIns="0" rIns="0" tIns="0" bIns="0">
-            <a:spAutoFit/>
-          </a:bodyPr>
-          <a:lstStyle/>
-          <a:p>
-            <a:pPr algn="l"/>
-            <a:r>
-              <a:rPr sz="950" b="0" i="0">
+            <a:off x="1005840" y="5321808"/>
+            <a:ext cx="10698480" cy="182880"/>
+          </a:xfrm>
+          <a:prstGeom prst="rect">
+            <a:avLst/>
+          </a:prstGeom>
+          <a:noFill/>
+        </p:spPr>
+        <p:txBody>
+          <a:bodyPr wrap="square" lIns="0" rIns="0" tIns="0" bIns="0">
+            <a:spAutoFit/>
+          </a:bodyPr>
+          <a:lstStyle/>
+          <a:p>
+            <a:pPr algn="l"/>
+            <a:r>
+              <a:rPr sz="900" b="0" i="0">
                 <a:solidFill>
                   <a:srgbClr val="333333"/>
                 </a:solidFill>
@@ -28162,8 +28162,8 @@
         </p:nvSpPr>
         <p:spPr>
           <a:xfrm>
-            <a:off x="365760" y="5852160"/>
-            <a:ext cx="502920" cy="384048"/>
+            <a:off x="365760" y="5522976"/>
+            <a:ext cx="502920" cy="365760"/>
           </a:xfrm>
           <a:prstGeom prst="rect">
             <a:avLst/>
@@ -28206,7 +28206,7 @@
         </p:nvSpPr>
         <p:spPr>
           <a:xfrm>
-            <a:off x="365760" y="5907024"/>
+            <a:off x="365760" y="5568696"/>
             <a:ext cx="502920" cy="274320"/>
           </a:xfrm>
           <a:prstGeom prst="rect">
@@ -28241,8 +28241,8 @@
         </p:nvSpPr>
         <p:spPr>
           <a:xfrm>
-            <a:off x="1005840" y="5852160"/>
-            <a:ext cx="10698480" cy="201168"/>
+            <a:off x="1005840" y="5522976"/>
+            <a:ext cx="10698480" cy="182880"/>
           </a:xfrm>
           <a:prstGeom prst="rect">
             <a:avLst/>
@@ -28276,23 +28276,23 @@
         </p:nvSpPr>
         <p:spPr>
           <a:xfrm>
-            <a:off x="1005840" y="6053328"/>
-            <a:ext cx="10698480" cy="201168"/>
-          </a:xfrm>
-          <a:prstGeom prst="rect">
-            <a:avLst/>
-          </a:prstGeom>
-          <a:noFill/>
-        </p:spPr>
-        <p:txBody>
-          <a:bodyPr wrap="square" lIns="0" rIns="0" tIns="0" bIns="0">
-            <a:spAutoFit/>
-          </a:bodyPr>
-          <a:lstStyle/>
-          <a:p>
-            <a:pPr algn="l"/>
-            <a:r>
-              <a:rPr sz="950" b="0" i="0">
+            <a:off x="1005840" y="5705856"/>
+            <a:ext cx="10698480" cy="182880"/>
+          </a:xfrm>
+          <a:prstGeom prst="rect">
+            <a:avLst/>
+          </a:prstGeom>
+          <a:noFill/>
+        </p:spPr>
+        <p:txBody>
+          <a:bodyPr wrap="square" lIns="0" rIns="0" tIns="0" bIns="0">
+            <a:spAutoFit/>
+          </a:bodyPr>
+          <a:lstStyle/>
+          <a:p>
+            <a:pPr algn="l"/>
+            <a:r>
+              <a:rPr sz="900" b="0" i="0">
                 <a:solidFill>
                   <a:srgbClr val="333333"/>
                 </a:solidFill>
@@ -28311,8 +28311,8 @@
         </p:nvSpPr>
         <p:spPr>
           <a:xfrm>
-            <a:off x="365760" y="6263640"/>
-            <a:ext cx="502920" cy="384048"/>
+            <a:off x="365760" y="5907024"/>
+            <a:ext cx="502920" cy="365760"/>
           </a:xfrm>
           <a:prstGeom prst="rect">
             <a:avLst/>
@@ -28355,7 +28355,7 @@
         </p:nvSpPr>
         <p:spPr>
           <a:xfrm>
-            <a:off x="365760" y="6318504"/>
+            <a:off x="365760" y="5952744"/>
             <a:ext cx="502920" cy="274320"/>
           </a:xfrm>
           <a:prstGeom prst="rect">
@@ -28390,8 +28390,8 @@
         </p:nvSpPr>
         <p:spPr>
           <a:xfrm>
-            <a:off x="1005840" y="6263640"/>
-            <a:ext cx="10698480" cy="201168"/>
+            <a:off x="1005840" y="5907024"/>
+            <a:ext cx="10698480" cy="182880"/>
           </a:xfrm>
           <a:prstGeom prst="rect">
             <a:avLst/>
@@ -28425,23 +28425,23 @@
         </p:nvSpPr>
         <p:spPr>
           <a:xfrm>
-            <a:off x="1005840" y="6464808"/>
-            <a:ext cx="10698480" cy="201168"/>
-          </a:xfrm>
-          <a:prstGeom prst="rect">
-            <a:avLst/>
-          </a:prstGeom>
-          <a:noFill/>
-        </p:spPr>
-        <p:txBody>
-          <a:bodyPr wrap="square" lIns="0" rIns="0" tIns="0" bIns="0">
-            <a:spAutoFit/>
-          </a:bodyPr>
-          <a:lstStyle/>
-          <a:p>
-            <a:pPr algn="l"/>
-            <a:r>
-              <a:rPr sz="950" b="0" i="0">
+            <a:off x="1005840" y="6089904"/>
+            <a:ext cx="10698480" cy="182880"/>
+          </a:xfrm>
+          <a:prstGeom prst="rect">
+            <a:avLst/>
+          </a:prstGeom>
+          <a:noFill/>
+        </p:spPr>
+        <p:txBody>
+          <a:bodyPr wrap="square" lIns="0" rIns="0" tIns="0" bIns="0">
+            <a:spAutoFit/>
+          </a:bodyPr>
+          <a:lstStyle/>
+          <a:p>
+            <a:pPr algn="l"/>
+            <a:r>
+              <a:rPr sz="900" b="0" i="0">
                 <a:solidFill>
                   <a:srgbClr val="333333"/>
                 </a:solidFill>
@@ -28821,22 +28821,22 @@
         <p:spPr>
           <a:xfrm>
             <a:off x="640080" y="1737360"/>
-            <a:ext cx="3291840" cy="228600"/>
-          </a:xfrm>
-          <a:prstGeom prst="rect">
-            <a:avLst/>
-          </a:prstGeom>
-          <a:noFill/>
-        </p:spPr>
-        <p:txBody>
-          <a:bodyPr wrap="square" lIns="0" rIns="0" tIns="0" bIns="0">
-            <a:spAutoFit/>
-          </a:bodyPr>
-          <a:lstStyle/>
-          <a:p>
-            <a:pPr algn="l"/>
-            <a:r>
-              <a:rPr sz="950" b="1" i="0">
+            <a:ext cx="3291840" cy="201168"/>
+          </a:xfrm>
+          <a:prstGeom prst="rect">
+            <a:avLst/>
+          </a:prstGeom>
+          <a:noFill/>
+        </p:spPr>
+        <p:txBody>
+          <a:bodyPr wrap="square" lIns="0" rIns="0" tIns="0" bIns="0">
+            <a:spAutoFit/>
+          </a:bodyPr>
+          <a:lstStyle/>
+          <a:p>
+            <a:pPr algn="l"/>
+            <a:r>
+              <a:rPr sz="850" b="1" i="0">
                 <a:solidFill>
                   <a:srgbClr val="333333"/>
                 </a:solidFill>
@@ -28856,22 +28856,22 @@
         <p:spPr>
           <a:xfrm>
             <a:off x="3977640" y="1737360"/>
-            <a:ext cx="2286000" cy="228600"/>
-          </a:xfrm>
-          <a:prstGeom prst="rect">
-            <a:avLst/>
-          </a:prstGeom>
-          <a:noFill/>
-        </p:spPr>
-        <p:txBody>
-          <a:bodyPr wrap="square" lIns="0" rIns="0" tIns="0" bIns="0">
-            <a:spAutoFit/>
-          </a:bodyPr>
-          <a:lstStyle/>
-          <a:p>
-            <a:pPr algn="l"/>
-            <a:r>
-              <a:rPr sz="950" b="0" i="0">
+            <a:ext cx="2011680" cy="201168"/>
+          </a:xfrm>
+          <a:prstGeom prst="rect">
+            <a:avLst/>
+          </a:prstGeom>
+          <a:noFill/>
+        </p:spPr>
+        <p:txBody>
+          <a:bodyPr wrap="square" lIns="0" rIns="0" tIns="0" bIns="0">
+            <a:spAutoFit/>
+          </a:bodyPr>
+          <a:lstStyle/>
+          <a:p>
+            <a:pPr algn="l"/>
+            <a:r>
+              <a:rPr sz="850" b="0" i="0">
                 <a:solidFill>
                   <a:srgbClr val="707070"/>
                 </a:solidFill>
@@ -28890,23 +28890,23 @@
         </p:nvSpPr>
         <p:spPr>
           <a:xfrm>
-            <a:off x="640080" y="2002536"/>
-            <a:ext cx="3291840" cy="228600"/>
-          </a:xfrm>
-          <a:prstGeom prst="rect">
-            <a:avLst/>
-          </a:prstGeom>
-          <a:noFill/>
-        </p:spPr>
-        <p:txBody>
-          <a:bodyPr wrap="square" lIns="0" rIns="0" tIns="0" bIns="0">
-            <a:spAutoFit/>
-          </a:bodyPr>
-          <a:lstStyle/>
-          <a:p>
-            <a:pPr algn="l"/>
-            <a:r>
-              <a:rPr sz="950" b="1" i="0">
+            <a:off x="640080" y="1975104"/>
+            <a:ext cx="3291840" cy="201168"/>
+          </a:xfrm>
+          <a:prstGeom prst="rect">
+            <a:avLst/>
+          </a:prstGeom>
+          <a:noFill/>
+        </p:spPr>
+        <p:txBody>
+          <a:bodyPr wrap="square" lIns="0" rIns="0" tIns="0" bIns="0">
+            <a:spAutoFit/>
+          </a:bodyPr>
+          <a:lstStyle/>
+          <a:p>
+            <a:pPr algn="l"/>
+            <a:r>
+              <a:rPr sz="850" b="1" i="0">
                 <a:solidFill>
                   <a:srgbClr val="333333"/>
                 </a:solidFill>
@@ -28925,23 +28925,23 @@
         </p:nvSpPr>
         <p:spPr>
           <a:xfrm>
-            <a:off x="3977640" y="2002536"/>
-            <a:ext cx="2286000" cy="228600"/>
-          </a:xfrm>
-          <a:prstGeom prst="rect">
-            <a:avLst/>
-          </a:prstGeom>
-          <a:noFill/>
-        </p:spPr>
-        <p:txBody>
-          <a:bodyPr wrap="square" lIns="0" rIns="0" tIns="0" bIns="0">
-            <a:spAutoFit/>
-          </a:bodyPr>
-          <a:lstStyle/>
-          <a:p>
-            <a:pPr algn="l"/>
-            <a:r>
-              <a:rPr sz="950" b="0" i="0">
+            <a:off x="3977640" y="1975104"/>
+            <a:ext cx="2011680" cy="201168"/>
+          </a:xfrm>
+          <a:prstGeom prst="rect">
+            <a:avLst/>
+          </a:prstGeom>
+          <a:noFill/>
+        </p:spPr>
+        <p:txBody>
+          <a:bodyPr wrap="square" lIns="0" rIns="0" tIns="0" bIns="0">
+            <a:spAutoFit/>
+          </a:bodyPr>
+          <a:lstStyle/>
+          <a:p>
+            <a:pPr algn="l"/>
+            <a:r>
+              <a:rPr sz="850" b="0" i="0">
                 <a:solidFill>
                   <a:srgbClr val="707070"/>
                 </a:solidFill>
@@ -28960,23 +28960,23 @@
         </p:nvSpPr>
         <p:spPr>
           <a:xfrm>
-            <a:off x="640080" y="2267712"/>
-            <a:ext cx="3291840" cy="228600"/>
-          </a:xfrm>
-          <a:prstGeom prst="rect">
-            <a:avLst/>
-          </a:prstGeom>
-          <a:noFill/>
-        </p:spPr>
-        <p:txBody>
-          <a:bodyPr wrap="square" lIns="0" rIns="0" tIns="0" bIns="0">
-            <a:spAutoFit/>
-          </a:bodyPr>
-          <a:lstStyle/>
-          <a:p>
-            <a:pPr algn="l"/>
-            <a:r>
-              <a:rPr sz="950" b="1" i="0">
+            <a:off x="640080" y="2212848"/>
+            <a:ext cx="3291840" cy="201168"/>
+          </a:xfrm>
+          <a:prstGeom prst="rect">
+            <a:avLst/>
+          </a:prstGeom>
+          <a:noFill/>
+        </p:spPr>
+        <p:txBody>
+          <a:bodyPr wrap="square" lIns="0" rIns="0" tIns="0" bIns="0">
+            <a:spAutoFit/>
+          </a:bodyPr>
+          <a:lstStyle/>
+          <a:p>
+            <a:pPr algn="l"/>
+            <a:r>
+              <a:rPr sz="850" b="1" i="0">
                 <a:solidFill>
                   <a:srgbClr val="333333"/>
                 </a:solidFill>
@@ -28995,23 +28995,23 @@
         </p:nvSpPr>
         <p:spPr>
           <a:xfrm>
-            <a:off x="3977640" y="2267712"/>
-            <a:ext cx="2286000" cy="228600"/>
-          </a:xfrm>
-          <a:prstGeom prst="rect">
-            <a:avLst/>
-          </a:prstGeom>
-          <a:noFill/>
-        </p:spPr>
-        <p:txBody>
-          <a:bodyPr wrap="square" lIns="0" rIns="0" tIns="0" bIns="0">
-            <a:spAutoFit/>
-          </a:bodyPr>
-          <a:lstStyle/>
-          <a:p>
-            <a:pPr algn="l"/>
-            <a:r>
-              <a:rPr sz="950" b="0" i="0">
+            <a:off x="3977640" y="2212848"/>
+            <a:ext cx="2011680" cy="201168"/>
+          </a:xfrm>
+          <a:prstGeom prst="rect">
+            <a:avLst/>
+          </a:prstGeom>
+          <a:noFill/>
+        </p:spPr>
+        <p:txBody>
+          <a:bodyPr wrap="square" lIns="0" rIns="0" tIns="0" bIns="0">
+            <a:spAutoFit/>
+          </a:bodyPr>
+          <a:lstStyle/>
+          <a:p>
+            <a:pPr algn="l"/>
+            <a:r>
+              <a:rPr sz="850" b="0" i="0">
                 <a:solidFill>
                   <a:srgbClr val="707070"/>
                 </a:solidFill>
@@ -29030,23 +29030,23 @@
         </p:nvSpPr>
         <p:spPr>
           <a:xfrm>
-            <a:off x="640080" y="2532888"/>
-            <a:ext cx="3291840" cy="228600"/>
-          </a:xfrm>
-          <a:prstGeom prst="rect">
-            <a:avLst/>
-          </a:prstGeom>
-          <a:noFill/>
-        </p:spPr>
-        <p:txBody>
-          <a:bodyPr wrap="square" lIns="0" rIns="0" tIns="0" bIns="0">
-            <a:spAutoFit/>
-          </a:bodyPr>
-          <a:lstStyle/>
-          <a:p>
-            <a:pPr algn="l"/>
-            <a:r>
-              <a:rPr sz="950" b="1" i="0">
+            <a:off x="640080" y="2450592"/>
+            <a:ext cx="3291840" cy="201168"/>
+          </a:xfrm>
+          <a:prstGeom prst="rect">
+            <a:avLst/>
+          </a:prstGeom>
+          <a:noFill/>
+        </p:spPr>
+        <p:txBody>
+          <a:bodyPr wrap="square" lIns="0" rIns="0" tIns="0" bIns="0">
+            <a:spAutoFit/>
+          </a:bodyPr>
+          <a:lstStyle/>
+          <a:p>
+            <a:pPr algn="l"/>
+            <a:r>
+              <a:rPr sz="850" b="1" i="0">
                 <a:solidFill>
                   <a:srgbClr val="333333"/>
                 </a:solidFill>
@@ -29065,23 +29065,23 @@
         </p:nvSpPr>
         <p:spPr>
           <a:xfrm>
-            <a:off x="3977640" y="2532888"/>
-            <a:ext cx="2286000" cy="228600"/>
-          </a:xfrm>
-          <a:prstGeom prst="rect">
-            <a:avLst/>
-          </a:prstGeom>
-          <a:noFill/>
-        </p:spPr>
-        <p:txBody>
-          <a:bodyPr wrap="square" lIns="0" rIns="0" tIns="0" bIns="0">
-            <a:spAutoFit/>
-          </a:bodyPr>
-          <a:lstStyle/>
-          <a:p>
-            <a:pPr algn="l"/>
-            <a:r>
-              <a:rPr sz="950" b="0" i="0">
+            <a:off x="3977640" y="2450592"/>
+            <a:ext cx="2011680" cy="201168"/>
+          </a:xfrm>
+          <a:prstGeom prst="rect">
+            <a:avLst/>
+          </a:prstGeom>
+          <a:noFill/>
+        </p:spPr>
+        <p:txBody>
+          <a:bodyPr wrap="square" lIns="0" rIns="0" tIns="0" bIns="0">
+            <a:spAutoFit/>
+          </a:bodyPr>
+          <a:lstStyle/>
+          <a:p>
+            <a:pPr algn="l"/>
+            <a:r>
+              <a:rPr sz="850" b="0" i="0">
                 <a:solidFill>
                   <a:srgbClr val="707070"/>
                 </a:solidFill>
@@ -29100,7 +29100,7 @@
         </p:nvSpPr>
         <p:spPr>
           <a:xfrm>
-            <a:off x="502920" y="2935224"/>
+            <a:off x="502920" y="2825496"/>
             <a:ext cx="5486400" cy="274320"/>
           </a:xfrm>
           <a:prstGeom prst="rect">
@@ -29135,23 +29135,23 @@
         </p:nvSpPr>
         <p:spPr>
           <a:xfrm>
-            <a:off x="640080" y="3255264"/>
-            <a:ext cx="3291840" cy="228600"/>
-          </a:xfrm>
-          <a:prstGeom prst="rect">
-            <a:avLst/>
-          </a:prstGeom>
-          <a:noFill/>
-        </p:spPr>
-        <p:txBody>
-          <a:bodyPr wrap="square" lIns="0" rIns="0" tIns="0" bIns="0">
-            <a:spAutoFit/>
-          </a:bodyPr>
-          <a:lstStyle/>
-          <a:p>
-            <a:pPr algn="l"/>
-            <a:r>
-              <a:rPr sz="950" b="1" i="0">
+            <a:off x="640080" y="3145536"/>
+            <a:ext cx="3291840" cy="201168"/>
+          </a:xfrm>
+          <a:prstGeom prst="rect">
+            <a:avLst/>
+          </a:prstGeom>
+          <a:noFill/>
+        </p:spPr>
+        <p:txBody>
+          <a:bodyPr wrap="square" lIns="0" rIns="0" tIns="0" bIns="0">
+            <a:spAutoFit/>
+          </a:bodyPr>
+          <a:lstStyle/>
+          <a:p>
+            <a:pPr algn="l"/>
+            <a:r>
+              <a:rPr sz="850" b="1" i="0">
                 <a:solidFill>
                   <a:srgbClr val="333333"/>
                 </a:solidFill>
@@ -29170,23 +29170,23 @@
         </p:nvSpPr>
         <p:spPr>
           <a:xfrm>
-            <a:off x="3977640" y="3255264"/>
-            <a:ext cx="2286000" cy="228600"/>
-          </a:xfrm>
-          <a:prstGeom prst="rect">
-            <a:avLst/>
-          </a:prstGeom>
-          <a:noFill/>
-        </p:spPr>
-        <p:txBody>
-          <a:bodyPr wrap="square" lIns="0" rIns="0" tIns="0" bIns="0">
-            <a:spAutoFit/>
-          </a:bodyPr>
-          <a:lstStyle/>
-          <a:p>
-            <a:pPr algn="l"/>
-            <a:r>
-              <a:rPr sz="950" b="0" i="0">
+            <a:off x="3977640" y="3145536"/>
+            <a:ext cx="2011680" cy="201168"/>
+          </a:xfrm>
+          <a:prstGeom prst="rect">
+            <a:avLst/>
+          </a:prstGeom>
+          <a:noFill/>
+        </p:spPr>
+        <p:txBody>
+          <a:bodyPr wrap="square" lIns="0" rIns="0" tIns="0" bIns="0">
+            <a:spAutoFit/>
+          </a:bodyPr>
+          <a:lstStyle/>
+          <a:p>
+            <a:pPr algn="l"/>
+            <a:r>
+              <a:rPr sz="850" b="0" i="0">
                 <a:solidFill>
                   <a:srgbClr val="707070"/>
                 </a:solidFill>
@@ -29205,23 +29205,23 @@
         </p:nvSpPr>
         <p:spPr>
           <a:xfrm>
-            <a:off x="640080" y="3520440"/>
-            <a:ext cx="3291840" cy="228600"/>
-          </a:xfrm>
-          <a:prstGeom prst="rect">
-            <a:avLst/>
-          </a:prstGeom>
-          <a:noFill/>
-        </p:spPr>
-        <p:txBody>
-          <a:bodyPr wrap="square" lIns="0" rIns="0" tIns="0" bIns="0">
-            <a:spAutoFit/>
-          </a:bodyPr>
-          <a:lstStyle/>
-          <a:p>
-            <a:pPr algn="l"/>
-            <a:r>
-              <a:rPr sz="950" b="1" i="0">
+            <a:off x="640080" y="3383280"/>
+            <a:ext cx="3291840" cy="201168"/>
+          </a:xfrm>
+          <a:prstGeom prst="rect">
+            <a:avLst/>
+          </a:prstGeom>
+          <a:noFill/>
+        </p:spPr>
+        <p:txBody>
+          <a:bodyPr wrap="square" lIns="0" rIns="0" tIns="0" bIns="0">
+            <a:spAutoFit/>
+          </a:bodyPr>
+          <a:lstStyle/>
+          <a:p>
+            <a:pPr algn="l"/>
+            <a:r>
+              <a:rPr sz="850" b="1" i="0">
                 <a:solidFill>
                   <a:srgbClr val="333333"/>
                 </a:solidFill>
@@ -29240,23 +29240,23 @@
         </p:nvSpPr>
         <p:spPr>
           <a:xfrm>
-            <a:off x="3977640" y="3520440"/>
-            <a:ext cx="2286000" cy="228600"/>
-          </a:xfrm>
-          <a:prstGeom prst="rect">
-            <a:avLst/>
-          </a:prstGeom>
-          <a:noFill/>
-        </p:spPr>
-        <p:txBody>
-          <a:bodyPr wrap="square" lIns="0" rIns="0" tIns="0" bIns="0">
-            <a:spAutoFit/>
-          </a:bodyPr>
-          <a:lstStyle/>
-          <a:p>
-            <a:pPr algn="l"/>
-            <a:r>
-              <a:rPr sz="950" b="0" i="0">
+            <a:off x="3977640" y="3383280"/>
+            <a:ext cx="2011680" cy="201168"/>
+          </a:xfrm>
+          <a:prstGeom prst="rect">
+            <a:avLst/>
+          </a:prstGeom>
+          <a:noFill/>
+        </p:spPr>
+        <p:txBody>
+          <a:bodyPr wrap="square" lIns="0" rIns="0" tIns="0" bIns="0">
+            <a:spAutoFit/>
+          </a:bodyPr>
+          <a:lstStyle/>
+          <a:p>
+            <a:pPr algn="l"/>
+            <a:r>
+              <a:rPr sz="850" b="0" i="0">
                 <a:solidFill>
                   <a:srgbClr val="707070"/>
                 </a:solidFill>
@@ -29275,23 +29275,23 @@
         </p:nvSpPr>
         <p:spPr>
           <a:xfrm>
-            <a:off x="640080" y="3785616"/>
-            <a:ext cx="3291840" cy="228600"/>
-          </a:xfrm>
-          <a:prstGeom prst="rect">
-            <a:avLst/>
-          </a:prstGeom>
-          <a:noFill/>
-        </p:spPr>
-        <p:txBody>
-          <a:bodyPr wrap="square" lIns="0" rIns="0" tIns="0" bIns="0">
-            <a:spAutoFit/>
-          </a:bodyPr>
-          <a:lstStyle/>
-          <a:p>
-            <a:pPr algn="l"/>
-            <a:r>
-              <a:rPr sz="950" b="1" i="0">
+            <a:off x="640080" y="3621024"/>
+            <a:ext cx="3291840" cy="201168"/>
+          </a:xfrm>
+          <a:prstGeom prst="rect">
+            <a:avLst/>
+          </a:prstGeom>
+          <a:noFill/>
+        </p:spPr>
+        <p:txBody>
+          <a:bodyPr wrap="square" lIns="0" rIns="0" tIns="0" bIns="0">
+            <a:spAutoFit/>
+          </a:bodyPr>
+          <a:lstStyle/>
+          <a:p>
+            <a:pPr algn="l"/>
+            <a:r>
+              <a:rPr sz="850" b="1" i="0">
                 <a:solidFill>
                   <a:srgbClr val="333333"/>
                 </a:solidFill>
@@ -29310,23 +29310,23 @@
         </p:nvSpPr>
         <p:spPr>
           <a:xfrm>
-            <a:off x="3977640" y="3785616"/>
-            <a:ext cx="2286000" cy="228600"/>
-          </a:xfrm>
-          <a:prstGeom prst="rect">
-            <a:avLst/>
-          </a:prstGeom>
-          <a:noFill/>
-        </p:spPr>
-        <p:txBody>
-          <a:bodyPr wrap="square" lIns="0" rIns="0" tIns="0" bIns="0">
-            <a:spAutoFit/>
-          </a:bodyPr>
-          <a:lstStyle/>
-          <a:p>
-            <a:pPr algn="l"/>
-            <a:r>
-              <a:rPr sz="950" b="0" i="0">
+            <a:off x="3977640" y="3621024"/>
+            <a:ext cx="2011680" cy="201168"/>
+          </a:xfrm>
+          <a:prstGeom prst="rect">
+            <a:avLst/>
+          </a:prstGeom>
+          <a:noFill/>
+        </p:spPr>
+        <p:txBody>
+          <a:bodyPr wrap="square" lIns="0" rIns="0" tIns="0" bIns="0">
+            <a:spAutoFit/>
+          </a:bodyPr>
+          <a:lstStyle/>
+          <a:p>
+            <a:pPr algn="l"/>
+            <a:r>
+              <a:rPr sz="850" b="0" i="0">
                 <a:solidFill>
                   <a:srgbClr val="707070"/>
                 </a:solidFill>
@@ -29345,23 +29345,23 @@
         </p:nvSpPr>
         <p:spPr>
           <a:xfrm>
-            <a:off x="640080" y="4050792"/>
-            <a:ext cx="3291840" cy="228600"/>
-          </a:xfrm>
-          <a:prstGeom prst="rect">
-            <a:avLst/>
-          </a:prstGeom>
-          <a:noFill/>
-        </p:spPr>
-        <p:txBody>
-          <a:bodyPr wrap="square" lIns="0" rIns="0" tIns="0" bIns="0">
-            <a:spAutoFit/>
-          </a:bodyPr>
-          <a:lstStyle/>
-          <a:p>
-            <a:pPr algn="l"/>
-            <a:r>
-              <a:rPr sz="950" b="1" i="0">
+            <a:off x="640080" y="3858768"/>
+            <a:ext cx="3291840" cy="201168"/>
+          </a:xfrm>
+          <a:prstGeom prst="rect">
+            <a:avLst/>
+          </a:prstGeom>
+          <a:noFill/>
+        </p:spPr>
+        <p:txBody>
+          <a:bodyPr wrap="square" lIns="0" rIns="0" tIns="0" bIns="0">
+            <a:spAutoFit/>
+          </a:bodyPr>
+          <a:lstStyle/>
+          <a:p>
+            <a:pPr algn="l"/>
+            <a:r>
+              <a:rPr sz="850" b="1" i="0">
                 <a:solidFill>
                   <a:srgbClr val="333333"/>
                 </a:solidFill>
@@ -29380,23 +29380,23 @@
         </p:nvSpPr>
         <p:spPr>
           <a:xfrm>
-            <a:off x="3977640" y="4050792"/>
-            <a:ext cx="2286000" cy="228600"/>
-          </a:xfrm>
-          <a:prstGeom prst="rect">
-            <a:avLst/>
-          </a:prstGeom>
-          <a:noFill/>
-        </p:spPr>
-        <p:txBody>
-          <a:bodyPr wrap="square" lIns="0" rIns="0" tIns="0" bIns="0">
-            <a:spAutoFit/>
-          </a:bodyPr>
-          <a:lstStyle/>
-          <a:p>
-            <a:pPr algn="l"/>
-            <a:r>
-              <a:rPr sz="950" b="0" i="0">
+            <a:off x="3977640" y="3858768"/>
+            <a:ext cx="2011680" cy="201168"/>
+          </a:xfrm>
+          <a:prstGeom prst="rect">
+            <a:avLst/>
+          </a:prstGeom>
+          <a:noFill/>
+        </p:spPr>
+        <p:txBody>
+          <a:bodyPr wrap="square" lIns="0" rIns="0" tIns="0" bIns="0">
+            <a:spAutoFit/>
+          </a:bodyPr>
+          <a:lstStyle/>
+          <a:p>
+            <a:pPr algn="l"/>
+            <a:r>
+              <a:rPr sz="850" b="0" i="0">
                 <a:solidFill>
                   <a:srgbClr val="707070"/>
                 </a:solidFill>
@@ -29415,23 +29415,23 @@
         </p:nvSpPr>
         <p:spPr>
           <a:xfrm>
-            <a:off x="640080" y="4315968"/>
-            <a:ext cx="3291840" cy="228600"/>
-          </a:xfrm>
-          <a:prstGeom prst="rect">
-            <a:avLst/>
-          </a:prstGeom>
-          <a:noFill/>
-        </p:spPr>
-        <p:txBody>
-          <a:bodyPr wrap="square" lIns="0" rIns="0" tIns="0" bIns="0">
-            <a:spAutoFit/>
-          </a:bodyPr>
-          <a:lstStyle/>
-          <a:p>
-            <a:pPr algn="l"/>
-            <a:r>
-              <a:rPr sz="950" b="1" i="0">
+            <a:off x="640080" y="4096512"/>
+            <a:ext cx="3291840" cy="201168"/>
+          </a:xfrm>
+          <a:prstGeom prst="rect">
+            <a:avLst/>
+          </a:prstGeom>
+          <a:noFill/>
+        </p:spPr>
+        <p:txBody>
+          <a:bodyPr wrap="square" lIns="0" rIns="0" tIns="0" bIns="0">
+            <a:spAutoFit/>
+          </a:bodyPr>
+          <a:lstStyle/>
+          <a:p>
+            <a:pPr algn="l"/>
+            <a:r>
+              <a:rPr sz="850" b="1" i="0">
                 <a:solidFill>
                   <a:srgbClr val="333333"/>
                 </a:solidFill>
@@ -29450,23 +29450,23 @@
         </p:nvSpPr>
         <p:spPr>
           <a:xfrm>
-            <a:off x="3977640" y="4315968"/>
-            <a:ext cx="2286000" cy="228600"/>
-          </a:xfrm>
-          <a:prstGeom prst="rect">
-            <a:avLst/>
-          </a:prstGeom>
-          <a:noFill/>
-        </p:spPr>
-        <p:txBody>
-          <a:bodyPr wrap="square" lIns="0" rIns="0" tIns="0" bIns="0">
-            <a:spAutoFit/>
-          </a:bodyPr>
-          <a:lstStyle/>
-          <a:p>
-            <a:pPr algn="l"/>
-            <a:r>
-              <a:rPr sz="950" b="0" i="0">
+            <a:off x="3977640" y="4096512"/>
+            <a:ext cx="2011680" cy="201168"/>
+          </a:xfrm>
+          <a:prstGeom prst="rect">
+            <a:avLst/>
+          </a:prstGeom>
+          <a:noFill/>
+        </p:spPr>
+        <p:txBody>
+          <a:bodyPr wrap="square" lIns="0" rIns="0" tIns="0" bIns="0">
+            <a:spAutoFit/>
+          </a:bodyPr>
+          <a:lstStyle/>
+          <a:p>
+            <a:pPr algn="l"/>
+            <a:r>
+              <a:rPr sz="850" b="0" i="0">
                 <a:solidFill>
                   <a:srgbClr val="707070"/>
                 </a:solidFill>
@@ -29485,23 +29485,23 @@
         </p:nvSpPr>
         <p:spPr>
           <a:xfrm>
-            <a:off x="640080" y="4581144"/>
-            <a:ext cx="3291840" cy="228600"/>
-          </a:xfrm>
-          <a:prstGeom prst="rect">
-            <a:avLst/>
-          </a:prstGeom>
-          <a:noFill/>
-        </p:spPr>
-        <p:txBody>
-          <a:bodyPr wrap="square" lIns="0" rIns="0" tIns="0" bIns="0">
-            <a:spAutoFit/>
-          </a:bodyPr>
-          <a:lstStyle/>
-          <a:p>
-            <a:pPr algn="l"/>
-            <a:r>
-              <a:rPr sz="950" b="1" i="0">
+            <a:off x="640080" y="4334256"/>
+            <a:ext cx="3291840" cy="201168"/>
+          </a:xfrm>
+          <a:prstGeom prst="rect">
+            <a:avLst/>
+          </a:prstGeom>
+          <a:noFill/>
+        </p:spPr>
+        <p:txBody>
+          <a:bodyPr wrap="square" lIns="0" rIns="0" tIns="0" bIns="0">
+            <a:spAutoFit/>
+          </a:bodyPr>
+          <a:lstStyle/>
+          <a:p>
+            <a:pPr algn="l"/>
+            <a:r>
+              <a:rPr sz="850" b="1" i="0">
                 <a:solidFill>
                   <a:srgbClr val="333333"/>
                 </a:solidFill>
@@ -29520,23 +29520,23 @@
         </p:nvSpPr>
         <p:spPr>
           <a:xfrm>
-            <a:off x="3977640" y="4581144"/>
-            <a:ext cx="2286000" cy="228600"/>
-          </a:xfrm>
-          <a:prstGeom prst="rect">
-            <a:avLst/>
-          </a:prstGeom>
-          <a:noFill/>
-        </p:spPr>
-        <p:txBody>
-          <a:bodyPr wrap="square" lIns="0" rIns="0" tIns="0" bIns="0">
-            <a:spAutoFit/>
-          </a:bodyPr>
-          <a:lstStyle/>
-          <a:p>
-            <a:pPr algn="l"/>
-            <a:r>
-              <a:rPr sz="950" b="0" i="0">
+            <a:off x="3977640" y="4334256"/>
+            <a:ext cx="2011680" cy="201168"/>
+          </a:xfrm>
+          <a:prstGeom prst="rect">
+            <a:avLst/>
+          </a:prstGeom>
+          <a:noFill/>
+        </p:spPr>
+        <p:txBody>
+          <a:bodyPr wrap="square" lIns="0" rIns="0" tIns="0" bIns="0">
+            <a:spAutoFit/>
+          </a:bodyPr>
+          <a:lstStyle/>
+          <a:p>
+            <a:pPr algn="l"/>
+            <a:r>
+              <a:rPr sz="850" b="0" i="0">
                 <a:solidFill>
                   <a:srgbClr val="707070"/>
                 </a:solidFill>
@@ -29591,22 +29591,22 @@
         <p:spPr>
           <a:xfrm>
             <a:off x="6629400" y="1737360"/>
-            <a:ext cx="3291840" cy="228600"/>
-          </a:xfrm>
-          <a:prstGeom prst="rect">
-            <a:avLst/>
-          </a:prstGeom>
-          <a:noFill/>
-        </p:spPr>
-        <p:txBody>
-          <a:bodyPr wrap="square" lIns="0" rIns="0" tIns="0" bIns="0">
-            <a:spAutoFit/>
-          </a:bodyPr>
-          <a:lstStyle/>
-          <a:p>
-            <a:pPr algn="l"/>
-            <a:r>
-              <a:rPr sz="950" b="1" i="0">
+            <a:ext cx="3291840" cy="201168"/>
+          </a:xfrm>
+          <a:prstGeom prst="rect">
+            <a:avLst/>
+          </a:prstGeom>
+          <a:noFill/>
+        </p:spPr>
+        <p:txBody>
+          <a:bodyPr wrap="square" lIns="0" rIns="0" tIns="0" bIns="0">
+            <a:spAutoFit/>
+          </a:bodyPr>
+          <a:lstStyle/>
+          <a:p>
+            <a:pPr algn="l"/>
+            <a:r>
+              <a:rPr sz="850" b="1" i="0">
                 <a:solidFill>
                   <a:srgbClr val="333333"/>
                 </a:solidFill>
@@ -29626,22 +29626,22 @@
         <p:spPr>
           <a:xfrm>
             <a:off x="9966960" y="1737360"/>
-            <a:ext cx="2286000" cy="228600"/>
-          </a:xfrm>
-          <a:prstGeom prst="rect">
-            <a:avLst/>
-          </a:prstGeom>
-          <a:noFill/>
-        </p:spPr>
-        <p:txBody>
-          <a:bodyPr wrap="square" lIns="0" rIns="0" tIns="0" bIns="0">
-            <a:spAutoFit/>
-          </a:bodyPr>
-          <a:lstStyle/>
-          <a:p>
-            <a:pPr algn="l"/>
-            <a:r>
-              <a:rPr sz="950" b="0" i="0">
+            <a:ext cx="2011680" cy="201168"/>
+          </a:xfrm>
+          <a:prstGeom prst="rect">
+            <a:avLst/>
+          </a:prstGeom>
+          <a:noFill/>
+        </p:spPr>
+        <p:txBody>
+          <a:bodyPr wrap="square" lIns="0" rIns="0" tIns="0" bIns="0">
+            <a:spAutoFit/>
+          </a:bodyPr>
+          <a:lstStyle/>
+          <a:p>
+            <a:pPr algn="l"/>
+            <a:r>
+              <a:rPr sz="850" b="0" i="0">
                 <a:solidFill>
                   <a:srgbClr val="707070"/>
                 </a:solidFill>
@@ -29660,23 +29660,23 @@
         </p:nvSpPr>
         <p:spPr>
           <a:xfrm>
-            <a:off x="6629400" y="2002536"/>
-            <a:ext cx="3291840" cy="228600"/>
-          </a:xfrm>
-          <a:prstGeom prst="rect">
-            <a:avLst/>
-          </a:prstGeom>
-          <a:noFill/>
-        </p:spPr>
-        <p:txBody>
-          <a:bodyPr wrap="square" lIns="0" rIns="0" tIns="0" bIns="0">
-            <a:spAutoFit/>
-          </a:bodyPr>
-          <a:lstStyle/>
-          <a:p>
-            <a:pPr algn="l"/>
-            <a:r>
-              <a:rPr sz="950" b="1" i="0">
+            <a:off x="6629400" y="1975104"/>
+            <a:ext cx="3291840" cy="201168"/>
+          </a:xfrm>
+          <a:prstGeom prst="rect">
+            <a:avLst/>
+          </a:prstGeom>
+          <a:noFill/>
+        </p:spPr>
+        <p:txBody>
+          <a:bodyPr wrap="square" lIns="0" rIns="0" tIns="0" bIns="0">
+            <a:spAutoFit/>
+          </a:bodyPr>
+          <a:lstStyle/>
+          <a:p>
+            <a:pPr algn="l"/>
+            <a:r>
+              <a:rPr sz="850" b="1" i="0">
                 <a:solidFill>
                   <a:srgbClr val="333333"/>
                 </a:solidFill>
@@ -29695,23 +29695,23 @@
         </p:nvSpPr>
         <p:spPr>
           <a:xfrm>
-            <a:off x="9966960" y="2002536"/>
-            <a:ext cx="2286000" cy="228600"/>
-          </a:xfrm>
-          <a:prstGeom prst="rect">
-            <a:avLst/>
-          </a:prstGeom>
-          <a:noFill/>
-        </p:spPr>
-        <p:txBody>
-          <a:bodyPr wrap="square" lIns="0" rIns="0" tIns="0" bIns="0">
-            <a:spAutoFit/>
-          </a:bodyPr>
-          <a:lstStyle/>
-          <a:p>
-            <a:pPr algn="l"/>
-            <a:r>
-              <a:rPr sz="950" b="0" i="0">
+            <a:off x="9966960" y="1975104"/>
+            <a:ext cx="2011680" cy="201168"/>
+          </a:xfrm>
+          <a:prstGeom prst="rect">
+            <a:avLst/>
+          </a:prstGeom>
+          <a:noFill/>
+        </p:spPr>
+        <p:txBody>
+          <a:bodyPr wrap="square" lIns="0" rIns="0" tIns="0" bIns="0">
+            <a:spAutoFit/>
+          </a:bodyPr>
+          <a:lstStyle/>
+          <a:p>
+            <a:pPr algn="l"/>
+            <a:r>
+              <a:rPr sz="850" b="0" i="0">
                 <a:solidFill>
                   <a:srgbClr val="707070"/>
                 </a:solidFill>
@@ -29730,23 +29730,23 @@
         </p:nvSpPr>
         <p:spPr>
           <a:xfrm>
-            <a:off x="6629400" y="2267712"/>
-            <a:ext cx="3291840" cy="228600"/>
-          </a:xfrm>
-          <a:prstGeom prst="rect">
-            <a:avLst/>
-          </a:prstGeom>
-          <a:noFill/>
-        </p:spPr>
-        <p:txBody>
-          <a:bodyPr wrap="square" lIns="0" rIns="0" tIns="0" bIns="0">
-            <a:spAutoFit/>
-          </a:bodyPr>
-          <a:lstStyle/>
-          <a:p>
-            <a:pPr algn="l"/>
-            <a:r>
-              <a:rPr sz="950" b="1" i="0">
+            <a:off x="6629400" y="2212848"/>
+            <a:ext cx="3291840" cy="201168"/>
+          </a:xfrm>
+          <a:prstGeom prst="rect">
+            <a:avLst/>
+          </a:prstGeom>
+          <a:noFill/>
+        </p:spPr>
+        <p:txBody>
+          <a:bodyPr wrap="square" lIns="0" rIns="0" tIns="0" bIns="0">
+            <a:spAutoFit/>
+          </a:bodyPr>
+          <a:lstStyle/>
+          <a:p>
+            <a:pPr algn="l"/>
+            <a:r>
+              <a:rPr sz="850" b="1" i="0">
                 <a:solidFill>
                   <a:srgbClr val="333333"/>
                 </a:solidFill>
@@ -29765,23 +29765,23 @@
         </p:nvSpPr>
         <p:spPr>
           <a:xfrm>
-            <a:off x="9966960" y="2267712"/>
-            <a:ext cx="2286000" cy="228600"/>
-          </a:xfrm>
-          <a:prstGeom prst="rect">
-            <a:avLst/>
-          </a:prstGeom>
-          <a:noFill/>
-        </p:spPr>
-        <p:txBody>
-          <a:bodyPr wrap="square" lIns="0" rIns="0" tIns="0" bIns="0">
-            <a:spAutoFit/>
-          </a:bodyPr>
-          <a:lstStyle/>
-          <a:p>
-            <a:pPr algn="l"/>
-            <a:r>
-              <a:rPr sz="950" b="0" i="0">
+            <a:off x="9966960" y="2212848"/>
+            <a:ext cx="2011680" cy="201168"/>
+          </a:xfrm>
+          <a:prstGeom prst="rect">
+            <a:avLst/>
+          </a:prstGeom>
+          <a:noFill/>
+        </p:spPr>
+        <p:txBody>
+          <a:bodyPr wrap="square" lIns="0" rIns="0" tIns="0" bIns="0">
+            <a:spAutoFit/>
+          </a:bodyPr>
+          <a:lstStyle/>
+          <a:p>
+            <a:pPr algn="l"/>
+            <a:r>
+              <a:rPr sz="850" b="0" i="0">
                 <a:solidFill>
                   <a:srgbClr val="707070"/>
                 </a:solidFill>
@@ -29800,23 +29800,23 @@
         </p:nvSpPr>
         <p:spPr>
           <a:xfrm>
-            <a:off x="6629400" y="2532888"/>
-            <a:ext cx="3291840" cy="228600"/>
-          </a:xfrm>
-          <a:prstGeom prst="rect">
-            <a:avLst/>
-          </a:prstGeom>
-          <a:noFill/>
-        </p:spPr>
-        <p:txBody>
-          <a:bodyPr wrap="square" lIns="0" rIns="0" tIns="0" bIns="0">
-            <a:spAutoFit/>
-          </a:bodyPr>
-          <a:lstStyle/>
-          <a:p>
-            <a:pPr algn="l"/>
-            <a:r>
-              <a:rPr sz="950" b="1" i="0">
+            <a:off x="6629400" y="2450592"/>
+            <a:ext cx="3291840" cy="201168"/>
+          </a:xfrm>
+          <a:prstGeom prst="rect">
+            <a:avLst/>
+          </a:prstGeom>
+          <a:noFill/>
+        </p:spPr>
+        <p:txBody>
+          <a:bodyPr wrap="square" lIns="0" rIns="0" tIns="0" bIns="0">
+            <a:spAutoFit/>
+          </a:bodyPr>
+          <a:lstStyle/>
+          <a:p>
+            <a:pPr algn="l"/>
+            <a:r>
+              <a:rPr sz="850" b="1" i="0">
                 <a:solidFill>
                   <a:srgbClr val="333333"/>
                 </a:solidFill>
@@ -29835,23 +29835,23 @@
         </p:nvSpPr>
         <p:spPr>
           <a:xfrm>
-            <a:off x="9966960" y="2532888"/>
-            <a:ext cx="2286000" cy="228600"/>
-          </a:xfrm>
-          <a:prstGeom prst="rect">
-            <a:avLst/>
-          </a:prstGeom>
-          <a:noFill/>
-        </p:spPr>
-        <p:txBody>
-          <a:bodyPr wrap="square" lIns="0" rIns="0" tIns="0" bIns="0">
-            <a:spAutoFit/>
-          </a:bodyPr>
-          <a:lstStyle/>
-          <a:p>
-            <a:pPr algn="l"/>
-            <a:r>
-              <a:rPr sz="950" b="0" i="0">
+            <a:off x="9966960" y="2450592"/>
+            <a:ext cx="2011680" cy="201168"/>
+          </a:xfrm>
+          <a:prstGeom prst="rect">
+            <a:avLst/>
+          </a:prstGeom>
+          <a:noFill/>
+        </p:spPr>
+        <p:txBody>
+          <a:bodyPr wrap="square" lIns="0" rIns="0" tIns="0" bIns="0">
+            <a:spAutoFit/>
+          </a:bodyPr>
+          <a:lstStyle/>
+          <a:p>
+            <a:pPr algn="l"/>
+            <a:r>
+              <a:rPr sz="850" b="0" i="0">
                 <a:solidFill>
                   <a:srgbClr val="707070"/>
                 </a:solidFill>
@@ -29870,23 +29870,23 @@
         </p:nvSpPr>
         <p:spPr>
           <a:xfrm>
-            <a:off x="6629400" y="2798064"/>
-            <a:ext cx="3291840" cy="228600"/>
-          </a:xfrm>
-          <a:prstGeom prst="rect">
-            <a:avLst/>
-          </a:prstGeom>
-          <a:noFill/>
-        </p:spPr>
-        <p:txBody>
-          <a:bodyPr wrap="square" lIns="0" rIns="0" tIns="0" bIns="0">
-            <a:spAutoFit/>
-          </a:bodyPr>
-          <a:lstStyle/>
-          <a:p>
-            <a:pPr algn="l"/>
-            <a:r>
-              <a:rPr sz="950" b="1" i="0">
+            <a:off x="6629400" y="2688336"/>
+            <a:ext cx="3291840" cy="201168"/>
+          </a:xfrm>
+          <a:prstGeom prst="rect">
+            <a:avLst/>
+          </a:prstGeom>
+          <a:noFill/>
+        </p:spPr>
+        <p:txBody>
+          <a:bodyPr wrap="square" lIns="0" rIns="0" tIns="0" bIns="0">
+            <a:spAutoFit/>
+          </a:bodyPr>
+          <a:lstStyle/>
+          <a:p>
+            <a:pPr algn="l"/>
+            <a:r>
+              <a:rPr sz="850" b="1" i="0">
                 <a:solidFill>
                   <a:srgbClr val="333333"/>
                 </a:solidFill>
@@ -29905,23 +29905,23 @@
         </p:nvSpPr>
         <p:spPr>
           <a:xfrm>
-            <a:off x="9966960" y="2798064"/>
-            <a:ext cx="2286000" cy="228600"/>
-          </a:xfrm>
-          <a:prstGeom prst="rect">
-            <a:avLst/>
-          </a:prstGeom>
-          <a:noFill/>
-        </p:spPr>
-        <p:txBody>
-          <a:bodyPr wrap="square" lIns="0" rIns="0" tIns="0" bIns="0">
-            <a:spAutoFit/>
-          </a:bodyPr>
-          <a:lstStyle/>
-          <a:p>
-            <a:pPr algn="l"/>
-            <a:r>
-              <a:rPr sz="950" b="0" i="0">
+            <a:off x="9966960" y="2688336"/>
+            <a:ext cx="2011680" cy="201168"/>
+          </a:xfrm>
+          <a:prstGeom prst="rect">
+            <a:avLst/>
+          </a:prstGeom>
+          <a:noFill/>
+        </p:spPr>
+        <p:txBody>
+          <a:bodyPr wrap="square" lIns="0" rIns="0" tIns="0" bIns="0">
+            <a:spAutoFit/>
+          </a:bodyPr>
+          <a:lstStyle/>
+          <a:p>
+            <a:pPr algn="l"/>
+            <a:r>
+              <a:rPr sz="850" b="0" i="0">
                 <a:solidFill>
                   <a:srgbClr val="707070"/>
                 </a:solidFill>
@@ -29940,23 +29940,23 @@
         </p:nvSpPr>
         <p:spPr>
           <a:xfrm>
-            <a:off x="6629400" y="3063240"/>
-            <a:ext cx="3291840" cy="228600"/>
-          </a:xfrm>
-          <a:prstGeom prst="rect">
-            <a:avLst/>
-          </a:prstGeom>
-          <a:noFill/>
-        </p:spPr>
-        <p:txBody>
-          <a:bodyPr wrap="square" lIns="0" rIns="0" tIns="0" bIns="0">
-            <a:spAutoFit/>
-          </a:bodyPr>
-          <a:lstStyle/>
-          <a:p>
-            <a:pPr algn="l"/>
-            <a:r>
-              <a:rPr sz="950" b="1" i="0">
+            <a:off x="6629400" y="2926080"/>
+            <a:ext cx="3291840" cy="201168"/>
+          </a:xfrm>
+          <a:prstGeom prst="rect">
+            <a:avLst/>
+          </a:prstGeom>
+          <a:noFill/>
+        </p:spPr>
+        <p:txBody>
+          <a:bodyPr wrap="square" lIns="0" rIns="0" tIns="0" bIns="0">
+            <a:spAutoFit/>
+          </a:bodyPr>
+          <a:lstStyle/>
+          <a:p>
+            <a:pPr algn="l"/>
+            <a:r>
+              <a:rPr sz="850" b="1" i="0">
                 <a:solidFill>
                   <a:srgbClr val="333333"/>
                 </a:solidFill>
@@ -29975,23 +29975,23 @@
         </p:nvSpPr>
         <p:spPr>
           <a:xfrm>
-            <a:off x="9966960" y="3063240"/>
-            <a:ext cx="2286000" cy="228600"/>
-          </a:xfrm>
-          <a:prstGeom prst="rect">
-            <a:avLst/>
-          </a:prstGeom>
-          <a:noFill/>
-        </p:spPr>
-        <p:txBody>
-          <a:bodyPr wrap="square" lIns="0" rIns="0" tIns="0" bIns="0">
-            <a:spAutoFit/>
-          </a:bodyPr>
-          <a:lstStyle/>
-          <a:p>
-            <a:pPr algn="l"/>
-            <a:r>
-              <a:rPr sz="950" b="0" i="0">
+            <a:off x="9966960" y="2926080"/>
+            <a:ext cx="2011680" cy="201168"/>
+          </a:xfrm>
+          <a:prstGeom prst="rect">
+            <a:avLst/>
+          </a:prstGeom>
+          <a:noFill/>
+        </p:spPr>
+        <p:txBody>
+          <a:bodyPr wrap="square" lIns="0" rIns="0" tIns="0" bIns="0">
+            <a:spAutoFit/>
+          </a:bodyPr>
+          <a:lstStyle/>
+          <a:p>
+            <a:pPr algn="l"/>
+            <a:r>
+              <a:rPr sz="850" b="0" i="0">
                 <a:solidFill>
                   <a:srgbClr val="707070"/>
                 </a:solidFill>
@@ -30010,7 +30010,7 @@
         </p:nvSpPr>
         <p:spPr>
           <a:xfrm>
-            <a:off x="6492240" y="3465576"/>
+            <a:off x="6492240" y="3300984"/>
             <a:ext cx="5486400" cy="274320"/>
           </a:xfrm>
           <a:prstGeom prst="rect">
@@ -30045,23 +30045,23 @@
         </p:nvSpPr>
         <p:spPr>
           <a:xfrm>
-            <a:off x="6629400" y="3785616"/>
-            <a:ext cx="3291840" cy="228600"/>
-          </a:xfrm>
-          <a:prstGeom prst="rect">
-            <a:avLst/>
-          </a:prstGeom>
-          <a:noFill/>
-        </p:spPr>
-        <p:txBody>
-          <a:bodyPr wrap="square" lIns="0" rIns="0" tIns="0" bIns="0">
-            <a:spAutoFit/>
-          </a:bodyPr>
-          <a:lstStyle/>
-          <a:p>
-            <a:pPr algn="l"/>
-            <a:r>
-              <a:rPr sz="950" b="1" i="0">
+            <a:off x="6629400" y="3621024"/>
+            <a:ext cx="3291840" cy="201168"/>
+          </a:xfrm>
+          <a:prstGeom prst="rect">
+            <a:avLst/>
+          </a:prstGeom>
+          <a:noFill/>
+        </p:spPr>
+        <p:txBody>
+          <a:bodyPr wrap="square" lIns="0" rIns="0" tIns="0" bIns="0">
+            <a:spAutoFit/>
+          </a:bodyPr>
+          <a:lstStyle/>
+          <a:p>
+            <a:pPr algn="l"/>
+            <a:r>
+              <a:rPr sz="850" b="1" i="0">
                 <a:solidFill>
                   <a:srgbClr val="333333"/>
                 </a:solidFill>
@@ -30080,23 +30080,23 @@
         </p:nvSpPr>
         <p:spPr>
           <a:xfrm>
-            <a:off x="9966960" y="3785616"/>
-            <a:ext cx="2286000" cy="228600"/>
-          </a:xfrm>
-          <a:prstGeom prst="rect">
-            <a:avLst/>
-          </a:prstGeom>
-          <a:noFill/>
-        </p:spPr>
-        <p:txBody>
-          <a:bodyPr wrap="square" lIns="0" rIns="0" tIns="0" bIns="0">
-            <a:spAutoFit/>
-          </a:bodyPr>
-          <a:lstStyle/>
-          <a:p>
-            <a:pPr algn="l"/>
-            <a:r>
-              <a:rPr sz="950" b="0" i="0">
+            <a:off x="9966960" y="3621024"/>
+            <a:ext cx="2011680" cy="201168"/>
+          </a:xfrm>
+          <a:prstGeom prst="rect">
+            <a:avLst/>
+          </a:prstGeom>
+          <a:noFill/>
+        </p:spPr>
+        <p:txBody>
+          <a:bodyPr wrap="square" lIns="0" rIns="0" tIns="0" bIns="0">
+            <a:spAutoFit/>
+          </a:bodyPr>
+          <a:lstStyle/>
+          <a:p>
+            <a:pPr algn="l"/>
+            <a:r>
+              <a:rPr sz="850" b="0" i="0">
                 <a:solidFill>
                   <a:srgbClr val="707070"/>
                 </a:solidFill>
@@ -30115,23 +30115,23 @@
         </p:nvSpPr>
         <p:spPr>
           <a:xfrm>
-            <a:off x="6629400" y="4050792"/>
-            <a:ext cx="3291840" cy="228600"/>
-          </a:xfrm>
-          <a:prstGeom prst="rect">
-            <a:avLst/>
-          </a:prstGeom>
-          <a:noFill/>
-        </p:spPr>
-        <p:txBody>
-          <a:bodyPr wrap="square" lIns="0" rIns="0" tIns="0" bIns="0">
-            <a:spAutoFit/>
-          </a:bodyPr>
-          <a:lstStyle/>
-          <a:p>
-            <a:pPr algn="l"/>
-            <a:r>
-              <a:rPr sz="950" b="1" i="0">
+            <a:off x="6629400" y="3858768"/>
+            <a:ext cx="3291840" cy="201168"/>
+          </a:xfrm>
+          <a:prstGeom prst="rect">
+            <a:avLst/>
+          </a:prstGeom>
+          <a:noFill/>
+        </p:spPr>
+        <p:txBody>
+          <a:bodyPr wrap="square" lIns="0" rIns="0" tIns="0" bIns="0">
+            <a:spAutoFit/>
+          </a:bodyPr>
+          <a:lstStyle/>
+          <a:p>
+            <a:pPr algn="l"/>
+            <a:r>
+              <a:rPr sz="850" b="1" i="0">
                 <a:solidFill>
                   <a:srgbClr val="333333"/>
                 </a:solidFill>
@@ -30150,23 +30150,23 @@
         </p:nvSpPr>
         <p:spPr>
           <a:xfrm>
-            <a:off x="9966960" y="4050792"/>
-            <a:ext cx="2286000" cy="228600"/>
-          </a:xfrm>
-          <a:prstGeom prst="rect">
-            <a:avLst/>
-          </a:prstGeom>
-          <a:noFill/>
-        </p:spPr>
-        <p:txBody>
-          <a:bodyPr wrap="square" lIns="0" rIns="0" tIns="0" bIns="0">
-            <a:spAutoFit/>
-          </a:bodyPr>
-          <a:lstStyle/>
-          <a:p>
-            <a:pPr algn="l"/>
-            <a:r>
-              <a:rPr sz="950" b="0" i="0">
+            <a:off x="9966960" y="3858768"/>
+            <a:ext cx="2011680" cy="201168"/>
+          </a:xfrm>
+          <a:prstGeom prst="rect">
+            <a:avLst/>
+          </a:prstGeom>
+          <a:noFill/>
+        </p:spPr>
+        <p:txBody>
+          <a:bodyPr wrap="square" lIns="0" rIns="0" tIns="0" bIns="0">
+            <a:spAutoFit/>
+          </a:bodyPr>
+          <a:lstStyle/>
+          <a:p>
+            <a:pPr algn="l"/>
+            <a:r>
+              <a:rPr sz="850" b="0" i="0">
                 <a:solidFill>
                   <a:srgbClr val="707070"/>
                 </a:solidFill>
@@ -30185,23 +30185,23 @@
         </p:nvSpPr>
         <p:spPr>
           <a:xfrm>
-            <a:off x="6629400" y="4315968"/>
-            <a:ext cx="3291840" cy="228600"/>
-          </a:xfrm>
-          <a:prstGeom prst="rect">
-            <a:avLst/>
-          </a:prstGeom>
-          <a:noFill/>
-        </p:spPr>
-        <p:txBody>
-          <a:bodyPr wrap="square" lIns="0" rIns="0" tIns="0" bIns="0">
-            <a:spAutoFit/>
-          </a:bodyPr>
-          <a:lstStyle/>
-          <a:p>
-            <a:pPr algn="l"/>
-            <a:r>
-              <a:rPr sz="950" b="1" i="0">
+            <a:off x="6629400" y="4096512"/>
+            <a:ext cx="3291840" cy="201168"/>
+          </a:xfrm>
+          <a:prstGeom prst="rect">
+            <a:avLst/>
+          </a:prstGeom>
+          <a:noFill/>
+        </p:spPr>
+        <p:txBody>
+          <a:bodyPr wrap="square" lIns="0" rIns="0" tIns="0" bIns="0">
+            <a:spAutoFit/>
+          </a:bodyPr>
+          <a:lstStyle/>
+          <a:p>
+            <a:pPr algn="l"/>
+            <a:r>
+              <a:rPr sz="850" b="1" i="0">
                 <a:solidFill>
                   <a:srgbClr val="333333"/>
                 </a:solidFill>
@@ -30220,23 +30220,23 @@
         </p:nvSpPr>
         <p:spPr>
           <a:xfrm>
-            <a:off x="9966960" y="4315968"/>
-            <a:ext cx="2286000" cy="228600"/>
-          </a:xfrm>
-          <a:prstGeom prst="rect">
-            <a:avLst/>
-          </a:prstGeom>
-          <a:noFill/>
-        </p:spPr>
-        <p:txBody>
-          <a:bodyPr wrap="square" lIns="0" rIns="0" tIns="0" bIns="0">
-            <a:spAutoFit/>
-          </a:bodyPr>
-          <a:lstStyle/>
-          <a:p>
-            <a:pPr algn="l"/>
-            <a:r>
-              <a:rPr sz="950" b="0" i="0">
+            <a:off x="9966960" y="4096512"/>
+            <a:ext cx="2011680" cy="201168"/>
+          </a:xfrm>
+          <a:prstGeom prst="rect">
+            <a:avLst/>
+          </a:prstGeom>
+          <a:noFill/>
+        </p:spPr>
+        <p:txBody>
+          <a:bodyPr wrap="square" lIns="0" rIns="0" tIns="0" bIns="0">
+            <a:spAutoFit/>
+          </a:bodyPr>
+          <a:lstStyle/>
+          <a:p>
+            <a:pPr algn="l"/>
+            <a:r>
+              <a:rPr sz="850" b="0" i="0">
                 <a:solidFill>
                   <a:srgbClr val="707070"/>
                 </a:solidFill>
@@ -30255,23 +30255,23 @@
         </p:nvSpPr>
         <p:spPr>
           <a:xfrm>
-            <a:off x="6629400" y="4581144"/>
-            <a:ext cx="3291840" cy="228600"/>
-          </a:xfrm>
-          <a:prstGeom prst="rect">
-            <a:avLst/>
-          </a:prstGeom>
-          <a:noFill/>
-        </p:spPr>
-        <p:txBody>
-          <a:bodyPr wrap="square" lIns="0" rIns="0" tIns="0" bIns="0">
-            <a:spAutoFit/>
-          </a:bodyPr>
-          <a:lstStyle/>
-          <a:p>
-            <a:pPr algn="l"/>
-            <a:r>
-              <a:rPr sz="950" b="1" i="0">
+            <a:off x="6629400" y="4334256"/>
+            <a:ext cx="3291840" cy="201168"/>
+          </a:xfrm>
+          <a:prstGeom prst="rect">
+            <a:avLst/>
+          </a:prstGeom>
+          <a:noFill/>
+        </p:spPr>
+        <p:txBody>
+          <a:bodyPr wrap="square" lIns="0" rIns="0" tIns="0" bIns="0">
+            <a:spAutoFit/>
+          </a:bodyPr>
+          <a:lstStyle/>
+          <a:p>
+            <a:pPr algn="l"/>
+            <a:r>
+              <a:rPr sz="850" b="1" i="0">
                 <a:solidFill>
                   <a:srgbClr val="333333"/>
                 </a:solidFill>
@@ -30290,23 +30290,23 @@
         </p:nvSpPr>
         <p:spPr>
           <a:xfrm>
-            <a:off x="9966960" y="4581144"/>
-            <a:ext cx="2286000" cy="228600"/>
-          </a:xfrm>
-          <a:prstGeom prst="rect">
-            <a:avLst/>
-          </a:prstGeom>
-          <a:noFill/>
-        </p:spPr>
-        <p:txBody>
-          <a:bodyPr wrap="square" lIns="0" rIns="0" tIns="0" bIns="0">
-            <a:spAutoFit/>
-          </a:bodyPr>
-          <a:lstStyle/>
-          <a:p>
-            <a:pPr algn="l"/>
-            <a:r>
-              <a:rPr sz="950" b="0" i="0">
+            <a:off x="9966960" y="4334256"/>
+            <a:ext cx="2011680" cy="201168"/>
+          </a:xfrm>
+          <a:prstGeom prst="rect">
+            <a:avLst/>
+          </a:prstGeom>
+          <a:noFill/>
+        </p:spPr>
+        <p:txBody>
+          <a:bodyPr wrap="square" lIns="0" rIns="0" tIns="0" bIns="0">
+            <a:spAutoFit/>
+          </a:bodyPr>
+          <a:lstStyle/>
+          <a:p>
+            <a:pPr algn="l"/>
+            <a:r>
+              <a:rPr sz="850" b="0" i="0">
                 <a:solidFill>
                   <a:srgbClr val="707070"/>
                 </a:solidFill>
@@ -30325,23 +30325,23 @@
         </p:nvSpPr>
         <p:spPr>
           <a:xfrm>
-            <a:off x="6629400" y="4846320"/>
-            <a:ext cx="3291840" cy="228600"/>
-          </a:xfrm>
-          <a:prstGeom prst="rect">
-            <a:avLst/>
-          </a:prstGeom>
-          <a:noFill/>
-        </p:spPr>
-        <p:txBody>
-          <a:bodyPr wrap="square" lIns="0" rIns="0" tIns="0" bIns="0">
-            <a:spAutoFit/>
-          </a:bodyPr>
-          <a:lstStyle/>
-          <a:p>
-            <a:pPr algn="l"/>
-            <a:r>
-              <a:rPr sz="950" b="1" i="0">
+            <a:off x="6629400" y="4572000"/>
+            <a:ext cx="3291840" cy="201168"/>
+          </a:xfrm>
+          <a:prstGeom prst="rect">
+            <a:avLst/>
+          </a:prstGeom>
+          <a:noFill/>
+        </p:spPr>
+        <p:txBody>
+          <a:bodyPr wrap="square" lIns="0" rIns="0" tIns="0" bIns="0">
+            <a:spAutoFit/>
+          </a:bodyPr>
+          <a:lstStyle/>
+          <a:p>
+            <a:pPr algn="l"/>
+            <a:r>
+              <a:rPr sz="850" b="1" i="0">
                 <a:solidFill>
                   <a:srgbClr val="333333"/>
                 </a:solidFill>
@@ -30360,23 +30360,23 @@
         </p:nvSpPr>
         <p:spPr>
           <a:xfrm>
-            <a:off x="9966960" y="4846320"/>
-            <a:ext cx="2286000" cy="228600"/>
-          </a:xfrm>
-          <a:prstGeom prst="rect">
-            <a:avLst/>
-          </a:prstGeom>
-          <a:noFill/>
-        </p:spPr>
-        <p:txBody>
-          <a:bodyPr wrap="square" lIns="0" rIns="0" tIns="0" bIns="0">
-            <a:spAutoFit/>
-          </a:bodyPr>
-          <a:lstStyle/>
-          <a:p>
-            <a:pPr algn="l"/>
-            <a:r>
-              <a:rPr sz="950" b="0" i="0">
+            <a:off x="9966960" y="4572000"/>
+            <a:ext cx="2011680" cy="201168"/>
+          </a:xfrm>
+          <a:prstGeom prst="rect">
+            <a:avLst/>
+          </a:prstGeom>
+          <a:noFill/>
+        </p:spPr>
+        <p:txBody>
+          <a:bodyPr wrap="square" lIns="0" rIns="0" tIns="0" bIns="0">
+            <a:spAutoFit/>
+          </a:bodyPr>
+          <a:lstStyle/>
+          <a:p>
+            <a:pPr algn="l"/>
+            <a:r>
+              <a:rPr sz="850" b="0" i="0">
                 <a:solidFill>
                   <a:srgbClr val="707070"/>
                 </a:solidFill>

</xml_diff>

<commit_message>
Refactor slide 24: national ranking trajectory table front and center
Replaced the old two-chart + subgroup-table layout with a hero
national ranking table (2019-2025, all U.S. districts) on the left,
scatter plot on the right, and a compact peer/MI context strip at
the bottom. Subgroup detail already lives on slide 23.

Co-Authored-By: Claude Opus 4.6 <noreply@anthropic.com>
</commit_message>
<xml_diff>
--- a/analysis/Troy_K5_ELA_Executive_Summary.pptx
+++ b/analysis/Troy_K5_ELA_Executive_Summary.pptx
@@ -19110,7 +19110,7 @@
                 </a:solidFill>
                 <a:latin typeface="Calibri"/>
               </a:rPr>
-              <a:t>Appendix — Troy dropped from top-third to bottom 40% on the ELA leaderboard</a:t>
+              <a:t>Appendix — Troy slid from top 3% to top 11% nationally in K-5 ELA</a:t>
             </a:r>
           </a:p>
         </p:txBody>
@@ -19145,14 +19145,1194 @@
                 </a:solidFill>
                 <a:latin typeface="Calibri"/>
               </a:rPr>
-              <a:t>Absolute performance level among 504 peers — not just change, but where Troy sits now</a:t>
+              <a:t>Year-by-year SEDA national ranking (all U.S. districts) + absolute level among 504 level-matched peers</a:t>
+            </a:r>
+          </a:p>
+        </p:txBody>
+      </p:sp>
+      <p:sp>
+        <p:nvSpPr>
+          <p:cNvPr id="5" name="Rectangle 4"/>
+          <p:cNvSpPr/>
+          <p:nvPr/>
+        </p:nvSpPr>
+        <p:spPr>
+          <a:xfrm>
+            <a:off x="274320" y="868680"/>
+            <a:ext cx="4754880" cy="4206240"/>
+          </a:xfrm>
+          <a:prstGeom prst="rect">
+            <a:avLst/>
+          </a:prstGeom>
+          <a:solidFill>
+            <a:srgbClr val="FCE4E4"/>
+          </a:solidFill>
+          <a:ln>
+            <a:noFill/>
+          </a:ln>
+          <a:effectLst/>
+        </p:spPr>
+        <p:style>
+          <a:lnRef idx="1">
+            <a:schemeClr val="accent1"/>
+          </a:lnRef>
+          <a:fillRef idx="3">
+            <a:schemeClr val="accent1"/>
+          </a:fillRef>
+          <a:effectRef idx="2">
+            <a:schemeClr val="accent1"/>
+          </a:effectRef>
+          <a:fontRef idx="minor">
+            <a:schemeClr val="lt1"/>
+          </a:fontRef>
+        </p:style>
+        <p:txBody>
+          <a:bodyPr rtlCol="0" anchor="ctr"/>
+          <a:lstStyle/>
+          <a:p>
+            <a:pPr algn="ctr"/>
+          </a:p>
+        </p:txBody>
+      </p:sp>
+      <p:sp>
+        <p:nvSpPr>
+          <p:cNvPr id="6" name="TextBox 5"/>
+          <p:cNvSpPr txBox="1"/>
+          <p:nvPr/>
+        </p:nvSpPr>
+        <p:spPr>
+          <a:xfrm>
+            <a:off x="457200" y="960120"/>
+            <a:ext cx="4389120" cy="320040"/>
+          </a:xfrm>
+          <a:prstGeom prst="rect">
+            <a:avLst/>
+          </a:prstGeom>
+          <a:noFill/>
+        </p:spPr>
+        <p:txBody>
+          <a:bodyPr wrap="square" lIns="0" rIns="0" tIns="0" bIns="0">
+            <a:spAutoFit/>
+          </a:bodyPr>
+          <a:lstStyle/>
+          <a:p>
+            <a:pPr algn="l"/>
+            <a:r>
+              <a:rPr sz="1400" b="1" i="0">
+                <a:solidFill>
+                  <a:srgbClr val="B02121"/>
+                </a:solidFill>
+                <a:latin typeface="Calibri"/>
+              </a:rPr>
+              <a:t>National K-5 ELA ranking trajectory</a:t>
+            </a:r>
+          </a:p>
+        </p:txBody>
+      </p:sp>
+      <p:sp>
+        <p:nvSpPr>
+          <p:cNvPr id="7" name="TextBox 6"/>
+          <p:cNvSpPr txBox="1"/>
+          <p:nvPr/>
+        </p:nvSpPr>
+        <p:spPr>
+          <a:xfrm>
+            <a:off x="457200" y="1261872"/>
+            <a:ext cx="4389120" cy="228600"/>
+          </a:xfrm>
+          <a:prstGeom prst="rect">
+            <a:avLst/>
+          </a:prstGeom>
+          <a:noFill/>
+        </p:spPr>
+        <p:txBody>
+          <a:bodyPr wrap="square" lIns="0" rIns="0" tIns="0" bIns="0">
+            <a:spAutoFit/>
+          </a:bodyPr>
+          <a:lstStyle/>
+          <a:p>
+            <a:pPr algn="l"/>
+            <a:r>
+              <a:rPr sz="950" b="0" i="1">
+                <a:solidFill>
+                  <a:srgbClr val="707070"/>
+                </a:solidFill>
+                <a:latin typeface="Calibri"/>
+              </a:rPr>
+              <a:t>SEDA 2025.1 cs scale — all U.S. districts with G3-G5 ELA data</a:t>
+            </a:r>
+          </a:p>
+        </p:txBody>
+      </p:sp>
+      <p:sp>
+        <p:nvSpPr>
+          <p:cNvPr id="8" name="Rectangle 7"/>
+          <p:cNvSpPr/>
+          <p:nvPr/>
+        </p:nvSpPr>
+        <p:spPr>
+          <a:xfrm>
+            <a:off x="365760" y="1600200"/>
+            <a:ext cx="4572000" cy="274320"/>
+          </a:xfrm>
+          <a:prstGeom prst="rect">
+            <a:avLst/>
+          </a:prstGeom>
+          <a:solidFill>
+            <a:srgbClr val="B02121"/>
+          </a:solidFill>
+          <a:ln>
+            <a:noFill/>
+          </a:ln>
+          <a:effectLst/>
+        </p:spPr>
+        <p:style>
+          <a:lnRef idx="1">
+            <a:schemeClr val="accent1"/>
+          </a:lnRef>
+          <a:fillRef idx="3">
+            <a:schemeClr val="accent1"/>
+          </a:fillRef>
+          <a:effectRef idx="2">
+            <a:schemeClr val="accent1"/>
+          </a:effectRef>
+          <a:fontRef idx="minor">
+            <a:schemeClr val="lt1"/>
+          </a:fontRef>
+        </p:style>
+        <p:txBody>
+          <a:bodyPr rtlCol="0" anchor="ctr"/>
+          <a:lstStyle/>
+          <a:p>
+            <a:pPr algn="ctr"/>
+          </a:p>
+        </p:txBody>
+      </p:sp>
+      <p:sp>
+        <p:nvSpPr>
+          <p:cNvPr id="9" name="TextBox 8"/>
+          <p:cNvSpPr txBox="1"/>
+          <p:nvPr/>
+        </p:nvSpPr>
+        <p:spPr>
+          <a:xfrm>
+            <a:off x="457200" y="1636776"/>
+            <a:ext cx="868680" cy="228600"/>
+          </a:xfrm>
+          <a:prstGeom prst="rect">
+            <a:avLst/>
+          </a:prstGeom>
+          <a:noFill/>
+        </p:spPr>
+        <p:txBody>
+          <a:bodyPr wrap="square" lIns="0" rIns="0" tIns="0" bIns="0">
+            <a:spAutoFit/>
+          </a:bodyPr>
+          <a:lstStyle/>
+          <a:p>
+            <a:pPr algn="l"/>
+            <a:r>
+              <a:rPr sz="1100" b="1" i="0">
+                <a:solidFill>
+                  <a:srgbClr val="FFFFFF"/>
+                </a:solidFill>
+                <a:latin typeface="Calibri"/>
+              </a:rPr>
+              <a:t>Year</a:t>
+            </a:r>
+          </a:p>
+        </p:txBody>
+      </p:sp>
+      <p:sp>
+        <p:nvSpPr>
+          <p:cNvPr id="10" name="TextBox 9"/>
+          <p:cNvSpPr txBox="1"/>
+          <p:nvPr/>
+        </p:nvSpPr>
+        <p:spPr>
+          <a:xfrm>
+            <a:off x="1417320" y="1636776"/>
+            <a:ext cx="1005840" cy="228600"/>
+          </a:xfrm>
+          <a:prstGeom prst="rect">
+            <a:avLst/>
+          </a:prstGeom>
+          <a:noFill/>
+        </p:spPr>
+        <p:txBody>
+          <a:bodyPr wrap="square" lIns="0" rIns="0" tIns="0" bIns="0">
+            <a:spAutoFit/>
+          </a:bodyPr>
+          <a:lstStyle/>
+          <a:p>
+            <a:pPr algn="l"/>
+            <a:r>
+              <a:rPr sz="1100" b="1" i="0">
+                <a:solidFill>
+                  <a:srgbClr val="FFFFFF"/>
+                </a:solidFill>
+                <a:latin typeface="Calibri"/>
+              </a:rPr>
+              <a:t>Score</a:t>
+            </a:r>
+          </a:p>
+        </p:txBody>
+      </p:sp>
+      <p:sp>
+        <p:nvSpPr>
+          <p:cNvPr id="11" name="TextBox 10"/>
+          <p:cNvSpPr txBox="1"/>
+          <p:nvPr/>
+        </p:nvSpPr>
+        <p:spPr>
+          <a:xfrm>
+            <a:off x="2514600" y="1636776"/>
+            <a:ext cx="868680" cy="228600"/>
+          </a:xfrm>
+          <a:prstGeom prst="rect">
+            <a:avLst/>
+          </a:prstGeom>
+          <a:noFill/>
+        </p:spPr>
+        <p:txBody>
+          <a:bodyPr wrap="square" lIns="0" rIns="0" tIns="0" bIns="0">
+            <a:spAutoFit/>
+          </a:bodyPr>
+          <a:lstStyle/>
+          <a:p>
+            <a:pPr algn="l"/>
+            <a:r>
+              <a:rPr sz="1100" b="1" i="0">
+                <a:solidFill>
+                  <a:srgbClr val="FFFFFF"/>
+                </a:solidFill>
+                <a:latin typeface="Calibri"/>
+              </a:rPr>
+              <a:t>Rank</a:t>
+            </a:r>
+          </a:p>
+        </p:txBody>
+      </p:sp>
+      <p:sp>
+        <p:nvSpPr>
+          <p:cNvPr id="12" name="TextBox 11"/>
+          <p:cNvSpPr txBox="1"/>
+          <p:nvPr/>
+        </p:nvSpPr>
+        <p:spPr>
+          <a:xfrm>
+            <a:off x="3429000" y="1636776"/>
+            <a:ext cx="1280160" cy="228600"/>
+          </a:xfrm>
+          <a:prstGeom prst="rect">
+            <a:avLst/>
+          </a:prstGeom>
+          <a:noFill/>
+        </p:spPr>
+        <p:txBody>
+          <a:bodyPr wrap="square" lIns="0" rIns="0" tIns="0" bIns="0">
+            <a:spAutoFit/>
+          </a:bodyPr>
+          <a:lstStyle/>
+          <a:p>
+            <a:pPr algn="l"/>
+            <a:r>
+              <a:rPr sz="1100" b="1" i="0">
+                <a:solidFill>
+                  <a:srgbClr val="FFFFFF"/>
+                </a:solidFill>
+                <a:latin typeface="Calibri"/>
+              </a:rPr>
+              <a:t>Percentile</a:t>
+            </a:r>
+          </a:p>
+        </p:txBody>
+      </p:sp>
+      <p:sp>
+        <p:nvSpPr>
+          <p:cNvPr id="13" name="Rectangle 12"/>
+          <p:cNvSpPr/>
+          <p:nvPr/>
+        </p:nvSpPr>
+        <p:spPr>
+          <a:xfrm>
+            <a:off x="365760" y="1929384"/>
+            <a:ext cx="4572000" cy="365760"/>
+          </a:xfrm>
+          <a:prstGeom prst="rect">
+            <a:avLst/>
+          </a:prstGeom>
+          <a:solidFill>
+            <a:srgbClr val="E6F4E8"/>
+          </a:solidFill>
+          <a:ln>
+            <a:noFill/>
+          </a:ln>
+          <a:effectLst/>
+        </p:spPr>
+        <p:style>
+          <a:lnRef idx="1">
+            <a:schemeClr val="accent1"/>
+          </a:lnRef>
+          <a:fillRef idx="3">
+            <a:schemeClr val="accent1"/>
+          </a:fillRef>
+          <a:effectRef idx="2">
+            <a:schemeClr val="accent1"/>
+          </a:effectRef>
+          <a:fontRef idx="minor">
+            <a:schemeClr val="lt1"/>
+          </a:fontRef>
+        </p:style>
+        <p:txBody>
+          <a:bodyPr rtlCol="0" anchor="ctr"/>
+          <a:lstStyle/>
+          <a:p>
+            <a:pPr algn="ctr"/>
+          </a:p>
+        </p:txBody>
+      </p:sp>
+      <p:sp>
+        <p:nvSpPr>
+          <p:cNvPr id="14" name="TextBox 13"/>
+          <p:cNvSpPr txBox="1"/>
+          <p:nvPr/>
+        </p:nvSpPr>
+        <p:spPr>
+          <a:xfrm>
+            <a:off x="457200" y="1947672"/>
+            <a:ext cx="868680" cy="320040"/>
+          </a:xfrm>
+          <a:prstGeom prst="rect">
+            <a:avLst/>
+          </a:prstGeom>
+          <a:noFill/>
+        </p:spPr>
+        <p:txBody>
+          <a:bodyPr wrap="square" lIns="0" rIns="0" tIns="0" bIns="0">
+            <a:spAutoFit/>
+          </a:bodyPr>
+          <a:lstStyle/>
+          <a:p>
+            <a:pPr algn="l"/>
+            <a:r>
+              <a:rPr sz="1400" b="1" i="0">
+                <a:solidFill>
+                  <a:srgbClr val="333333"/>
+                </a:solidFill>
+                <a:latin typeface="Calibri"/>
+              </a:rPr>
+              <a:t>2019</a:t>
+            </a:r>
+          </a:p>
+        </p:txBody>
+      </p:sp>
+      <p:sp>
+        <p:nvSpPr>
+          <p:cNvPr id="15" name="TextBox 14"/>
+          <p:cNvSpPr txBox="1"/>
+          <p:nvPr/>
+        </p:nvSpPr>
+        <p:spPr>
+          <a:xfrm>
+            <a:off x="1417320" y="1947672"/>
+            <a:ext cx="1005840" cy="320040"/>
+          </a:xfrm>
+          <a:prstGeom prst="rect">
+            <a:avLst/>
+          </a:prstGeom>
+          <a:noFill/>
+        </p:spPr>
+        <p:txBody>
+          <a:bodyPr wrap="square" lIns="0" rIns="0" tIns="0" bIns="0">
+            <a:spAutoFit/>
+          </a:bodyPr>
+          <a:lstStyle/>
+          <a:p>
+            <a:pPr algn="l"/>
+            <a:r>
+              <a:rPr sz="1400" b="0" i="0">
+                <a:solidFill>
+                  <a:srgbClr val="333333"/>
+                </a:solidFill>
+                <a:latin typeface="Consolas"/>
+              </a:rPr>
+              <a:t>+0.747</a:t>
+            </a:r>
+          </a:p>
+        </p:txBody>
+      </p:sp>
+      <p:sp>
+        <p:nvSpPr>
+          <p:cNvPr id="16" name="TextBox 15"/>
+          <p:cNvSpPr txBox="1"/>
+          <p:nvPr/>
+        </p:nvSpPr>
+        <p:spPr>
+          <a:xfrm>
+            <a:off x="2514600" y="1947672"/>
+            <a:ext cx="868680" cy="320040"/>
+          </a:xfrm>
+          <a:prstGeom prst="rect">
+            <a:avLst/>
+          </a:prstGeom>
+          <a:noFill/>
+        </p:spPr>
+        <p:txBody>
+          <a:bodyPr wrap="square" lIns="0" rIns="0" tIns="0" bIns="0">
+            <a:spAutoFit/>
+          </a:bodyPr>
+          <a:lstStyle/>
+          <a:p>
+            <a:pPr algn="l"/>
+            <a:r>
+              <a:rPr sz="1200" b="0" i="0">
+                <a:solidFill>
+                  <a:srgbClr val="333333"/>
+                </a:solidFill>
+                <a:latin typeface="Consolas"/>
+              </a:rPr>
+              <a:t>380 / 12,241</a:t>
+            </a:r>
+          </a:p>
+        </p:txBody>
+      </p:sp>
+      <p:sp>
+        <p:nvSpPr>
+          <p:cNvPr id="17" name="TextBox 16"/>
+          <p:cNvSpPr txBox="1"/>
+          <p:nvPr/>
+        </p:nvSpPr>
+        <p:spPr>
+          <a:xfrm>
+            <a:off x="3429000" y="1947672"/>
+            <a:ext cx="1280160" cy="320040"/>
+          </a:xfrm>
+          <a:prstGeom prst="rect">
+            <a:avLst/>
+          </a:prstGeom>
+          <a:noFill/>
+        </p:spPr>
+        <p:txBody>
+          <a:bodyPr wrap="square" lIns="0" rIns="0" tIns="0" bIns="0">
+            <a:spAutoFit/>
+          </a:bodyPr>
+          <a:lstStyle/>
+          <a:p>
+            <a:pPr algn="l"/>
+            <a:r>
+              <a:rPr sz="1300" b="1" i="0">
+                <a:solidFill>
+                  <a:srgbClr val="1F7A3D"/>
+                </a:solidFill>
+                <a:latin typeface="Calibri"/>
+              </a:rPr>
+              <a:t>Top 3.1%</a:t>
+            </a:r>
+          </a:p>
+        </p:txBody>
+      </p:sp>
+      <p:sp>
+        <p:nvSpPr>
+          <p:cNvPr id="18" name="TextBox 17"/>
+          <p:cNvSpPr txBox="1"/>
+          <p:nvPr/>
+        </p:nvSpPr>
+        <p:spPr>
+          <a:xfrm>
+            <a:off x="457200" y="2331720"/>
+            <a:ext cx="868680" cy="320040"/>
+          </a:xfrm>
+          <a:prstGeom prst="rect">
+            <a:avLst/>
+          </a:prstGeom>
+          <a:noFill/>
+        </p:spPr>
+        <p:txBody>
+          <a:bodyPr wrap="square" lIns="0" rIns="0" tIns="0" bIns="0">
+            <a:spAutoFit/>
+          </a:bodyPr>
+          <a:lstStyle/>
+          <a:p>
+            <a:pPr algn="l"/>
+            <a:r>
+              <a:rPr sz="1400" b="1" i="0">
+                <a:solidFill>
+                  <a:srgbClr val="333333"/>
+                </a:solidFill>
+                <a:latin typeface="Calibri"/>
+              </a:rPr>
+              <a:t>2022</a:t>
+            </a:r>
+          </a:p>
+        </p:txBody>
+      </p:sp>
+      <p:sp>
+        <p:nvSpPr>
+          <p:cNvPr id="19" name="TextBox 18"/>
+          <p:cNvSpPr txBox="1"/>
+          <p:nvPr/>
+        </p:nvSpPr>
+        <p:spPr>
+          <a:xfrm>
+            <a:off x="1417320" y="2331720"/>
+            <a:ext cx="1005840" cy="320040"/>
+          </a:xfrm>
+          <a:prstGeom prst="rect">
+            <a:avLst/>
+          </a:prstGeom>
+          <a:noFill/>
+        </p:spPr>
+        <p:txBody>
+          <a:bodyPr wrap="square" lIns="0" rIns="0" tIns="0" bIns="0">
+            <a:spAutoFit/>
+          </a:bodyPr>
+          <a:lstStyle/>
+          <a:p>
+            <a:pPr algn="l"/>
+            <a:r>
+              <a:rPr sz="1400" b="0" i="0">
+                <a:solidFill>
+                  <a:srgbClr val="333333"/>
+                </a:solidFill>
+                <a:latin typeface="Consolas"/>
+              </a:rPr>
+              <a:t>+0.605</a:t>
+            </a:r>
+          </a:p>
+        </p:txBody>
+      </p:sp>
+      <p:sp>
+        <p:nvSpPr>
+          <p:cNvPr id="20" name="TextBox 19"/>
+          <p:cNvSpPr txBox="1"/>
+          <p:nvPr/>
+        </p:nvSpPr>
+        <p:spPr>
+          <a:xfrm>
+            <a:off x="2514600" y="2331720"/>
+            <a:ext cx="868680" cy="320040"/>
+          </a:xfrm>
+          <a:prstGeom prst="rect">
+            <a:avLst/>
+          </a:prstGeom>
+          <a:noFill/>
+        </p:spPr>
+        <p:txBody>
+          <a:bodyPr wrap="square" lIns="0" rIns="0" tIns="0" bIns="0">
+            <a:spAutoFit/>
+          </a:bodyPr>
+          <a:lstStyle/>
+          <a:p>
+            <a:pPr algn="l"/>
+            <a:r>
+              <a:rPr sz="1200" b="0" i="0">
+                <a:solidFill>
+                  <a:srgbClr val="333333"/>
+                </a:solidFill>
+                <a:latin typeface="Consolas"/>
+              </a:rPr>
+              <a:t>604 / 10,588</a:t>
+            </a:r>
+          </a:p>
+        </p:txBody>
+      </p:sp>
+      <p:sp>
+        <p:nvSpPr>
+          <p:cNvPr id="21" name="TextBox 20"/>
+          <p:cNvSpPr txBox="1"/>
+          <p:nvPr/>
+        </p:nvSpPr>
+        <p:spPr>
+          <a:xfrm>
+            <a:off x="3429000" y="2331720"/>
+            <a:ext cx="1280160" cy="320040"/>
+          </a:xfrm>
+          <a:prstGeom prst="rect">
+            <a:avLst/>
+          </a:prstGeom>
+          <a:noFill/>
+        </p:spPr>
+        <p:txBody>
+          <a:bodyPr wrap="square" lIns="0" rIns="0" tIns="0" bIns="0">
+            <a:spAutoFit/>
+          </a:bodyPr>
+          <a:lstStyle/>
+          <a:p>
+            <a:pPr algn="l"/>
+            <a:r>
+              <a:rPr sz="1300" b="1" i="0">
+                <a:solidFill>
+                  <a:srgbClr val="333333"/>
+                </a:solidFill>
+                <a:latin typeface="Calibri"/>
+              </a:rPr>
+              <a:t>Top 5.7%</a:t>
+            </a:r>
+          </a:p>
+        </p:txBody>
+      </p:sp>
+      <p:sp>
+        <p:nvSpPr>
+          <p:cNvPr id="22" name="TextBox 21"/>
+          <p:cNvSpPr txBox="1"/>
+          <p:nvPr/>
+        </p:nvSpPr>
+        <p:spPr>
+          <a:xfrm>
+            <a:off x="457200" y="2715768"/>
+            <a:ext cx="868680" cy="320040"/>
+          </a:xfrm>
+          <a:prstGeom prst="rect">
+            <a:avLst/>
+          </a:prstGeom>
+          <a:noFill/>
+        </p:spPr>
+        <p:txBody>
+          <a:bodyPr wrap="square" lIns="0" rIns="0" tIns="0" bIns="0">
+            <a:spAutoFit/>
+          </a:bodyPr>
+          <a:lstStyle/>
+          <a:p>
+            <a:pPr algn="l"/>
+            <a:r>
+              <a:rPr sz="1400" b="1" i="0">
+                <a:solidFill>
+                  <a:srgbClr val="333333"/>
+                </a:solidFill>
+                <a:latin typeface="Calibri"/>
+              </a:rPr>
+              <a:t>2023</a:t>
+            </a:r>
+          </a:p>
+        </p:txBody>
+      </p:sp>
+      <p:sp>
+        <p:nvSpPr>
+          <p:cNvPr id="23" name="TextBox 22"/>
+          <p:cNvSpPr txBox="1"/>
+          <p:nvPr/>
+        </p:nvSpPr>
+        <p:spPr>
+          <a:xfrm>
+            <a:off x="1417320" y="2715768"/>
+            <a:ext cx="1005840" cy="320040"/>
+          </a:xfrm>
+          <a:prstGeom prst="rect">
+            <a:avLst/>
+          </a:prstGeom>
+          <a:noFill/>
+        </p:spPr>
+        <p:txBody>
+          <a:bodyPr wrap="square" lIns="0" rIns="0" tIns="0" bIns="0">
+            <a:spAutoFit/>
+          </a:bodyPr>
+          <a:lstStyle/>
+          <a:p>
+            <a:pPr algn="l"/>
+            <a:r>
+              <a:rPr sz="1400" b="0" i="0">
+                <a:solidFill>
+                  <a:srgbClr val="333333"/>
+                </a:solidFill>
+                <a:latin typeface="Consolas"/>
+              </a:rPr>
+              <a:t>+0.526</a:t>
+            </a:r>
+          </a:p>
+        </p:txBody>
+      </p:sp>
+      <p:sp>
+        <p:nvSpPr>
+          <p:cNvPr id="24" name="TextBox 23"/>
+          <p:cNvSpPr txBox="1"/>
+          <p:nvPr/>
+        </p:nvSpPr>
+        <p:spPr>
+          <a:xfrm>
+            <a:off x="2514600" y="2715768"/>
+            <a:ext cx="868680" cy="320040"/>
+          </a:xfrm>
+          <a:prstGeom prst="rect">
+            <a:avLst/>
+          </a:prstGeom>
+          <a:noFill/>
+        </p:spPr>
+        <p:txBody>
+          <a:bodyPr wrap="square" lIns="0" rIns="0" tIns="0" bIns="0">
+            <a:spAutoFit/>
+          </a:bodyPr>
+          <a:lstStyle/>
+          <a:p>
+            <a:pPr algn="l"/>
+            <a:r>
+              <a:rPr sz="1200" b="0" i="0">
+                <a:solidFill>
+                  <a:srgbClr val="333333"/>
+                </a:solidFill>
+                <a:latin typeface="Consolas"/>
+              </a:rPr>
+              <a:t>740 / 10,632</a:t>
+            </a:r>
+          </a:p>
+        </p:txBody>
+      </p:sp>
+      <p:sp>
+        <p:nvSpPr>
+          <p:cNvPr id="25" name="TextBox 24"/>
+          <p:cNvSpPr txBox="1"/>
+          <p:nvPr/>
+        </p:nvSpPr>
+        <p:spPr>
+          <a:xfrm>
+            <a:off x="3429000" y="2715768"/>
+            <a:ext cx="1280160" cy="320040"/>
+          </a:xfrm>
+          <a:prstGeom prst="rect">
+            <a:avLst/>
+          </a:prstGeom>
+          <a:noFill/>
+        </p:spPr>
+        <p:txBody>
+          <a:bodyPr wrap="square" lIns="0" rIns="0" tIns="0" bIns="0">
+            <a:spAutoFit/>
+          </a:bodyPr>
+          <a:lstStyle/>
+          <a:p>
+            <a:pPr algn="l"/>
+            <a:r>
+              <a:rPr sz="1300" b="1" i="0">
+                <a:solidFill>
+                  <a:srgbClr val="333333"/>
+                </a:solidFill>
+                <a:latin typeface="Calibri"/>
+              </a:rPr>
+              <a:t>Top 7.0%</a:t>
+            </a:r>
+          </a:p>
+        </p:txBody>
+      </p:sp>
+      <p:sp>
+        <p:nvSpPr>
+          <p:cNvPr id="26" name="TextBox 25"/>
+          <p:cNvSpPr txBox="1"/>
+          <p:nvPr/>
+        </p:nvSpPr>
+        <p:spPr>
+          <a:xfrm>
+            <a:off x="457200" y="3099816"/>
+            <a:ext cx="868680" cy="320040"/>
+          </a:xfrm>
+          <a:prstGeom prst="rect">
+            <a:avLst/>
+          </a:prstGeom>
+          <a:noFill/>
+        </p:spPr>
+        <p:txBody>
+          <a:bodyPr wrap="square" lIns="0" rIns="0" tIns="0" bIns="0">
+            <a:spAutoFit/>
+          </a:bodyPr>
+          <a:lstStyle/>
+          <a:p>
+            <a:pPr algn="l"/>
+            <a:r>
+              <a:rPr sz="1400" b="1" i="0">
+                <a:solidFill>
+                  <a:srgbClr val="B02121"/>
+                </a:solidFill>
+                <a:latin typeface="Calibri"/>
+              </a:rPr>
+              <a:t>2024</a:t>
+            </a:r>
+          </a:p>
+        </p:txBody>
+      </p:sp>
+      <p:sp>
+        <p:nvSpPr>
+          <p:cNvPr id="27" name="TextBox 26"/>
+          <p:cNvSpPr txBox="1"/>
+          <p:nvPr/>
+        </p:nvSpPr>
+        <p:spPr>
+          <a:xfrm>
+            <a:off x="1417320" y="3099816"/>
+            <a:ext cx="1005840" cy="320040"/>
+          </a:xfrm>
+          <a:prstGeom prst="rect">
+            <a:avLst/>
+          </a:prstGeom>
+          <a:noFill/>
+        </p:spPr>
+        <p:txBody>
+          <a:bodyPr wrap="square" lIns="0" rIns="0" tIns="0" bIns="0">
+            <a:spAutoFit/>
+          </a:bodyPr>
+          <a:lstStyle/>
+          <a:p>
+            <a:pPr algn="l"/>
+            <a:r>
+              <a:rPr sz="1400" b="0" i="0">
+                <a:solidFill>
+                  <a:srgbClr val="B02121"/>
+                </a:solidFill>
+                <a:latin typeface="Consolas"/>
+              </a:rPr>
+              <a:t>+0.390</a:t>
+            </a:r>
+          </a:p>
+        </p:txBody>
+      </p:sp>
+      <p:sp>
+        <p:nvSpPr>
+          <p:cNvPr id="28" name="TextBox 27"/>
+          <p:cNvSpPr txBox="1"/>
+          <p:nvPr/>
+        </p:nvSpPr>
+        <p:spPr>
+          <a:xfrm>
+            <a:off x="2514600" y="3099816"/>
+            <a:ext cx="868680" cy="320040"/>
+          </a:xfrm>
+          <a:prstGeom prst="rect">
+            <a:avLst/>
+          </a:prstGeom>
+          <a:noFill/>
+        </p:spPr>
+        <p:txBody>
+          <a:bodyPr wrap="square" lIns="0" rIns="0" tIns="0" bIns="0">
+            <a:spAutoFit/>
+          </a:bodyPr>
+          <a:lstStyle/>
+          <a:p>
+            <a:pPr algn="l"/>
+            <a:r>
+              <a:rPr sz="1200" b="0" i="0">
+                <a:solidFill>
+                  <a:srgbClr val="B02121"/>
+                </a:solidFill>
+                <a:latin typeface="Consolas"/>
+              </a:rPr>
+              <a:t>1,106 / 10,457</a:t>
+            </a:r>
+          </a:p>
+        </p:txBody>
+      </p:sp>
+      <p:sp>
+        <p:nvSpPr>
+          <p:cNvPr id="29" name="TextBox 28"/>
+          <p:cNvSpPr txBox="1"/>
+          <p:nvPr/>
+        </p:nvSpPr>
+        <p:spPr>
+          <a:xfrm>
+            <a:off x="3429000" y="3099816"/>
+            <a:ext cx="1280160" cy="320040"/>
+          </a:xfrm>
+          <a:prstGeom prst="rect">
+            <a:avLst/>
+          </a:prstGeom>
+          <a:noFill/>
+        </p:spPr>
+        <p:txBody>
+          <a:bodyPr wrap="square" lIns="0" rIns="0" tIns="0" bIns="0">
+            <a:spAutoFit/>
+          </a:bodyPr>
+          <a:lstStyle/>
+          <a:p>
+            <a:pPr algn="l"/>
+            <a:r>
+              <a:rPr sz="1300" b="1" i="0">
+                <a:solidFill>
+                  <a:srgbClr val="B02121"/>
+                </a:solidFill>
+                <a:latin typeface="Calibri"/>
+              </a:rPr>
+              <a:t>Top 10.6%</a:t>
+            </a:r>
+          </a:p>
+        </p:txBody>
+      </p:sp>
+      <p:sp>
+        <p:nvSpPr>
+          <p:cNvPr id="30" name="TextBox 29"/>
+          <p:cNvSpPr txBox="1"/>
+          <p:nvPr/>
+        </p:nvSpPr>
+        <p:spPr>
+          <a:xfrm>
+            <a:off x="457200" y="3483864"/>
+            <a:ext cx="868680" cy="320040"/>
+          </a:xfrm>
+          <a:prstGeom prst="rect">
+            <a:avLst/>
+          </a:prstGeom>
+          <a:noFill/>
+        </p:spPr>
+        <p:txBody>
+          <a:bodyPr wrap="square" lIns="0" rIns="0" tIns="0" bIns="0">
+            <a:spAutoFit/>
+          </a:bodyPr>
+          <a:lstStyle/>
+          <a:p>
+            <a:pPr algn="l"/>
+            <a:r>
+              <a:rPr sz="1400" b="1" i="0">
+                <a:solidFill>
+                  <a:srgbClr val="B02121"/>
+                </a:solidFill>
+                <a:latin typeface="Calibri"/>
+              </a:rPr>
+              <a:t>2025</a:t>
+            </a:r>
+          </a:p>
+        </p:txBody>
+      </p:sp>
+      <p:sp>
+        <p:nvSpPr>
+          <p:cNvPr id="31" name="TextBox 30"/>
+          <p:cNvSpPr txBox="1"/>
+          <p:nvPr/>
+        </p:nvSpPr>
+        <p:spPr>
+          <a:xfrm>
+            <a:off x="1417320" y="3483864"/>
+            <a:ext cx="1005840" cy="320040"/>
+          </a:xfrm>
+          <a:prstGeom prst="rect">
+            <a:avLst/>
+          </a:prstGeom>
+          <a:noFill/>
+        </p:spPr>
+        <p:txBody>
+          <a:bodyPr wrap="square" lIns="0" rIns="0" tIns="0" bIns="0">
+            <a:spAutoFit/>
+          </a:bodyPr>
+          <a:lstStyle/>
+          <a:p>
+            <a:pPr algn="l"/>
+            <a:r>
+              <a:rPr sz="1400" b="0" i="0">
+                <a:solidFill>
+                  <a:srgbClr val="B02121"/>
+                </a:solidFill>
+                <a:latin typeface="Consolas"/>
+              </a:rPr>
+              <a:t>+0.387</a:t>
+            </a:r>
+          </a:p>
+        </p:txBody>
+      </p:sp>
+      <p:sp>
+        <p:nvSpPr>
+          <p:cNvPr id="32" name="TextBox 31"/>
+          <p:cNvSpPr txBox="1"/>
+          <p:nvPr/>
+        </p:nvSpPr>
+        <p:spPr>
+          <a:xfrm>
+            <a:off x="2514600" y="3483864"/>
+            <a:ext cx="868680" cy="320040"/>
+          </a:xfrm>
+          <a:prstGeom prst="rect">
+            <a:avLst/>
+          </a:prstGeom>
+          <a:noFill/>
+        </p:spPr>
+        <p:txBody>
+          <a:bodyPr wrap="square" lIns="0" rIns="0" tIns="0" bIns="0">
+            <a:spAutoFit/>
+          </a:bodyPr>
+          <a:lstStyle/>
+          <a:p>
+            <a:pPr algn="l"/>
+            <a:r>
+              <a:rPr sz="1200" b="0" i="0">
+                <a:solidFill>
+                  <a:srgbClr val="B02121"/>
+                </a:solidFill>
+                <a:latin typeface="Consolas"/>
+              </a:rPr>
+              <a:t>969 / 8,921</a:t>
+            </a:r>
+          </a:p>
+        </p:txBody>
+      </p:sp>
+      <p:sp>
+        <p:nvSpPr>
+          <p:cNvPr id="33" name="TextBox 32"/>
+          <p:cNvSpPr txBox="1"/>
+          <p:nvPr/>
+        </p:nvSpPr>
+        <p:spPr>
+          <a:xfrm>
+            <a:off x="3429000" y="3483864"/>
+            <a:ext cx="1280160" cy="320040"/>
+          </a:xfrm>
+          <a:prstGeom prst="rect">
+            <a:avLst/>
+          </a:prstGeom>
+          <a:noFill/>
+        </p:spPr>
+        <p:txBody>
+          <a:bodyPr wrap="square" lIns="0" rIns="0" tIns="0" bIns="0">
+            <a:spAutoFit/>
+          </a:bodyPr>
+          <a:lstStyle/>
+          <a:p>
+            <a:pPr algn="l"/>
+            <a:r>
+              <a:rPr sz="1300" b="1" i="0">
+                <a:solidFill>
+                  <a:srgbClr val="B02121"/>
+                </a:solidFill>
+                <a:latin typeface="Calibri"/>
+              </a:rPr>
+              <a:t>Top 10.9%</a:t>
+            </a:r>
+          </a:p>
+        </p:txBody>
+      </p:sp>
+      <p:sp>
+        <p:nvSpPr>
+          <p:cNvPr id="34" name="Rectangle 33"/>
+          <p:cNvSpPr/>
+          <p:nvPr/>
+        </p:nvSpPr>
+        <p:spPr>
+          <a:xfrm>
+            <a:off x="365760" y="3611880"/>
+            <a:ext cx="4572000" cy="36576"/>
+          </a:xfrm>
+          <a:prstGeom prst="rect">
+            <a:avLst/>
+          </a:prstGeom>
+          <a:solidFill>
+            <a:srgbClr val="B02121"/>
+          </a:solidFill>
+          <a:ln>
+            <a:noFill/>
+          </a:ln>
+          <a:effectLst/>
+        </p:spPr>
+        <p:style>
+          <a:lnRef idx="1">
+            <a:schemeClr val="accent1"/>
+          </a:lnRef>
+          <a:fillRef idx="3">
+            <a:schemeClr val="accent1"/>
+          </a:fillRef>
+          <a:effectRef idx="2">
+            <a:schemeClr val="accent1"/>
+          </a:effectRef>
+          <a:fontRef idx="minor">
+            <a:schemeClr val="lt1"/>
+          </a:fontRef>
+        </p:style>
+        <p:txBody>
+          <a:bodyPr rtlCol="0" anchor="ctr"/>
+          <a:lstStyle/>
+          <a:p>
+            <a:pPr algn="ctr"/>
+          </a:p>
+        </p:txBody>
+      </p:sp>
+      <p:sp>
+        <p:nvSpPr>
+          <p:cNvPr id="35" name="TextBox 34"/>
+          <p:cNvSpPr txBox="1"/>
+          <p:nvPr/>
+        </p:nvSpPr>
+        <p:spPr>
+          <a:xfrm>
+            <a:off x="457200" y="3749039"/>
+            <a:ext cx="4389120" cy="320040"/>
+          </a:xfrm>
+          <a:prstGeom prst="rect">
+            <a:avLst/>
+          </a:prstGeom>
+          <a:noFill/>
+        </p:spPr>
+        <p:txBody>
+          <a:bodyPr wrap="square" lIns="0" rIns="0" tIns="0" bIns="0">
+            <a:spAutoFit/>
+          </a:bodyPr>
+          <a:lstStyle/>
+          <a:p>
+            <a:pPr algn="l"/>
+            <a:r>
+              <a:rPr sz="1600" b="1" i="0">
+                <a:solidFill>
+                  <a:srgbClr val="B02121"/>
+                </a:solidFill>
+                <a:latin typeface="Calibri"/>
+              </a:rPr>
+              <a:t>Dropped ~600 places in 4 years</a:t>
+            </a:r>
+          </a:p>
+        </p:txBody>
+      </p:sp>
+      <p:sp>
+        <p:nvSpPr>
+          <p:cNvPr id="36" name="TextBox 35"/>
+          <p:cNvSpPr txBox="1"/>
+          <p:nvPr/>
+        </p:nvSpPr>
+        <p:spPr>
+          <a:xfrm>
+            <a:off x="457200" y="4114800"/>
+            <a:ext cx="4389120" cy="822960"/>
+          </a:xfrm>
+          <a:prstGeom prst="rect">
+            <a:avLst/>
+          </a:prstGeom>
+          <a:noFill/>
+        </p:spPr>
+        <p:txBody>
+          <a:bodyPr wrap="square" lIns="0" rIns="0" tIns="0" bIns="0">
+            <a:spAutoFit/>
+          </a:bodyPr>
+          <a:lstStyle/>
+          <a:p>
+            <a:pPr algn="l"/>
+            <a:r>
+              <a:rPr sz="1100" b="0" i="0">
+                <a:solidFill>
+                  <a:srgbClr val="333333"/>
+                </a:solidFill>
+                <a:latin typeface="Calibri"/>
+              </a:rPr>
+              <a:t>Troy went from top 3% nationally to the edge of the top decile.</a:t>
+            </a:r>
+          </a:p>
+          <a:p>
+            <a:pPr algn="l"/>
+            <a:r>
+              <a:rPr sz="1100" b="0" i="0">
+                <a:solidFill>
+                  <a:srgbClr val="333333"/>
+                </a:solidFill>
+                <a:latin typeface="Calibri"/>
+              </a:rPr>
+              <a:t>Score declined −0.360 grade levels (nearly half a grade).</a:t>
+            </a:r>
+          </a:p>
+          <a:p>
+            <a:pPr algn="l"/>
+            <a:r>
+              <a:rPr sz="1100" b="0" i="0">
+                <a:solidFill>
+                  <a:srgbClr val="333333"/>
+                </a:solidFill>
+                <a:latin typeface="Calibri"/>
+              </a:rPr>
+              <a:t>2025 rank ticks up slightly only because fewer districts reported.</a:t>
             </a:r>
           </a:p>
         </p:txBody>
       </p:sp>
       <p:pic>
         <p:nvPicPr>
-          <p:cNvPr id="5" name="Picture 4" descr="chart_seda_scatter.png"/>
+          <p:cNvPr id="37" name="Picture 36" descr="chart_seda_scatter.png"/>
           <p:cNvPicPr>
             <a:picLocks noChangeAspect="1"/>
           </p:cNvPicPr>
@@ -19166,48 +20346,24 @@
         </p:blipFill>
         <p:spPr>
           <a:xfrm>
-            <a:off x="274320" y="868680"/>
-            <a:ext cx="5669280" cy="4157472"/>
+            <a:off x="5212080" y="868680"/>
+            <a:ext cx="6675120" cy="4895088"/>
           </a:xfrm>
           <a:prstGeom prst="rect">
             <a:avLst/>
           </a:prstGeom>
         </p:spPr>
       </p:pic>
-      <p:pic>
-        <p:nvPicPr>
-          <p:cNvPr id="6" name="Picture 5" descr="chart_seda_rank_shift.png"/>
-          <p:cNvPicPr>
-            <a:picLocks noChangeAspect="1"/>
-          </p:cNvPicPr>
-          <p:nvPr/>
-        </p:nvPicPr>
-        <p:blipFill>
-          <a:blip r:embed="rId3"/>
-          <a:stretch>
-            <a:fillRect/>
-          </a:stretch>
-        </p:blipFill>
-        <p:spPr>
-          <a:xfrm>
-            <a:off x="6126480" y="868680"/>
-            <a:ext cx="5760720" cy="4224528"/>
-          </a:xfrm>
-          <a:prstGeom prst="rect">
-            <a:avLst/>
-          </a:prstGeom>
-        </p:spPr>
-      </p:pic>
-      <p:sp>
-        <p:nvSpPr>
-          <p:cNvPr id="7" name="Rectangle 6"/>
+      <p:sp>
+        <p:nvSpPr>
+          <p:cNvPr id="38" name="Rectangle 37"/>
           <p:cNvSpPr/>
           <p:nvPr/>
         </p:nvSpPr>
         <p:spPr>
           <a:xfrm>
-            <a:off x="274320" y="5029200"/>
-            <a:ext cx="11612880" cy="1371600"/>
+            <a:off x="274320" y="5166360"/>
+            <a:ext cx="11612880" cy="1234440"/>
           </a:xfrm>
           <a:prstGeom prst="rect">
             <a:avLst/>
@@ -19244,49 +20400,178 @@
       </p:sp>
       <p:sp>
         <p:nvSpPr>
-          <p:cNvPr id="8" name="TextBox 7"/>
-          <p:cNvSpPr txBox="1"/>
-          <p:nvPr/>
-        </p:nvSpPr>
-        <p:spPr>
-          <a:xfrm>
-            <a:off x="457200" y="5074920"/>
-            <a:ext cx="10972800" cy="228600"/>
-          </a:xfrm>
-          <a:prstGeom prst="rect">
-            <a:avLst/>
-          </a:prstGeom>
-          <a:noFill/>
-        </p:spPr>
-        <p:txBody>
-          <a:bodyPr wrap="square" lIns="0" rIns="0" tIns="0" bIns="0">
-            <a:spAutoFit/>
-          </a:bodyPr>
-          <a:lstStyle/>
-          <a:p>
-            <a:pPr algn="l"/>
-            <a:r>
-              <a:rPr sz="1000" b="1" i="0">
+          <p:cNvPr id="39" name="TextBox 38"/>
+          <p:cNvSpPr txBox="1"/>
+          <p:nvPr/>
+        </p:nvSpPr>
+        <p:spPr>
+          <a:xfrm>
+            <a:off x="457200" y="5212080"/>
+            <a:ext cx="4572000" cy="228600"/>
+          </a:xfrm>
+          <a:prstGeom prst="rect">
+            <a:avLst/>
+          </a:prstGeom>
+          <a:noFill/>
+        </p:spPr>
+        <p:txBody>
+          <a:bodyPr wrap="square" lIns="0" rIns="0" tIns="0" bIns="0">
+            <a:spAutoFit/>
+          </a:bodyPr>
+          <a:lstStyle/>
+          <a:p>
+            <a:pPr algn="l"/>
+            <a:r>
+              <a:rPr sz="1100" b="1" i="0">
                 <a:solidFill>
                   <a:srgbClr val="1F3A5F"/>
                 </a:solidFill>
                 <a:latin typeface="Calibri"/>
               </a:rPr>
-              <a:t>Every subgroup: pre-COVID rank → post-COVID rank (among 504 level-matched peers, 1 = highest)</a:t>
-            </a:r>
-          </a:p>
-        </p:txBody>
-      </p:sp>
-      <p:sp>
-        <p:nvSpPr>
-          <p:cNvPr id="9" name="TextBox 8"/>
-          <p:cNvSpPr txBox="1"/>
-          <p:nvPr/>
-        </p:nvSpPr>
-        <p:spPr>
-          <a:xfrm>
-            <a:off x="457200" y="5321808"/>
-            <a:ext cx="1463040" cy="182880"/>
+              <a:t>Among 504 level-matched peers</a:t>
+            </a:r>
+          </a:p>
+        </p:txBody>
+      </p:sp>
+      <p:sp>
+        <p:nvSpPr>
+          <p:cNvPr id="40" name="TextBox 39"/>
+          <p:cNvSpPr txBox="1"/>
+          <p:nvPr/>
+        </p:nvSpPr>
+        <p:spPr>
+          <a:xfrm>
+            <a:off x="457200" y="5440680"/>
+            <a:ext cx="4572000" cy="822960"/>
+          </a:xfrm>
+          <a:prstGeom prst="rect">
+            <a:avLst/>
+          </a:prstGeom>
+          <a:noFill/>
+        </p:spPr>
+        <p:txBody>
+          <a:bodyPr wrap="square" lIns="0" rIns="0" tIns="0" bIns="0">
+            <a:spAutoFit/>
+          </a:bodyPr>
+          <a:lstStyle/>
+          <a:p>
+            <a:pPr algn="l"/>
+            <a:r>
+              <a:rPr sz="1100" b="0" i="0">
+                <a:solidFill>
+                  <a:srgbClr val="333333"/>
+                </a:solidFill>
+                <a:latin typeface="Consolas"/>
+              </a:rPr>
+              <a:t>Pre-COVID rank: 171 / 504  (top third)</a:t>
+            </a:r>
+          </a:p>
+          <a:p>
+            <a:pPr algn="l"/>
+            <a:r>
+              <a:rPr sz="1100" b="0" i="0">
+                <a:solidFill>
+                  <a:srgbClr val="333333"/>
+                </a:solidFill>
+                <a:latin typeface="Consolas"/>
+              </a:rPr>
+              <a:t>Post-COVID rank: 313 / 504  (bottom 40%)</a:t>
+            </a:r>
+          </a:p>
+          <a:p>
+            <a:pPr algn="l"/>
+            <a:r>
+              <a:rPr sz="1100" b="0" i="0">
+                <a:solidFill>
+                  <a:srgbClr val="333333"/>
+                </a:solidFill>
+                <a:latin typeface="Consolas"/>
+              </a:rPr>
+              <a:t>150 districts leapfrogged Troy</a:t>
+            </a:r>
+          </a:p>
+        </p:txBody>
+      </p:sp>
+      <p:sp>
+        <p:nvSpPr>
+          <p:cNvPr id="41" name="TextBox 40"/>
+          <p:cNvSpPr txBox="1"/>
+          <p:nvPr/>
+        </p:nvSpPr>
+        <p:spPr>
+          <a:xfrm>
+            <a:off x="5212080" y="5212080"/>
+            <a:ext cx="6400800" cy="228600"/>
+          </a:xfrm>
+          <a:prstGeom prst="rect">
+            <a:avLst/>
+          </a:prstGeom>
+          <a:noFill/>
+        </p:spPr>
+        <p:txBody>
+          <a:bodyPr wrap="square" lIns="0" rIns="0" tIns="0" bIns="0">
+            <a:spAutoFit/>
+          </a:bodyPr>
+          <a:lstStyle/>
+          <a:p>
+            <a:pPr algn="l"/>
+            <a:r>
+              <a:rPr sz="1100" b="1" i="0">
+                <a:solidFill>
+                  <a:srgbClr val="1F3A5F"/>
+                </a:solidFill>
+                <a:latin typeface="Calibri"/>
+              </a:rPr>
+              <a:t>Michigan affluent peers — all declined, Troy fell furthest</a:t>
+            </a:r>
+          </a:p>
+        </p:txBody>
+      </p:sp>
+      <p:sp>
+        <p:nvSpPr>
+          <p:cNvPr id="42" name="TextBox 41"/>
+          <p:cNvSpPr txBox="1"/>
+          <p:nvPr/>
+        </p:nvSpPr>
+        <p:spPr>
+          <a:xfrm>
+            <a:off x="5212080" y="5468112"/>
+            <a:ext cx="960120" cy="274320"/>
+          </a:xfrm>
+          <a:prstGeom prst="rect">
+            <a:avLst/>
+          </a:prstGeom>
+          <a:noFill/>
+        </p:spPr>
+        <p:txBody>
+          <a:bodyPr wrap="square" lIns="0" rIns="0" tIns="0" bIns="0">
+            <a:spAutoFit/>
+          </a:bodyPr>
+          <a:lstStyle/>
+          <a:p>
+            <a:pPr algn="l"/>
+            <a:r>
+              <a:rPr sz="850" b="0" i="0">
+                <a:solidFill>
+                  <a:srgbClr val="333333"/>
+                </a:solidFill>
+                <a:latin typeface="Calibri"/>
+              </a:rPr>
+              <a:t>Byron Center</a:t>
+            </a:r>
+          </a:p>
+        </p:txBody>
+      </p:sp>
+      <p:sp>
+        <p:nvSpPr>
+          <p:cNvPr id="43" name="TextBox 42"/>
+          <p:cNvSpPr txBox="1"/>
+          <p:nvPr/>
+        </p:nvSpPr>
+        <p:spPr>
+          <a:xfrm>
+            <a:off x="6172200" y="5468112"/>
+            <a:ext cx="594360" cy="274320"/>
           </a:xfrm>
           <a:prstGeom prst="rect">
             <a:avLst/>
@@ -19303,25 +20588,60 @@
             <a:r>
               <a:rPr sz="900" b="1" i="0">
                 <a:solidFill>
-                  <a:srgbClr val="1F3A5F"/>
-                </a:solidFill>
-                <a:latin typeface="Calibri"/>
-              </a:rPr>
-              <a:t>Subgroup</a:t>
-            </a:r>
-          </a:p>
-        </p:txBody>
-      </p:sp>
-      <p:sp>
-        <p:nvSpPr>
-          <p:cNvPr id="10" name="TextBox 9"/>
-          <p:cNvSpPr txBox="1"/>
-          <p:nvPr/>
-        </p:nvSpPr>
-        <p:spPr>
-          <a:xfrm>
-            <a:off x="2377440" y="5321808"/>
-            <a:ext cx="1463040" cy="182880"/>
+                  <a:srgbClr val="1F7A3D"/>
+                </a:solidFill>
+                <a:latin typeface="Calibri"/>
+              </a:rPr>
+              <a:t>▲ 41</a:t>
+            </a:r>
+          </a:p>
+        </p:txBody>
+      </p:sp>
+      <p:sp>
+        <p:nvSpPr>
+          <p:cNvPr id="44" name="TextBox 43"/>
+          <p:cNvSpPr txBox="1"/>
+          <p:nvPr/>
+        </p:nvSpPr>
+        <p:spPr>
+          <a:xfrm>
+            <a:off x="6812280" y="5468112"/>
+            <a:ext cx="960120" cy="274320"/>
+          </a:xfrm>
+          <a:prstGeom prst="rect">
+            <a:avLst/>
+          </a:prstGeom>
+          <a:noFill/>
+        </p:spPr>
+        <p:txBody>
+          <a:bodyPr wrap="square" lIns="0" rIns="0" tIns="0" bIns="0">
+            <a:spAutoFit/>
+          </a:bodyPr>
+          <a:lstStyle/>
+          <a:p>
+            <a:pPr algn="l"/>
+            <a:r>
+              <a:rPr sz="850" b="0" i="0">
+                <a:solidFill>
+                  <a:srgbClr val="333333"/>
+                </a:solidFill>
+                <a:latin typeface="Calibri"/>
+              </a:rPr>
+              <a:t>Spring Lake</a:t>
+            </a:r>
+          </a:p>
+        </p:txBody>
+      </p:sp>
+      <p:sp>
+        <p:nvSpPr>
+          <p:cNvPr id="45" name="TextBox 44"/>
+          <p:cNvSpPr txBox="1"/>
+          <p:nvPr/>
+        </p:nvSpPr>
+        <p:spPr>
+          <a:xfrm>
+            <a:off x="7772400" y="5468112"/>
+            <a:ext cx="594360" cy="274320"/>
           </a:xfrm>
           <a:prstGeom prst="rect">
             <a:avLst/>
@@ -19338,25 +20658,60 @@
             <a:r>
               <a:rPr sz="900" b="1" i="0">
                 <a:solidFill>
-                  <a:srgbClr val="1F3A5F"/>
-                </a:solidFill>
-                <a:latin typeface="Calibri"/>
-              </a:rPr>
-              <a:t>Pre Rank</a:t>
-            </a:r>
-          </a:p>
-        </p:txBody>
-      </p:sp>
-      <p:sp>
-        <p:nvSpPr>
-          <p:cNvPr id="11" name="TextBox 10"/>
-          <p:cNvSpPr txBox="1"/>
-          <p:nvPr/>
-        </p:nvSpPr>
-        <p:spPr>
-          <a:xfrm>
-            <a:off x="4114800" y="5321808"/>
-            <a:ext cx="1463040" cy="182880"/>
+                  <a:srgbClr val="1F7A3D"/>
+                </a:solidFill>
+                <a:latin typeface="Calibri"/>
+              </a:rPr>
+              <a:t>▲ 21</a:t>
+            </a:r>
+          </a:p>
+        </p:txBody>
+      </p:sp>
+      <p:sp>
+        <p:nvSpPr>
+          <p:cNvPr id="46" name="TextBox 45"/>
+          <p:cNvSpPr txBox="1"/>
+          <p:nvPr/>
+        </p:nvSpPr>
+        <p:spPr>
+          <a:xfrm>
+            <a:off x="8412480" y="5468112"/>
+            <a:ext cx="960120" cy="274320"/>
+          </a:xfrm>
+          <a:prstGeom prst="rect">
+            <a:avLst/>
+          </a:prstGeom>
+          <a:noFill/>
+        </p:spPr>
+        <p:txBody>
+          <a:bodyPr wrap="square" lIns="0" rIns="0" tIns="0" bIns="0">
+            <a:spAutoFit/>
+          </a:bodyPr>
+          <a:lstStyle/>
+          <a:p>
+            <a:pPr algn="l"/>
+            <a:r>
+              <a:rPr sz="850" b="0" i="0">
+                <a:solidFill>
+                  <a:srgbClr val="333333"/>
+                </a:solidFill>
+                <a:latin typeface="Calibri"/>
+              </a:rPr>
+              <a:t>E. Grand Rapids</a:t>
+            </a:r>
+          </a:p>
+        </p:txBody>
+      </p:sp>
+      <p:sp>
+        <p:nvSpPr>
+          <p:cNvPr id="47" name="TextBox 46"/>
+          <p:cNvSpPr txBox="1"/>
+          <p:nvPr/>
+        </p:nvSpPr>
+        <p:spPr>
+          <a:xfrm>
+            <a:off x="9372600" y="5468112"/>
+            <a:ext cx="594360" cy="274320"/>
           </a:xfrm>
           <a:prstGeom prst="rect">
             <a:avLst/>
@@ -19373,25 +20728,60 @@
             <a:r>
               <a:rPr sz="900" b="1" i="0">
                 <a:solidFill>
-                  <a:srgbClr val="1F3A5F"/>
-                </a:solidFill>
-                <a:latin typeface="Calibri"/>
-              </a:rPr>
-              <a:t>Post Rank</a:t>
-            </a:r>
-          </a:p>
-        </p:txBody>
-      </p:sp>
-      <p:sp>
-        <p:nvSpPr>
-          <p:cNvPr id="12" name="TextBox 11"/>
-          <p:cNvSpPr txBox="1"/>
-          <p:nvPr/>
-        </p:nvSpPr>
-        <p:spPr>
-          <a:xfrm>
-            <a:off x="5760720" y="5321808"/>
-            <a:ext cx="1463040" cy="182880"/>
+                  <a:srgbClr val="333333"/>
+                </a:solidFill>
+                <a:latin typeface="Calibri"/>
+              </a:rPr>
+              <a:t>▼ 12</a:t>
+            </a:r>
+          </a:p>
+        </p:txBody>
+      </p:sp>
+      <p:sp>
+        <p:nvSpPr>
+          <p:cNvPr id="48" name="TextBox 47"/>
+          <p:cNvSpPr txBox="1"/>
+          <p:nvPr/>
+        </p:nvSpPr>
+        <p:spPr>
+          <a:xfrm>
+            <a:off x="10012680" y="5468112"/>
+            <a:ext cx="960120" cy="274320"/>
+          </a:xfrm>
+          <a:prstGeom prst="rect">
+            <a:avLst/>
+          </a:prstGeom>
+          <a:noFill/>
+        </p:spPr>
+        <p:txBody>
+          <a:bodyPr wrap="square" lIns="0" rIns="0" tIns="0" bIns="0">
+            <a:spAutoFit/>
+          </a:bodyPr>
+          <a:lstStyle/>
+          <a:p>
+            <a:pPr algn="l"/>
+            <a:r>
+              <a:rPr sz="850" b="0" i="0">
+                <a:solidFill>
+                  <a:srgbClr val="333333"/>
+                </a:solidFill>
+                <a:latin typeface="Calibri"/>
+              </a:rPr>
+              <a:t>Birmingham</a:t>
+            </a:r>
+          </a:p>
+        </p:txBody>
+      </p:sp>
+      <p:sp>
+        <p:nvSpPr>
+          <p:cNvPr id="49" name="TextBox 48"/>
+          <p:cNvSpPr txBox="1"/>
+          <p:nvPr/>
+        </p:nvSpPr>
+        <p:spPr>
+          <a:xfrm>
+            <a:off x="10972800" y="5468112"/>
+            <a:ext cx="594360" cy="274320"/>
           </a:xfrm>
           <a:prstGeom prst="rect">
             <a:avLst/>
@@ -19408,25 +20798,60 @@
             <a:r>
               <a:rPr sz="900" b="1" i="0">
                 <a:solidFill>
-                  <a:srgbClr val="1F3A5F"/>
-                </a:solidFill>
-                <a:latin typeface="Calibri"/>
-              </a:rPr>
-              <a:t>Shift</a:t>
-            </a:r>
-          </a:p>
-        </p:txBody>
-      </p:sp>
-      <p:sp>
-        <p:nvSpPr>
-          <p:cNvPr id="13" name="TextBox 12"/>
-          <p:cNvSpPr txBox="1"/>
-          <p:nvPr/>
-        </p:nvSpPr>
-        <p:spPr>
-          <a:xfrm>
-            <a:off x="7132320" y="5321808"/>
-            <a:ext cx="1463040" cy="182880"/>
+                  <a:srgbClr val="B02121"/>
+                </a:solidFill>
+                <a:latin typeface="Calibri"/>
+              </a:rPr>
+              <a:t>▼ 39</a:t>
+            </a:r>
+          </a:p>
+        </p:txBody>
+      </p:sp>
+      <p:sp>
+        <p:nvSpPr>
+          <p:cNvPr id="50" name="TextBox 49"/>
+          <p:cNvSpPr txBox="1"/>
+          <p:nvPr/>
+        </p:nvSpPr>
+        <p:spPr>
+          <a:xfrm>
+            <a:off x="5212080" y="5788152"/>
+            <a:ext cx="960120" cy="274320"/>
+          </a:xfrm>
+          <a:prstGeom prst="rect">
+            <a:avLst/>
+          </a:prstGeom>
+          <a:noFill/>
+        </p:spPr>
+        <p:txBody>
+          <a:bodyPr wrap="square" lIns="0" rIns="0" tIns="0" bIns="0">
+            <a:spAutoFit/>
+          </a:bodyPr>
+          <a:lstStyle/>
+          <a:p>
+            <a:pPr algn="l"/>
+            <a:r>
+              <a:rPr sz="850" b="0" i="0">
+                <a:solidFill>
+                  <a:srgbClr val="333333"/>
+                </a:solidFill>
+                <a:latin typeface="Calibri"/>
+              </a:rPr>
+              <a:t>Troy SD</a:t>
+            </a:r>
+          </a:p>
+        </p:txBody>
+      </p:sp>
+      <p:sp>
+        <p:nvSpPr>
+          <p:cNvPr id="51" name="TextBox 50"/>
+          <p:cNvSpPr txBox="1"/>
+          <p:nvPr/>
+        </p:nvSpPr>
+        <p:spPr>
+          <a:xfrm>
+            <a:off x="6172200" y="5788152"/>
+            <a:ext cx="594360" cy="274320"/>
           </a:xfrm>
           <a:prstGeom prst="rect">
             <a:avLst/>
@@ -19443,25 +20868,60 @@
             <a:r>
               <a:rPr sz="900" b="1" i="0">
                 <a:solidFill>
-                  <a:srgbClr val="1F3A5F"/>
-                </a:solidFill>
-                <a:latin typeface="Calibri"/>
-              </a:rPr>
-              <a:t>Pre Level</a:t>
-            </a:r>
-          </a:p>
-        </p:txBody>
-      </p:sp>
-      <p:sp>
-        <p:nvSpPr>
-          <p:cNvPr id="14" name="TextBox 13"/>
-          <p:cNvSpPr txBox="1"/>
-          <p:nvPr/>
-        </p:nvSpPr>
-        <p:spPr>
-          <a:xfrm>
-            <a:off x="8686800" y="5321808"/>
-            <a:ext cx="1463040" cy="182880"/>
+                  <a:srgbClr val="B02121"/>
+                </a:solidFill>
+                <a:latin typeface="Calibri"/>
+              </a:rPr>
+              <a:t>▼ 142</a:t>
+            </a:r>
+          </a:p>
+        </p:txBody>
+      </p:sp>
+      <p:sp>
+        <p:nvSpPr>
+          <p:cNvPr id="52" name="TextBox 51"/>
+          <p:cNvSpPr txBox="1"/>
+          <p:nvPr/>
+        </p:nvSpPr>
+        <p:spPr>
+          <a:xfrm>
+            <a:off x="6812280" y="5788152"/>
+            <a:ext cx="960120" cy="274320"/>
+          </a:xfrm>
+          <a:prstGeom prst="rect">
+            <a:avLst/>
+          </a:prstGeom>
+          <a:noFill/>
+        </p:spPr>
+        <p:txBody>
+          <a:bodyPr wrap="square" lIns="0" rIns="0" tIns="0" bIns="0">
+            <a:spAutoFit/>
+          </a:bodyPr>
+          <a:lstStyle/>
+          <a:p>
+            <a:pPr algn="l"/>
+            <a:r>
+              <a:rPr sz="850" b="0" i="0">
+                <a:solidFill>
+                  <a:srgbClr val="333333"/>
+                </a:solidFill>
+                <a:latin typeface="Calibri"/>
+              </a:rPr>
+              <a:t>Novi</a:t>
+            </a:r>
+          </a:p>
+        </p:txBody>
+      </p:sp>
+      <p:sp>
+        <p:nvSpPr>
+          <p:cNvPr id="53" name="TextBox 52"/>
+          <p:cNvSpPr txBox="1"/>
+          <p:nvPr/>
+        </p:nvSpPr>
+        <p:spPr>
+          <a:xfrm>
+            <a:off x="7772400" y="5788152"/>
+            <a:ext cx="594360" cy="274320"/>
           </a:xfrm>
           <a:prstGeom prst="rect">
             <a:avLst/>
@@ -19478,25 +20938,60 @@
             <a:r>
               <a:rPr sz="900" b="1" i="0">
                 <a:solidFill>
-                  <a:srgbClr val="1F3A5F"/>
-                </a:solidFill>
-                <a:latin typeface="Calibri"/>
-              </a:rPr>
-              <a:t>Post Level</a:t>
-            </a:r>
-          </a:p>
-        </p:txBody>
-      </p:sp>
-      <p:sp>
-        <p:nvSpPr>
-          <p:cNvPr id="15" name="TextBox 14"/>
-          <p:cNvSpPr txBox="1"/>
-          <p:nvPr/>
-        </p:nvSpPr>
-        <p:spPr>
-          <a:xfrm>
-            <a:off x="10241280" y="5321808"/>
-            <a:ext cx="1463040" cy="182880"/>
+                  <a:srgbClr val="B02121"/>
+                </a:solidFill>
+                <a:latin typeface="Calibri"/>
+              </a:rPr>
+              <a:t>▼ 60</a:t>
+            </a:r>
+          </a:p>
+        </p:txBody>
+      </p:sp>
+      <p:sp>
+        <p:nvSpPr>
+          <p:cNvPr id="54" name="TextBox 53"/>
+          <p:cNvSpPr txBox="1"/>
+          <p:nvPr/>
+        </p:nvSpPr>
+        <p:spPr>
+          <a:xfrm>
+            <a:off x="8412480" y="5788152"/>
+            <a:ext cx="960120" cy="274320"/>
+          </a:xfrm>
+          <a:prstGeom prst="rect">
+            <a:avLst/>
+          </a:prstGeom>
+          <a:noFill/>
+        </p:spPr>
+        <p:txBody>
+          <a:bodyPr wrap="square" lIns="0" rIns="0" tIns="0" bIns="0">
+            <a:spAutoFit/>
+          </a:bodyPr>
+          <a:lstStyle/>
+          <a:p>
+            <a:pPr algn="l"/>
+            <a:r>
+              <a:rPr sz="850" b="0" i="0">
+                <a:solidFill>
+                  <a:srgbClr val="333333"/>
+                </a:solidFill>
+                <a:latin typeface="Calibri"/>
+              </a:rPr>
+              <a:t>Rochester</a:t>
+            </a:r>
+          </a:p>
+        </p:txBody>
+      </p:sp>
+      <p:sp>
+        <p:nvSpPr>
+          <p:cNvPr id="55" name="TextBox 54"/>
+          <p:cNvSpPr txBox="1"/>
+          <p:nvPr/>
+        </p:nvSpPr>
+        <p:spPr>
+          <a:xfrm>
+            <a:off x="9372600" y="5788152"/>
+            <a:ext cx="594360" cy="274320"/>
           </a:xfrm>
           <a:prstGeom prst="rect">
             <a:avLst/>
@@ -19513,1411 +21008,11 @@
             <a:r>
               <a:rPr sz="900" b="1" i="0">
                 <a:solidFill>
-                  <a:srgbClr val="1F3A5F"/>
-                </a:solidFill>
-                <a:latin typeface="Calibri"/>
-              </a:rPr>
-              <a:t>Δ</a:t>
-            </a:r>
-          </a:p>
-        </p:txBody>
-      </p:sp>
-      <p:sp>
-        <p:nvSpPr>
-          <p:cNvPr id="16" name="TextBox 15"/>
-          <p:cNvSpPr txBox="1"/>
-          <p:nvPr/>
-        </p:nvSpPr>
-        <p:spPr>
-          <a:xfrm>
-            <a:off x="457200" y="5532120"/>
-            <a:ext cx="1463040" cy="155448"/>
-          </a:xfrm>
-          <a:prstGeom prst="rect">
-            <a:avLst/>
-          </a:prstGeom>
-          <a:noFill/>
-        </p:spPr>
-        <p:txBody>
-          <a:bodyPr wrap="square" lIns="0" rIns="0" tIns="0" bIns="0">
-            <a:spAutoFit/>
-          </a:bodyPr>
-          <a:lstStyle/>
-          <a:p>
-            <a:pPr algn="l"/>
-            <a:r>
-              <a:rPr sz="850" b="0" i="0">
-                <a:solidFill>
-                  <a:srgbClr val="333333"/>
-                </a:solidFill>
-                <a:latin typeface="Calibri"/>
-              </a:rPr>
-              <a:t>All Students</a:t>
-            </a:r>
-          </a:p>
-        </p:txBody>
-      </p:sp>
-      <p:sp>
-        <p:nvSpPr>
-          <p:cNvPr id="17" name="TextBox 16"/>
-          <p:cNvSpPr txBox="1"/>
-          <p:nvPr/>
-        </p:nvSpPr>
-        <p:spPr>
-          <a:xfrm>
-            <a:off x="2377440" y="5532120"/>
-            <a:ext cx="1463040" cy="155448"/>
-          </a:xfrm>
-          <a:prstGeom prst="rect">
-            <a:avLst/>
-          </a:prstGeom>
-          <a:noFill/>
-        </p:spPr>
-        <p:txBody>
-          <a:bodyPr wrap="square" lIns="0" rIns="0" tIns="0" bIns="0">
-            <a:spAutoFit/>
-          </a:bodyPr>
-          <a:lstStyle/>
-          <a:p>
-            <a:pPr algn="l"/>
-            <a:r>
-              <a:rPr sz="850" b="0" i="0">
-                <a:solidFill>
-                  <a:srgbClr val="333333"/>
-                </a:solidFill>
-                <a:latin typeface="Calibri"/>
-              </a:rPr>
-              <a:t>171 / 504</a:t>
-            </a:r>
-          </a:p>
-        </p:txBody>
-      </p:sp>
-      <p:sp>
-        <p:nvSpPr>
-          <p:cNvPr id="18" name="TextBox 17"/>
-          <p:cNvSpPr txBox="1"/>
-          <p:nvPr/>
-        </p:nvSpPr>
-        <p:spPr>
-          <a:xfrm>
-            <a:off x="4114800" y="5532120"/>
-            <a:ext cx="1463040" cy="155448"/>
-          </a:xfrm>
-          <a:prstGeom prst="rect">
-            <a:avLst/>
-          </a:prstGeom>
-          <a:noFill/>
-        </p:spPr>
-        <p:txBody>
-          <a:bodyPr wrap="square" lIns="0" rIns="0" tIns="0" bIns="0">
-            <a:spAutoFit/>
-          </a:bodyPr>
-          <a:lstStyle/>
-          <a:p>
-            <a:pPr algn="l"/>
-            <a:r>
-              <a:rPr sz="850" b="0" i="0">
-                <a:solidFill>
-                  <a:srgbClr val="333333"/>
-                </a:solidFill>
-                <a:latin typeface="Calibri"/>
-              </a:rPr>
-              <a:t>313 / 504</a:t>
-            </a:r>
-          </a:p>
-        </p:txBody>
-      </p:sp>
-      <p:sp>
-        <p:nvSpPr>
-          <p:cNvPr id="19" name="TextBox 18"/>
-          <p:cNvSpPr txBox="1"/>
-          <p:nvPr/>
-        </p:nvSpPr>
-        <p:spPr>
-          <a:xfrm>
-            <a:off x="5760720" y="5532120"/>
-            <a:ext cx="1463040" cy="155448"/>
-          </a:xfrm>
-          <a:prstGeom prst="rect">
-            <a:avLst/>
-          </a:prstGeom>
-          <a:noFill/>
-        </p:spPr>
-        <p:txBody>
-          <a:bodyPr wrap="square" lIns="0" rIns="0" tIns="0" bIns="0">
-            <a:spAutoFit/>
-          </a:bodyPr>
-          <a:lstStyle/>
-          <a:p>
-            <a:pPr algn="l"/>
-            <a:r>
-              <a:rPr sz="850" b="1" i="0">
-                <a:solidFill>
                   <a:srgbClr val="B02121"/>
                 </a:solidFill>
                 <a:latin typeface="Calibri"/>
               </a:rPr>
-              <a:t>▼ 142</a:t>
-            </a:r>
-          </a:p>
-        </p:txBody>
-      </p:sp>
-      <p:sp>
-        <p:nvSpPr>
-          <p:cNvPr id="20" name="TextBox 19"/>
-          <p:cNvSpPr txBox="1"/>
-          <p:nvPr/>
-        </p:nvSpPr>
-        <p:spPr>
-          <a:xfrm>
-            <a:off x="7132320" y="5532120"/>
-            <a:ext cx="1463040" cy="155448"/>
-          </a:xfrm>
-          <a:prstGeom prst="rect">
-            <a:avLst/>
-          </a:prstGeom>
-          <a:noFill/>
-        </p:spPr>
-        <p:txBody>
-          <a:bodyPr wrap="square" lIns="0" rIns="0" tIns="0" bIns="0">
-            <a:spAutoFit/>
-          </a:bodyPr>
-          <a:lstStyle/>
-          <a:p>
-            <a:pPr algn="l"/>
-            <a:r>
-              <a:rPr sz="850" b="0" i="0">
-                <a:solidFill>
-                  <a:srgbClr val="333333"/>
-                </a:solidFill>
-                <a:latin typeface="Calibri"/>
-              </a:rPr>
-              <a:t>+0.729</a:t>
-            </a:r>
-          </a:p>
-        </p:txBody>
-      </p:sp>
-      <p:sp>
-        <p:nvSpPr>
-          <p:cNvPr id="21" name="TextBox 20"/>
-          <p:cNvSpPr txBox="1"/>
-          <p:nvPr/>
-        </p:nvSpPr>
-        <p:spPr>
-          <a:xfrm>
-            <a:off x="8686800" y="5532120"/>
-            <a:ext cx="1463040" cy="155448"/>
-          </a:xfrm>
-          <a:prstGeom prst="rect">
-            <a:avLst/>
-          </a:prstGeom>
-          <a:noFill/>
-        </p:spPr>
-        <p:txBody>
-          <a:bodyPr wrap="square" lIns="0" rIns="0" tIns="0" bIns="0">
-            <a:spAutoFit/>
-          </a:bodyPr>
-          <a:lstStyle/>
-          <a:p>
-            <a:pPr algn="l"/>
-            <a:r>
-              <a:rPr sz="850" b="0" i="0">
-                <a:solidFill>
-                  <a:srgbClr val="333333"/>
-                </a:solidFill>
-                <a:latin typeface="Calibri"/>
-              </a:rPr>
-              <a:t>+0.476</a:t>
-            </a:r>
-          </a:p>
-        </p:txBody>
-      </p:sp>
-      <p:sp>
-        <p:nvSpPr>
-          <p:cNvPr id="22" name="TextBox 21"/>
-          <p:cNvSpPr txBox="1"/>
-          <p:nvPr/>
-        </p:nvSpPr>
-        <p:spPr>
-          <a:xfrm>
-            <a:off x="10241280" y="5532120"/>
-            <a:ext cx="1463040" cy="155448"/>
-          </a:xfrm>
-          <a:prstGeom prst="rect">
-            <a:avLst/>
-          </a:prstGeom>
-          <a:noFill/>
-        </p:spPr>
-        <p:txBody>
-          <a:bodyPr wrap="square" lIns="0" rIns="0" tIns="0" bIns="0">
-            <a:spAutoFit/>
-          </a:bodyPr>
-          <a:lstStyle/>
-          <a:p>
-            <a:pPr algn="l"/>
-            <a:r>
-              <a:rPr sz="850" b="0" i="0">
-                <a:solidFill>
-                  <a:srgbClr val="333333"/>
-                </a:solidFill>
-                <a:latin typeface="Calibri"/>
-              </a:rPr>
-              <a:t>-0.252</a:t>
-            </a:r>
-          </a:p>
-        </p:txBody>
-      </p:sp>
-      <p:sp>
-        <p:nvSpPr>
-          <p:cNvPr id="23" name="TextBox 22"/>
-          <p:cNvSpPr txBox="1"/>
-          <p:nvPr/>
-        </p:nvSpPr>
-        <p:spPr>
-          <a:xfrm>
-            <a:off x="457200" y="5646420"/>
-            <a:ext cx="1463040" cy="155448"/>
-          </a:xfrm>
-          <a:prstGeom prst="rect">
-            <a:avLst/>
-          </a:prstGeom>
-          <a:noFill/>
-        </p:spPr>
-        <p:txBody>
-          <a:bodyPr wrap="square" lIns="0" rIns="0" tIns="0" bIns="0">
-            <a:spAutoFit/>
-          </a:bodyPr>
-          <a:lstStyle/>
-          <a:p>
-            <a:pPr algn="l"/>
-            <a:r>
-              <a:rPr sz="850" b="0" i="0">
-                <a:solidFill>
-                  <a:srgbClr val="333333"/>
-                </a:solidFill>
-                <a:latin typeface="Calibri"/>
-              </a:rPr>
-              <a:t>Asian</a:t>
-            </a:r>
-          </a:p>
-        </p:txBody>
-      </p:sp>
-      <p:sp>
-        <p:nvSpPr>
-          <p:cNvPr id="24" name="TextBox 23"/>
-          <p:cNvSpPr txBox="1"/>
-          <p:nvPr/>
-        </p:nvSpPr>
-        <p:spPr>
-          <a:xfrm>
-            <a:off x="2377440" y="5646420"/>
-            <a:ext cx="1463040" cy="155448"/>
-          </a:xfrm>
-          <a:prstGeom prst="rect">
-            <a:avLst/>
-          </a:prstGeom>
-          <a:noFill/>
-        </p:spPr>
-        <p:txBody>
-          <a:bodyPr wrap="square" lIns="0" rIns="0" tIns="0" bIns="0">
-            <a:spAutoFit/>
-          </a:bodyPr>
-          <a:lstStyle/>
-          <a:p>
-            <a:pPr algn="l"/>
-            <a:r>
-              <a:rPr sz="850" b="0" i="0">
-                <a:solidFill>
-                  <a:srgbClr val="333333"/>
-                </a:solidFill>
-                <a:latin typeface="Calibri"/>
-              </a:rPr>
-              <a:t>106 / 284</a:t>
-            </a:r>
-          </a:p>
-        </p:txBody>
-      </p:sp>
-      <p:sp>
-        <p:nvSpPr>
-          <p:cNvPr id="25" name="TextBox 24"/>
-          <p:cNvSpPr txBox="1"/>
-          <p:nvPr/>
-        </p:nvSpPr>
-        <p:spPr>
-          <a:xfrm>
-            <a:off x="4114800" y="5646420"/>
-            <a:ext cx="1463040" cy="155448"/>
-          </a:xfrm>
-          <a:prstGeom prst="rect">
-            <a:avLst/>
-          </a:prstGeom>
-          <a:noFill/>
-        </p:spPr>
-        <p:txBody>
-          <a:bodyPr wrap="square" lIns="0" rIns="0" tIns="0" bIns="0">
-            <a:spAutoFit/>
-          </a:bodyPr>
-          <a:lstStyle/>
-          <a:p>
-            <a:pPr algn="l"/>
-            <a:r>
-              <a:rPr sz="850" b="0" i="0">
-                <a:solidFill>
-                  <a:srgbClr val="333333"/>
-                </a:solidFill>
-                <a:latin typeface="Calibri"/>
-              </a:rPr>
-              <a:t>221 / 294</a:t>
-            </a:r>
-          </a:p>
-        </p:txBody>
-      </p:sp>
-      <p:sp>
-        <p:nvSpPr>
-          <p:cNvPr id="26" name="TextBox 25"/>
-          <p:cNvSpPr txBox="1"/>
-          <p:nvPr/>
-        </p:nvSpPr>
-        <p:spPr>
-          <a:xfrm>
-            <a:off x="5760720" y="5646420"/>
-            <a:ext cx="1463040" cy="155448"/>
-          </a:xfrm>
-          <a:prstGeom prst="rect">
-            <a:avLst/>
-          </a:prstGeom>
-          <a:noFill/>
-        </p:spPr>
-        <p:txBody>
-          <a:bodyPr wrap="square" lIns="0" rIns="0" tIns="0" bIns="0">
-            <a:spAutoFit/>
-          </a:bodyPr>
-          <a:lstStyle/>
-          <a:p>
-            <a:pPr algn="l"/>
-            <a:r>
-              <a:rPr sz="850" b="1" i="0">
-                <a:solidFill>
-                  <a:srgbClr val="B02121"/>
-                </a:solidFill>
-                <a:latin typeface="Calibri"/>
-              </a:rPr>
-              <a:t>▼ 115</a:t>
-            </a:r>
-          </a:p>
-        </p:txBody>
-      </p:sp>
-      <p:sp>
-        <p:nvSpPr>
-          <p:cNvPr id="27" name="TextBox 26"/>
-          <p:cNvSpPr txBox="1"/>
-          <p:nvPr/>
-        </p:nvSpPr>
-        <p:spPr>
-          <a:xfrm>
-            <a:off x="7132320" y="5646420"/>
-            <a:ext cx="1463040" cy="155448"/>
-          </a:xfrm>
-          <a:prstGeom prst="rect">
-            <a:avLst/>
-          </a:prstGeom>
-          <a:noFill/>
-        </p:spPr>
-        <p:txBody>
-          <a:bodyPr wrap="square" lIns="0" rIns="0" tIns="0" bIns="0">
-            <a:spAutoFit/>
-          </a:bodyPr>
-          <a:lstStyle/>
-          <a:p>
-            <a:pPr algn="l"/>
-            <a:r>
-              <a:rPr sz="850" b="0" i="0">
-                <a:solidFill>
-                  <a:srgbClr val="333333"/>
-                </a:solidFill>
-                <a:latin typeface="Calibri"/>
-              </a:rPr>
-              <a:t>+1.089</a:t>
-            </a:r>
-          </a:p>
-        </p:txBody>
-      </p:sp>
-      <p:sp>
-        <p:nvSpPr>
-          <p:cNvPr id="28" name="TextBox 27"/>
-          <p:cNvSpPr txBox="1"/>
-          <p:nvPr/>
-        </p:nvSpPr>
-        <p:spPr>
-          <a:xfrm>
-            <a:off x="8686800" y="5646420"/>
-            <a:ext cx="1463040" cy="155448"/>
-          </a:xfrm>
-          <a:prstGeom prst="rect">
-            <a:avLst/>
-          </a:prstGeom>
-          <a:noFill/>
-        </p:spPr>
-        <p:txBody>
-          <a:bodyPr wrap="square" lIns="0" rIns="0" tIns="0" bIns="0">
-            <a:spAutoFit/>
-          </a:bodyPr>
-          <a:lstStyle/>
-          <a:p>
-            <a:pPr algn="l"/>
-            <a:r>
-              <a:rPr sz="850" b="0" i="0">
-                <a:solidFill>
-                  <a:srgbClr val="333333"/>
-                </a:solidFill>
-                <a:latin typeface="Calibri"/>
-              </a:rPr>
-              <a:t>+0.753</a:t>
-            </a:r>
-          </a:p>
-        </p:txBody>
-      </p:sp>
-      <p:sp>
-        <p:nvSpPr>
-          <p:cNvPr id="29" name="TextBox 28"/>
-          <p:cNvSpPr txBox="1"/>
-          <p:nvPr/>
-        </p:nvSpPr>
-        <p:spPr>
-          <a:xfrm>
-            <a:off x="10241280" y="5646420"/>
-            <a:ext cx="1463040" cy="155448"/>
-          </a:xfrm>
-          <a:prstGeom prst="rect">
-            <a:avLst/>
-          </a:prstGeom>
-          <a:noFill/>
-        </p:spPr>
-        <p:txBody>
-          <a:bodyPr wrap="square" lIns="0" rIns="0" tIns="0" bIns="0">
-            <a:spAutoFit/>
-          </a:bodyPr>
-          <a:lstStyle/>
-          <a:p>
-            <a:pPr algn="l"/>
-            <a:r>
-              <a:rPr sz="850" b="0" i="0">
-                <a:solidFill>
-                  <a:srgbClr val="333333"/>
-                </a:solidFill>
-                <a:latin typeface="Calibri"/>
-              </a:rPr>
-              <a:t>-0.336</a:t>
-            </a:r>
-          </a:p>
-        </p:txBody>
-      </p:sp>
-      <p:sp>
-        <p:nvSpPr>
-          <p:cNvPr id="30" name="TextBox 29"/>
-          <p:cNvSpPr txBox="1"/>
-          <p:nvPr/>
-        </p:nvSpPr>
-        <p:spPr>
-          <a:xfrm>
-            <a:off x="457200" y="5760720"/>
-            <a:ext cx="1463040" cy="155448"/>
-          </a:xfrm>
-          <a:prstGeom prst="rect">
-            <a:avLst/>
-          </a:prstGeom>
-          <a:noFill/>
-        </p:spPr>
-        <p:txBody>
-          <a:bodyPr wrap="square" lIns="0" rIns="0" tIns="0" bIns="0">
-            <a:spAutoFit/>
-          </a:bodyPr>
-          <a:lstStyle/>
-          <a:p>
-            <a:pPr algn="l"/>
-            <a:r>
-              <a:rPr sz="850" b="0" i="0">
-                <a:solidFill>
-                  <a:srgbClr val="333333"/>
-                </a:solidFill>
-                <a:latin typeface="Calibri"/>
-              </a:rPr>
-              <a:t>White</a:t>
-            </a:r>
-          </a:p>
-        </p:txBody>
-      </p:sp>
-      <p:sp>
-        <p:nvSpPr>
-          <p:cNvPr id="31" name="TextBox 30"/>
-          <p:cNvSpPr txBox="1"/>
-          <p:nvPr/>
-        </p:nvSpPr>
-        <p:spPr>
-          <a:xfrm>
-            <a:off x="2377440" y="5760720"/>
-            <a:ext cx="1463040" cy="155448"/>
-          </a:xfrm>
-          <a:prstGeom prst="rect">
-            <a:avLst/>
-          </a:prstGeom>
-          <a:noFill/>
-        </p:spPr>
-        <p:txBody>
-          <a:bodyPr wrap="square" lIns="0" rIns="0" tIns="0" bIns="0">
-            <a:spAutoFit/>
-          </a:bodyPr>
-          <a:lstStyle/>
-          <a:p>
-            <a:pPr algn="l"/>
-            <a:r>
-              <a:rPr sz="850" b="0" i="0">
-                <a:solidFill>
-                  <a:srgbClr val="333333"/>
-                </a:solidFill>
-                <a:latin typeface="Calibri"/>
-              </a:rPr>
-              <a:t>373 / 503</a:t>
-            </a:r>
-          </a:p>
-        </p:txBody>
-      </p:sp>
-      <p:sp>
-        <p:nvSpPr>
-          <p:cNvPr id="32" name="TextBox 31"/>
-          <p:cNvSpPr txBox="1"/>
-          <p:nvPr/>
-        </p:nvSpPr>
-        <p:spPr>
-          <a:xfrm>
-            <a:off x="4114800" y="5760720"/>
-            <a:ext cx="1463040" cy="155448"/>
-          </a:xfrm>
-          <a:prstGeom prst="rect">
-            <a:avLst/>
-          </a:prstGeom>
-          <a:noFill/>
-        </p:spPr>
-        <p:txBody>
-          <a:bodyPr wrap="square" lIns="0" rIns="0" tIns="0" bIns="0">
-            <a:spAutoFit/>
-          </a:bodyPr>
-          <a:lstStyle/>
-          <a:p>
-            <a:pPr algn="l"/>
-            <a:r>
-              <a:rPr sz="850" b="0" i="0">
-                <a:solidFill>
-                  <a:srgbClr val="333333"/>
-                </a:solidFill>
-                <a:latin typeface="Calibri"/>
-              </a:rPr>
-              <a:t>432 / 497</a:t>
-            </a:r>
-          </a:p>
-        </p:txBody>
-      </p:sp>
-      <p:sp>
-        <p:nvSpPr>
-          <p:cNvPr id="33" name="TextBox 32"/>
-          <p:cNvSpPr txBox="1"/>
-          <p:nvPr/>
-        </p:nvSpPr>
-        <p:spPr>
-          <a:xfrm>
-            <a:off x="5760720" y="5760720"/>
-            <a:ext cx="1463040" cy="155448"/>
-          </a:xfrm>
-          <a:prstGeom prst="rect">
-            <a:avLst/>
-          </a:prstGeom>
-          <a:noFill/>
-        </p:spPr>
-        <p:txBody>
-          <a:bodyPr wrap="square" lIns="0" rIns="0" tIns="0" bIns="0">
-            <a:spAutoFit/>
-          </a:bodyPr>
-          <a:lstStyle/>
-          <a:p>
-            <a:pPr algn="l"/>
-            <a:r>
-              <a:rPr sz="850" b="1" i="0">
-                <a:solidFill>
-                  <a:srgbClr val="B02121"/>
-                </a:solidFill>
-                <a:latin typeface="Calibri"/>
-              </a:rPr>
-              <a:t>▼ 59</a:t>
-            </a:r>
-          </a:p>
-        </p:txBody>
-      </p:sp>
-      <p:sp>
-        <p:nvSpPr>
-          <p:cNvPr id="34" name="TextBox 33"/>
-          <p:cNvSpPr txBox="1"/>
-          <p:nvPr/>
-        </p:nvSpPr>
-        <p:spPr>
-          <a:xfrm>
-            <a:off x="7132320" y="5760720"/>
-            <a:ext cx="1463040" cy="155448"/>
-          </a:xfrm>
-          <a:prstGeom prst="rect">
-            <a:avLst/>
-          </a:prstGeom>
-          <a:noFill/>
-        </p:spPr>
-        <p:txBody>
-          <a:bodyPr wrap="square" lIns="0" rIns="0" tIns="0" bIns="0">
-            <a:spAutoFit/>
-          </a:bodyPr>
-          <a:lstStyle/>
-          <a:p>
-            <a:pPr algn="l"/>
-            <a:r>
-              <a:rPr sz="850" b="0" i="0">
-                <a:solidFill>
-                  <a:srgbClr val="333333"/>
-                </a:solidFill>
-                <a:latin typeface="Calibri"/>
-              </a:rPr>
-              <a:t>+0.592</a:t>
-            </a:r>
-          </a:p>
-        </p:txBody>
-      </p:sp>
-      <p:sp>
-        <p:nvSpPr>
-          <p:cNvPr id="35" name="TextBox 34"/>
-          <p:cNvSpPr txBox="1"/>
-          <p:nvPr/>
-        </p:nvSpPr>
-        <p:spPr>
-          <a:xfrm>
-            <a:off x="8686800" y="5760720"/>
-            <a:ext cx="1463040" cy="155448"/>
-          </a:xfrm>
-          <a:prstGeom prst="rect">
-            <a:avLst/>
-          </a:prstGeom>
-          <a:noFill/>
-        </p:spPr>
-        <p:txBody>
-          <a:bodyPr wrap="square" lIns="0" rIns="0" tIns="0" bIns="0">
-            <a:spAutoFit/>
-          </a:bodyPr>
-          <a:lstStyle/>
-          <a:p>
-            <a:pPr algn="l"/>
-            <a:r>
-              <a:rPr sz="850" b="0" i="0">
-                <a:solidFill>
-                  <a:srgbClr val="333333"/>
-                </a:solidFill>
-                <a:latin typeface="Calibri"/>
-              </a:rPr>
-              <a:t>+0.362</a:t>
-            </a:r>
-          </a:p>
-        </p:txBody>
-      </p:sp>
-      <p:sp>
-        <p:nvSpPr>
-          <p:cNvPr id="36" name="TextBox 35"/>
-          <p:cNvSpPr txBox="1"/>
-          <p:nvPr/>
-        </p:nvSpPr>
-        <p:spPr>
-          <a:xfrm>
-            <a:off x="10241280" y="5760720"/>
-            <a:ext cx="1463040" cy="155448"/>
-          </a:xfrm>
-          <a:prstGeom prst="rect">
-            <a:avLst/>
-          </a:prstGeom>
-          <a:noFill/>
-        </p:spPr>
-        <p:txBody>
-          <a:bodyPr wrap="square" lIns="0" rIns="0" tIns="0" bIns="0">
-            <a:spAutoFit/>
-          </a:bodyPr>
-          <a:lstStyle/>
-          <a:p>
-            <a:pPr algn="l"/>
-            <a:r>
-              <a:rPr sz="850" b="0" i="0">
-                <a:solidFill>
-                  <a:srgbClr val="333333"/>
-                </a:solidFill>
-                <a:latin typeface="Calibri"/>
-              </a:rPr>
-              <a:t>-0.230</a:t>
-            </a:r>
-          </a:p>
-        </p:txBody>
-      </p:sp>
-      <p:sp>
-        <p:nvSpPr>
-          <p:cNvPr id="37" name="TextBox 36"/>
-          <p:cNvSpPr txBox="1"/>
-          <p:nvPr/>
-        </p:nvSpPr>
-        <p:spPr>
-          <a:xfrm>
-            <a:off x="457200" y="5875020"/>
-            <a:ext cx="1463040" cy="155448"/>
-          </a:xfrm>
-          <a:prstGeom prst="rect">
-            <a:avLst/>
-          </a:prstGeom>
-          <a:noFill/>
-        </p:spPr>
-        <p:txBody>
-          <a:bodyPr wrap="square" lIns="0" rIns="0" tIns="0" bIns="0">
-            <a:spAutoFit/>
-          </a:bodyPr>
-          <a:lstStyle/>
-          <a:p>
-            <a:pPr algn="l"/>
-            <a:r>
-              <a:rPr sz="850" b="0" i="0">
-                <a:solidFill>
-                  <a:srgbClr val="333333"/>
-                </a:solidFill>
-                <a:latin typeface="Calibri"/>
-              </a:rPr>
-              <a:t>Black</a:t>
-            </a:r>
-          </a:p>
-        </p:txBody>
-      </p:sp>
-      <p:sp>
-        <p:nvSpPr>
-          <p:cNvPr id="38" name="TextBox 37"/>
-          <p:cNvSpPr txBox="1"/>
-          <p:nvPr/>
-        </p:nvSpPr>
-        <p:spPr>
-          <a:xfrm>
-            <a:off x="2377440" y="5875020"/>
-            <a:ext cx="1463040" cy="155448"/>
-          </a:xfrm>
-          <a:prstGeom prst="rect">
-            <a:avLst/>
-          </a:prstGeom>
-          <a:noFill/>
-        </p:spPr>
-        <p:txBody>
-          <a:bodyPr wrap="square" lIns="0" rIns="0" tIns="0" bIns="0">
-            <a:spAutoFit/>
-          </a:bodyPr>
-          <a:lstStyle/>
-          <a:p>
-            <a:pPr algn="l"/>
-            <a:r>
-              <a:rPr sz="850" b="0" i="0">
-                <a:solidFill>
-                  <a:srgbClr val="333333"/>
-                </a:solidFill>
-                <a:latin typeface="Calibri"/>
-              </a:rPr>
-              <a:t>124 / 175</a:t>
-            </a:r>
-          </a:p>
-        </p:txBody>
-      </p:sp>
-      <p:sp>
-        <p:nvSpPr>
-          <p:cNvPr id="39" name="TextBox 38"/>
-          <p:cNvSpPr txBox="1"/>
-          <p:nvPr/>
-        </p:nvSpPr>
-        <p:spPr>
-          <a:xfrm>
-            <a:off x="4114800" y="5875020"/>
-            <a:ext cx="1463040" cy="155448"/>
-          </a:xfrm>
-          <a:prstGeom prst="rect">
-            <a:avLst/>
-          </a:prstGeom>
-          <a:noFill/>
-        </p:spPr>
-        <p:txBody>
-          <a:bodyPr wrap="square" lIns="0" rIns="0" tIns="0" bIns="0">
-            <a:spAutoFit/>
-          </a:bodyPr>
-          <a:lstStyle/>
-          <a:p>
-            <a:pPr algn="l"/>
-            <a:r>
-              <a:rPr sz="850" b="0" i="0">
-                <a:solidFill>
-                  <a:srgbClr val="333333"/>
-                </a:solidFill>
-                <a:latin typeface="Calibri"/>
-              </a:rPr>
-              <a:t>147 / 179</a:t>
-            </a:r>
-          </a:p>
-        </p:txBody>
-      </p:sp>
-      <p:sp>
-        <p:nvSpPr>
-          <p:cNvPr id="40" name="TextBox 39"/>
-          <p:cNvSpPr txBox="1"/>
-          <p:nvPr/>
-        </p:nvSpPr>
-        <p:spPr>
-          <a:xfrm>
-            <a:off x="5760720" y="5875020"/>
-            <a:ext cx="1463040" cy="155448"/>
-          </a:xfrm>
-          <a:prstGeom prst="rect">
-            <a:avLst/>
-          </a:prstGeom>
-          <a:noFill/>
-        </p:spPr>
-        <p:txBody>
-          <a:bodyPr wrap="square" lIns="0" rIns="0" tIns="0" bIns="0">
-            <a:spAutoFit/>
-          </a:bodyPr>
-          <a:lstStyle/>
-          <a:p>
-            <a:pPr algn="l"/>
-            <a:r>
-              <a:rPr sz="850" b="1" i="0">
-                <a:solidFill>
-                  <a:srgbClr val="333333"/>
-                </a:solidFill>
-                <a:latin typeface="Calibri"/>
-              </a:rPr>
-              <a:t>▼ 23</a:t>
-            </a:r>
-          </a:p>
-        </p:txBody>
-      </p:sp>
-      <p:sp>
-        <p:nvSpPr>
-          <p:cNvPr id="41" name="TextBox 40"/>
-          <p:cNvSpPr txBox="1"/>
-          <p:nvPr/>
-        </p:nvSpPr>
-        <p:spPr>
-          <a:xfrm>
-            <a:off x="7132320" y="5875020"/>
-            <a:ext cx="1463040" cy="155448"/>
-          </a:xfrm>
-          <a:prstGeom prst="rect">
-            <a:avLst/>
-          </a:prstGeom>
-          <a:noFill/>
-        </p:spPr>
-        <p:txBody>
-          <a:bodyPr wrap="square" lIns="0" rIns="0" tIns="0" bIns="0">
-            <a:spAutoFit/>
-          </a:bodyPr>
-          <a:lstStyle/>
-          <a:p>
-            <a:pPr algn="l"/>
-            <a:r>
-              <a:rPr sz="850" b="0" i="0">
-                <a:solidFill>
-                  <a:srgbClr val="333333"/>
-                </a:solidFill>
-                <a:latin typeface="Calibri"/>
-              </a:rPr>
-              <a:t>-0.054</a:t>
-            </a:r>
-          </a:p>
-        </p:txBody>
-      </p:sp>
-      <p:sp>
-        <p:nvSpPr>
-          <p:cNvPr id="42" name="TextBox 41"/>
-          <p:cNvSpPr txBox="1"/>
-          <p:nvPr/>
-        </p:nvSpPr>
-        <p:spPr>
-          <a:xfrm>
-            <a:off x="8686800" y="5875020"/>
-            <a:ext cx="1463040" cy="155448"/>
-          </a:xfrm>
-          <a:prstGeom prst="rect">
-            <a:avLst/>
-          </a:prstGeom>
-          <a:noFill/>
-        </p:spPr>
-        <p:txBody>
-          <a:bodyPr wrap="square" lIns="0" rIns="0" tIns="0" bIns="0">
-            <a:spAutoFit/>
-          </a:bodyPr>
-          <a:lstStyle/>
-          <a:p>
-            <a:pPr algn="l"/>
-            <a:r>
-              <a:rPr sz="850" b="0" i="0">
-                <a:solidFill>
-                  <a:srgbClr val="333333"/>
-                </a:solidFill>
-                <a:latin typeface="Calibri"/>
-              </a:rPr>
-              <a:t>-0.324</a:t>
-            </a:r>
-          </a:p>
-        </p:txBody>
-      </p:sp>
-      <p:sp>
-        <p:nvSpPr>
-          <p:cNvPr id="43" name="TextBox 42"/>
-          <p:cNvSpPr txBox="1"/>
-          <p:nvPr/>
-        </p:nvSpPr>
-        <p:spPr>
-          <a:xfrm>
-            <a:off x="10241280" y="5875020"/>
-            <a:ext cx="1463040" cy="155448"/>
-          </a:xfrm>
-          <a:prstGeom prst="rect">
-            <a:avLst/>
-          </a:prstGeom>
-          <a:noFill/>
-        </p:spPr>
-        <p:txBody>
-          <a:bodyPr wrap="square" lIns="0" rIns="0" tIns="0" bIns="0">
-            <a:spAutoFit/>
-          </a:bodyPr>
-          <a:lstStyle/>
-          <a:p>
-            <a:pPr algn="l"/>
-            <a:r>
-              <a:rPr sz="850" b="0" i="0">
-                <a:solidFill>
-                  <a:srgbClr val="333333"/>
-                </a:solidFill>
-                <a:latin typeface="Calibri"/>
-              </a:rPr>
-              <a:t>-0.270</a:t>
-            </a:r>
-          </a:p>
-        </p:txBody>
-      </p:sp>
-      <p:sp>
-        <p:nvSpPr>
-          <p:cNvPr id="44" name="TextBox 43"/>
-          <p:cNvSpPr txBox="1"/>
-          <p:nvPr/>
-        </p:nvSpPr>
-        <p:spPr>
-          <a:xfrm>
-            <a:off x="457200" y="5989320"/>
-            <a:ext cx="1463040" cy="155448"/>
-          </a:xfrm>
-          <a:prstGeom prst="rect">
-            <a:avLst/>
-          </a:prstGeom>
-          <a:noFill/>
-        </p:spPr>
-        <p:txBody>
-          <a:bodyPr wrap="square" lIns="0" rIns="0" tIns="0" bIns="0">
-            <a:spAutoFit/>
-          </a:bodyPr>
-          <a:lstStyle/>
-          <a:p>
-            <a:pPr algn="l"/>
-            <a:r>
-              <a:rPr sz="850" b="0" i="0">
-                <a:solidFill>
-                  <a:srgbClr val="333333"/>
-                </a:solidFill>
-                <a:latin typeface="Calibri"/>
-              </a:rPr>
-              <a:t>Hispanic</a:t>
-            </a:r>
-          </a:p>
-        </p:txBody>
-      </p:sp>
-      <p:sp>
-        <p:nvSpPr>
-          <p:cNvPr id="45" name="TextBox 44"/>
-          <p:cNvSpPr txBox="1"/>
-          <p:nvPr/>
-        </p:nvSpPr>
-        <p:spPr>
-          <a:xfrm>
-            <a:off x="2377440" y="5989320"/>
-            <a:ext cx="1463040" cy="155448"/>
-          </a:xfrm>
-          <a:prstGeom prst="rect">
-            <a:avLst/>
-          </a:prstGeom>
-          <a:noFill/>
-        </p:spPr>
-        <p:txBody>
-          <a:bodyPr wrap="square" lIns="0" rIns="0" tIns="0" bIns="0">
-            <a:spAutoFit/>
-          </a:bodyPr>
-          <a:lstStyle/>
-          <a:p>
-            <a:pPr algn="l"/>
-            <a:r>
-              <a:rPr sz="850" b="0" i="0">
-                <a:solidFill>
-                  <a:srgbClr val="333333"/>
-                </a:solidFill>
-                <a:latin typeface="Calibri"/>
-              </a:rPr>
-              <a:t>230 / 331</a:t>
-            </a:r>
-          </a:p>
-        </p:txBody>
-      </p:sp>
-      <p:sp>
-        <p:nvSpPr>
-          <p:cNvPr id="46" name="TextBox 45"/>
-          <p:cNvSpPr txBox="1"/>
-          <p:nvPr/>
-        </p:nvSpPr>
-        <p:spPr>
-          <a:xfrm>
-            <a:off x="4114800" y="5989320"/>
-            <a:ext cx="1463040" cy="155448"/>
-          </a:xfrm>
-          <a:prstGeom prst="rect">
-            <a:avLst/>
-          </a:prstGeom>
-          <a:noFill/>
-        </p:spPr>
-        <p:txBody>
-          <a:bodyPr wrap="square" lIns="0" rIns="0" tIns="0" bIns="0">
-            <a:spAutoFit/>
-          </a:bodyPr>
-          <a:lstStyle/>
-          <a:p>
-            <a:pPr algn="l"/>
-            <a:r>
-              <a:rPr sz="850" b="0" i="0">
-                <a:solidFill>
-                  <a:srgbClr val="333333"/>
-                </a:solidFill>
-                <a:latin typeface="Calibri"/>
-              </a:rPr>
-              <a:t>197 / 376</a:t>
-            </a:r>
-          </a:p>
-        </p:txBody>
-      </p:sp>
-      <p:sp>
-        <p:nvSpPr>
-          <p:cNvPr id="47" name="TextBox 46"/>
-          <p:cNvSpPr txBox="1"/>
-          <p:nvPr/>
-        </p:nvSpPr>
-        <p:spPr>
-          <a:xfrm>
-            <a:off x="5760720" y="5989320"/>
-            <a:ext cx="1463040" cy="155448"/>
-          </a:xfrm>
-          <a:prstGeom prst="rect">
-            <a:avLst/>
-          </a:prstGeom>
-          <a:noFill/>
-        </p:spPr>
-        <p:txBody>
-          <a:bodyPr wrap="square" lIns="0" rIns="0" tIns="0" bIns="0">
-            <a:spAutoFit/>
-          </a:bodyPr>
-          <a:lstStyle/>
-          <a:p>
-            <a:pPr algn="l"/>
-            <a:r>
-              <a:rPr sz="850" b="1" i="0">
-                <a:solidFill>
-                  <a:srgbClr val="1F7A3D"/>
-                </a:solidFill>
-                <a:latin typeface="Calibri"/>
-              </a:rPr>
-              <a:t>▲ 33</a:t>
-            </a:r>
-          </a:p>
-        </p:txBody>
-      </p:sp>
-      <p:sp>
-        <p:nvSpPr>
-          <p:cNvPr id="48" name="TextBox 47"/>
-          <p:cNvSpPr txBox="1"/>
-          <p:nvPr/>
-        </p:nvSpPr>
-        <p:spPr>
-          <a:xfrm>
-            <a:off x="7132320" y="5989320"/>
-            <a:ext cx="1463040" cy="155448"/>
-          </a:xfrm>
-          <a:prstGeom prst="rect">
-            <a:avLst/>
-          </a:prstGeom>
-          <a:noFill/>
-        </p:spPr>
-        <p:txBody>
-          <a:bodyPr wrap="square" lIns="0" rIns="0" tIns="0" bIns="0">
-            <a:spAutoFit/>
-          </a:bodyPr>
-          <a:lstStyle/>
-          <a:p>
-            <a:pPr algn="l"/>
-            <a:r>
-              <a:rPr sz="850" b="0" i="0">
-                <a:solidFill>
-                  <a:srgbClr val="333333"/>
-                </a:solidFill>
-                <a:latin typeface="Calibri"/>
-              </a:rPr>
-              <a:t>+0.160</a:t>
-            </a:r>
-          </a:p>
-        </p:txBody>
-      </p:sp>
-      <p:sp>
-        <p:nvSpPr>
-          <p:cNvPr id="49" name="TextBox 48"/>
-          <p:cNvSpPr txBox="1"/>
-          <p:nvPr/>
-        </p:nvSpPr>
-        <p:spPr>
-          <a:xfrm>
-            <a:off x="8686800" y="5989320"/>
-            <a:ext cx="1463040" cy="155448"/>
-          </a:xfrm>
-          <a:prstGeom prst="rect">
-            <a:avLst/>
-          </a:prstGeom>
-          <a:noFill/>
-        </p:spPr>
-        <p:txBody>
-          <a:bodyPr wrap="square" lIns="0" rIns="0" tIns="0" bIns="0">
-            <a:spAutoFit/>
-          </a:bodyPr>
-          <a:lstStyle/>
-          <a:p>
-            <a:pPr algn="l"/>
-            <a:r>
-              <a:rPr sz="850" b="0" i="0">
-                <a:solidFill>
-                  <a:srgbClr val="333333"/>
-                </a:solidFill>
-                <a:latin typeface="Calibri"/>
-              </a:rPr>
-              <a:t>+0.127</a:t>
-            </a:r>
-          </a:p>
-        </p:txBody>
-      </p:sp>
-      <p:sp>
-        <p:nvSpPr>
-          <p:cNvPr id="50" name="TextBox 49"/>
-          <p:cNvSpPr txBox="1"/>
-          <p:nvPr/>
-        </p:nvSpPr>
-        <p:spPr>
-          <a:xfrm>
-            <a:off x="10241280" y="5989320"/>
-            <a:ext cx="1463040" cy="155448"/>
-          </a:xfrm>
-          <a:prstGeom prst="rect">
-            <a:avLst/>
-          </a:prstGeom>
-          <a:noFill/>
-        </p:spPr>
-        <p:txBody>
-          <a:bodyPr wrap="square" lIns="0" rIns="0" tIns="0" bIns="0">
-            <a:spAutoFit/>
-          </a:bodyPr>
-          <a:lstStyle/>
-          <a:p>
-            <a:pPr algn="l"/>
-            <a:r>
-              <a:rPr sz="850" b="0" i="0">
-                <a:solidFill>
-                  <a:srgbClr val="333333"/>
-                </a:solidFill>
-                <a:latin typeface="Calibri"/>
-              </a:rPr>
-              <a:t>-0.033</a:t>
-            </a:r>
-          </a:p>
-        </p:txBody>
-      </p:sp>
-      <p:sp>
-        <p:nvSpPr>
-          <p:cNvPr id="51" name="TextBox 50"/>
-          <p:cNvSpPr txBox="1"/>
-          <p:nvPr/>
-        </p:nvSpPr>
-        <p:spPr>
-          <a:xfrm>
-            <a:off x="457200" y="6103620"/>
-            <a:ext cx="1463040" cy="155448"/>
-          </a:xfrm>
-          <a:prstGeom prst="rect">
-            <a:avLst/>
-          </a:prstGeom>
-          <a:noFill/>
-        </p:spPr>
-        <p:txBody>
-          <a:bodyPr wrap="square" lIns="0" rIns="0" tIns="0" bIns="0">
-            <a:spAutoFit/>
-          </a:bodyPr>
-          <a:lstStyle/>
-          <a:p>
-            <a:pPr algn="l"/>
-            <a:r>
-              <a:rPr sz="850" b="0" i="0">
-                <a:solidFill>
-                  <a:srgbClr val="333333"/>
-                </a:solidFill>
-                <a:latin typeface="Calibri"/>
-              </a:rPr>
-              <a:t>Not Econ Disadv</a:t>
-            </a:r>
-          </a:p>
-        </p:txBody>
-      </p:sp>
-      <p:sp>
-        <p:nvSpPr>
-          <p:cNvPr id="52" name="TextBox 51"/>
-          <p:cNvSpPr txBox="1"/>
-          <p:nvPr/>
-        </p:nvSpPr>
-        <p:spPr>
-          <a:xfrm>
-            <a:off x="2377440" y="6103620"/>
-            <a:ext cx="1463040" cy="155448"/>
-          </a:xfrm>
-          <a:prstGeom prst="rect">
-            <a:avLst/>
-          </a:prstGeom>
-          <a:noFill/>
-        </p:spPr>
-        <p:txBody>
-          <a:bodyPr wrap="square" lIns="0" rIns="0" tIns="0" bIns="0">
-            <a:spAutoFit/>
-          </a:bodyPr>
-          <a:lstStyle/>
-          <a:p>
-            <a:pPr algn="l"/>
-            <a:r>
-              <a:rPr sz="850" b="0" i="0">
-                <a:solidFill>
-                  <a:srgbClr val="333333"/>
-                </a:solidFill>
-                <a:latin typeface="Calibri"/>
-              </a:rPr>
-              <a:t>155 / 503</a:t>
-            </a:r>
-          </a:p>
-        </p:txBody>
-      </p:sp>
-      <p:sp>
-        <p:nvSpPr>
-          <p:cNvPr id="53" name="TextBox 52"/>
-          <p:cNvSpPr txBox="1"/>
-          <p:nvPr/>
-        </p:nvSpPr>
-        <p:spPr>
-          <a:xfrm>
-            <a:off x="4114800" y="6103620"/>
-            <a:ext cx="1463040" cy="155448"/>
-          </a:xfrm>
-          <a:prstGeom prst="rect">
-            <a:avLst/>
-          </a:prstGeom>
-          <a:noFill/>
-        </p:spPr>
-        <p:txBody>
-          <a:bodyPr wrap="square" lIns="0" rIns="0" tIns="0" bIns="0">
-            <a:spAutoFit/>
-          </a:bodyPr>
-          <a:lstStyle/>
-          <a:p>
-            <a:pPr algn="l"/>
-            <a:r>
-              <a:rPr sz="850" b="0" i="0">
-                <a:solidFill>
-                  <a:srgbClr val="333333"/>
-                </a:solidFill>
-                <a:latin typeface="Calibri"/>
-              </a:rPr>
-              <a:t>325 / 495</a:t>
-            </a:r>
-          </a:p>
-        </p:txBody>
-      </p:sp>
-      <p:sp>
-        <p:nvSpPr>
-          <p:cNvPr id="54" name="TextBox 53"/>
-          <p:cNvSpPr txBox="1"/>
-          <p:nvPr/>
-        </p:nvSpPr>
-        <p:spPr>
-          <a:xfrm>
-            <a:off x="5760720" y="6103620"/>
-            <a:ext cx="1463040" cy="155448"/>
-          </a:xfrm>
-          <a:prstGeom prst="rect">
-            <a:avLst/>
-          </a:prstGeom>
-          <a:noFill/>
-        </p:spPr>
-        <p:txBody>
-          <a:bodyPr wrap="square" lIns="0" rIns="0" tIns="0" bIns="0">
-            <a:spAutoFit/>
-          </a:bodyPr>
-          <a:lstStyle/>
-          <a:p>
-            <a:pPr algn="l"/>
-            <a:r>
-              <a:rPr sz="850" b="1" i="0">
-                <a:solidFill>
-                  <a:srgbClr val="B02121"/>
-                </a:solidFill>
-                <a:latin typeface="Calibri"/>
-              </a:rPr>
-              <a:t>▼ 170</a:t>
-            </a:r>
-          </a:p>
-        </p:txBody>
-      </p:sp>
-      <p:sp>
-        <p:nvSpPr>
-          <p:cNvPr id="55" name="TextBox 54"/>
-          <p:cNvSpPr txBox="1"/>
-          <p:nvPr/>
-        </p:nvSpPr>
-        <p:spPr>
-          <a:xfrm>
-            <a:off x="7132320" y="6103620"/>
-            <a:ext cx="1463040" cy="155448"/>
-          </a:xfrm>
-          <a:prstGeom prst="rect">
-            <a:avLst/>
-          </a:prstGeom>
-          <a:noFill/>
-        </p:spPr>
-        <p:txBody>
-          <a:bodyPr wrap="square" lIns="0" rIns="0" tIns="0" bIns="0">
-            <a:spAutoFit/>
-          </a:bodyPr>
-          <a:lstStyle/>
-          <a:p>
-            <a:pPr algn="l"/>
-            <a:r>
-              <a:rPr sz="850" b="0" i="0">
-                <a:solidFill>
-                  <a:srgbClr val="333333"/>
-                </a:solidFill>
-                <a:latin typeface="Calibri"/>
-              </a:rPr>
-              <a:t>+0.846</a:t>
+              <a:t>▼ 80</a:t>
             </a:r>
           </a:p>
         </p:txBody>
@@ -20925,321 +21020,6 @@
       <p:sp>
         <p:nvSpPr>
           <p:cNvPr id="56" name="TextBox 55"/>
-          <p:cNvSpPr txBox="1"/>
-          <p:nvPr/>
-        </p:nvSpPr>
-        <p:spPr>
-          <a:xfrm>
-            <a:off x="8686800" y="6103620"/>
-            <a:ext cx="1463040" cy="155448"/>
-          </a:xfrm>
-          <a:prstGeom prst="rect">
-            <a:avLst/>
-          </a:prstGeom>
-          <a:noFill/>
-        </p:spPr>
-        <p:txBody>
-          <a:bodyPr wrap="square" lIns="0" rIns="0" tIns="0" bIns="0">
-            <a:spAutoFit/>
-          </a:bodyPr>
-          <a:lstStyle/>
-          <a:p>
-            <a:pPr algn="l"/>
-            <a:r>
-              <a:rPr sz="850" b="0" i="0">
-                <a:solidFill>
-                  <a:srgbClr val="333333"/>
-                </a:solidFill>
-                <a:latin typeface="Calibri"/>
-              </a:rPr>
-              <a:t>+0.595</a:t>
-            </a:r>
-          </a:p>
-        </p:txBody>
-      </p:sp>
-      <p:sp>
-        <p:nvSpPr>
-          <p:cNvPr id="57" name="TextBox 56"/>
-          <p:cNvSpPr txBox="1"/>
-          <p:nvPr/>
-        </p:nvSpPr>
-        <p:spPr>
-          <a:xfrm>
-            <a:off x="10241280" y="6103620"/>
-            <a:ext cx="1463040" cy="155448"/>
-          </a:xfrm>
-          <a:prstGeom prst="rect">
-            <a:avLst/>
-          </a:prstGeom>
-          <a:noFill/>
-        </p:spPr>
-        <p:txBody>
-          <a:bodyPr wrap="square" lIns="0" rIns="0" tIns="0" bIns="0">
-            <a:spAutoFit/>
-          </a:bodyPr>
-          <a:lstStyle/>
-          <a:p>
-            <a:pPr algn="l"/>
-            <a:r>
-              <a:rPr sz="850" b="0" i="0">
-                <a:solidFill>
-                  <a:srgbClr val="333333"/>
-                </a:solidFill>
-                <a:latin typeface="Calibri"/>
-              </a:rPr>
-              <a:t>-0.251</a:t>
-            </a:r>
-          </a:p>
-        </p:txBody>
-      </p:sp>
-      <p:sp>
-        <p:nvSpPr>
-          <p:cNvPr id="58" name="TextBox 57"/>
-          <p:cNvSpPr txBox="1"/>
-          <p:nvPr/>
-        </p:nvSpPr>
-        <p:spPr>
-          <a:xfrm>
-            <a:off x="457200" y="6217920"/>
-            <a:ext cx="1463040" cy="155448"/>
-          </a:xfrm>
-          <a:prstGeom prst="rect">
-            <a:avLst/>
-          </a:prstGeom>
-          <a:noFill/>
-        </p:spPr>
-        <p:txBody>
-          <a:bodyPr wrap="square" lIns="0" rIns="0" tIns="0" bIns="0">
-            <a:spAutoFit/>
-          </a:bodyPr>
-          <a:lstStyle/>
-          <a:p>
-            <a:pPr algn="l"/>
-            <a:r>
-              <a:rPr sz="850" b="0" i="0">
-                <a:solidFill>
-                  <a:srgbClr val="333333"/>
-                </a:solidFill>
-                <a:latin typeface="Calibri"/>
-              </a:rPr>
-              <a:t>Econ Disadv</a:t>
-            </a:r>
-          </a:p>
-        </p:txBody>
-      </p:sp>
-      <p:sp>
-        <p:nvSpPr>
-          <p:cNvPr id="59" name="TextBox 58"/>
-          <p:cNvSpPr txBox="1"/>
-          <p:nvPr/>
-        </p:nvSpPr>
-        <p:spPr>
-          <a:xfrm>
-            <a:off x="2377440" y="6217920"/>
-            <a:ext cx="1463040" cy="155448"/>
-          </a:xfrm>
-          <a:prstGeom prst="rect">
-            <a:avLst/>
-          </a:prstGeom>
-          <a:noFill/>
-        </p:spPr>
-        <p:txBody>
-          <a:bodyPr wrap="square" lIns="0" rIns="0" tIns="0" bIns="0">
-            <a:spAutoFit/>
-          </a:bodyPr>
-          <a:lstStyle/>
-          <a:p>
-            <a:pPr algn="l"/>
-            <a:r>
-              <a:rPr sz="850" b="0" i="0">
-                <a:solidFill>
-                  <a:srgbClr val="333333"/>
-                </a:solidFill>
-                <a:latin typeface="Calibri"/>
-              </a:rPr>
-              <a:t>313 / 449</a:t>
-            </a:r>
-          </a:p>
-        </p:txBody>
-      </p:sp>
-      <p:sp>
-        <p:nvSpPr>
-          <p:cNvPr id="60" name="TextBox 59"/>
-          <p:cNvSpPr txBox="1"/>
-          <p:nvPr/>
-        </p:nvSpPr>
-        <p:spPr>
-          <a:xfrm>
-            <a:off x="4114800" y="6217920"/>
-            <a:ext cx="1463040" cy="155448"/>
-          </a:xfrm>
-          <a:prstGeom prst="rect">
-            <a:avLst/>
-          </a:prstGeom>
-          <a:noFill/>
-        </p:spPr>
-        <p:txBody>
-          <a:bodyPr wrap="square" lIns="0" rIns="0" tIns="0" bIns="0">
-            <a:spAutoFit/>
-          </a:bodyPr>
-          <a:lstStyle/>
-          <a:p>
-            <a:pPr algn="l"/>
-            <a:r>
-              <a:rPr sz="850" b="0" i="0">
-                <a:solidFill>
-                  <a:srgbClr val="333333"/>
-                </a:solidFill>
-                <a:latin typeface="Calibri"/>
-              </a:rPr>
-              <a:t>318 / 461</a:t>
-            </a:r>
-          </a:p>
-        </p:txBody>
-      </p:sp>
-      <p:sp>
-        <p:nvSpPr>
-          <p:cNvPr id="61" name="TextBox 60"/>
-          <p:cNvSpPr txBox="1"/>
-          <p:nvPr/>
-        </p:nvSpPr>
-        <p:spPr>
-          <a:xfrm>
-            <a:off x="5760720" y="6217920"/>
-            <a:ext cx="1463040" cy="155448"/>
-          </a:xfrm>
-          <a:prstGeom prst="rect">
-            <a:avLst/>
-          </a:prstGeom>
-          <a:noFill/>
-        </p:spPr>
-        <p:txBody>
-          <a:bodyPr wrap="square" lIns="0" rIns="0" tIns="0" bIns="0">
-            <a:spAutoFit/>
-          </a:bodyPr>
-          <a:lstStyle/>
-          <a:p>
-            <a:pPr algn="l"/>
-            <a:r>
-              <a:rPr sz="850" b="1" i="0">
-                <a:solidFill>
-                  <a:srgbClr val="333333"/>
-                </a:solidFill>
-                <a:latin typeface="Calibri"/>
-              </a:rPr>
-              <a:t>▼ 5</a:t>
-            </a:r>
-          </a:p>
-        </p:txBody>
-      </p:sp>
-      <p:sp>
-        <p:nvSpPr>
-          <p:cNvPr id="62" name="TextBox 61"/>
-          <p:cNvSpPr txBox="1"/>
-          <p:nvPr/>
-        </p:nvSpPr>
-        <p:spPr>
-          <a:xfrm>
-            <a:off x="7132320" y="6217920"/>
-            <a:ext cx="1463040" cy="155448"/>
-          </a:xfrm>
-          <a:prstGeom prst="rect">
-            <a:avLst/>
-          </a:prstGeom>
-          <a:noFill/>
-        </p:spPr>
-        <p:txBody>
-          <a:bodyPr wrap="square" lIns="0" rIns="0" tIns="0" bIns="0">
-            <a:spAutoFit/>
-          </a:bodyPr>
-          <a:lstStyle/>
-          <a:p>
-            <a:pPr algn="l"/>
-            <a:r>
-              <a:rPr sz="850" b="0" i="0">
-                <a:solidFill>
-                  <a:srgbClr val="333333"/>
-                </a:solidFill>
-                <a:latin typeface="Calibri"/>
-              </a:rPr>
-              <a:t>+0.012</a:t>
-            </a:r>
-          </a:p>
-        </p:txBody>
-      </p:sp>
-      <p:sp>
-        <p:nvSpPr>
-          <p:cNvPr id="63" name="TextBox 62"/>
-          <p:cNvSpPr txBox="1"/>
-          <p:nvPr/>
-        </p:nvSpPr>
-        <p:spPr>
-          <a:xfrm>
-            <a:off x="8686800" y="6217920"/>
-            <a:ext cx="1463040" cy="155448"/>
-          </a:xfrm>
-          <a:prstGeom prst="rect">
-            <a:avLst/>
-          </a:prstGeom>
-          <a:noFill/>
-        </p:spPr>
-        <p:txBody>
-          <a:bodyPr wrap="square" lIns="0" rIns="0" tIns="0" bIns="0">
-            <a:spAutoFit/>
-          </a:bodyPr>
-          <a:lstStyle/>
-          <a:p>
-            <a:pPr algn="l"/>
-            <a:r>
-              <a:rPr sz="850" b="0" i="0">
-                <a:solidFill>
-                  <a:srgbClr val="333333"/>
-                </a:solidFill>
-                <a:latin typeface="Calibri"/>
-              </a:rPr>
-              <a:t>-0.133</a:t>
-            </a:r>
-          </a:p>
-        </p:txBody>
-      </p:sp>
-      <p:sp>
-        <p:nvSpPr>
-          <p:cNvPr id="64" name="TextBox 63"/>
-          <p:cNvSpPr txBox="1"/>
-          <p:nvPr/>
-        </p:nvSpPr>
-        <p:spPr>
-          <a:xfrm>
-            <a:off x="10241280" y="6217920"/>
-            <a:ext cx="1463040" cy="155448"/>
-          </a:xfrm>
-          <a:prstGeom prst="rect">
-            <a:avLst/>
-          </a:prstGeom>
-          <a:noFill/>
-        </p:spPr>
-        <p:txBody>
-          <a:bodyPr wrap="square" lIns="0" rIns="0" tIns="0" bIns="0">
-            <a:spAutoFit/>
-          </a:bodyPr>
-          <a:lstStyle/>
-          <a:p>
-            <a:pPr algn="l"/>
-            <a:r>
-              <a:rPr sz="850" b="0" i="0">
-                <a:solidFill>
-                  <a:srgbClr val="333333"/>
-                </a:solidFill>
-                <a:latin typeface="Calibri"/>
-              </a:rPr>
-              <a:t>-0.145</a:t>
-            </a:r>
-          </a:p>
-        </p:txBody>
-      </p:sp>
-      <p:sp>
-        <p:nvSpPr>
-          <p:cNvPr id="65" name="TextBox 64"/>
           <p:cNvSpPr txBox="1"/>
           <p:nvPr/>
         </p:nvSpPr>
@@ -21274,7 +21054,7 @@
       </p:sp>
       <p:sp>
         <p:nvSpPr>
-          <p:cNvPr id="66" name="TextBox 65"/>
+          <p:cNvPr id="57" name="TextBox 56"/>
           <p:cNvSpPr txBox="1"/>
           <p:nvPr/>
         </p:nvSpPr>

</xml_diff>

<commit_message>
Fix slide 24 text overlaps: row 4 bleeding into callout, title into subtitle
Co-Authored-By: Claude Opus 4.6 <noreply@anthropic.com>
</commit_message>
<xml_diff>
--- a/analysis/Troy_K5_ELA_Executive_Summary.pptx
+++ b/analysis/Troy_K5_ELA_Executive_Summary.pptx
@@ -19237,7 +19237,7 @@
         </p:nvSpPr>
         <p:spPr>
           <a:xfrm>
-            <a:off x="457200" y="1261872"/>
+            <a:off x="457200" y="1298448"/>
             <a:ext cx="4389120" cy="228600"/>
           </a:xfrm>
           <a:prstGeom prst="rect">
@@ -20194,45 +20194,36 @@
       </p:sp>
       <p:sp>
         <p:nvSpPr>
-          <p:cNvPr id="34" name="Rectangle 33"/>
-          <p:cNvSpPr/>
-          <p:nvPr/>
-        </p:nvSpPr>
-        <p:spPr>
-          <a:xfrm>
-            <a:off x="365760" y="3611880"/>
-            <a:ext cx="4572000" cy="36576"/>
-          </a:xfrm>
-          <a:prstGeom prst="rect">
-            <a:avLst/>
-          </a:prstGeom>
-          <a:solidFill>
-            <a:srgbClr val="B02121"/>
-          </a:solidFill>
-          <a:ln>
-            <a:noFill/>
-          </a:ln>
-          <a:effectLst/>
-        </p:spPr>
-        <p:style>
-          <a:lnRef idx="1">
-            <a:schemeClr val="accent1"/>
-          </a:lnRef>
-          <a:fillRef idx="3">
-            <a:schemeClr val="accent1"/>
-          </a:fillRef>
-          <a:effectRef idx="2">
-            <a:schemeClr val="accent1"/>
-          </a:effectRef>
-          <a:fontRef idx="minor">
-            <a:schemeClr val="lt1"/>
-          </a:fontRef>
-        </p:style>
-        <p:txBody>
-          <a:bodyPr rtlCol="0" anchor="ctr"/>
-          <a:lstStyle/>
-          <a:p>
-            <a:pPr algn="ctr"/>
+          <p:cNvPr id="34" name="TextBox 33"/>
+          <p:cNvSpPr txBox="1"/>
+          <p:nvPr/>
+        </p:nvSpPr>
+        <p:spPr>
+          <a:xfrm>
+            <a:off x="457200" y="3858768"/>
+            <a:ext cx="4389120" cy="274320"/>
+          </a:xfrm>
+          <a:prstGeom prst="rect">
+            <a:avLst/>
+          </a:prstGeom>
+          <a:noFill/>
+        </p:spPr>
+        <p:txBody>
+          <a:bodyPr wrap="square" lIns="0" rIns="0" tIns="0" bIns="0">
+            <a:spAutoFit/>
+          </a:bodyPr>
+          <a:lstStyle/>
+          <a:p>
+            <a:pPr algn="l"/>
+            <a:r>
+              <a:rPr sz="1600" b="1" i="0">
+                <a:solidFill>
+                  <a:srgbClr val="B02121"/>
+                </a:solidFill>
+                <a:latin typeface="Calibri"/>
+              </a:rPr>
+              <a:t>Dropped ~600 places in 4 years</a:t>
+            </a:r>
           </a:p>
         </p:txBody>
       </p:sp>
@@ -20244,43 +20235,8 @@
         </p:nvSpPr>
         <p:spPr>
           <a:xfrm>
-            <a:off x="457200" y="3749039"/>
-            <a:ext cx="4389120" cy="320040"/>
-          </a:xfrm>
-          <a:prstGeom prst="rect">
-            <a:avLst/>
-          </a:prstGeom>
-          <a:noFill/>
-        </p:spPr>
-        <p:txBody>
-          <a:bodyPr wrap="square" lIns="0" rIns="0" tIns="0" bIns="0">
-            <a:spAutoFit/>
-          </a:bodyPr>
-          <a:lstStyle/>
-          <a:p>
-            <a:pPr algn="l"/>
-            <a:r>
-              <a:rPr sz="1600" b="1" i="0">
-                <a:solidFill>
-                  <a:srgbClr val="B02121"/>
-                </a:solidFill>
-                <a:latin typeface="Calibri"/>
-              </a:rPr>
-              <a:t>Dropped ~600 places in 4 years</a:t>
-            </a:r>
-          </a:p>
-        </p:txBody>
-      </p:sp>
-      <p:sp>
-        <p:nvSpPr>
-          <p:cNvPr id="36" name="TextBox 35"/>
-          <p:cNvSpPr txBox="1"/>
-          <p:nvPr/>
-        </p:nvSpPr>
-        <p:spPr>
-          <a:xfrm>
-            <a:off x="457200" y="4114800"/>
-            <a:ext cx="4389120" cy="822960"/>
+            <a:off x="457200" y="4187952"/>
+            <a:ext cx="4389120" cy="777240"/>
           </a:xfrm>
           <a:prstGeom prst="rect">
             <a:avLst/>
@@ -20332,7 +20288,7 @@
       </p:sp>
       <p:pic>
         <p:nvPicPr>
-          <p:cNvPr id="37" name="Picture 36" descr="chart_seda_scatter.png"/>
+          <p:cNvPr id="36" name="Picture 35" descr="chart_seda_scatter.png"/>
           <p:cNvPicPr>
             <a:picLocks noChangeAspect="1"/>
           </p:cNvPicPr>
@@ -20356,7 +20312,7 @@
       </p:pic>
       <p:sp>
         <p:nvSpPr>
-          <p:cNvPr id="38" name="Rectangle 37"/>
+          <p:cNvPr id="37" name="Rectangle 36"/>
           <p:cNvSpPr/>
           <p:nvPr/>
         </p:nvSpPr>
@@ -20400,7 +20356,7 @@
       </p:sp>
       <p:sp>
         <p:nvSpPr>
-          <p:cNvPr id="39" name="TextBox 38"/>
+          <p:cNvPr id="38" name="TextBox 37"/>
           <p:cNvSpPr txBox="1"/>
           <p:nvPr/>
         </p:nvSpPr>
@@ -20435,7 +20391,7 @@
       </p:sp>
       <p:sp>
         <p:nvSpPr>
-          <p:cNvPr id="40" name="TextBox 39"/>
+          <p:cNvPr id="39" name="TextBox 38"/>
           <p:cNvSpPr txBox="1"/>
           <p:nvPr/>
         </p:nvSpPr>
@@ -20494,7 +20450,7 @@
       </p:sp>
       <p:sp>
         <p:nvSpPr>
-          <p:cNvPr id="41" name="TextBox 40"/>
+          <p:cNvPr id="40" name="TextBox 39"/>
           <p:cNvSpPr txBox="1"/>
           <p:nvPr/>
         </p:nvSpPr>
@@ -20529,7 +20485,7 @@
       </p:sp>
       <p:sp>
         <p:nvSpPr>
-          <p:cNvPr id="42" name="TextBox 41"/>
+          <p:cNvPr id="41" name="TextBox 40"/>
           <p:cNvSpPr txBox="1"/>
           <p:nvPr/>
         </p:nvSpPr>
@@ -20564,7 +20520,7 @@
       </p:sp>
       <p:sp>
         <p:nvSpPr>
-          <p:cNvPr id="43" name="TextBox 42"/>
+          <p:cNvPr id="42" name="TextBox 41"/>
           <p:cNvSpPr txBox="1"/>
           <p:nvPr/>
         </p:nvSpPr>
@@ -20599,7 +20555,7 @@
       </p:sp>
       <p:sp>
         <p:nvSpPr>
-          <p:cNvPr id="44" name="TextBox 43"/>
+          <p:cNvPr id="43" name="TextBox 42"/>
           <p:cNvSpPr txBox="1"/>
           <p:nvPr/>
         </p:nvSpPr>
@@ -20634,7 +20590,7 @@
       </p:sp>
       <p:sp>
         <p:nvSpPr>
-          <p:cNvPr id="45" name="TextBox 44"/>
+          <p:cNvPr id="44" name="TextBox 43"/>
           <p:cNvSpPr txBox="1"/>
           <p:nvPr/>
         </p:nvSpPr>
@@ -20669,7 +20625,7 @@
       </p:sp>
       <p:sp>
         <p:nvSpPr>
-          <p:cNvPr id="46" name="TextBox 45"/>
+          <p:cNvPr id="45" name="TextBox 44"/>
           <p:cNvSpPr txBox="1"/>
           <p:nvPr/>
         </p:nvSpPr>
@@ -20704,7 +20660,7 @@
       </p:sp>
       <p:sp>
         <p:nvSpPr>
-          <p:cNvPr id="47" name="TextBox 46"/>
+          <p:cNvPr id="46" name="TextBox 45"/>
           <p:cNvSpPr txBox="1"/>
           <p:nvPr/>
         </p:nvSpPr>
@@ -20739,7 +20695,7 @@
       </p:sp>
       <p:sp>
         <p:nvSpPr>
-          <p:cNvPr id="48" name="TextBox 47"/>
+          <p:cNvPr id="47" name="TextBox 46"/>
           <p:cNvSpPr txBox="1"/>
           <p:nvPr/>
         </p:nvSpPr>
@@ -20774,7 +20730,7 @@
       </p:sp>
       <p:sp>
         <p:nvSpPr>
-          <p:cNvPr id="49" name="TextBox 48"/>
+          <p:cNvPr id="48" name="TextBox 47"/>
           <p:cNvSpPr txBox="1"/>
           <p:nvPr/>
         </p:nvSpPr>
@@ -20809,7 +20765,7 @@
       </p:sp>
       <p:sp>
         <p:nvSpPr>
-          <p:cNvPr id="50" name="TextBox 49"/>
+          <p:cNvPr id="49" name="TextBox 48"/>
           <p:cNvSpPr txBox="1"/>
           <p:nvPr/>
         </p:nvSpPr>
@@ -20844,7 +20800,7 @@
       </p:sp>
       <p:sp>
         <p:nvSpPr>
-          <p:cNvPr id="51" name="TextBox 50"/>
+          <p:cNvPr id="50" name="TextBox 49"/>
           <p:cNvSpPr txBox="1"/>
           <p:nvPr/>
         </p:nvSpPr>
@@ -20879,7 +20835,7 @@
       </p:sp>
       <p:sp>
         <p:nvSpPr>
-          <p:cNvPr id="52" name="TextBox 51"/>
+          <p:cNvPr id="51" name="TextBox 50"/>
           <p:cNvSpPr txBox="1"/>
           <p:nvPr/>
         </p:nvSpPr>
@@ -20914,7 +20870,7 @@
       </p:sp>
       <p:sp>
         <p:nvSpPr>
-          <p:cNvPr id="53" name="TextBox 52"/>
+          <p:cNvPr id="52" name="TextBox 51"/>
           <p:cNvSpPr txBox="1"/>
           <p:nvPr/>
         </p:nvSpPr>
@@ -20949,7 +20905,7 @@
       </p:sp>
       <p:sp>
         <p:nvSpPr>
-          <p:cNvPr id="54" name="TextBox 53"/>
+          <p:cNvPr id="53" name="TextBox 52"/>
           <p:cNvSpPr txBox="1"/>
           <p:nvPr/>
         </p:nvSpPr>
@@ -20984,7 +20940,7 @@
       </p:sp>
       <p:sp>
         <p:nvSpPr>
-          <p:cNvPr id="55" name="TextBox 54"/>
+          <p:cNvPr id="54" name="TextBox 53"/>
           <p:cNvSpPr txBox="1"/>
           <p:nvPr/>
         </p:nvSpPr>
@@ -21019,7 +20975,7 @@
       </p:sp>
       <p:sp>
         <p:nvSpPr>
-          <p:cNvPr id="56" name="TextBox 55"/>
+          <p:cNvPr id="55" name="TextBox 54"/>
           <p:cNvSpPr txBox="1"/>
           <p:nvPr/>
         </p:nvSpPr>
@@ -21054,7 +21010,7 @@
       </p:sp>
       <p:sp>
         <p:nvSpPr>
-          <p:cNvPr id="57" name="TextBox 56"/>
+          <p:cNvPr id="56" name="TextBox 55"/>
           <p:cNvSpPr txBox="1"/>
           <p:nvPr/>
         </p:nvSpPr>

</xml_diff>